<commit_message>
Restyle PnP cards: 20pt type, face bottom / back top anchors.
</commit_message>
<xml_diff>
--- a/output/svet-moy-zerkalce-cards.pptx
+++ b/output/svet-moy-zerkalce-cards.pptx
@@ -3108,7 +3108,7 @@
           <a:effectLst/>
         </p:spPr>
         <p:txBody>
-          <a:bodyPr wrap="square" anchor="ctr">
+          <a:bodyPr wrap="square" anchor="b">
             <a:spAutoFit/>
           </a:bodyPr>
           <a:lstStyle/>
@@ -3122,7 +3122,7 @@
               </a:spcAft>
             </a:pPr>
             <a:r>
-              <a:rPr sz="800" b="1">
+              <a:rPr sz="2000" b="1">
                 <a:solidFill>
                   <a:srgbClr val="1A1A1A"/>
                 </a:solidFill>
@@ -3151,7 +3151,7 @@
           <a:effectLst/>
         </p:spPr>
         <p:txBody>
-          <a:bodyPr wrap="square" anchor="ctr">
+          <a:bodyPr wrap="square" anchor="b">
             <a:spAutoFit/>
           </a:bodyPr>
           <a:lstStyle/>
@@ -3165,7 +3165,7 @@
               </a:spcAft>
             </a:pPr>
             <a:r>
-              <a:rPr sz="800" b="1">
+              <a:rPr sz="2000" b="1">
                 <a:solidFill>
                   <a:srgbClr val="1A1A1A"/>
                 </a:solidFill>
@@ -3194,7 +3194,7 @@
           <a:effectLst/>
         </p:spPr>
         <p:txBody>
-          <a:bodyPr wrap="square" anchor="ctr">
+          <a:bodyPr wrap="square" anchor="b">
             <a:spAutoFit/>
           </a:bodyPr>
           <a:lstStyle/>
@@ -3208,7 +3208,7 @@
               </a:spcAft>
             </a:pPr>
             <a:r>
-              <a:rPr sz="1000" b="1">
+              <a:rPr sz="2000" b="1">
                 <a:solidFill>
                   <a:srgbClr val="1A1A1A"/>
                 </a:solidFill>
@@ -3237,7 +3237,7 @@
           <a:effectLst/>
         </p:spPr>
         <p:txBody>
-          <a:bodyPr wrap="square" anchor="ctr">
+          <a:bodyPr wrap="square" anchor="b">
             <a:spAutoFit/>
           </a:bodyPr>
           <a:lstStyle/>
@@ -3251,7 +3251,7 @@
               </a:spcAft>
             </a:pPr>
             <a:r>
-              <a:rPr sz="1000" b="1">
+              <a:rPr sz="2000" b="1">
                 <a:solidFill>
                   <a:srgbClr val="1A1A1A"/>
                 </a:solidFill>
@@ -3280,7 +3280,7 @@
           <a:effectLst/>
         </p:spPr>
         <p:txBody>
-          <a:bodyPr wrap="square" anchor="ctr">
+          <a:bodyPr wrap="square" anchor="b">
             <a:spAutoFit/>
           </a:bodyPr>
           <a:lstStyle/>
@@ -3294,7 +3294,7 @@
               </a:spcAft>
             </a:pPr>
             <a:r>
-              <a:rPr sz="1000" b="1">
+              <a:rPr sz="2000" b="1">
                 <a:solidFill>
                   <a:srgbClr val="1A1A1A"/>
                 </a:solidFill>
@@ -3323,7 +3323,7 @@
           <a:effectLst/>
         </p:spPr>
         <p:txBody>
-          <a:bodyPr wrap="square" anchor="ctr">
+          <a:bodyPr wrap="square" anchor="b">
             <a:spAutoFit/>
           </a:bodyPr>
           <a:lstStyle/>
@@ -3337,7 +3337,7 @@
               </a:spcAft>
             </a:pPr>
             <a:r>
-              <a:rPr sz="1000" b="1">
+              <a:rPr sz="2000" b="1">
                 <a:solidFill>
                   <a:srgbClr val="1A1A1A"/>
                 </a:solidFill>
@@ -3366,7 +3366,7 @@
           <a:effectLst/>
         </p:spPr>
         <p:txBody>
-          <a:bodyPr wrap="square" anchor="ctr">
+          <a:bodyPr wrap="square" anchor="b">
             <a:spAutoFit/>
           </a:bodyPr>
           <a:lstStyle/>
@@ -3380,7 +3380,7 @@
               </a:spcAft>
             </a:pPr>
             <a:r>
-              <a:rPr sz="1000" b="1">
+              <a:rPr sz="2000" b="1">
                 <a:solidFill>
                   <a:srgbClr val="1A1A1A"/>
                 </a:solidFill>
@@ -3409,7 +3409,7 @@
           <a:effectLst/>
         </p:spPr>
         <p:txBody>
-          <a:bodyPr wrap="square" anchor="ctr">
+          <a:bodyPr wrap="square" anchor="b">
             <a:spAutoFit/>
           </a:bodyPr>
           <a:lstStyle/>
@@ -3423,7 +3423,7 @@
               </a:spcAft>
             </a:pPr>
             <a:r>
-              <a:rPr sz="1000" b="1">
+              <a:rPr sz="2000" b="1">
                 <a:solidFill>
                   <a:srgbClr val="1A1A1A"/>
                 </a:solidFill>
@@ -3452,7 +3452,7 @@
           <a:effectLst/>
         </p:spPr>
         <p:txBody>
-          <a:bodyPr wrap="square" anchor="ctr">
+          <a:bodyPr wrap="square" anchor="b">
             <a:spAutoFit/>
           </a:bodyPr>
           <a:lstStyle/>
@@ -3466,7 +3466,7 @@
               </a:spcAft>
             </a:pPr>
             <a:r>
-              <a:rPr sz="1000" b="1">
+              <a:rPr sz="2000" b="1">
                 <a:solidFill>
                   <a:srgbClr val="1A1A1A"/>
                 </a:solidFill>
@@ -3495,7 +3495,7 @@
           <a:effectLst/>
         </p:spPr>
         <p:txBody>
-          <a:bodyPr wrap="square" anchor="ctr">
+          <a:bodyPr wrap="square" anchor="b">
             <a:spAutoFit/>
           </a:bodyPr>
           <a:lstStyle/>
@@ -3509,7 +3509,7 @@
               </a:spcAft>
             </a:pPr>
             <a:r>
-              <a:rPr sz="1000" b="1">
+              <a:rPr sz="2000" b="1">
                 <a:solidFill>
                   <a:srgbClr val="1A1A1A"/>
                 </a:solidFill>
@@ -3538,7 +3538,7 @@
           <a:effectLst/>
         </p:spPr>
         <p:txBody>
-          <a:bodyPr wrap="square" anchor="ctr">
+          <a:bodyPr wrap="square" anchor="b">
             <a:spAutoFit/>
           </a:bodyPr>
           <a:lstStyle/>
@@ -3552,7 +3552,7 @@
               </a:spcAft>
             </a:pPr>
             <a:r>
-              <a:rPr sz="800" b="1">
+              <a:rPr sz="2000" b="1">
                 <a:solidFill>
                   <a:srgbClr val="1A1A1A"/>
                 </a:solidFill>
@@ -3581,7 +3581,7 @@
           <a:effectLst/>
         </p:spPr>
         <p:txBody>
-          <a:bodyPr wrap="square" anchor="ctr">
+          <a:bodyPr wrap="square" anchor="b">
             <a:spAutoFit/>
           </a:bodyPr>
           <a:lstStyle/>
@@ -3595,7 +3595,7 @@
               </a:spcAft>
             </a:pPr>
             <a:r>
-              <a:rPr sz="800" b="1">
+              <a:rPr sz="2000" b="1">
                 <a:solidFill>
                   <a:srgbClr val="1A1A1A"/>
                 </a:solidFill>
@@ -3624,7 +3624,7 @@
           <a:effectLst/>
         </p:spPr>
         <p:txBody>
-          <a:bodyPr wrap="square" anchor="ctr">
+          <a:bodyPr wrap="square" anchor="b">
             <a:spAutoFit/>
           </a:bodyPr>
           <a:lstStyle/>
@@ -3638,7 +3638,7 @@
               </a:spcAft>
             </a:pPr>
             <a:r>
-              <a:rPr sz="800" b="1">
+              <a:rPr sz="2000" b="1">
                 <a:solidFill>
                   <a:srgbClr val="1A1A1A"/>
                 </a:solidFill>
@@ -3667,7 +3667,7 @@
           <a:effectLst/>
         </p:spPr>
         <p:txBody>
-          <a:bodyPr wrap="square" anchor="ctr">
+          <a:bodyPr wrap="square" anchor="b">
             <a:spAutoFit/>
           </a:bodyPr>
           <a:lstStyle/>
@@ -3681,7 +3681,7 @@
               </a:spcAft>
             </a:pPr>
             <a:r>
-              <a:rPr sz="1000" b="1">
+              <a:rPr sz="2000" b="1">
                 <a:solidFill>
                   <a:srgbClr val="1A1A1A"/>
                 </a:solidFill>
@@ -3710,7 +3710,7 @@
           <a:effectLst/>
         </p:spPr>
         <p:txBody>
-          <a:bodyPr wrap="square" anchor="ctr">
+          <a:bodyPr wrap="square" anchor="b">
             <a:spAutoFit/>
           </a:bodyPr>
           <a:lstStyle/>
@@ -3724,7 +3724,7 @@
               </a:spcAft>
             </a:pPr>
             <a:r>
-              <a:rPr sz="1000" b="1">
+              <a:rPr sz="2000" b="1">
                 <a:solidFill>
                   <a:srgbClr val="1A1A1A"/>
                 </a:solidFill>
@@ -3753,7 +3753,7 @@
           <a:effectLst/>
         </p:spPr>
         <p:txBody>
-          <a:bodyPr wrap="square" anchor="ctr">
+          <a:bodyPr wrap="square" anchor="b">
             <a:spAutoFit/>
           </a:bodyPr>
           <a:lstStyle/>
@@ -3767,7 +3767,7 @@
               </a:spcAft>
             </a:pPr>
             <a:r>
-              <a:rPr sz="1000" b="1">
+              <a:rPr sz="2000" b="1">
                 <a:solidFill>
                   <a:srgbClr val="1A1A1A"/>
                 </a:solidFill>
@@ -3796,7 +3796,7 @@
           <a:effectLst/>
         </p:spPr>
         <p:txBody>
-          <a:bodyPr wrap="square" anchor="ctr">
+          <a:bodyPr wrap="square" anchor="b">
             <a:spAutoFit/>
           </a:bodyPr>
           <a:lstStyle/>
@@ -3810,7 +3810,7 @@
               </a:spcAft>
             </a:pPr>
             <a:r>
-              <a:rPr sz="1000" b="1">
+              <a:rPr sz="2000" b="1">
                 <a:solidFill>
                   <a:srgbClr val="1A1A1A"/>
                 </a:solidFill>
@@ -3839,7 +3839,7 @@
           <a:effectLst/>
         </p:spPr>
         <p:txBody>
-          <a:bodyPr wrap="square" anchor="ctr">
+          <a:bodyPr wrap="square" anchor="b">
             <a:spAutoFit/>
           </a:bodyPr>
           <a:lstStyle/>
@@ -3853,7 +3853,7 @@
               </a:spcAft>
             </a:pPr>
             <a:r>
-              <a:rPr sz="800" b="1">
+              <a:rPr sz="2000" b="1">
                 <a:solidFill>
                   <a:srgbClr val="1A1A1A"/>
                 </a:solidFill>
@@ -3882,7 +3882,7 @@
           <a:effectLst/>
         </p:spPr>
         <p:txBody>
-          <a:bodyPr wrap="square" anchor="ctr">
+          <a:bodyPr wrap="square" anchor="b">
             <a:spAutoFit/>
           </a:bodyPr>
           <a:lstStyle/>
@@ -3896,7 +3896,7 @@
               </a:spcAft>
             </a:pPr>
             <a:r>
-              <a:rPr sz="800" b="1">
+              <a:rPr sz="2000" b="1">
                 <a:solidFill>
                   <a:srgbClr val="1A1A1A"/>
                 </a:solidFill>
@@ -3925,7 +3925,7 @@
           <a:effectLst/>
         </p:spPr>
         <p:txBody>
-          <a:bodyPr wrap="square" anchor="ctr">
+          <a:bodyPr wrap="square" anchor="b">
             <a:spAutoFit/>
           </a:bodyPr>
           <a:lstStyle/>
@@ -3939,7 +3939,7 @@
               </a:spcAft>
             </a:pPr>
             <a:r>
-              <a:rPr sz="1000" b="1">
+              <a:rPr sz="2000" b="1">
                 <a:solidFill>
                   <a:srgbClr val="1A1A1A"/>
                 </a:solidFill>
@@ -6142,7 +6142,7 @@
           <a:effectLst/>
         </p:spPr>
         <p:txBody>
-          <a:bodyPr wrap="square" anchor="ctr">
+          <a:bodyPr wrap="square" anchor="t">
             <a:spAutoFit/>
           </a:bodyPr>
           <a:lstStyle/>
@@ -6156,7 +6156,7 @@
               </a:spcAft>
             </a:pPr>
             <a:r>
-              <a:rPr sz="1000" b="1">
+              <a:rPr sz="2000" b="1">
                 <a:solidFill>
                   <a:srgbClr val="1A1A1A"/>
                 </a:solidFill>
@@ -6185,7 +6185,7 @@
           <a:effectLst/>
         </p:spPr>
         <p:txBody>
-          <a:bodyPr wrap="square" anchor="ctr">
+          <a:bodyPr wrap="square" anchor="t">
             <a:spAutoFit/>
           </a:bodyPr>
           <a:lstStyle/>
@@ -6199,7 +6199,7 @@
               </a:spcAft>
             </a:pPr>
             <a:r>
-              <a:rPr sz="1000" b="1">
+              <a:rPr sz="2000" b="1">
                 <a:solidFill>
                   <a:srgbClr val="1A1A1A"/>
                 </a:solidFill>
@@ -6228,7 +6228,7 @@
           <a:effectLst/>
         </p:spPr>
         <p:txBody>
-          <a:bodyPr wrap="square" anchor="ctr">
+          <a:bodyPr wrap="square" anchor="t">
             <a:spAutoFit/>
           </a:bodyPr>
           <a:lstStyle/>
@@ -6242,7 +6242,7 @@
               </a:spcAft>
             </a:pPr>
             <a:r>
-              <a:rPr sz="1000" b="1">
+              <a:rPr sz="2000" b="1">
                 <a:solidFill>
                   <a:srgbClr val="1A1A1A"/>
                 </a:solidFill>
@@ -6271,7 +6271,7 @@
           <a:effectLst/>
         </p:spPr>
         <p:txBody>
-          <a:bodyPr wrap="square" anchor="ctr">
+          <a:bodyPr wrap="square" anchor="t">
             <a:spAutoFit/>
           </a:bodyPr>
           <a:lstStyle/>
@@ -6285,7 +6285,7 @@
               </a:spcAft>
             </a:pPr>
             <a:r>
-              <a:rPr sz="1000" b="1">
+              <a:rPr sz="2000" b="1">
                 <a:solidFill>
                   <a:srgbClr val="1A1A1A"/>
                 </a:solidFill>
@@ -6314,7 +6314,7 @@
           <a:effectLst/>
         </p:spPr>
         <p:txBody>
-          <a:bodyPr wrap="square" anchor="ctr">
+          <a:bodyPr wrap="square" anchor="t">
             <a:spAutoFit/>
           </a:bodyPr>
           <a:lstStyle/>
@@ -6328,7 +6328,7 @@
               </a:spcAft>
             </a:pPr>
             <a:r>
-              <a:rPr sz="1000" b="1">
+              <a:rPr sz="2000" b="1">
                 <a:solidFill>
                   <a:srgbClr val="1A1A1A"/>
                 </a:solidFill>
@@ -6357,7 +6357,7 @@
           <a:effectLst/>
         </p:spPr>
         <p:txBody>
-          <a:bodyPr wrap="square" anchor="ctr">
+          <a:bodyPr wrap="square" anchor="t">
             <a:spAutoFit/>
           </a:bodyPr>
           <a:lstStyle/>
@@ -6371,7 +6371,7 @@
               </a:spcAft>
             </a:pPr>
             <a:r>
-              <a:rPr sz="1000" b="1">
+              <a:rPr sz="2000" b="1">
                 <a:solidFill>
                   <a:srgbClr val="1A1A1A"/>
                 </a:solidFill>
@@ -6400,7 +6400,7 @@
           <a:effectLst/>
         </p:spPr>
         <p:txBody>
-          <a:bodyPr wrap="square" anchor="ctr">
+          <a:bodyPr wrap="square" anchor="t">
             <a:spAutoFit/>
           </a:bodyPr>
           <a:lstStyle/>
@@ -6414,7 +6414,7 @@
               </a:spcAft>
             </a:pPr>
             <a:r>
-              <a:rPr sz="800" b="1">
+              <a:rPr sz="2000" b="1">
                 <a:solidFill>
                   <a:srgbClr val="1A1A1A"/>
                 </a:solidFill>
@@ -6443,7 +6443,7 @@
           <a:effectLst/>
         </p:spPr>
         <p:txBody>
-          <a:bodyPr wrap="square" anchor="ctr">
+          <a:bodyPr wrap="square" anchor="t">
             <a:spAutoFit/>
           </a:bodyPr>
           <a:lstStyle/>
@@ -6457,7 +6457,7 @@
               </a:spcAft>
             </a:pPr>
             <a:r>
-              <a:rPr sz="1000" b="1">
+              <a:rPr sz="2000" b="1">
                 <a:solidFill>
                   <a:srgbClr val="1A1A1A"/>
                 </a:solidFill>
@@ -6486,7 +6486,7 @@
           <a:effectLst/>
         </p:spPr>
         <p:txBody>
-          <a:bodyPr wrap="square" anchor="ctr">
+          <a:bodyPr wrap="square" anchor="t">
             <a:spAutoFit/>
           </a:bodyPr>
           <a:lstStyle/>
@@ -6500,7 +6500,7 @@
               </a:spcAft>
             </a:pPr>
             <a:r>
-              <a:rPr sz="1000" b="1">
+              <a:rPr sz="2000" b="1">
                 <a:solidFill>
                   <a:srgbClr val="1A1A1A"/>
                 </a:solidFill>
@@ -6529,7 +6529,7 @@
           <a:effectLst/>
         </p:spPr>
         <p:txBody>
-          <a:bodyPr wrap="square" anchor="ctr">
+          <a:bodyPr wrap="square" anchor="t">
             <a:spAutoFit/>
           </a:bodyPr>
           <a:lstStyle/>
@@ -6543,7 +6543,7 @@
               </a:spcAft>
             </a:pPr>
             <a:r>
-              <a:rPr sz="1000" b="1">
+              <a:rPr sz="2000" b="1">
                 <a:solidFill>
                   <a:srgbClr val="1A1A1A"/>
                 </a:solidFill>
@@ -6572,7 +6572,7 @@
           <a:effectLst/>
         </p:spPr>
         <p:txBody>
-          <a:bodyPr wrap="square" anchor="ctr">
+          <a:bodyPr wrap="square" anchor="t">
             <a:spAutoFit/>
           </a:bodyPr>
           <a:lstStyle/>
@@ -6586,7 +6586,7 @@
               </a:spcAft>
             </a:pPr>
             <a:r>
-              <a:rPr sz="1000" b="1">
+              <a:rPr sz="2000" b="1">
                 <a:solidFill>
                   <a:srgbClr val="1A1A1A"/>
                 </a:solidFill>
@@ -6615,7 +6615,7 @@
           <a:effectLst/>
         </p:spPr>
         <p:txBody>
-          <a:bodyPr wrap="square" anchor="ctr">
+          <a:bodyPr wrap="square" anchor="t">
             <a:spAutoFit/>
           </a:bodyPr>
           <a:lstStyle/>
@@ -6629,7 +6629,7 @@
               </a:spcAft>
             </a:pPr>
             <a:r>
-              <a:rPr sz="1000" b="1">
+              <a:rPr sz="2000" b="1">
                 <a:solidFill>
                   <a:srgbClr val="1A1A1A"/>
                 </a:solidFill>
@@ -6658,7 +6658,7 @@
           <a:effectLst/>
         </p:spPr>
         <p:txBody>
-          <a:bodyPr wrap="square" anchor="ctr">
+          <a:bodyPr wrap="square" anchor="t">
             <a:spAutoFit/>
           </a:bodyPr>
           <a:lstStyle/>
@@ -6672,7 +6672,7 @@
               </a:spcAft>
             </a:pPr>
             <a:r>
-              <a:rPr sz="1000" b="1">
+              <a:rPr sz="2000" b="1">
                 <a:solidFill>
                   <a:srgbClr val="1A1A1A"/>
                 </a:solidFill>
@@ -6701,7 +6701,7 @@
           <a:effectLst/>
         </p:spPr>
         <p:txBody>
-          <a:bodyPr wrap="square" anchor="ctr">
+          <a:bodyPr wrap="square" anchor="t">
             <a:spAutoFit/>
           </a:bodyPr>
           <a:lstStyle/>
@@ -6715,7 +6715,7 @@
               </a:spcAft>
             </a:pPr>
             <a:r>
-              <a:rPr sz="1000" b="1">
+              <a:rPr sz="2000" b="1">
                 <a:solidFill>
                   <a:srgbClr val="1A1A1A"/>
                 </a:solidFill>
@@ -6744,7 +6744,7 @@
           <a:effectLst/>
         </p:spPr>
         <p:txBody>
-          <a:bodyPr wrap="square" anchor="ctr">
+          <a:bodyPr wrap="square" anchor="t">
             <a:spAutoFit/>
           </a:bodyPr>
           <a:lstStyle/>
@@ -6758,7 +6758,7 @@
               </a:spcAft>
             </a:pPr>
             <a:r>
-              <a:rPr sz="1000" b="1">
+              <a:rPr sz="2000" b="1">
                 <a:solidFill>
                   <a:srgbClr val="1A1A1A"/>
                 </a:solidFill>
@@ -6787,7 +6787,7 @@
           <a:effectLst/>
         </p:spPr>
         <p:txBody>
-          <a:bodyPr wrap="square" anchor="ctr">
+          <a:bodyPr wrap="square" anchor="t">
             <a:spAutoFit/>
           </a:bodyPr>
           <a:lstStyle/>
@@ -6801,7 +6801,7 @@
               </a:spcAft>
             </a:pPr>
             <a:r>
-              <a:rPr sz="1000" b="1">
+              <a:rPr sz="2000" b="1">
                 <a:solidFill>
                   <a:srgbClr val="1A1A1A"/>
                 </a:solidFill>
@@ -6830,7 +6830,7 @@
           <a:effectLst/>
         </p:spPr>
         <p:txBody>
-          <a:bodyPr wrap="square" anchor="ctr">
+          <a:bodyPr wrap="square" anchor="t">
             <a:spAutoFit/>
           </a:bodyPr>
           <a:lstStyle/>
@@ -6844,7 +6844,7 @@
               </a:spcAft>
             </a:pPr>
             <a:r>
-              <a:rPr sz="1000" b="1">
+              <a:rPr sz="2000" b="1">
                 <a:solidFill>
                   <a:srgbClr val="1A1A1A"/>
                 </a:solidFill>
@@ -6873,7 +6873,7 @@
           <a:effectLst/>
         </p:spPr>
         <p:txBody>
-          <a:bodyPr wrap="square" anchor="ctr">
+          <a:bodyPr wrap="square" anchor="t">
             <a:spAutoFit/>
           </a:bodyPr>
           <a:lstStyle/>
@@ -6887,7 +6887,7 @@
               </a:spcAft>
             </a:pPr>
             <a:r>
-              <a:rPr sz="1000" b="1">
+              <a:rPr sz="2000" b="1">
                 <a:solidFill>
                   <a:srgbClr val="1A1A1A"/>
                 </a:solidFill>
@@ -6916,7 +6916,7 @@
           <a:effectLst/>
         </p:spPr>
         <p:txBody>
-          <a:bodyPr wrap="square" anchor="ctr">
+          <a:bodyPr wrap="square" anchor="t">
             <a:spAutoFit/>
           </a:bodyPr>
           <a:lstStyle/>
@@ -6930,7 +6930,7 @@
               </a:spcAft>
             </a:pPr>
             <a:r>
-              <a:rPr sz="1000" b="1">
+              <a:rPr sz="2000" b="1">
                 <a:solidFill>
                   <a:srgbClr val="1A1A1A"/>
                 </a:solidFill>
@@ -6959,7 +6959,7 @@
           <a:effectLst/>
         </p:spPr>
         <p:txBody>
-          <a:bodyPr wrap="square" anchor="ctr">
+          <a:bodyPr wrap="square" anchor="t">
             <a:spAutoFit/>
           </a:bodyPr>
           <a:lstStyle/>
@@ -6973,7 +6973,7 @@
               </a:spcAft>
             </a:pPr>
             <a:r>
-              <a:rPr sz="1000" b="1">
+              <a:rPr sz="2000" b="1">
                 <a:solidFill>
                   <a:srgbClr val="1A1A1A"/>
                 </a:solidFill>
@@ -9190,7 +9190,7 @@
               </a:spcAft>
             </a:pPr>
             <a:r>
-              <a:rPr sz="1000" b="1">
+              <a:rPr sz="2000" b="1">
                 <a:solidFill>
                   <a:srgbClr val="1A1A1A"/>
                 </a:solidFill>
@@ -9233,7 +9233,7 @@
               </a:spcAft>
             </a:pPr>
             <a:r>
-              <a:rPr sz="1000" b="1">
+              <a:rPr sz="2000" b="1">
                 <a:solidFill>
                   <a:srgbClr val="C62828"/>
                 </a:solidFill>
@@ -9295,7 +9295,7 @@
               </a:spcAft>
             </a:pPr>
             <a:r>
-              <a:rPr sz="1000" b="1">
+              <a:rPr sz="2000" b="1">
                 <a:solidFill>
                   <a:srgbClr val="1565C0"/>
                 </a:solidFill>
@@ -9357,7 +9357,7 @@
               </a:spcAft>
             </a:pPr>
             <a:r>
-              <a:rPr sz="1000" b="1">
+              <a:rPr sz="2000" b="1">
                 <a:solidFill>
                   <a:srgbClr val="2E7D32"/>
                 </a:solidFill>
@@ -9419,7 +9419,7 @@
               </a:spcAft>
             </a:pPr>
             <a:r>
-              <a:rPr sz="1000" b="1">
+              <a:rPr sz="2000" b="1">
                 <a:solidFill>
                   <a:srgbClr val="EF6C00"/>
                 </a:solidFill>
@@ -9481,7 +9481,7 @@
               </a:spcAft>
             </a:pPr>
             <a:r>
-              <a:rPr sz="1000" b="1">
+              <a:rPr sz="2000" b="1">
                 <a:solidFill>
                   <a:srgbClr val="6A1B9A"/>
                 </a:solidFill>
@@ -9543,7 +9543,7 @@
               </a:spcAft>
             </a:pPr>
             <a:r>
-              <a:rPr sz="1000" b="1">
+              <a:rPr sz="2000" b="1">
                 <a:solidFill>
                   <a:srgbClr val="00838F"/>
                 </a:solidFill>
@@ -9611,7 +9611,7 @@
                 </a:solidFill>
                 <a:latin typeface="Arial"/>
               </a:rPr>
-              <a:t>Памятка</a:t>
+              <a:t>Без тормозов</a:t>
             </a:r>
           </a:p>
           <a:p>
@@ -9630,7 +9630,7 @@
                 </a:solidFill>
                 <a:latin typeface="Arial"/>
               </a:rPr>
-              <a:t>1. Открой зеркало-запрос</a:t>
+              <a:t>• Первый накрывает «Я первый»</a:t>
             </a:r>
           </a:p>
           <a:p>
@@ -9649,7 +9649,7 @@
                 </a:solidFill>
                 <a:latin typeface="Arial"/>
               </a:rPr>
-              <a:t>2. Ответ из букв (рубашка = джокер)</a:t>
+              <a:t>• Остальным: «Не тормози!» + 10 пальцев</a:t>
             </a:r>
           </a:p>
           <a:p>
@@ -9668,7 +9668,7 @@
                 </a:solidFill>
                 <a:latin typeface="Arial"/>
               </a:rPr>
-              <a:t>3. Кинь «Ты лучший!» другому</a:t>
+              <a:t>• Не успел — пропуск (не цель голоса, сам кидает)</a:t>
             </a:r>
           </a:p>
           <a:p>
@@ -9687,144 +9687,6 @@
                 </a:solidFill>
                 <a:latin typeface="Arial"/>
               </a:rPr>
-              <a:t>4. Больше голосов — лицевая карта</a:t>
-            </a:r>
-          </a:p>
-          <a:p>
-            <a:pPr algn="l">
-              <a:spcBef>
-                <a:spcPts val="0"/>
-              </a:spcBef>
-              <a:spcAft>
-                <a:spcPts val="0"/>
-              </a:spcAft>
-            </a:pPr>
-            <a:r>
-              <a:rPr sz="800" b="0">
-                <a:solidFill>
-                  <a:srgbClr val="1A1A1A"/>
-                </a:solidFill>
-                <a:latin typeface="Arial"/>
-              </a:rPr>
-              <a:t>5. Буквы влево; если &lt;10 — добор справа</a:t>
-            </a:r>
-          </a:p>
-        </p:txBody>
-      </p:sp>
-      <p:sp>
-        <p:nvSpPr>
-          <p:cNvPr id="10" name="TextBox 9"/>
-          <p:cNvSpPr txBox="1"/>
-          <p:nvPr/>
-        </p:nvSpPr>
-        <p:spPr>
-          <a:xfrm>
-            <a:off x="6443442" y="2234888"/>
-            <a:ext cx="1934105" cy="1492955"/>
-          </a:xfrm>
-          <a:prstGeom prst="rect">
-            <a:avLst/>
-          </a:prstGeom>
-          <a:noFill/>
-          <a:effectLst/>
-        </p:spPr>
-        <p:txBody>
-          <a:bodyPr wrap="square" anchor="t">
-            <a:spAutoFit/>
-          </a:bodyPr>
-          <a:lstStyle/>
-          <a:p>
-            <a:pPr algn="ctr">
-              <a:spcBef>
-                <a:spcPts val="0"/>
-              </a:spcBef>
-              <a:spcAft>
-                <a:spcPts val="200"/>
-              </a:spcAft>
-            </a:pPr>
-            <a:r>
-              <a:rPr sz="1000" b="1">
-                <a:solidFill>
-                  <a:srgbClr val="1A1A1A"/>
-                </a:solidFill>
-                <a:latin typeface="Arial"/>
-              </a:rPr>
-              <a:t>Без тормозов</a:t>
-            </a:r>
-          </a:p>
-          <a:p>
-            <a:pPr algn="l">
-              <a:spcBef>
-                <a:spcPts val="0"/>
-              </a:spcBef>
-              <a:spcAft>
-                <a:spcPts val="0"/>
-              </a:spcAft>
-            </a:pPr>
-            <a:r>
-              <a:rPr sz="800" b="0">
-                <a:solidFill>
-                  <a:srgbClr val="1A1A1A"/>
-                </a:solidFill>
-                <a:latin typeface="Arial"/>
-              </a:rPr>
-              <a:t>• Первый накрывает «Я первый»</a:t>
-            </a:r>
-          </a:p>
-          <a:p>
-            <a:pPr algn="l">
-              <a:spcBef>
-                <a:spcPts val="0"/>
-              </a:spcBef>
-              <a:spcAft>
-                <a:spcPts val="0"/>
-              </a:spcAft>
-            </a:pPr>
-            <a:r>
-              <a:rPr sz="800" b="0">
-                <a:solidFill>
-                  <a:srgbClr val="1A1A1A"/>
-                </a:solidFill>
-                <a:latin typeface="Arial"/>
-              </a:rPr>
-              <a:t>• Остальным: «Не тормози!» + 10 пальцев</a:t>
-            </a:r>
-          </a:p>
-          <a:p>
-            <a:pPr algn="l">
-              <a:spcBef>
-                <a:spcPts val="0"/>
-              </a:spcBef>
-              <a:spcAft>
-                <a:spcPts val="0"/>
-              </a:spcAft>
-            </a:pPr>
-            <a:r>
-              <a:rPr sz="800" b="0">
-                <a:solidFill>
-                  <a:srgbClr val="1A1A1A"/>
-                </a:solidFill>
-                <a:latin typeface="Arial"/>
-              </a:rPr>
-              <a:t>• Не успел — пропуск (не цель голоса, сам кидает)</a:t>
-            </a:r>
-          </a:p>
-          <a:p>
-            <a:pPr algn="l">
-              <a:spcBef>
-                <a:spcPts val="0"/>
-              </a:spcBef>
-              <a:spcAft>
-                <a:spcPts val="0"/>
-              </a:spcAft>
-            </a:pPr>
-            <a:r>
-              <a:rPr sz="800" b="0">
-                <a:solidFill>
-                  <a:srgbClr val="1A1A1A"/>
-                </a:solidFill>
-                <a:latin typeface="Arial"/>
-              </a:rPr>
               <a:t>• Ничья голосов: «Я первый» побеждает один</a:t>
             </a:r>
           </a:p>
@@ -9832,7 +9694,7 @@
       </p:sp>
       <p:sp>
         <p:nvSpPr>
-          <p:cNvPr id="11" name="Rectangle 10"/>
+          <p:cNvPr id="10" name="Rectangle 9"/>
           <p:cNvSpPr/>
           <p:nvPr/>
         </p:nvSpPr>
@@ -9876,7 +9738,7 @@
       </p:sp>
       <p:sp>
         <p:nvSpPr>
-          <p:cNvPr id="12" name="Rectangle 11"/>
+          <p:cNvPr id="11" name="Rectangle 10"/>
           <p:cNvSpPr/>
           <p:nvPr/>
         </p:nvSpPr>
@@ -9920,7 +9782,7 @@
       </p:sp>
       <p:sp>
         <p:nvSpPr>
-          <p:cNvPr id="13" name="Rectangle 12"/>
+          <p:cNvPr id="12" name="Rectangle 11"/>
           <p:cNvSpPr/>
           <p:nvPr/>
         </p:nvSpPr>
@@ -9964,7 +9826,7 @@
       </p:sp>
       <p:sp>
         <p:nvSpPr>
-          <p:cNvPr id="14" name="Rectangle 13"/>
+          <p:cNvPr id="13" name="Rectangle 12"/>
           <p:cNvSpPr/>
           <p:nvPr/>
         </p:nvSpPr>
@@ -10008,7 +9870,7 @@
       </p:sp>
       <p:sp>
         <p:nvSpPr>
-          <p:cNvPr id="15" name="Rectangle 14"/>
+          <p:cNvPr id="14" name="Rectangle 13"/>
           <p:cNvSpPr/>
           <p:nvPr/>
         </p:nvSpPr>
@@ -10052,7 +9914,7 @@
       </p:sp>
       <p:sp>
         <p:nvSpPr>
-          <p:cNvPr id="16" name="Rectangle 15"/>
+          <p:cNvPr id="15" name="Rectangle 14"/>
           <p:cNvSpPr/>
           <p:nvPr/>
         </p:nvSpPr>
@@ -10096,7 +9958,7 @@
       </p:sp>
       <p:sp>
         <p:nvSpPr>
-          <p:cNvPr id="17" name="Rectangle 16"/>
+          <p:cNvPr id="16" name="Rectangle 15"/>
           <p:cNvSpPr/>
           <p:nvPr/>
         </p:nvSpPr>
@@ -10140,7 +10002,7 @@
       </p:sp>
       <p:sp>
         <p:nvSpPr>
-          <p:cNvPr id="18" name="Rectangle 17"/>
+          <p:cNvPr id="17" name="Rectangle 16"/>
           <p:cNvSpPr/>
           <p:nvPr/>
         </p:nvSpPr>
@@ -10184,7 +10046,7 @@
       </p:sp>
       <p:sp>
         <p:nvSpPr>
-          <p:cNvPr id="19" name="Rectangle 18"/>
+          <p:cNvPr id="18" name="Rectangle 17"/>
           <p:cNvSpPr/>
           <p:nvPr/>
         </p:nvSpPr>
@@ -10228,7 +10090,7 @@
       </p:sp>
       <p:sp>
         <p:nvSpPr>
-          <p:cNvPr id="20" name="Rectangle 19"/>
+          <p:cNvPr id="19" name="Rectangle 18"/>
           <p:cNvSpPr/>
           <p:nvPr/>
         </p:nvSpPr>
@@ -10272,7 +10134,7 @@
       </p:sp>
       <p:sp>
         <p:nvSpPr>
-          <p:cNvPr id="21" name="Rectangle 20"/>
+          <p:cNvPr id="20" name="Rectangle 19"/>
           <p:cNvSpPr/>
           <p:nvPr/>
         </p:nvSpPr>
@@ -10316,7 +10178,7 @@
       </p:sp>
       <p:sp>
         <p:nvSpPr>
-          <p:cNvPr id="22" name="Rectangle 21"/>
+          <p:cNvPr id="21" name="Rectangle 20"/>
           <p:cNvSpPr/>
           <p:nvPr/>
         </p:nvSpPr>
@@ -10360,7 +10222,7 @@
       </p:sp>
       <p:sp>
         <p:nvSpPr>
-          <p:cNvPr id="23" name="Rectangle 22"/>
+          <p:cNvPr id="22" name="Rectangle 21"/>
           <p:cNvSpPr/>
           <p:nvPr/>
         </p:nvSpPr>
@@ -10404,51 +10266,7 @@
       </p:sp>
       <p:sp>
         <p:nvSpPr>
-          <p:cNvPr id="24" name="Rectangle 23"/>
-          <p:cNvSpPr/>
-          <p:nvPr/>
-        </p:nvSpPr>
-        <p:spPr>
-          <a:xfrm>
-            <a:off x="6378247" y="3775237"/>
-            <a:ext cx="2064494" cy="9525"/>
-          </a:xfrm>
-          <a:prstGeom prst="rect">
-            <a:avLst/>
-          </a:prstGeom>
-          <a:solidFill>
-            <a:srgbClr val="C0C0C0"/>
-          </a:solidFill>
-          <a:ln>
-            <a:noFill/>
-          </a:ln>
-          <a:effectLst/>
-        </p:spPr>
-        <p:style>
-          <a:lnRef idx="1">
-            <a:schemeClr val="accent1"/>
-          </a:lnRef>
-          <a:fillRef idx="3">
-            <a:schemeClr val="accent1"/>
-          </a:fillRef>
-          <a:effectRef idx="2">
-            <a:schemeClr val="accent1"/>
-          </a:effectRef>
-          <a:fontRef idx="minor">
-            <a:schemeClr val="lt1"/>
-          </a:fontRef>
-        </p:style>
-        <p:txBody>
-          <a:bodyPr rtlCol="0" anchor="ctr"/>
-          <a:lstStyle/>
-          <a:p>
-            <a:pPr algn="ctr"/>
-          </a:p>
-        </p:txBody>
-      </p:sp>
-      <p:sp>
-        <p:nvSpPr>
-          <p:cNvPr id="25" name="Rectangle 24"/>
+          <p:cNvPr id="23" name="Rectangle 22"/>
           <p:cNvSpPr/>
           <p:nvPr/>
         </p:nvSpPr>
@@ -10492,7 +10310,7 @@
       </p:sp>
       <p:sp>
         <p:nvSpPr>
-          <p:cNvPr id="26" name="Rectangle 25"/>
+          <p:cNvPr id="24" name="Rectangle 23"/>
           <p:cNvSpPr/>
           <p:nvPr/>
         </p:nvSpPr>
@@ -10536,7 +10354,7 @@
       </p:sp>
       <p:sp>
         <p:nvSpPr>
-          <p:cNvPr id="27" name="Rectangle 26"/>
+          <p:cNvPr id="25" name="Rectangle 24"/>
           <p:cNvSpPr/>
           <p:nvPr/>
         </p:nvSpPr>
@@ -10580,7 +10398,7 @@
       </p:sp>
       <p:sp>
         <p:nvSpPr>
-          <p:cNvPr id="28" name="Rectangle 27"/>
+          <p:cNvPr id="26" name="Rectangle 25"/>
           <p:cNvSpPr/>
           <p:nvPr/>
         </p:nvSpPr>
@@ -10624,7 +10442,7 @@
       </p:sp>
       <p:sp>
         <p:nvSpPr>
-          <p:cNvPr id="29" name="Rectangle 28"/>
+          <p:cNvPr id="27" name="Rectangle 26"/>
           <p:cNvSpPr/>
           <p:nvPr/>
         </p:nvSpPr>
@@ -10668,7 +10486,7 @@
       </p:sp>
       <p:sp>
         <p:nvSpPr>
-          <p:cNvPr id="30" name="Rectangle 29"/>
+          <p:cNvPr id="28" name="Rectangle 27"/>
           <p:cNvSpPr/>
           <p:nvPr/>
         </p:nvSpPr>
@@ -10712,7 +10530,7 @@
       </p:sp>
       <p:sp>
         <p:nvSpPr>
-          <p:cNvPr id="31" name="Rectangle 30"/>
+          <p:cNvPr id="29" name="Rectangle 28"/>
           <p:cNvSpPr/>
           <p:nvPr/>
         </p:nvSpPr>
@@ -10756,7 +10574,7 @@
       </p:sp>
       <p:sp>
         <p:nvSpPr>
-          <p:cNvPr id="32" name="Rectangle 31"/>
+          <p:cNvPr id="30" name="Rectangle 29"/>
           <p:cNvSpPr/>
           <p:nvPr/>
         </p:nvSpPr>
@@ -10800,7 +10618,7 @@
       </p:sp>
       <p:sp>
         <p:nvSpPr>
-          <p:cNvPr id="33" name="Rectangle 32"/>
+          <p:cNvPr id="31" name="Rectangle 30"/>
           <p:cNvSpPr/>
           <p:nvPr/>
         </p:nvSpPr>
@@ -10844,51 +10662,7 @@
       </p:sp>
       <p:sp>
         <p:nvSpPr>
-          <p:cNvPr id="34" name="Rectangle 33"/>
-          <p:cNvSpPr/>
-          <p:nvPr/>
-        </p:nvSpPr>
-        <p:spPr>
-          <a:xfrm>
-            <a:off x="8437980" y="2182732"/>
-            <a:ext cx="9525" cy="1597267"/>
-          </a:xfrm>
-          <a:prstGeom prst="rect">
-            <a:avLst/>
-          </a:prstGeom>
-          <a:solidFill>
-            <a:srgbClr val="C0C0C0"/>
-          </a:solidFill>
-          <a:ln>
-            <a:noFill/>
-          </a:ln>
-          <a:effectLst/>
-        </p:spPr>
-        <p:style>
-          <a:lnRef idx="1">
-            <a:schemeClr val="accent1"/>
-          </a:lnRef>
-          <a:fillRef idx="3">
-            <a:schemeClr val="accent1"/>
-          </a:fillRef>
-          <a:effectRef idx="2">
-            <a:schemeClr val="accent1"/>
-          </a:effectRef>
-          <a:fontRef idx="minor">
-            <a:schemeClr val="lt1"/>
-          </a:fontRef>
-        </p:style>
-        <p:txBody>
-          <a:bodyPr rtlCol="0" anchor="ctr"/>
-          <a:lstStyle/>
-          <a:p>
-            <a:pPr algn="ctr"/>
-          </a:p>
-        </p:txBody>
-      </p:sp>
-      <p:sp>
-        <p:nvSpPr>
-          <p:cNvPr id="35" name="Rectangle 34"/>
+          <p:cNvPr id="32" name="Rectangle 31"/>
           <p:cNvSpPr/>
           <p:nvPr/>
         </p:nvSpPr>

</xml_diff>

<commit_message>
Put PnP card labels on shape text_frame, not textboxes.
</commit_message>
<xml_diff>
--- a/output/svet-moy-zerkalce-cards.pptx
+++ b/output/svet-moy-zerkalce-cards.pptx
@@ -3092,25 +3092,40 @@
       <p:grpSpPr/>
       <p:sp>
         <p:nvSpPr>
-          <p:cNvPr id="2" name="TextBox 1"/>
-          <p:cNvSpPr txBox="1"/>
-          <p:nvPr/>
-        </p:nvSpPr>
-        <p:spPr>
-          <a:xfrm>
-            <a:off x="257200" y="643416"/>
-            <a:ext cx="1919618" cy="1481365"/>
+          <p:cNvPr id="2" name="Rectangle 1"/>
+          <p:cNvSpPr/>
+          <p:nvPr/>
+        </p:nvSpPr>
+        <p:spPr>
+          <a:xfrm>
+            <a:off x="184762" y="585465"/>
+            <a:ext cx="2064494" cy="1597267"/>
           </a:xfrm>
           <a:prstGeom prst="rect">
             <a:avLst/>
           </a:prstGeom>
           <a:noFill/>
-          <a:effectLst/>
-        </p:spPr>
-        <p:txBody>
-          <a:bodyPr wrap="square" anchor="b">
-            <a:spAutoFit/>
-          </a:bodyPr>
+          <a:ln>
+            <a:noFill/>
+          </a:ln>
+          <a:effectLst/>
+        </p:spPr>
+        <p:style>
+          <a:lnRef idx="1">
+            <a:schemeClr val="accent1"/>
+          </a:lnRef>
+          <a:fillRef idx="3">
+            <a:schemeClr val="accent1"/>
+          </a:fillRef>
+          <a:effectRef idx="2">
+            <a:schemeClr val="accent1"/>
+          </a:effectRef>
+          <a:fontRef idx="minor">
+            <a:schemeClr val="lt1"/>
+          </a:fontRef>
+        </p:style>
+        <p:txBody>
+          <a:bodyPr rtlCol="0" anchor="b" wrap="square" lIns="72438" rIns="72438" tIns="57950" bIns="57950"/>
           <a:lstStyle/>
           <a:p>
             <a:pPr algn="ctr">
@@ -3135,25 +3150,40 @@
       </p:sp>
       <p:sp>
         <p:nvSpPr>
-          <p:cNvPr id="3" name="TextBox 2"/>
-          <p:cNvSpPr txBox="1"/>
-          <p:nvPr/>
-        </p:nvSpPr>
-        <p:spPr>
-          <a:xfrm>
-            <a:off x="2321695" y="643416"/>
-            <a:ext cx="1919618" cy="1481365"/>
+          <p:cNvPr id="3" name="Rectangle 2"/>
+          <p:cNvSpPr/>
+          <p:nvPr/>
+        </p:nvSpPr>
+        <p:spPr>
+          <a:xfrm>
+            <a:off x="2249257" y="585465"/>
+            <a:ext cx="2064494" cy="1597267"/>
           </a:xfrm>
           <a:prstGeom prst="rect">
             <a:avLst/>
           </a:prstGeom>
           <a:noFill/>
-          <a:effectLst/>
-        </p:spPr>
-        <p:txBody>
-          <a:bodyPr wrap="square" anchor="b">
-            <a:spAutoFit/>
-          </a:bodyPr>
+          <a:ln>
+            <a:noFill/>
+          </a:ln>
+          <a:effectLst/>
+        </p:spPr>
+        <p:style>
+          <a:lnRef idx="1">
+            <a:schemeClr val="accent1"/>
+          </a:lnRef>
+          <a:fillRef idx="3">
+            <a:schemeClr val="accent1"/>
+          </a:fillRef>
+          <a:effectRef idx="2">
+            <a:schemeClr val="accent1"/>
+          </a:effectRef>
+          <a:fontRef idx="minor">
+            <a:schemeClr val="lt1"/>
+          </a:fontRef>
+        </p:style>
+        <p:txBody>
+          <a:bodyPr rtlCol="0" anchor="b" wrap="square" lIns="72438" rIns="72438" tIns="57950" bIns="57950"/>
           <a:lstStyle/>
           <a:p>
             <a:pPr algn="ctr">
@@ -3178,25 +3208,40 @@
       </p:sp>
       <p:sp>
         <p:nvSpPr>
-          <p:cNvPr id="4" name="TextBox 3"/>
-          <p:cNvSpPr txBox="1"/>
-          <p:nvPr/>
-        </p:nvSpPr>
-        <p:spPr>
-          <a:xfrm>
-            <a:off x="4386190" y="643416"/>
-            <a:ext cx="1919618" cy="1481365"/>
+          <p:cNvPr id="4" name="Rectangle 3"/>
+          <p:cNvSpPr/>
+          <p:nvPr/>
+        </p:nvSpPr>
+        <p:spPr>
+          <a:xfrm>
+            <a:off x="4313752" y="585465"/>
+            <a:ext cx="2064494" cy="1597267"/>
           </a:xfrm>
           <a:prstGeom prst="rect">
             <a:avLst/>
           </a:prstGeom>
           <a:noFill/>
-          <a:effectLst/>
-        </p:spPr>
-        <p:txBody>
-          <a:bodyPr wrap="square" anchor="b">
-            <a:spAutoFit/>
-          </a:bodyPr>
+          <a:ln>
+            <a:noFill/>
+          </a:ln>
+          <a:effectLst/>
+        </p:spPr>
+        <p:style>
+          <a:lnRef idx="1">
+            <a:schemeClr val="accent1"/>
+          </a:lnRef>
+          <a:fillRef idx="3">
+            <a:schemeClr val="accent1"/>
+          </a:fillRef>
+          <a:effectRef idx="2">
+            <a:schemeClr val="accent1"/>
+          </a:effectRef>
+          <a:fontRef idx="minor">
+            <a:schemeClr val="lt1"/>
+          </a:fontRef>
+        </p:style>
+        <p:txBody>
+          <a:bodyPr rtlCol="0" anchor="b" wrap="square" lIns="72438" rIns="72438" tIns="57950" bIns="57950"/>
           <a:lstStyle/>
           <a:p>
             <a:pPr algn="ctr">
@@ -3221,25 +3266,40 @@
       </p:sp>
       <p:sp>
         <p:nvSpPr>
-          <p:cNvPr id="5" name="TextBox 4"/>
-          <p:cNvSpPr txBox="1"/>
-          <p:nvPr/>
-        </p:nvSpPr>
-        <p:spPr>
-          <a:xfrm>
-            <a:off x="6450685" y="643416"/>
-            <a:ext cx="1919618" cy="1481365"/>
+          <p:cNvPr id="5" name="Rectangle 4"/>
+          <p:cNvSpPr/>
+          <p:nvPr/>
+        </p:nvSpPr>
+        <p:spPr>
+          <a:xfrm>
+            <a:off x="6378247" y="585465"/>
+            <a:ext cx="2064494" cy="1597267"/>
           </a:xfrm>
           <a:prstGeom prst="rect">
             <a:avLst/>
           </a:prstGeom>
           <a:noFill/>
-          <a:effectLst/>
-        </p:spPr>
-        <p:txBody>
-          <a:bodyPr wrap="square" anchor="b">
-            <a:spAutoFit/>
-          </a:bodyPr>
+          <a:ln>
+            <a:noFill/>
+          </a:ln>
+          <a:effectLst/>
+        </p:spPr>
+        <p:style>
+          <a:lnRef idx="1">
+            <a:schemeClr val="accent1"/>
+          </a:lnRef>
+          <a:fillRef idx="3">
+            <a:schemeClr val="accent1"/>
+          </a:fillRef>
+          <a:effectRef idx="2">
+            <a:schemeClr val="accent1"/>
+          </a:effectRef>
+          <a:fontRef idx="minor">
+            <a:schemeClr val="lt1"/>
+          </a:fontRef>
+        </p:style>
+        <p:txBody>
+          <a:bodyPr rtlCol="0" anchor="b" wrap="square" lIns="72438" rIns="72438" tIns="57950" bIns="57950"/>
           <a:lstStyle/>
           <a:p>
             <a:pPr algn="ctr">
@@ -3264,25 +3324,40 @@
       </p:sp>
       <p:sp>
         <p:nvSpPr>
-          <p:cNvPr id="6" name="TextBox 5"/>
-          <p:cNvSpPr txBox="1"/>
-          <p:nvPr/>
-        </p:nvSpPr>
-        <p:spPr>
-          <a:xfrm>
-            <a:off x="8515180" y="643416"/>
-            <a:ext cx="1919618" cy="1481365"/>
+          <p:cNvPr id="6" name="Rectangle 5"/>
+          <p:cNvSpPr/>
+          <p:nvPr/>
+        </p:nvSpPr>
+        <p:spPr>
+          <a:xfrm>
+            <a:off x="8442742" y="585465"/>
+            <a:ext cx="2064494" cy="1597267"/>
           </a:xfrm>
           <a:prstGeom prst="rect">
             <a:avLst/>
           </a:prstGeom>
           <a:noFill/>
-          <a:effectLst/>
-        </p:spPr>
-        <p:txBody>
-          <a:bodyPr wrap="square" anchor="b">
-            <a:spAutoFit/>
-          </a:bodyPr>
+          <a:ln>
+            <a:noFill/>
+          </a:ln>
+          <a:effectLst/>
+        </p:spPr>
+        <p:style>
+          <a:lnRef idx="1">
+            <a:schemeClr val="accent1"/>
+          </a:lnRef>
+          <a:fillRef idx="3">
+            <a:schemeClr val="accent1"/>
+          </a:fillRef>
+          <a:effectRef idx="2">
+            <a:schemeClr val="accent1"/>
+          </a:effectRef>
+          <a:fontRef idx="minor">
+            <a:schemeClr val="lt1"/>
+          </a:fontRef>
+        </p:style>
+        <p:txBody>
+          <a:bodyPr rtlCol="0" anchor="b" wrap="square" lIns="72438" rIns="72438" tIns="57950" bIns="57950"/>
           <a:lstStyle/>
           <a:p>
             <a:pPr algn="ctr">
@@ -3307,25 +3382,40 @@
       </p:sp>
       <p:sp>
         <p:nvSpPr>
-          <p:cNvPr id="7" name="TextBox 6"/>
-          <p:cNvSpPr txBox="1"/>
-          <p:nvPr/>
-        </p:nvSpPr>
-        <p:spPr>
-          <a:xfrm>
-            <a:off x="257200" y="2240683"/>
-            <a:ext cx="1919618" cy="1481365"/>
+          <p:cNvPr id="7" name="Rectangle 6"/>
+          <p:cNvSpPr/>
+          <p:nvPr/>
+        </p:nvSpPr>
+        <p:spPr>
+          <a:xfrm>
+            <a:off x="184762" y="2182732"/>
+            <a:ext cx="2064494" cy="1597267"/>
           </a:xfrm>
           <a:prstGeom prst="rect">
             <a:avLst/>
           </a:prstGeom>
           <a:noFill/>
-          <a:effectLst/>
-        </p:spPr>
-        <p:txBody>
-          <a:bodyPr wrap="square" anchor="b">
-            <a:spAutoFit/>
-          </a:bodyPr>
+          <a:ln>
+            <a:noFill/>
+          </a:ln>
+          <a:effectLst/>
+        </p:spPr>
+        <p:style>
+          <a:lnRef idx="1">
+            <a:schemeClr val="accent1"/>
+          </a:lnRef>
+          <a:fillRef idx="3">
+            <a:schemeClr val="accent1"/>
+          </a:fillRef>
+          <a:effectRef idx="2">
+            <a:schemeClr val="accent1"/>
+          </a:effectRef>
+          <a:fontRef idx="minor">
+            <a:schemeClr val="lt1"/>
+          </a:fontRef>
+        </p:style>
+        <p:txBody>
+          <a:bodyPr rtlCol="0" anchor="b" wrap="square" lIns="72438" rIns="72438" tIns="57950" bIns="57950"/>
           <a:lstStyle/>
           <a:p>
             <a:pPr algn="ctr">
@@ -3350,25 +3440,40 @@
       </p:sp>
       <p:sp>
         <p:nvSpPr>
-          <p:cNvPr id="8" name="TextBox 7"/>
-          <p:cNvSpPr txBox="1"/>
-          <p:nvPr/>
-        </p:nvSpPr>
-        <p:spPr>
-          <a:xfrm>
-            <a:off x="2321695" y="2240683"/>
-            <a:ext cx="1919618" cy="1481365"/>
+          <p:cNvPr id="8" name="Rectangle 7"/>
+          <p:cNvSpPr/>
+          <p:nvPr/>
+        </p:nvSpPr>
+        <p:spPr>
+          <a:xfrm>
+            <a:off x="2249257" y="2182732"/>
+            <a:ext cx="2064494" cy="1597267"/>
           </a:xfrm>
           <a:prstGeom prst="rect">
             <a:avLst/>
           </a:prstGeom>
           <a:noFill/>
-          <a:effectLst/>
-        </p:spPr>
-        <p:txBody>
-          <a:bodyPr wrap="square" anchor="b">
-            <a:spAutoFit/>
-          </a:bodyPr>
+          <a:ln>
+            <a:noFill/>
+          </a:ln>
+          <a:effectLst/>
+        </p:spPr>
+        <p:style>
+          <a:lnRef idx="1">
+            <a:schemeClr val="accent1"/>
+          </a:lnRef>
+          <a:fillRef idx="3">
+            <a:schemeClr val="accent1"/>
+          </a:fillRef>
+          <a:effectRef idx="2">
+            <a:schemeClr val="accent1"/>
+          </a:effectRef>
+          <a:fontRef idx="minor">
+            <a:schemeClr val="lt1"/>
+          </a:fontRef>
+        </p:style>
+        <p:txBody>
+          <a:bodyPr rtlCol="0" anchor="b" wrap="square" lIns="72438" rIns="72438" tIns="57950" bIns="57950"/>
           <a:lstStyle/>
           <a:p>
             <a:pPr algn="ctr">
@@ -3393,25 +3498,40 @@
       </p:sp>
       <p:sp>
         <p:nvSpPr>
-          <p:cNvPr id="9" name="TextBox 8"/>
-          <p:cNvSpPr txBox="1"/>
-          <p:nvPr/>
-        </p:nvSpPr>
-        <p:spPr>
-          <a:xfrm>
-            <a:off x="4386190" y="2240683"/>
-            <a:ext cx="1919618" cy="1481365"/>
+          <p:cNvPr id="9" name="Rectangle 8"/>
+          <p:cNvSpPr/>
+          <p:nvPr/>
+        </p:nvSpPr>
+        <p:spPr>
+          <a:xfrm>
+            <a:off x="4313752" y="2182732"/>
+            <a:ext cx="2064494" cy="1597267"/>
           </a:xfrm>
           <a:prstGeom prst="rect">
             <a:avLst/>
           </a:prstGeom>
           <a:noFill/>
-          <a:effectLst/>
-        </p:spPr>
-        <p:txBody>
-          <a:bodyPr wrap="square" anchor="b">
-            <a:spAutoFit/>
-          </a:bodyPr>
+          <a:ln>
+            <a:noFill/>
+          </a:ln>
+          <a:effectLst/>
+        </p:spPr>
+        <p:style>
+          <a:lnRef idx="1">
+            <a:schemeClr val="accent1"/>
+          </a:lnRef>
+          <a:fillRef idx="3">
+            <a:schemeClr val="accent1"/>
+          </a:fillRef>
+          <a:effectRef idx="2">
+            <a:schemeClr val="accent1"/>
+          </a:effectRef>
+          <a:fontRef idx="minor">
+            <a:schemeClr val="lt1"/>
+          </a:fontRef>
+        </p:style>
+        <p:txBody>
+          <a:bodyPr rtlCol="0" anchor="b" wrap="square" lIns="72438" rIns="72438" tIns="57950" bIns="57950"/>
           <a:lstStyle/>
           <a:p>
             <a:pPr algn="ctr">
@@ -3436,25 +3556,40 @@
       </p:sp>
       <p:sp>
         <p:nvSpPr>
-          <p:cNvPr id="10" name="TextBox 9"/>
-          <p:cNvSpPr txBox="1"/>
-          <p:nvPr/>
-        </p:nvSpPr>
-        <p:spPr>
-          <a:xfrm>
-            <a:off x="6450685" y="2240683"/>
-            <a:ext cx="1919618" cy="1481365"/>
+          <p:cNvPr id="10" name="Rectangle 9"/>
+          <p:cNvSpPr/>
+          <p:nvPr/>
+        </p:nvSpPr>
+        <p:spPr>
+          <a:xfrm>
+            <a:off x="6378247" y="2182732"/>
+            <a:ext cx="2064494" cy="1597267"/>
           </a:xfrm>
           <a:prstGeom prst="rect">
             <a:avLst/>
           </a:prstGeom>
           <a:noFill/>
-          <a:effectLst/>
-        </p:spPr>
-        <p:txBody>
-          <a:bodyPr wrap="square" anchor="b">
-            <a:spAutoFit/>
-          </a:bodyPr>
+          <a:ln>
+            <a:noFill/>
+          </a:ln>
+          <a:effectLst/>
+        </p:spPr>
+        <p:style>
+          <a:lnRef idx="1">
+            <a:schemeClr val="accent1"/>
+          </a:lnRef>
+          <a:fillRef idx="3">
+            <a:schemeClr val="accent1"/>
+          </a:fillRef>
+          <a:effectRef idx="2">
+            <a:schemeClr val="accent1"/>
+          </a:effectRef>
+          <a:fontRef idx="minor">
+            <a:schemeClr val="lt1"/>
+          </a:fontRef>
+        </p:style>
+        <p:txBody>
+          <a:bodyPr rtlCol="0" anchor="b" wrap="square" lIns="72438" rIns="72438" tIns="57950" bIns="57950"/>
           <a:lstStyle/>
           <a:p>
             <a:pPr algn="ctr">
@@ -3479,25 +3614,40 @@
       </p:sp>
       <p:sp>
         <p:nvSpPr>
-          <p:cNvPr id="11" name="TextBox 10"/>
-          <p:cNvSpPr txBox="1"/>
-          <p:nvPr/>
-        </p:nvSpPr>
-        <p:spPr>
-          <a:xfrm>
-            <a:off x="8515180" y="2240683"/>
-            <a:ext cx="1919618" cy="1481365"/>
+          <p:cNvPr id="11" name="Rectangle 10"/>
+          <p:cNvSpPr/>
+          <p:nvPr/>
+        </p:nvSpPr>
+        <p:spPr>
+          <a:xfrm>
+            <a:off x="8442742" y="2182732"/>
+            <a:ext cx="2064494" cy="1597267"/>
           </a:xfrm>
           <a:prstGeom prst="rect">
             <a:avLst/>
           </a:prstGeom>
           <a:noFill/>
-          <a:effectLst/>
-        </p:spPr>
-        <p:txBody>
-          <a:bodyPr wrap="square" anchor="b">
-            <a:spAutoFit/>
-          </a:bodyPr>
+          <a:ln>
+            <a:noFill/>
+          </a:ln>
+          <a:effectLst/>
+        </p:spPr>
+        <p:style>
+          <a:lnRef idx="1">
+            <a:schemeClr val="accent1"/>
+          </a:lnRef>
+          <a:fillRef idx="3">
+            <a:schemeClr val="accent1"/>
+          </a:fillRef>
+          <a:effectRef idx="2">
+            <a:schemeClr val="accent1"/>
+          </a:effectRef>
+          <a:fontRef idx="minor">
+            <a:schemeClr val="lt1"/>
+          </a:fontRef>
+        </p:style>
+        <p:txBody>
+          <a:bodyPr rtlCol="0" anchor="b" wrap="square" lIns="72438" rIns="72438" tIns="57950" bIns="57950"/>
           <a:lstStyle/>
           <a:p>
             <a:pPr algn="ctr">
@@ -3522,25 +3672,40 @@
       </p:sp>
       <p:sp>
         <p:nvSpPr>
-          <p:cNvPr id="12" name="TextBox 11"/>
-          <p:cNvSpPr txBox="1"/>
-          <p:nvPr/>
-        </p:nvSpPr>
-        <p:spPr>
-          <a:xfrm>
-            <a:off x="257200" y="3837950"/>
-            <a:ext cx="1919618" cy="1481365"/>
+          <p:cNvPr id="12" name="Rectangle 11"/>
+          <p:cNvSpPr/>
+          <p:nvPr/>
+        </p:nvSpPr>
+        <p:spPr>
+          <a:xfrm>
+            <a:off x="184762" y="3780000"/>
+            <a:ext cx="2064494" cy="1597267"/>
           </a:xfrm>
           <a:prstGeom prst="rect">
             <a:avLst/>
           </a:prstGeom>
           <a:noFill/>
-          <a:effectLst/>
-        </p:spPr>
-        <p:txBody>
-          <a:bodyPr wrap="square" anchor="b">
-            <a:spAutoFit/>
-          </a:bodyPr>
+          <a:ln>
+            <a:noFill/>
+          </a:ln>
+          <a:effectLst/>
+        </p:spPr>
+        <p:style>
+          <a:lnRef idx="1">
+            <a:schemeClr val="accent1"/>
+          </a:lnRef>
+          <a:fillRef idx="3">
+            <a:schemeClr val="accent1"/>
+          </a:fillRef>
+          <a:effectRef idx="2">
+            <a:schemeClr val="accent1"/>
+          </a:effectRef>
+          <a:fontRef idx="minor">
+            <a:schemeClr val="lt1"/>
+          </a:fontRef>
+        </p:style>
+        <p:txBody>
+          <a:bodyPr rtlCol="0" anchor="b" wrap="square" lIns="72438" rIns="72438" tIns="57950" bIns="57950"/>
           <a:lstStyle/>
           <a:p>
             <a:pPr algn="ctr">
@@ -3565,25 +3730,40 @@
       </p:sp>
       <p:sp>
         <p:nvSpPr>
-          <p:cNvPr id="13" name="TextBox 12"/>
-          <p:cNvSpPr txBox="1"/>
-          <p:nvPr/>
-        </p:nvSpPr>
-        <p:spPr>
-          <a:xfrm>
-            <a:off x="2321695" y="3837950"/>
-            <a:ext cx="1919618" cy="1481365"/>
+          <p:cNvPr id="13" name="Rectangle 12"/>
+          <p:cNvSpPr/>
+          <p:nvPr/>
+        </p:nvSpPr>
+        <p:spPr>
+          <a:xfrm>
+            <a:off x="2249257" y="3780000"/>
+            <a:ext cx="2064494" cy="1597267"/>
           </a:xfrm>
           <a:prstGeom prst="rect">
             <a:avLst/>
           </a:prstGeom>
           <a:noFill/>
-          <a:effectLst/>
-        </p:spPr>
-        <p:txBody>
-          <a:bodyPr wrap="square" anchor="b">
-            <a:spAutoFit/>
-          </a:bodyPr>
+          <a:ln>
+            <a:noFill/>
+          </a:ln>
+          <a:effectLst/>
+        </p:spPr>
+        <p:style>
+          <a:lnRef idx="1">
+            <a:schemeClr val="accent1"/>
+          </a:lnRef>
+          <a:fillRef idx="3">
+            <a:schemeClr val="accent1"/>
+          </a:fillRef>
+          <a:effectRef idx="2">
+            <a:schemeClr val="accent1"/>
+          </a:effectRef>
+          <a:fontRef idx="minor">
+            <a:schemeClr val="lt1"/>
+          </a:fontRef>
+        </p:style>
+        <p:txBody>
+          <a:bodyPr rtlCol="0" anchor="b" wrap="square" lIns="72438" rIns="72438" tIns="57950" bIns="57950"/>
           <a:lstStyle/>
           <a:p>
             <a:pPr algn="ctr">
@@ -3608,25 +3788,40 @@
       </p:sp>
       <p:sp>
         <p:nvSpPr>
-          <p:cNvPr id="14" name="TextBox 13"/>
-          <p:cNvSpPr txBox="1"/>
-          <p:nvPr/>
-        </p:nvSpPr>
-        <p:spPr>
-          <a:xfrm>
-            <a:off x="4386190" y="3837950"/>
-            <a:ext cx="1919618" cy="1481365"/>
+          <p:cNvPr id="14" name="Rectangle 13"/>
+          <p:cNvSpPr/>
+          <p:nvPr/>
+        </p:nvSpPr>
+        <p:spPr>
+          <a:xfrm>
+            <a:off x="4313752" y="3780000"/>
+            <a:ext cx="2064494" cy="1597267"/>
           </a:xfrm>
           <a:prstGeom prst="rect">
             <a:avLst/>
           </a:prstGeom>
           <a:noFill/>
-          <a:effectLst/>
-        </p:spPr>
-        <p:txBody>
-          <a:bodyPr wrap="square" anchor="b">
-            <a:spAutoFit/>
-          </a:bodyPr>
+          <a:ln>
+            <a:noFill/>
+          </a:ln>
+          <a:effectLst/>
+        </p:spPr>
+        <p:style>
+          <a:lnRef idx="1">
+            <a:schemeClr val="accent1"/>
+          </a:lnRef>
+          <a:fillRef idx="3">
+            <a:schemeClr val="accent1"/>
+          </a:fillRef>
+          <a:effectRef idx="2">
+            <a:schemeClr val="accent1"/>
+          </a:effectRef>
+          <a:fontRef idx="minor">
+            <a:schemeClr val="lt1"/>
+          </a:fontRef>
+        </p:style>
+        <p:txBody>
+          <a:bodyPr rtlCol="0" anchor="b" wrap="square" lIns="72438" rIns="72438" tIns="57950" bIns="57950"/>
           <a:lstStyle/>
           <a:p>
             <a:pPr algn="ctr">
@@ -3651,25 +3846,40 @@
       </p:sp>
       <p:sp>
         <p:nvSpPr>
-          <p:cNvPr id="15" name="TextBox 14"/>
-          <p:cNvSpPr txBox="1"/>
-          <p:nvPr/>
-        </p:nvSpPr>
-        <p:spPr>
-          <a:xfrm>
-            <a:off x="6450685" y="3837950"/>
-            <a:ext cx="1919618" cy="1481365"/>
+          <p:cNvPr id="15" name="Rectangle 14"/>
+          <p:cNvSpPr/>
+          <p:nvPr/>
+        </p:nvSpPr>
+        <p:spPr>
+          <a:xfrm>
+            <a:off x="6378247" y="3780000"/>
+            <a:ext cx="2064494" cy="1597267"/>
           </a:xfrm>
           <a:prstGeom prst="rect">
             <a:avLst/>
           </a:prstGeom>
           <a:noFill/>
-          <a:effectLst/>
-        </p:spPr>
-        <p:txBody>
-          <a:bodyPr wrap="square" anchor="b">
-            <a:spAutoFit/>
-          </a:bodyPr>
+          <a:ln>
+            <a:noFill/>
+          </a:ln>
+          <a:effectLst/>
+        </p:spPr>
+        <p:style>
+          <a:lnRef idx="1">
+            <a:schemeClr val="accent1"/>
+          </a:lnRef>
+          <a:fillRef idx="3">
+            <a:schemeClr val="accent1"/>
+          </a:fillRef>
+          <a:effectRef idx="2">
+            <a:schemeClr val="accent1"/>
+          </a:effectRef>
+          <a:fontRef idx="minor">
+            <a:schemeClr val="lt1"/>
+          </a:fontRef>
+        </p:style>
+        <p:txBody>
+          <a:bodyPr rtlCol="0" anchor="b" wrap="square" lIns="72438" rIns="72438" tIns="57950" bIns="57950"/>
           <a:lstStyle/>
           <a:p>
             <a:pPr algn="ctr">
@@ -3694,25 +3904,40 @@
       </p:sp>
       <p:sp>
         <p:nvSpPr>
-          <p:cNvPr id="16" name="TextBox 15"/>
-          <p:cNvSpPr txBox="1"/>
-          <p:nvPr/>
-        </p:nvSpPr>
-        <p:spPr>
-          <a:xfrm>
-            <a:off x="8515180" y="3837950"/>
-            <a:ext cx="1919618" cy="1481365"/>
+          <p:cNvPr id="16" name="Rectangle 15"/>
+          <p:cNvSpPr/>
+          <p:nvPr/>
+        </p:nvSpPr>
+        <p:spPr>
+          <a:xfrm>
+            <a:off x="8442742" y="3780000"/>
+            <a:ext cx="2064494" cy="1597267"/>
           </a:xfrm>
           <a:prstGeom prst="rect">
             <a:avLst/>
           </a:prstGeom>
           <a:noFill/>
-          <a:effectLst/>
-        </p:spPr>
-        <p:txBody>
-          <a:bodyPr wrap="square" anchor="b">
-            <a:spAutoFit/>
-          </a:bodyPr>
+          <a:ln>
+            <a:noFill/>
+          </a:ln>
+          <a:effectLst/>
+        </p:spPr>
+        <p:style>
+          <a:lnRef idx="1">
+            <a:schemeClr val="accent1"/>
+          </a:lnRef>
+          <a:fillRef idx="3">
+            <a:schemeClr val="accent1"/>
+          </a:fillRef>
+          <a:effectRef idx="2">
+            <a:schemeClr val="accent1"/>
+          </a:effectRef>
+          <a:fontRef idx="minor">
+            <a:schemeClr val="lt1"/>
+          </a:fontRef>
+        </p:style>
+        <p:txBody>
+          <a:bodyPr rtlCol="0" anchor="b" wrap="square" lIns="72438" rIns="72438" tIns="57950" bIns="57950"/>
           <a:lstStyle/>
           <a:p>
             <a:pPr algn="ctr">
@@ -3737,25 +3962,40 @@
       </p:sp>
       <p:sp>
         <p:nvSpPr>
-          <p:cNvPr id="17" name="TextBox 16"/>
-          <p:cNvSpPr txBox="1"/>
-          <p:nvPr/>
-        </p:nvSpPr>
-        <p:spPr>
-          <a:xfrm>
-            <a:off x="257200" y="5435217"/>
-            <a:ext cx="1919618" cy="1481365"/>
+          <p:cNvPr id="17" name="Rectangle 16"/>
+          <p:cNvSpPr/>
+          <p:nvPr/>
+        </p:nvSpPr>
+        <p:spPr>
+          <a:xfrm>
+            <a:off x="184762" y="5377267"/>
+            <a:ext cx="2064494" cy="1597267"/>
           </a:xfrm>
           <a:prstGeom prst="rect">
             <a:avLst/>
           </a:prstGeom>
           <a:noFill/>
-          <a:effectLst/>
-        </p:spPr>
-        <p:txBody>
-          <a:bodyPr wrap="square" anchor="b">
-            <a:spAutoFit/>
-          </a:bodyPr>
+          <a:ln>
+            <a:noFill/>
+          </a:ln>
+          <a:effectLst/>
+        </p:spPr>
+        <p:style>
+          <a:lnRef idx="1">
+            <a:schemeClr val="accent1"/>
+          </a:lnRef>
+          <a:fillRef idx="3">
+            <a:schemeClr val="accent1"/>
+          </a:fillRef>
+          <a:effectRef idx="2">
+            <a:schemeClr val="accent1"/>
+          </a:effectRef>
+          <a:fontRef idx="minor">
+            <a:schemeClr val="lt1"/>
+          </a:fontRef>
+        </p:style>
+        <p:txBody>
+          <a:bodyPr rtlCol="0" anchor="b" wrap="square" lIns="72438" rIns="72438" tIns="57950" bIns="57950"/>
           <a:lstStyle/>
           <a:p>
             <a:pPr algn="ctr">
@@ -3780,25 +4020,40 @@
       </p:sp>
       <p:sp>
         <p:nvSpPr>
-          <p:cNvPr id="18" name="TextBox 17"/>
-          <p:cNvSpPr txBox="1"/>
-          <p:nvPr/>
-        </p:nvSpPr>
-        <p:spPr>
-          <a:xfrm>
-            <a:off x="2321695" y="5435217"/>
-            <a:ext cx="1919618" cy="1481365"/>
+          <p:cNvPr id="18" name="Rectangle 17"/>
+          <p:cNvSpPr/>
+          <p:nvPr/>
+        </p:nvSpPr>
+        <p:spPr>
+          <a:xfrm>
+            <a:off x="2249257" y="5377267"/>
+            <a:ext cx="2064494" cy="1597267"/>
           </a:xfrm>
           <a:prstGeom prst="rect">
             <a:avLst/>
           </a:prstGeom>
           <a:noFill/>
-          <a:effectLst/>
-        </p:spPr>
-        <p:txBody>
-          <a:bodyPr wrap="square" anchor="b">
-            <a:spAutoFit/>
-          </a:bodyPr>
+          <a:ln>
+            <a:noFill/>
+          </a:ln>
+          <a:effectLst/>
+        </p:spPr>
+        <p:style>
+          <a:lnRef idx="1">
+            <a:schemeClr val="accent1"/>
+          </a:lnRef>
+          <a:fillRef idx="3">
+            <a:schemeClr val="accent1"/>
+          </a:fillRef>
+          <a:effectRef idx="2">
+            <a:schemeClr val="accent1"/>
+          </a:effectRef>
+          <a:fontRef idx="minor">
+            <a:schemeClr val="lt1"/>
+          </a:fontRef>
+        </p:style>
+        <p:txBody>
+          <a:bodyPr rtlCol="0" anchor="b" wrap="square" lIns="72438" rIns="72438" tIns="57950" bIns="57950"/>
           <a:lstStyle/>
           <a:p>
             <a:pPr algn="ctr">
@@ -3823,25 +4078,40 @@
       </p:sp>
       <p:sp>
         <p:nvSpPr>
-          <p:cNvPr id="19" name="TextBox 18"/>
-          <p:cNvSpPr txBox="1"/>
-          <p:nvPr/>
-        </p:nvSpPr>
-        <p:spPr>
-          <a:xfrm>
-            <a:off x="4386190" y="5435217"/>
-            <a:ext cx="1919618" cy="1481365"/>
+          <p:cNvPr id="19" name="Rectangle 18"/>
+          <p:cNvSpPr/>
+          <p:nvPr/>
+        </p:nvSpPr>
+        <p:spPr>
+          <a:xfrm>
+            <a:off x="4313752" y="5377267"/>
+            <a:ext cx="2064494" cy="1597267"/>
           </a:xfrm>
           <a:prstGeom prst="rect">
             <a:avLst/>
           </a:prstGeom>
           <a:noFill/>
-          <a:effectLst/>
-        </p:spPr>
-        <p:txBody>
-          <a:bodyPr wrap="square" anchor="b">
-            <a:spAutoFit/>
-          </a:bodyPr>
+          <a:ln>
+            <a:noFill/>
+          </a:ln>
+          <a:effectLst/>
+        </p:spPr>
+        <p:style>
+          <a:lnRef idx="1">
+            <a:schemeClr val="accent1"/>
+          </a:lnRef>
+          <a:fillRef idx="3">
+            <a:schemeClr val="accent1"/>
+          </a:fillRef>
+          <a:effectRef idx="2">
+            <a:schemeClr val="accent1"/>
+          </a:effectRef>
+          <a:fontRef idx="minor">
+            <a:schemeClr val="lt1"/>
+          </a:fontRef>
+        </p:style>
+        <p:txBody>
+          <a:bodyPr rtlCol="0" anchor="b" wrap="square" lIns="72438" rIns="72438" tIns="57950" bIns="57950"/>
           <a:lstStyle/>
           <a:p>
             <a:pPr algn="ctr">
@@ -3866,25 +4136,40 @@
       </p:sp>
       <p:sp>
         <p:nvSpPr>
-          <p:cNvPr id="20" name="TextBox 19"/>
-          <p:cNvSpPr txBox="1"/>
-          <p:nvPr/>
-        </p:nvSpPr>
-        <p:spPr>
-          <a:xfrm>
-            <a:off x="6450685" y="5435217"/>
-            <a:ext cx="1919618" cy="1481365"/>
+          <p:cNvPr id="20" name="Rectangle 19"/>
+          <p:cNvSpPr/>
+          <p:nvPr/>
+        </p:nvSpPr>
+        <p:spPr>
+          <a:xfrm>
+            <a:off x="6378247" y="5377267"/>
+            <a:ext cx="2064494" cy="1597267"/>
           </a:xfrm>
           <a:prstGeom prst="rect">
             <a:avLst/>
           </a:prstGeom>
           <a:noFill/>
-          <a:effectLst/>
-        </p:spPr>
-        <p:txBody>
-          <a:bodyPr wrap="square" anchor="b">
-            <a:spAutoFit/>
-          </a:bodyPr>
+          <a:ln>
+            <a:noFill/>
+          </a:ln>
+          <a:effectLst/>
+        </p:spPr>
+        <p:style>
+          <a:lnRef idx="1">
+            <a:schemeClr val="accent1"/>
+          </a:lnRef>
+          <a:fillRef idx="3">
+            <a:schemeClr val="accent1"/>
+          </a:fillRef>
+          <a:effectRef idx="2">
+            <a:schemeClr val="accent1"/>
+          </a:effectRef>
+          <a:fontRef idx="minor">
+            <a:schemeClr val="lt1"/>
+          </a:fontRef>
+        </p:style>
+        <p:txBody>
+          <a:bodyPr rtlCol="0" anchor="b" wrap="square" lIns="72438" rIns="72438" tIns="57950" bIns="57950"/>
           <a:lstStyle/>
           <a:p>
             <a:pPr algn="ctr">
@@ -3909,25 +4194,40 @@
       </p:sp>
       <p:sp>
         <p:nvSpPr>
-          <p:cNvPr id="21" name="TextBox 20"/>
-          <p:cNvSpPr txBox="1"/>
-          <p:nvPr/>
-        </p:nvSpPr>
-        <p:spPr>
-          <a:xfrm>
-            <a:off x="8515180" y="5435217"/>
-            <a:ext cx="1919618" cy="1481365"/>
+          <p:cNvPr id="21" name="Rectangle 20"/>
+          <p:cNvSpPr/>
+          <p:nvPr/>
+        </p:nvSpPr>
+        <p:spPr>
+          <a:xfrm>
+            <a:off x="8442742" y="5377267"/>
+            <a:ext cx="2064494" cy="1597267"/>
           </a:xfrm>
           <a:prstGeom prst="rect">
             <a:avLst/>
           </a:prstGeom>
           <a:noFill/>
-          <a:effectLst/>
-        </p:spPr>
-        <p:txBody>
-          <a:bodyPr wrap="square" anchor="b">
-            <a:spAutoFit/>
-          </a:bodyPr>
+          <a:ln>
+            <a:noFill/>
+          </a:ln>
+          <a:effectLst/>
+        </p:spPr>
+        <p:style>
+          <a:lnRef idx="1">
+            <a:schemeClr val="accent1"/>
+          </a:lnRef>
+          <a:fillRef idx="3">
+            <a:schemeClr val="accent1"/>
+          </a:fillRef>
+          <a:effectRef idx="2">
+            <a:schemeClr val="accent1"/>
+          </a:effectRef>
+          <a:fontRef idx="minor">
+            <a:schemeClr val="lt1"/>
+          </a:fontRef>
+        </p:style>
+        <p:txBody>
+          <a:bodyPr rtlCol="0" anchor="b" wrap="square" lIns="72438" rIns="72438" tIns="57950" bIns="57950"/>
           <a:lstStyle/>
           <a:p>
             <a:pPr algn="ctr">
@@ -6126,25 +6426,40 @@
       <p:grpSpPr/>
       <p:sp>
         <p:nvSpPr>
-          <p:cNvPr id="2" name="TextBox 1"/>
-          <p:cNvSpPr txBox="1"/>
-          <p:nvPr/>
-        </p:nvSpPr>
-        <p:spPr>
-          <a:xfrm>
-            <a:off x="257200" y="643416"/>
-            <a:ext cx="1919618" cy="1481365"/>
+          <p:cNvPr id="2" name="Rectangle 1"/>
+          <p:cNvSpPr/>
+          <p:nvPr/>
+        </p:nvSpPr>
+        <p:spPr>
+          <a:xfrm>
+            <a:off x="184762" y="585465"/>
+            <a:ext cx="2064494" cy="1597267"/>
           </a:xfrm>
           <a:prstGeom prst="rect">
             <a:avLst/>
           </a:prstGeom>
           <a:noFill/>
-          <a:effectLst/>
-        </p:spPr>
-        <p:txBody>
-          <a:bodyPr wrap="square" anchor="t">
-            <a:spAutoFit/>
-          </a:bodyPr>
+          <a:ln>
+            <a:noFill/>
+          </a:ln>
+          <a:effectLst/>
+        </p:spPr>
+        <p:style>
+          <a:lnRef idx="1">
+            <a:schemeClr val="accent1"/>
+          </a:lnRef>
+          <a:fillRef idx="3">
+            <a:schemeClr val="accent1"/>
+          </a:fillRef>
+          <a:effectRef idx="2">
+            <a:schemeClr val="accent1"/>
+          </a:effectRef>
+          <a:fontRef idx="minor">
+            <a:schemeClr val="lt1"/>
+          </a:fontRef>
+        </p:style>
+        <p:txBody>
+          <a:bodyPr rtlCol="0" anchor="t" wrap="square" lIns="72438" rIns="72438" tIns="57950" bIns="57950"/>
           <a:lstStyle/>
           <a:p>
             <a:pPr algn="ctr">
@@ -6169,25 +6484,40 @@
       </p:sp>
       <p:sp>
         <p:nvSpPr>
-          <p:cNvPr id="3" name="TextBox 2"/>
-          <p:cNvSpPr txBox="1"/>
-          <p:nvPr/>
-        </p:nvSpPr>
-        <p:spPr>
-          <a:xfrm>
-            <a:off x="2321695" y="643416"/>
-            <a:ext cx="1919618" cy="1481365"/>
+          <p:cNvPr id="3" name="Rectangle 2"/>
+          <p:cNvSpPr/>
+          <p:nvPr/>
+        </p:nvSpPr>
+        <p:spPr>
+          <a:xfrm>
+            <a:off x="2249257" y="585465"/>
+            <a:ext cx="2064494" cy="1597267"/>
           </a:xfrm>
           <a:prstGeom prst="rect">
             <a:avLst/>
           </a:prstGeom>
           <a:noFill/>
-          <a:effectLst/>
-        </p:spPr>
-        <p:txBody>
-          <a:bodyPr wrap="square" anchor="t">
-            <a:spAutoFit/>
-          </a:bodyPr>
+          <a:ln>
+            <a:noFill/>
+          </a:ln>
+          <a:effectLst/>
+        </p:spPr>
+        <p:style>
+          <a:lnRef idx="1">
+            <a:schemeClr val="accent1"/>
+          </a:lnRef>
+          <a:fillRef idx="3">
+            <a:schemeClr val="accent1"/>
+          </a:fillRef>
+          <a:effectRef idx="2">
+            <a:schemeClr val="accent1"/>
+          </a:effectRef>
+          <a:fontRef idx="minor">
+            <a:schemeClr val="lt1"/>
+          </a:fontRef>
+        </p:style>
+        <p:txBody>
+          <a:bodyPr rtlCol="0" anchor="t" wrap="square" lIns="72438" rIns="72438" tIns="57950" bIns="57950"/>
           <a:lstStyle/>
           <a:p>
             <a:pPr algn="ctr">
@@ -6212,25 +6542,40 @@
       </p:sp>
       <p:sp>
         <p:nvSpPr>
-          <p:cNvPr id="4" name="TextBox 3"/>
-          <p:cNvSpPr txBox="1"/>
-          <p:nvPr/>
-        </p:nvSpPr>
-        <p:spPr>
-          <a:xfrm>
-            <a:off x="4386190" y="643416"/>
-            <a:ext cx="1919618" cy="1481365"/>
+          <p:cNvPr id="4" name="Rectangle 3"/>
+          <p:cNvSpPr/>
+          <p:nvPr/>
+        </p:nvSpPr>
+        <p:spPr>
+          <a:xfrm>
+            <a:off x="4313752" y="585465"/>
+            <a:ext cx="2064494" cy="1597267"/>
           </a:xfrm>
           <a:prstGeom prst="rect">
             <a:avLst/>
           </a:prstGeom>
           <a:noFill/>
-          <a:effectLst/>
-        </p:spPr>
-        <p:txBody>
-          <a:bodyPr wrap="square" anchor="t">
-            <a:spAutoFit/>
-          </a:bodyPr>
+          <a:ln>
+            <a:noFill/>
+          </a:ln>
+          <a:effectLst/>
+        </p:spPr>
+        <p:style>
+          <a:lnRef idx="1">
+            <a:schemeClr val="accent1"/>
+          </a:lnRef>
+          <a:fillRef idx="3">
+            <a:schemeClr val="accent1"/>
+          </a:fillRef>
+          <a:effectRef idx="2">
+            <a:schemeClr val="accent1"/>
+          </a:effectRef>
+          <a:fontRef idx="minor">
+            <a:schemeClr val="lt1"/>
+          </a:fontRef>
+        </p:style>
+        <p:txBody>
+          <a:bodyPr rtlCol="0" anchor="t" wrap="square" lIns="72438" rIns="72438" tIns="57950" bIns="57950"/>
           <a:lstStyle/>
           <a:p>
             <a:pPr algn="ctr">
@@ -6255,25 +6600,40 @@
       </p:sp>
       <p:sp>
         <p:nvSpPr>
-          <p:cNvPr id="5" name="TextBox 4"/>
-          <p:cNvSpPr txBox="1"/>
-          <p:nvPr/>
-        </p:nvSpPr>
-        <p:spPr>
-          <a:xfrm>
-            <a:off x="6450685" y="643416"/>
-            <a:ext cx="1919618" cy="1481365"/>
+          <p:cNvPr id="5" name="Rectangle 4"/>
+          <p:cNvSpPr/>
+          <p:nvPr/>
+        </p:nvSpPr>
+        <p:spPr>
+          <a:xfrm>
+            <a:off x="6378247" y="585465"/>
+            <a:ext cx="2064494" cy="1597267"/>
           </a:xfrm>
           <a:prstGeom prst="rect">
             <a:avLst/>
           </a:prstGeom>
           <a:noFill/>
-          <a:effectLst/>
-        </p:spPr>
-        <p:txBody>
-          <a:bodyPr wrap="square" anchor="t">
-            <a:spAutoFit/>
-          </a:bodyPr>
+          <a:ln>
+            <a:noFill/>
+          </a:ln>
+          <a:effectLst/>
+        </p:spPr>
+        <p:style>
+          <a:lnRef idx="1">
+            <a:schemeClr val="accent1"/>
+          </a:lnRef>
+          <a:fillRef idx="3">
+            <a:schemeClr val="accent1"/>
+          </a:fillRef>
+          <a:effectRef idx="2">
+            <a:schemeClr val="accent1"/>
+          </a:effectRef>
+          <a:fontRef idx="minor">
+            <a:schemeClr val="lt1"/>
+          </a:fontRef>
+        </p:style>
+        <p:txBody>
+          <a:bodyPr rtlCol="0" anchor="t" wrap="square" lIns="72438" rIns="72438" tIns="57950" bIns="57950"/>
           <a:lstStyle/>
           <a:p>
             <a:pPr algn="ctr">
@@ -6298,25 +6658,40 @@
       </p:sp>
       <p:sp>
         <p:nvSpPr>
-          <p:cNvPr id="6" name="TextBox 5"/>
-          <p:cNvSpPr txBox="1"/>
-          <p:nvPr/>
-        </p:nvSpPr>
-        <p:spPr>
-          <a:xfrm>
-            <a:off x="8515180" y="643416"/>
-            <a:ext cx="1919618" cy="1481365"/>
+          <p:cNvPr id="6" name="Rectangle 5"/>
+          <p:cNvSpPr/>
+          <p:nvPr/>
+        </p:nvSpPr>
+        <p:spPr>
+          <a:xfrm>
+            <a:off x="8442742" y="585465"/>
+            <a:ext cx="2064494" cy="1597267"/>
           </a:xfrm>
           <a:prstGeom prst="rect">
             <a:avLst/>
           </a:prstGeom>
           <a:noFill/>
-          <a:effectLst/>
-        </p:spPr>
-        <p:txBody>
-          <a:bodyPr wrap="square" anchor="t">
-            <a:spAutoFit/>
-          </a:bodyPr>
+          <a:ln>
+            <a:noFill/>
+          </a:ln>
+          <a:effectLst/>
+        </p:spPr>
+        <p:style>
+          <a:lnRef idx="1">
+            <a:schemeClr val="accent1"/>
+          </a:lnRef>
+          <a:fillRef idx="3">
+            <a:schemeClr val="accent1"/>
+          </a:fillRef>
+          <a:effectRef idx="2">
+            <a:schemeClr val="accent1"/>
+          </a:effectRef>
+          <a:fontRef idx="minor">
+            <a:schemeClr val="lt1"/>
+          </a:fontRef>
+        </p:style>
+        <p:txBody>
+          <a:bodyPr rtlCol="0" anchor="t" wrap="square" lIns="72438" rIns="72438" tIns="57950" bIns="57950"/>
           <a:lstStyle/>
           <a:p>
             <a:pPr algn="ctr">
@@ -6341,25 +6716,40 @@
       </p:sp>
       <p:sp>
         <p:nvSpPr>
-          <p:cNvPr id="7" name="TextBox 6"/>
-          <p:cNvSpPr txBox="1"/>
-          <p:nvPr/>
-        </p:nvSpPr>
-        <p:spPr>
-          <a:xfrm>
-            <a:off x="257200" y="2240683"/>
-            <a:ext cx="1919618" cy="1481365"/>
+          <p:cNvPr id="7" name="Rectangle 6"/>
+          <p:cNvSpPr/>
+          <p:nvPr/>
+        </p:nvSpPr>
+        <p:spPr>
+          <a:xfrm>
+            <a:off x="184762" y="2182732"/>
+            <a:ext cx="2064494" cy="1597267"/>
           </a:xfrm>
           <a:prstGeom prst="rect">
             <a:avLst/>
           </a:prstGeom>
           <a:noFill/>
-          <a:effectLst/>
-        </p:spPr>
-        <p:txBody>
-          <a:bodyPr wrap="square" anchor="t">
-            <a:spAutoFit/>
-          </a:bodyPr>
+          <a:ln>
+            <a:noFill/>
+          </a:ln>
+          <a:effectLst/>
+        </p:spPr>
+        <p:style>
+          <a:lnRef idx="1">
+            <a:schemeClr val="accent1"/>
+          </a:lnRef>
+          <a:fillRef idx="3">
+            <a:schemeClr val="accent1"/>
+          </a:fillRef>
+          <a:effectRef idx="2">
+            <a:schemeClr val="accent1"/>
+          </a:effectRef>
+          <a:fontRef idx="minor">
+            <a:schemeClr val="lt1"/>
+          </a:fontRef>
+        </p:style>
+        <p:txBody>
+          <a:bodyPr rtlCol="0" anchor="t" wrap="square" lIns="72438" rIns="72438" tIns="57950" bIns="57950"/>
           <a:lstStyle/>
           <a:p>
             <a:pPr algn="ctr">
@@ -6384,25 +6774,40 @@
       </p:sp>
       <p:sp>
         <p:nvSpPr>
-          <p:cNvPr id="8" name="TextBox 7"/>
-          <p:cNvSpPr txBox="1"/>
-          <p:nvPr/>
-        </p:nvSpPr>
-        <p:spPr>
-          <a:xfrm>
-            <a:off x="2321695" y="2240683"/>
-            <a:ext cx="1919618" cy="1481365"/>
+          <p:cNvPr id="8" name="Rectangle 7"/>
+          <p:cNvSpPr/>
+          <p:nvPr/>
+        </p:nvSpPr>
+        <p:spPr>
+          <a:xfrm>
+            <a:off x="2249257" y="2182732"/>
+            <a:ext cx="2064494" cy="1597267"/>
           </a:xfrm>
           <a:prstGeom prst="rect">
             <a:avLst/>
           </a:prstGeom>
           <a:noFill/>
-          <a:effectLst/>
-        </p:spPr>
-        <p:txBody>
-          <a:bodyPr wrap="square" anchor="t">
-            <a:spAutoFit/>
-          </a:bodyPr>
+          <a:ln>
+            <a:noFill/>
+          </a:ln>
+          <a:effectLst/>
+        </p:spPr>
+        <p:style>
+          <a:lnRef idx="1">
+            <a:schemeClr val="accent1"/>
+          </a:lnRef>
+          <a:fillRef idx="3">
+            <a:schemeClr val="accent1"/>
+          </a:fillRef>
+          <a:effectRef idx="2">
+            <a:schemeClr val="accent1"/>
+          </a:effectRef>
+          <a:fontRef idx="minor">
+            <a:schemeClr val="lt1"/>
+          </a:fontRef>
+        </p:style>
+        <p:txBody>
+          <a:bodyPr rtlCol="0" anchor="t" wrap="square" lIns="72438" rIns="72438" tIns="57950" bIns="57950"/>
           <a:lstStyle/>
           <a:p>
             <a:pPr algn="ctr">
@@ -6427,25 +6832,40 @@
       </p:sp>
       <p:sp>
         <p:nvSpPr>
-          <p:cNvPr id="9" name="TextBox 8"/>
-          <p:cNvSpPr txBox="1"/>
-          <p:nvPr/>
-        </p:nvSpPr>
-        <p:spPr>
-          <a:xfrm>
-            <a:off x="4386190" y="2240683"/>
-            <a:ext cx="1919618" cy="1481365"/>
+          <p:cNvPr id="9" name="Rectangle 8"/>
+          <p:cNvSpPr/>
+          <p:nvPr/>
+        </p:nvSpPr>
+        <p:spPr>
+          <a:xfrm>
+            <a:off x="4313752" y="2182732"/>
+            <a:ext cx="2064494" cy="1597267"/>
           </a:xfrm>
           <a:prstGeom prst="rect">
             <a:avLst/>
           </a:prstGeom>
           <a:noFill/>
-          <a:effectLst/>
-        </p:spPr>
-        <p:txBody>
-          <a:bodyPr wrap="square" anchor="t">
-            <a:spAutoFit/>
-          </a:bodyPr>
+          <a:ln>
+            <a:noFill/>
+          </a:ln>
+          <a:effectLst/>
+        </p:spPr>
+        <p:style>
+          <a:lnRef idx="1">
+            <a:schemeClr val="accent1"/>
+          </a:lnRef>
+          <a:fillRef idx="3">
+            <a:schemeClr val="accent1"/>
+          </a:fillRef>
+          <a:effectRef idx="2">
+            <a:schemeClr val="accent1"/>
+          </a:effectRef>
+          <a:fontRef idx="minor">
+            <a:schemeClr val="lt1"/>
+          </a:fontRef>
+        </p:style>
+        <p:txBody>
+          <a:bodyPr rtlCol="0" anchor="t" wrap="square" lIns="72438" rIns="72438" tIns="57950" bIns="57950"/>
           <a:lstStyle/>
           <a:p>
             <a:pPr algn="ctr">
@@ -6470,25 +6890,40 @@
       </p:sp>
       <p:sp>
         <p:nvSpPr>
-          <p:cNvPr id="10" name="TextBox 9"/>
-          <p:cNvSpPr txBox="1"/>
-          <p:nvPr/>
-        </p:nvSpPr>
-        <p:spPr>
-          <a:xfrm>
-            <a:off x="6450685" y="2240683"/>
-            <a:ext cx="1919618" cy="1481365"/>
+          <p:cNvPr id="10" name="Rectangle 9"/>
+          <p:cNvSpPr/>
+          <p:nvPr/>
+        </p:nvSpPr>
+        <p:spPr>
+          <a:xfrm>
+            <a:off x="6378247" y="2182732"/>
+            <a:ext cx="2064494" cy="1597267"/>
           </a:xfrm>
           <a:prstGeom prst="rect">
             <a:avLst/>
           </a:prstGeom>
           <a:noFill/>
-          <a:effectLst/>
-        </p:spPr>
-        <p:txBody>
-          <a:bodyPr wrap="square" anchor="t">
-            <a:spAutoFit/>
-          </a:bodyPr>
+          <a:ln>
+            <a:noFill/>
+          </a:ln>
+          <a:effectLst/>
+        </p:spPr>
+        <p:style>
+          <a:lnRef idx="1">
+            <a:schemeClr val="accent1"/>
+          </a:lnRef>
+          <a:fillRef idx="3">
+            <a:schemeClr val="accent1"/>
+          </a:fillRef>
+          <a:effectRef idx="2">
+            <a:schemeClr val="accent1"/>
+          </a:effectRef>
+          <a:fontRef idx="minor">
+            <a:schemeClr val="lt1"/>
+          </a:fontRef>
+        </p:style>
+        <p:txBody>
+          <a:bodyPr rtlCol="0" anchor="t" wrap="square" lIns="72438" rIns="72438" tIns="57950" bIns="57950"/>
           <a:lstStyle/>
           <a:p>
             <a:pPr algn="ctr">
@@ -6513,25 +6948,40 @@
       </p:sp>
       <p:sp>
         <p:nvSpPr>
-          <p:cNvPr id="11" name="TextBox 10"/>
-          <p:cNvSpPr txBox="1"/>
-          <p:nvPr/>
-        </p:nvSpPr>
-        <p:spPr>
-          <a:xfrm>
-            <a:off x="8515180" y="2240683"/>
-            <a:ext cx="1919618" cy="1481365"/>
+          <p:cNvPr id="11" name="Rectangle 10"/>
+          <p:cNvSpPr/>
+          <p:nvPr/>
+        </p:nvSpPr>
+        <p:spPr>
+          <a:xfrm>
+            <a:off x="8442742" y="2182732"/>
+            <a:ext cx="2064494" cy="1597267"/>
           </a:xfrm>
           <a:prstGeom prst="rect">
             <a:avLst/>
           </a:prstGeom>
           <a:noFill/>
-          <a:effectLst/>
-        </p:spPr>
-        <p:txBody>
-          <a:bodyPr wrap="square" anchor="t">
-            <a:spAutoFit/>
-          </a:bodyPr>
+          <a:ln>
+            <a:noFill/>
+          </a:ln>
+          <a:effectLst/>
+        </p:spPr>
+        <p:style>
+          <a:lnRef idx="1">
+            <a:schemeClr val="accent1"/>
+          </a:lnRef>
+          <a:fillRef idx="3">
+            <a:schemeClr val="accent1"/>
+          </a:fillRef>
+          <a:effectRef idx="2">
+            <a:schemeClr val="accent1"/>
+          </a:effectRef>
+          <a:fontRef idx="minor">
+            <a:schemeClr val="lt1"/>
+          </a:fontRef>
+        </p:style>
+        <p:txBody>
+          <a:bodyPr rtlCol="0" anchor="t" wrap="square" lIns="72438" rIns="72438" tIns="57950" bIns="57950"/>
           <a:lstStyle/>
           <a:p>
             <a:pPr algn="ctr">
@@ -6556,25 +7006,40 @@
       </p:sp>
       <p:sp>
         <p:nvSpPr>
-          <p:cNvPr id="12" name="TextBox 11"/>
-          <p:cNvSpPr txBox="1"/>
-          <p:nvPr/>
-        </p:nvSpPr>
-        <p:spPr>
-          <a:xfrm>
-            <a:off x="257200" y="3837950"/>
-            <a:ext cx="1919618" cy="1481365"/>
+          <p:cNvPr id="12" name="Rectangle 11"/>
+          <p:cNvSpPr/>
+          <p:nvPr/>
+        </p:nvSpPr>
+        <p:spPr>
+          <a:xfrm>
+            <a:off x="184762" y="3780000"/>
+            <a:ext cx="2064494" cy="1597267"/>
           </a:xfrm>
           <a:prstGeom prst="rect">
             <a:avLst/>
           </a:prstGeom>
           <a:noFill/>
-          <a:effectLst/>
-        </p:spPr>
-        <p:txBody>
-          <a:bodyPr wrap="square" anchor="t">
-            <a:spAutoFit/>
-          </a:bodyPr>
+          <a:ln>
+            <a:noFill/>
+          </a:ln>
+          <a:effectLst/>
+        </p:spPr>
+        <p:style>
+          <a:lnRef idx="1">
+            <a:schemeClr val="accent1"/>
+          </a:lnRef>
+          <a:fillRef idx="3">
+            <a:schemeClr val="accent1"/>
+          </a:fillRef>
+          <a:effectRef idx="2">
+            <a:schemeClr val="accent1"/>
+          </a:effectRef>
+          <a:fontRef idx="minor">
+            <a:schemeClr val="lt1"/>
+          </a:fontRef>
+        </p:style>
+        <p:txBody>
+          <a:bodyPr rtlCol="0" anchor="t" wrap="square" lIns="72438" rIns="72438" tIns="57950" bIns="57950"/>
           <a:lstStyle/>
           <a:p>
             <a:pPr algn="ctr">
@@ -6599,25 +7064,40 @@
       </p:sp>
       <p:sp>
         <p:nvSpPr>
-          <p:cNvPr id="13" name="TextBox 12"/>
-          <p:cNvSpPr txBox="1"/>
-          <p:nvPr/>
-        </p:nvSpPr>
-        <p:spPr>
-          <a:xfrm>
-            <a:off x="2321695" y="3837950"/>
-            <a:ext cx="1919618" cy="1481365"/>
+          <p:cNvPr id="13" name="Rectangle 12"/>
+          <p:cNvSpPr/>
+          <p:nvPr/>
+        </p:nvSpPr>
+        <p:spPr>
+          <a:xfrm>
+            <a:off x="2249257" y="3780000"/>
+            <a:ext cx="2064494" cy="1597267"/>
           </a:xfrm>
           <a:prstGeom prst="rect">
             <a:avLst/>
           </a:prstGeom>
           <a:noFill/>
-          <a:effectLst/>
-        </p:spPr>
-        <p:txBody>
-          <a:bodyPr wrap="square" anchor="t">
-            <a:spAutoFit/>
-          </a:bodyPr>
+          <a:ln>
+            <a:noFill/>
+          </a:ln>
+          <a:effectLst/>
+        </p:spPr>
+        <p:style>
+          <a:lnRef idx="1">
+            <a:schemeClr val="accent1"/>
+          </a:lnRef>
+          <a:fillRef idx="3">
+            <a:schemeClr val="accent1"/>
+          </a:fillRef>
+          <a:effectRef idx="2">
+            <a:schemeClr val="accent1"/>
+          </a:effectRef>
+          <a:fontRef idx="minor">
+            <a:schemeClr val="lt1"/>
+          </a:fontRef>
+        </p:style>
+        <p:txBody>
+          <a:bodyPr rtlCol="0" anchor="t" wrap="square" lIns="72438" rIns="72438" tIns="57950" bIns="57950"/>
           <a:lstStyle/>
           <a:p>
             <a:pPr algn="ctr">
@@ -6642,25 +7122,40 @@
       </p:sp>
       <p:sp>
         <p:nvSpPr>
-          <p:cNvPr id="14" name="TextBox 13"/>
-          <p:cNvSpPr txBox="1"/>
-          <p:nvPr/>
-        </p:nvSpPr>
-        <p:spPr>
-          <a:xfrm>
-            <a:off x="4386190" y="3837950"/>
-            <a:ext cx="1919618" cy="1481365"/>
+          <p:cNvPr id="14" name="Rectangle 13"/>
+          <p:cNvSpPr/>
+          <p:nvPr/>
+        </p:nvSpPr>
+        <p:spPr>
+          <a:xfrm>
+            <a:off x="4313752" y="3780000"/>
+            <a:ext cx="2064494" cy="1597267"/>
           </a:xfrm>
           <a:prstGeom prst="rect">
             <a:avLst/>
           </a:prstGeom>
           <a:noFill/>
-          <a:effectLst/>
-        </p:spPr>
-        <p:txBody>
-          <a:bodyPr wrap="square" anchor="t">
-            <a:spAutoFit/>
-          </a:bodyPr>
+          <a:ln>
+            <a:noFill/>
+          </a:ln>
+          <a:effectLst/>
+        </p:spPr>
+        <p:style>
+          <a:lnRef idx="1">
+            <a:schemeClr val="accent1"/>
+          </a:lnRef>
+          <a:fillRef idx="3">
+            <a:schemeClr val="accent1"/>
+          </a:fillRef>
+          <a:effectRef idx="2">
+            <a:schemeClr val="accent1"/>
+          </a:effectRef>
+          <a:fontRef idx="minor">
+            <a:schemeClr val="lt1"/>
+          </a:fontRef>
+        </p:style>
+        <p:txBody>
+          <a:bodyPr rtlCol="0" anchor="t" wrap="square" lIns="72438" rIns="72438" tIns="57950" bIns="57950"/>
           <a:lstStyle/>
           <a:p>
             <a:pPr algn="ctr">
@@ -6685,25 +7180,40 @@
       </p:sp>
       <p:sp>
         <p:nvSpPr>
-          <p:cNvPr id="15" name="TextBox 14"/>
-          <p:cNvSpPr txBox="1"/>
-          <p:nvPr/>
-        </p:nvSpPr>
-        <p:spPr>
-          <a:xfrm>
-            <a:off x="6450685" y="3837950"/>
-            <a:ext cx="1919618" cy="1481365"/>
+          <p:cNvPr id="15" name="Rectangle 14"/>
+          <p:cNvSpPr/>
+          <p:nvPr/>
+        </p:nvSpPr>
+        <p:spPr>
+          <a:xfrm>
+            <a:off x="6378247" y="3780000"/>
+            <a:ext cx="2064494" cy="1597267"/>
           </a:xfrm>
           <a:prstGeom prst="rect">
             <a:avLst/>
           </a:prstGeom>
           <a:noFill/>
-          <a:effectLst/>
-        </p:spPr>
-        <p:txBody>
-          <a:bodyPr wrap="square" anchor="t">
-            <a:spAutoFit/>
-          </a:bodyPr>
+          <a:ln>
+            <a:noFill/>
+          </a:ln>
+          <a:effectLst/>
+        </p:spPr>
+        <p:style>
+          <a:lnRef idx="1">
+            <a:schemeClr val="accent1"/>
+          </a:lnRef>
+          <a:fillRef idx="3">
+            <a:schemeClr val="accent1"/>
+          </a:fillRef>
+          <a:effectRef idx="2">
+            <a:schemeClr val="accent1"/>
+          </a:effectRef>
+          <a:fontRef idx="minor">
+            <a:schemeClr val="lt1"/>
+          </a:fontRef>
+        </p:style>
+        <p:txBody>
+          <a:bodyPr rtlCol="0" anchor="t" wrap="square" lIns="72438" rIns="72438" tIns="57950" bIns="57950"/>
           <a:lstStyle/>
           <a:p>
             <a:pPr algn="ctr">
@@ -6728,25 +7238,40 @@
       </p:sp>
       <p:sp>
         <p:nvSpPr>
-          <p:cNvPr id="16" name="TextBox 15"/>
-          <p:cNvSpPr txBox="1"/>
-          <p:nvPr/>
-        </p:nvSpPr>
-        <p:spPr>
-          <a:xfrm>
-            <a:off x="8515180" y="3837950"/>
-            <a:ext cx="1919618" cy="1481365"/>
+          <p:cNvPr id="16" name="Rectangle 15"/>
+          <p:cNvSpPr/>
+          <p:nvPr/>
+        </p:nvSpPr>
+        <p:spPr>
+          <a:xfrm>
+            <a:off x="8442742" y="3780000"/>
+            <a:ext cx="2064494" cy="1597267"/>
           </a:xfrm>
           <a:prstGeom prst="rect">
             <a:avLst/>
           </a:prstGeom>
           <a:noFill/>
-          <a:effectLst/>
-        </p:spPr>
-        <p:txBody>
-          <a:bodyPr wrap="square" anchor="t">
-            <a:spAutoFit/>
-          </a:bodyPr>
+          <a:ln>
+            <a:noFill/>
+          </a:ln>
+          <a:effectLst/>
+        </p:spPr>
+        <p:style>
+          <a:lnRef idx="1">
+            <a:schemeClr val="accent1"/>
+          </a:lnRef>
+          <a:fillRef idx="3">
+            <a:schemeClr val="accent1"/>
+          </a:fillRef>
+          <a:effectRef idx="2">
+            <a:schemeClr val="accent1"/>
+          </a:effectRef>
+          <a:fontRef idx="minor">
+            <a:schemeClr val="lt1"/>
+          </a:fontRef>
+        </p:style>
+        <p:txBody>
+          <a:bodyPr rtlCol="0" anchor="t" wrap="square" lIns="72438" rIns="72438" tIns="57950" bIns="57950"/>
           <a:lstStyle/>
           <a:p>
             <a:pPr algn="ctr">
@@ -6771,25 +7296,40 @@
       </p:sp>
       <p:sp>
         <p:nvSpPr>
-          <p:cNvPr id="17" name="TextBox 16"/>
-          <p:cNvSpPr txBox="1"/>
-          <p:nvPr/>
-        </p:nvSpPr>
-        <p:spPr>
-          <a:xfrm>
-            <a:off x="257200" y="5435217"/>
-            <a:ext cx="1919618" cy="1481365"/>
+          <p:cNvPr id="17" name="Rectangle 16"/>
+          <p:cNvSpPr/>
+          <p:nvPr/>
+        </p:nvSpPr>
+        <p:spPr>
+          <a:xfrm>
+            <a:off x="184762" y="5377267"/>
+            <a:ext cx="2064494" cy="1597267"/>
           </a:xfrm>
           <a:prstGeom prst="rect">
             <a:avLst/>
           </a:prstGeom>
           <a:noFill/>
-          <a:effectLst/>
-        </p:spPr>
-        <p:txBody>
-          <a:bodyPr wrap="square" anchor="t">
-            <a:spAutoFit/>
-          </a:bodyPr>
+          <a:ln>
+            <a:noFill/>
+          </a:ln>
+          <a:effectLst/>
+        </p:spPr>
+        <p:style>
+          <a:lnRef idx="1">
+            <a:schemeClr val="accent1"/>
+          </a:lnRef>
+          <a:fillRef idx="3">
+            <a:schemeClr val="accent1"/>
+          </a:fillRef>
+          <a:effectRef idx="2">
+            <a:schemeClr val="accent1"/>
+          </a:effectRef>
+          <a:fontRef idx="minor">
+            <a:schemeClr val="lt1"/>
+          </a:fontRef>
+        </p:style>
+        <p:txBody>
+          <a:bodyPr rtlCol="0" anchor="t" wrap="square" lIns="72438" rIns="72438" tIns="57950" bIns="57950"/>
           <a:lstStyle/>
           <a:p>
             <a:pPr algn="ctr">
@@ -6814,25 +7354,40 @@
       </p:sp>
       <p:sp>
         <p:nvSpPr>
-          <p:cNvPr id="18" name="TextBox 17"/>
-          <p:cNvSpPr txBox="1"/>
-          <p:nvPr/>
-        </p:nvSpPr>
-        <p:spPr>
-          <a:xfrm>
-            <a:off x="2321695" y="5435217"/>
-            <a:ext cx="1919618" cy="1481365"/>
+          <p:cNvPr id="18" name="Rectangle 17"/>
+          <p:cNvSpPr/>
+          <p:nvPr/>
+        </p:nvSpPr>
+        <p:spPr>
+          <a:xfrm>
+            <a:off x="2249257" y="5377267"/>
+            <a:ext cx="2064494" cy="1597267"/>
           </a:xfrm>
           <a:prstGeom prst="rect">
             <a:avLst/>
           </a:prstGeom>
           <a:noFill/>
-          <a:effectLst/>
-        </p:spPr>
-        <p:txBody>
-          <a:bodyPr wrap="square" anchor="t">
-            <a:spAutoFit/>
-          </a:bodyPr>
+          <a:ln>
+            <a:noFill/>
+          </a:ln>
+          <a:effectLst/>
+        </p:spPr>
+        <p:style>
+          <a:lnRef idx="1">
+            <a:schemeClr val="accent1"/>
+          </a:lnRef>
+          <a:fillRef idx="3">
+            <a:schemeClr val="accent1"/>
+          </a:fillRef>
+          <a:effectRef idx="2">
+            <a:schemeClr val="accent1"/>
+          </a:effectRef>
+          <a:fontRef idx="minor">
+            <a:schemeClr val="lt1"/>
+          </a:fontRef>
+        </p:style>
+        <p:txBody>
+          <a:bodyPr rtlCol="0" anchor="t" wrap="square" lIns="72438" rIns="72438" tIns="57950" bIns="57950"/>
           <a:lstStyle/>
           <a:p>
             <a:pPr algn="ctr">
@@ -6857,25 +7412,40 @@
       </p:sp>
       <p:sp>
         <p:nvSpPr>
-          <p:cNvPr id="19" name="TextBox 18"/>
-          <p:cNvSpPr txBox="1"/>
-          <p:nvPr/>
-        </p:nvSpPr>
-        <p:spPr>
-          <a:xfrm>
-            <a:off x="4386190" y="5435217"/>
-            <a:ext cx="1919618" cy="1481365"/>
+          <p:cNvPr id="19" name="Rectangle 18"/>
+          <p:cNvSpPr/>
+          <p:nvPr/>
+        </p:nvSpPr>
+        <p:spPr>
+          <a:xfrm>
+            <a:off x="4313752" y="5377267"/>
+            <a:ext cx="2064494" cy="1597267"/>
           </a:xfrm>
           <a:prstGeom prst="rect">
             <a:avLst/>
           </a:prstGeom>
           <a:noFill/>
-          <a:effectLst/>
-        </p:spPr>
-        <p:txBody>
-          <a:bodyPr wrap="square" anchor="t">
-            <a:spAutoFit/>
-          </a:bodyPr>
+          <a:ln>
+            <a:noFill/>
+          </a:ln>
+          <a:effectLst/>
+        </p:spPr>
+        <p:style>
+          <a:lnRef idx="1">
+            <a:schemeClr val="accent1"/>
+          </a:lnRef>
+          <a:fillRef idx="3">
+            <a:schemeClr val="accent1"/>
+          </a:fillRef>
+          <a:effectRef idx="2">
+            <a:schemeClr val="accent1"/>
+          </a:effectRef>
+          <a:fontRef idx="minor">
+            <a:schemeClr val="lt1"/>
+          </a:fontRef>
+        </p:style>
+        <p:txBody>
+          <a:bodyPr rtlCol="0" anchor="t" wrap="square" lIns="72438" rIns="72438" tIns="57950" bIns="57950"/>
           <a:lstStyle/>
           <a:p>
             <a:pPr algn="ctr">
@@ -6900,25 +7470,40 @@
       </p:sp>
       <p:sp>
         <p:nvSpPr>
-          <p:cNvPr id="20" name="TextBox 19"/>
-          <p:cNvSpPr txBox="1"/>
-          <p:nvPr/>
-        </p:nvSpPr>
-        <p:spPr>
-          <a:xfrm>
-            <a:off x="6450685" y="5435217"/>
-            <a:ext cx="1919618" cy="1481365"/>
+          <p:cNvPr id="20" name="Rectangle 19"/>
+          <p:cNvSpPr/>
+          <p:nvPr/>
+        </p:nvSpPr>
+        <p:spPr>
+          <a:xfrm>
+            <a:off x="6378247" y="5377267"/>
+            <a:ext cx="2064494" cy="1597267"/>
           </a:xfrm>
           <a:prstGeom prst="rect">
             <a:avLst/>
           </a:prstGeom>
           <a:noFill/>
-          <a:effectLst/>
-        </p:spPr>
-        <p:txBody>
-          <a:bodyPr wrap="square" anchor="t">
-            <a:spAutoFit/>
-          </a:bodyPr>
+          <a:ln>
+            <a:noFill/>
+          </a:ln>
+          <a:effectLst/>
+        </p:spPr>
+        <p:style>
+          <a:lnRef idx="1">
+            <a:schemeClr val="accent1"/>
+          </a:lnRef>
+          <a:fillRef idx="3">
+            <a:schemeClr val="accent1"/>
+          </a:fillRef>
+          <a:effectRef idx="2">
+            <a:schemeClr val="accent1"/>
+          </a:effectRef>
+          <a:fontRef idx="minor">
+            <a:schemeClr val="lt1"/>
+          </a:fontRef>
+        </p:style>
+        <p:txBody>
+          <a:bodyPr rtlCol="0" anchor="t" wrap="square" lIns="72438" rIns="72438" tIns="57950" bIns="57950"/>
           <a:lstStyle/>
           <a:p>
             <a:pPr algn="ctr">
@@ -6943,25 +7528,40 @@
       </p:sp>
       <p:sp>
         <p:nvSpPr>
-          <p:cNvPr id="21" name="TextBox 20"/>
-          <p:cNvSpPr txBox="1"/>
-          <p:nvPr/>
-        </p:nvSpPr>
-        <p:spPr>
-          <a:xfrm>
-            <a:off x="8515180" y="5435217"/>
-            <a:ext cx="1919618" cy="1481365"/>
+          <p:cNvPr id="21" name="Rectangle 20"/>
+          <p:cNvSpPr/>
+          <p:nvPr/>
+        </p:nvSpPr>
+        <p:spPr>
+          <a:xfrm>
+            <a:off x="8442742" y="5377267"/>
+            <a:ext cx="2064494" cy="1597267"/>
           </a:xfrm>
           <a:prstGeom prst="rect">
             <a:avLst/>
           </a:prstGeom>
           <a:noFill/>
-          <a:effectLst/>
-        </p:spPr>
-        <p:txBody>
-          <a:bodyPr wrap="square" anchor="t">
-            <a:spAutoFit/>
-          </a:bodyPr>
+          <a:ln>
+            <a:noFill/>
+          </a:ln>
+          <a:effectLst/>
+        </p:spPr>
+        <p:style>
+          <a:lnRef idx="1">
+            <a:schemeClr val="accent1"/>
+          </a:lnRef>
+          <a:fillRef idx="3">
+            <a:schemeClr val="accent1"/>
+          </a:fillRef>
+          <a:effectRef idx="2">
+            <a:schemeClr val="accent1"/>
+          </a:effectRef>
+          <a:fontRef idx="minor">
+            <a:schemeClr val="lt1"/>
+          </a:fontRef>
+        </p:style>
+        <p:txBody>
+          <a:bodyPr rtlCol="0" anchor="t" wrap="square" lIns="72438" rIns="72438" tIns="57950" bIns="57950"/>
           <a:lstStyle/>
           <a:p>
             <a:pPr algn="ctr">
@@ -9160,25 +9760,40 @@
       <p:grpSpPr/>
       <p:sp>
         <p:nvSpPr>
-          <p:cNvPr id="2" name="TextBox 1"/>
-          <p:cNvSpPr txBox="1"/>
-          <p:nvPr/>
-        </p:nvSpPr>
-        <p:spPr>
-          <a:xfrm>
-            <a:off x="257200" y="643416"/>
-            <a:ext cx="1919618" cy="1481365"/>
+          <p:cNvPr id="2" name="Rectangle 1"/>
+          <p:cNvSpPr/>
+          <p:nvPr/>
+        </p:nvSpPr>
+        <p:spPr>
+          <a:xfrm>
+            <a:off x="184762" y="585465"/>
+            <a:ext cx="2064494" cy="1597267"/>
           </a:xfrm>
           <a:prstGeom prst="rect">
             <a:avLst/>
           </a:prstGeom>
           <a:noFill/>
-          <a:effectLst/>
-        </p:spPr>
-        <p:txBody>
-          <a:bodyPr wrap="square" anchor="ctr">
-            <a:spAutoFit/>
-          </a:bodyPr>
+          <a:ln>
+            <a:noFill/>
+          </a:ln>
+          <a:effectLst/>
+        </p:spPr>
+        <p:style>
+          <a:lnRef idx="1">
+            <a:schemeClr val="accent1"/>
+          </a:lnRef>
+          <a:fillRef idx="3">
+            <a:schemeClr val="accent1"/>
+          </a:fillRef>
+          <a:effectRef idx="2">
+            <a:schemeClr val="accent1"/>
+          </a:effectRef>
+          <a:fontRef idx="minor">
+            <a:schemeClr val="lt1"/>
+          </a:fontRef>
+        </p:style>
+        <p:txBody>
+          <a:bodyPr rtlCol="0" anchor="ctr" wrap="square" lIns="72438" rIns="72438" tIns="57950" bIns="57950"/>
           <a:lstStyle/>
           <a:p>
             <a:pPr algn="ctr">
@@ -9203,25 +9818,40 @@
       </p:sp>
       <p:sp>
         <p:nvSpPr>
-          <p:cNvPr id="3" name="TextBox 2"/>
-          <p:cNvSpPr txBox="1"/>
-          <p:nvPr/>
-        </p:nvSpPr>
-        <p:spPr>
-          <a:xfrm>
-            <a:off x="2321695" y="643416"/>
-            <a:ext cx="1919618" cy="1481365"/>
+          <p:cNvPr id="3" name="Rectangle 2"/>
+          <p:cNvSpPr/>
+          <p:nvPr/>
+        </p:nvSpPr>
+        <p:spPr>
+          <a:xfrm>
+            <a:off x="2249257" y="585465"/>
+            <a:ext cx="2064494" cy="1597267"/>
           </a:xfrm>
           <a:prstGeom prst="rect">
             <a:avLst/>
           </a:prstGeom>
           <a:noFill/>
-          <a:effectLst/>
-        </p:spPr>
-        <p:txBody>
-          <a:bodyPr wrap="square" anchor="ctr">
-            <a:spAutoFit/>
-          </a:bodyPr>
+          <a:ln>
+            <a:noFill/>
+          </a:ln>
+          <a:effectLst/>
+        </p:spPr>
+        <p:style>
+          <a:lnRef idx="1">
+            <a:schemeClr val="accent1"/>
+          </a:lnRef>
+          <a:fillRef idx="3">
+            <a:schemeClr val="accent1"/>
+          </a:fillRef>
+          <a:effectRef idx="2">
+            <a:schemeClr val="accent1"/>
+          </a:effectRef>
+          <a:fontRef idx="minor">
+            <a:schemeClr val="lt1"/>
+          </a:fontRef>
+        </p:style>
+        <p:txBody>
+          <a:bodyPr rtlCol="0" anchor="ctr" wrap="square" lIns="72438" rIns="72438" tIns="57950" bIns="57950"/>
           <a:lstStyle/>
           <a:p>
             <a:pPr algn="ctr">
@@ -9265,25 +9895,40 @@
       </p:sp>
       <p:sp>
         <p:nvSpPr>
-          <p:cNvPr id="4" name="TextBox 3"/>
-          <p:cNvSpPr txBox="1"/>
-          <p:nvPr/>
-        </p:nvSpPr>
-        <p:spPr>
-          <a:xfrm>
-            <a:off x="4386190" y="643416"/>
-            <a:ext cx="1919618" cy="1481365"/>
+          <p:cNvPr id="4" name="Rectangle 3"/>
+          <p:cNvSpPr/>
+          <p:nvPr/>
+        </p:nvSpPr>
+        <p:spPr>
+          <a:xfrm>
+            <a:off x="4313752" y="585465"/>
+            <a:ext cx="2064494" cy="1597267"/>
           </a:xfrm>
           <a:prstGeom prst="rect">
             <a:avLst/>
           </a:prstGeom>
           <a:noFill/>
-          <a:effectLst/>
-        </p:spPr>
-        <p:txBody>
-          <a:bodyPr wrap="square" anchor="ctr">
-            <a:spAutoFit/>
-          </a:bodyPr>
+          <a:ln>
+            <a:noFill/>
+          </a:ln>
+          <a:effectLst/>
+        </p:spPr>
+        <p:style>
+          <a:lnRef idx="1">
+            <a:schemeClr val="accent1"/>
+          </a:lnRef>
+          <a:fillRef idx="3">
+            <a:schemeClr val="accent1"/>
+          </a:fillRef>
+          <a:effectRef idx="2">
+            <a:schemeClr val="accent1"/>
+          </a:effectRef>
+          <a:fontRef idx="minor">
+            <a:schemeClr val="lt1"/>
+          </a:fontRef>
+        </p:style>
+        <p:txBody>
+          <a:bodyPr rtlCol="0" anchor="ctr" wrap="square" lIns="72438" rIns="72438" tIns="57950" bIns="57950"/>
           <a:lstStyle/>
           <a:p>
             <a:pPr algn="ctr">
@@ -9327,25 +9972,40 @@
       </p:sp>
       <p:sp>
         <p:nvSpPr>
-          <p:cNvPr id="5" name="TextBox 4"/>
-          <p:cNvSpPr txBox="1"/>
-          <p:nvPr/>
-        </p:nvSpPr>
-        <p:spPr>
-          <a:xfrm>
-            <a:off x="6450685" y="643416"/>
-            <a:ext cx="1919618" cy="1481365"/>
+          <p:cNvPr id="5" name="Rectangle 4"/>
+          <p:cNvSpPr/>
+          <p:nvPr/>
+        </p:nvSpPr>
+        <p:spPr>
+          <a:xfrm>
+            <a:off x="6378247" y="585465"/>
+            <a:ext cx="2064494" cy="1597267"/>
           </a:xfrm>
           <a:prstGeom prst="rect">
             <a:avLst/>
           </a:prstGeom>
           <a:noFill/>
-          <a:effectLst/>
-        </p:spPr>
-        <p:txBody>
-          <a:bodyPr wrap="square" anchor="ctr">
-            <a:spAutoFit/>
-          </a:bodyPr>
+          <a:ln>
+            <a:noFill/>
+          </a:ln>
+          <a:effectLst/>
+        </p:spPr>
+        <p:style>
+          <a:lnRef idx="1">
+            <a:schemeClr val="accent1"/>
+          </a:lnRef>
+          <a:fillRef idx="3">
+            <a:schemeClr val="accent1"/>
+          </a:fillRef>
+          <a:effectRef idx="2">
+            <a:schemeClr val="accent1"/>
+          </a:effectRef>
+          <a:fontRef idx="minor">
+            <a:schemeClr val="lt1"/>
+          </a:fontRef>
+        </p:style>
+        <p:txBody>
+          <a:bodyPr rtlCol="0" anchor="ctr" wrap="square" lIns="72438" rIns="72438" tIns="57950" bIns="57950"/>
           <a:lstStyle/>
           <a:p>
             <a:pPr algn="ctr">
@@ -9389,25 +10049,40 @@
       </p:sp>
       <p:sp>
         <p:nvSpPr>
-          <p:cNvPr id="6" name="TextBox 5"/>
-          <p:cNvSpPr txBox="1"/>
-          <p:nvPr/>
-        </p:nvSpPr>
-        <p:spPr>
-          <a:xfrm>
-            <a:off x="8515180" y="643416"/>
-            <a:ext cx="1919618" cy="1481365"/>
+          <p:cNvPr id="6" name="Rectangle 5"/>
+          <p:cNvSpPr/>
+          <p:nvPr/>
+        </p:nvSpPr>
+        <p:spPr>
+          <a:xfrm>
+            <a:off x="8442742" y="585465"/>
+            <a:ext cx="2064494" cy="1597267"/>
           </a:xfrm>
           <a:prstGeom prst="rect">
             <a:avLst/>
           </a:prstGeom>
           <a:noFill/>
-          <a:effectLst/>
-        </p:spPr>
-        <p:txBody>
-          <a:bodyPr wrap="square" anchor="ctr">
-            <a:spAutoFit/>
-          </a:bodyPr>
+          <a:ln>
+            <a:noFill/>
+          </a:ln>
+          <a:effectLst/>
+        </p:spPr>
+        <p:style>
+          <a:lnRef idx="1">
+            <a:schemeClr val="accent1"/>
+          </a:lnRef>
+          <a:fillRef idx="3">
+            <a:schemeClr val="accent1"/>
+          </a:fillRef>
+          <a:effectRef idx="2">
+            <a:schemeClr val="accent1"/>
+          </a:effectRef>
+          <a:fontRef idx="minor">
+            <a:schemeClr val="lt1"/>
+          </a:fontRef>
+        </p:style>
+        <p:txBody>
+          <a:bodyPr rtlCol="0" anchor="ctr" wrap="square" lIns="72438" rIns="72438" tIns="57950" bIns="57950"/>
           <a:lstStyle/>
           <a:p>
             <a:pPr algn="ctr">
@@ -9451,25 +10126,40 @@
       </p:sp>
       <p:sp>
         <p:nvSpPr>
-          <p:cNvPr id="7" name="TextBox 6"/>
-          <p:cNvSpPr txBox="1"/>
-          <p:nvPr/>
-        </p:nvSpPr>
-        <p:spPr>
-          <a:xfrm>
-            <a:off x="257200" y="2240683"/>
-            <a:ext cx="1919618" cy="1481365"/>
+          <p:cNvPr id="7" name="Rectangle 6"/>
+          <p:cNvSpPr/>
+          <p:nvPr/>
+        </p:nvSpPr>
+        <p:spPr>
+          <a:xfrm>
+            <a:off x="184762" y="2182732"/>
+            <a:ext cx="2064494" cy="1597267"/>
           </a:xfrm>
           <a:prstGeom prst="rect">
             <a:avLst/>
           </a:prstGeom>
           <a:noFill/>
-          <a:effectLst/>
-        </p:spPr>
-        <p:txBody>
-          <a:bodyPr wrap="square" anchor="ctr">
-            <a:spAutoFit/>
-          </a:bodyPr>
+          <a:ln>
+            <a:noFill/>
+          </a:ln>
+          <a:effectLst/>
+        </p:spPr>
+        <p:style>
+          <a:lnRef idx="1">
+            <a:schemeClr val="accent1"/>
+          </a:lnRef>
+          <a:fillRef idx="3">
+            <a:schemeClr val="accent1"/>
+          </a:fillRef>
+          <a:effectRef idx="2">
+            <a:schemeClr val="accent1"/>
+          </a:effectRef>
+          <a:fontRef idx="minor">
+            <a:schemeClr val="lt1"/>
+          </a:fontRef>
+        </p:style>
+        <p:txBody>
+          <a:bodyPr rtlCol="0" anchor="ctr" wrap="square" lIns="72438" rIns="72438" tIns="57950" bIns="57950"/>
           <a:lstStyle/>
           <a:p>
             <a:pPr algn="ctr">
@@ -9513,25 +10203,40 @@
       </p:sp>
       <p:sp>
         <p:nvSpPr>
-          <p:cNvPr id="8" name="TextBox 7"/>
-          <p:cNvSpPr txBox="1"/>
-          <p:nvPr/>
-        </p:nvSpPr>
-        <p:spPr>
-          <a:xfrm>
-            <a:off x="2321695" y="2240683"/>
-            <a:ext cx="1919618" cy="1481365"/>
+          <p:cNvPr id="8" name="Rectangle 7"/>
+          <p:cNvSpPr/>
+          <p:nvPr/>
+        </p:nvSpPr>
+        <p:spPr>
+          <a:xfrm>
+            <a:off x="2249257" y="2182732"/>
+            <a:ext cx="2064494" cy="1597267"/>
           </a:xfrm>
           <a:prstGeom prst="rect">
             <a:avLst/>
           </a:prstGeom>
           <a:noFill/>
-          <a:effectLst/>
-        </p:spPr>
-        <p:txBody>
-          <a:bodyPr wrap="square" anchor="ctr">
-            <a:spAutoFit/>
-          </a:bodyPr>
+          <a:ln>
+            <a:noFill/>
+          </a:ln>
+          <a:effectLst/>
+        </p:spPr>
+        <p:style>
+          <a:lnRef idx="1">
+            <a:schemeClr val="accent1"/>
+          </a:lnRef>
+          <a:fillRef idx="3">
+            <a:schemeClr val="accent1"/>
+          </a:fillRef>
+          <a:effectRef idx="2">
+            <a:schemeClr val="accent1"/>
+          </a:effectRef>
+          <a:fontRef idx="minor">
+            <a:schemeClr val="lt1"/>
+          </a:fontRef>
+        </p:style>
+        <p:txBody>
+          <a:bodyPr rtlCol="0" anchor="ctr" wrap="square" lIns="72438" rIns="72438" tIns="57950" bIns="57950"/>
           <a:lstStyle/>
           <a:p>
             <a:pPr algn="ctr">
@@ -9575,25 +10280,40 @@
       </p:sp>
       <p:sp>
         <p:nvSpPr>
-          <p:cNvPr id="9" name="TextBox 8"/>
-          <p:cNvSpPr txBox="1"/>
-          <p:nvPr/>
-        </p:nvSpPr>
-        <p:spPr>
-          <a:xfrm>
-            <a:off x="4378947" y="2234888"/>
-            <a:ext cx="1934105" cy="1492955"/>
+          <p:cNvPr id="9" name="Rectangle 8"/>
+          <p:cNvSpPr/>
+          <p:nvPr/>
+        </p:nvSpPr>
+        <p:spPr>
+          <a:xfrm>
+            <a:off x="4313752" y="2182732"/>
+            <a:ext cx="2064494" cy="1597267"/>
           </a:xfrm>
           <a:prstGeom prst="rect">
             <a:avLst/>
           </a:prstGeom>
           <a:noFill/>
-          <a:effectLst/>
-        </p:spPr>
-        <p:txBody>
-          <a:bodyPr wrap="square" anchor="t">
-            <a:spAutoFit/>
-          </a:bodyPr>
+          <a:ln>
+            <a:noFill/>
+          </a:ln>
+          <a:effectLst/>
+        </p:spPr>
+        <p:style>
+          <a:lnRef idx="1">
+            <a:schemeClr val="accent1"/>
+          </a:lnRef>
+          <a:fillRef idx="3">
+            <a:schemeClr val="accent1"/>
+          </a:fillRef>
+          <a:effectRef idx="2">
+            <a:schemeClr val="accent1"/>
+          </a:effectRef>
+          <a:fontRef idx="minor">
+            <a:schemeClr val="lt1"/>
+          </a:fontRef>
+        </p:style>
+        <p:txBody>
+          <a:bodyPr rtlCol="0" anchor="t" wrap="square" lIns="65194" rIns="65194" tIns="52155" bIns="52155"/>
           <a:lstStyle/>
           <a:p>
             <a:pPr algn="ctr">

</xml_diff>

<commit_message>
Expand request pools to 31x34 with kid markers and PPTX refresh.
</commit_message>
<xml_diff>
--- a/output/svet-moy-zerkalce-cards.pptx
+++ b/output/svet-moy-zerkalce-cards.pptx
@@ -8,6 +8,8 @@
     <p:sldId id="256" r:id="rId7"/>
     <p:sldId id="257" r:id="rId8"/>
     <p:sldId id="258" r:id="rId9"/>
+    <p:sldId id="259" r:id="rId10"/>
+    <p:sldId id="260" r:id="rId11"/>
   </p:sldIdLst>
   <p:sldSz cx="10692000" cy="7560000" type="screen4x3"/>
   <p:notesSz cx="6858000" cy="9144000"/>
@@ -3201,7 +3203,7 @@
                 </a:solidFill>
                 <a:latin typeface="Arial"/>
               </a:rPr>
-              <a:t>Произнеси заклинание усыпления для</a:t>
+              <a:t>Произнеси заклинание превращения в*</a:t>
             </a:r>
           </a:p>
         </p:txBody>
@@ -3259,7 +3261,7 @@
                 </a:solidFill>
                 <a:latin typeface="Arial"/>
               </a:rPr>
-              <a:t>Скажи кто самый вонючий из</a:t>
+              <a:t>Скажи кто самый вонючий из*</a:t>
             </a:r>
           </a:p>
         </p:txBody>
@@ -3317,7 +3319,7 @@
                 </a:solidFill>
                 <a:latin typeface="Arial"/>
               </a:rPr>
-              <a:t>Расскажи чем испугать всех</a:t>
+              <a:t>Расскажи чем испугать всех*</a:t>
             </a:r>
           </a:p>
         </p:txBody>
@@ -3375,7 +3377,7 @@
                 </a:solidFill>
                 <a:latin typeface="Arial"/>
               </a:rPr>
-              <a:t>Посоветуй чем подкупать</a:t>
+              <a:t>Посоветуй чем подкупать*</a:t>
             </a:r>
           </a:p>
         </p:txBody>
@@ -3433,7 +3435,7 @@
                 </a:solidFill>
                 <a:latin typeface="Arial"/>
               </a:rPr>
-              <a:t>Назови тайную слабость</a:t>
+              <a:t>Назови тайную слабость*</a:t>
             </a:r>
           </a:p>
         </p:txBody>
@@ -3491,7 +3493,7 @@
                 </a:solidFill>
                 <a:latin typeface="Arial"/>
               </a:rPr>
-              <a:t>Подбери прозвище для любого из</a:t>
+              <a:t>Подбери прозвище для любого из*</a:t>
             </a:r>
           </a:p>
         </p:txBody>
@@ -3607,7 +3609,7 @@
                 </a:solidFill>
                 <a:latin typeface="Arial"/>
               </a:rPr>
-              <a:t>Придумай страшное проклятие для</a:t>
+              <a:t>Придумай страшное проклятие для*</a:t>
             </a:r>
           </a:p>
         </p:txBody>
@@ -3665,7 +3667,7 @@
                 </a:solidFill>
                 <a:latin typeface="Arial"/>
               </a:rPr>
-              <a:t>Скажи чем эффективнее будить</a:t>
+              <a:t>Скажи чем эффективнее будить*</a:t>
             </a:r>
           </a:p>
         </p:txBody>
@@ -3723,7 +3725,7 @@
                 </a:solidFill>
                 <a:latin typeface="Arial"/>
               </a:rPr>
-              <a:t>Составь комплимент, который вгонит в краску</a:t>
+              <a:t>Составь комплимент, который вгонит в краску*</a:t>
             </a:r>
           </a:p>
         </p:txBody>
@@ -3897,7 +3899,7 @@
                 </a:solidFill>
                 <a:latin typeface="Arial"/>
               </a:rPr>
-              <a:t>Придумай алиби для кого-то из</a:t>
+              <a:t>Какое преступление типично для</a:t>
             </a:r>
           </a:p>
         </p:txBody>
@@ -4129,7 +4131,7 @@
                 </a:solidFill>
                 <a:latin typeface="Arial"/>
               </a:rPr>
-              <a:t>Сочини смс «мы должны серьёзно поговорить» для</a:t>
+              <a:t>Сочини сообщение «мы должны серьёзно поговорить» для</a:t>
             </a:r>
           </a:p>
         </p:txBody>
@@ -4187,7 +4189,7 @@
                 </a:solidFill>
                 <a:latin typeface="Arial"/>
               </a:rPr>
-              <a:t>Расскажи чем заменить утренний кофе для</a:t>
+              <a:t>Расскажи чем заменить утренний кофе для*</a:t>
             </a:r>
           </a:p>
         </p:txBody>
@@ -4245,7 +4247,7 @@
                 </a:solidFill>
                 <a:latin typeface="Arial"/>
               </a:rPr>
-              <a:t>Придумай челлендж на слабо для</a:t>
+              <a:t>Придумай чем взять на слабо*</a:t>
             </a:r>
           </a:p>
         </p:txBody>
@@ -6477,7 +6479,7 @@
                 </a:solidFill>
                 <a:latin typeface="Arial"/>
               </a:rPr>
-              <a:t>здесь присутствующих</a:t>
+              <a:t>*здесь присутствующих</a:t>
             </a:r>
           </a:p>
         </p:txBody>
@@ -6593,7 +6595,7 @@
                 </a:solidFill>
                 <a:latin typeface="Arial"/>
               </a:rPr>
-              <a:t>героев тупых комедий</a:t>
+              <a:t>*героев тупых комедий</a:t>
             </a:r>
           </a:p>
         </p:txBody>
@@ -6651,7 +6653,7 @@
                 </a:solidFill>
                 <a:latin typeface="Arial"/>
               </a:rPr>
-              <a:t>животных на ферме</a:t>
+              <a:t>*животных на ферме</a:t>
             </a:r>
           </a:p>
         </p:txBody>
@@ -6709,7 +6711,7 @@
                 </a:solidFill>
                 <a:latin typeface="Arial"/>
               </a:rPr>
-              <a:t>бородатых мужиков</a:t>
+              <a:t>*бородатых мужиков</a:t>
             </a:r>
           </a:p>
         </p:txBody>
@@ -6767,7 +6769,7 @@
                 </a:solidFill>
                 <a:latin typeface="Arial"/>
               </a:rPr>
-              <a:t>соседей сверху</a:t>
+              <a:t>*соседей сверху</a:t>
             </a:r>
           </a:p>
         </p:txBody>
@@ -6941,7 +6943,7 @@
                 </a:solidFill>
                 <a:latin typeface="Arial"/>
               </a:rPr>
-              <a:t>типичных героев мемов</a:t>
+              <a:t>*типичных героев мемов</a:t>
             </a:r>
           </a:p>
         </p:txBody>
@@ -6999,7 +7001,7 @@
                 </a:solidFill>
                 <a:latin typeface="Arial"/>
               </a:rPr>
-              <a:t>дровосеков</a:t>
+              <a:t>*ухоженных дровосеков</a:t>
             </a:r>
           </a:p>
         </p:txBody>
@@ -7057,7 +7059,7 @@
                 </a:solidFill>
                 <a:latin typeface="Arial"/>
               </a:rPr>
-              <a:t>любителей настолок</a:t>
+              <a:t>*любителей настолок</a:t>
             </a:r>
           </a:p>
         </p:txBody>
@@ -7115,7 +7117,7 @@
                 </a:solidFill>
                 <a:latin typeface="Arial"/>
               </a:rPr>
-              <a:t>фанатов комиксов</a:t>
+              <a:t>*фанатов комиксов</a:t>
             </a:r>
           </a:p>
         </p:txBody>
@@ -7289,7 +7291,7 @@
                 </a:solidFill>
                 <a:latin typeface="Arial"/>
               </a:rPr>
-              <a:t>вечных опоздунов</a:t>
+              <a:t>*вечных опоздунов</a:t>
             </a:r>
           </a:p>
         </p:txBody>
@@ -7347,7 +7349,7 @@
                 </a:solidFill>
                 <a:latin typeface="Arial"/>
               </a:rPr>
-              <a:t>величайших злодеев в истории</a:t>
+              <a:t>*величайших злодеев в истории</a:t>
             </a:r>
           </a:p>
         </p:txBody>
@@ -7405,7 +7407,7 @@
                 </a:solidFill>
                 <a:latin typeface="Arial"/>
               </a:rPr>
-              <a:t>маменьких сынков</a:t>
+              <a:t>*маменькиных сынков</a:t>
             </a:r>
           </a:p>
         </p:txBody>
@@ -7463,7 +7465,7 @@
                 </a:solidFill>
                 <a:latin typeface="Arial"/>
               </a:rPr>
-              <a:t>самокатчиков</a:t>
+              <a:t>*самокатчиков</a:t>
             </a:r>
           </a:p>
         </p:txBody>
@@ -7521,7 +7523,7 @@
                 </a:solidFill>
                 <a:latin typeface="Arial"/>
               </a:rPr>
-              <a:t>криптоинвестеров</a:t>
+              <a:t>*криптоинвестеров</a:t>
             </a:r>
           </a:p>
         </p:txBody>
@@ -7579,7 +7581,7 @@
                 </a:solidFill>
                 <a:latin typeface="Arial"/>
               </a:rPr>
-              <a:t>ручных питомцев</a:t>
+              <a:t>*ручных питомцев</a:t>
             </a:r>
           </a:p>
         </p:txBody>
@@ -9749,6 +9751,4396 @@
 </file>
 
 <file path=ppt/slides/slide3.xml><?xml version="1.0" encoding="utf-8"?>
+<p:sld xmlns:a="http://schemas.openxmlformats.org/drawingml/2006/main" xmlns:p="http://schemas.openxmlformats.org/presentationml/2006/main" xmlns:r="http://schemas.openxmlformats.org/officeDocument/2006/relationships">
+  <p:cSld>
+    <p:spTree>
+      <p:nvGrpSpPr>
+        <p:cNvPr id="1" name=""/>
+        <p:cNvGrpSpPr/>
+        <p:nvPr/>
+      </p:nvGrpSpPr>
+      <p:grpSpPr/>
+      <p:sp>
+        <p:nvSpPr>
+          <p:cNvPr id="2" name="Rectangle 1"/>
+          <p:cNvSpPr/>
+          <p:nvPr/>
+        </p:nvSpPr>
+        <p:spPr>
+          <a:xfrm>
+            <a:off x="184762" y="585465"/>
+            <a:ext cx="2064494" cy="1597267"/>
+          </a:xfrm>
+          <a:prstGeom prst="rect">
+            <a:avLst/>
+          </a:prstGeom>
+          <a:noFill/>
+          <a:ln>
+            <a:noFill/>
+          </a:ln>
+          <a:effectLst/>
+        </p:spPr>
+        <p:style>
+          <a:lnRef idx="1">
+            <a:schemeClr val="accent1"/>
+          </a:lnRef>
+          <a:fillRef idx="3">
+            <a:schemeClr val="accent1"/>
+          </a:fillRef>
+          <a:effectRef idx="2">
+            <a:schemeClr val="accent1"/>
+          </a:effectRef>
+          <a:fontRef idx="minor">
+            <a:schemeClr val="lt1"/>
+          </a:fontRef>
+        </p:style>
+        <p:txBody>
+          <a:bodyPr rtlCol="0" anchor="b" wrap="square" lIns="72438" rIns="72438" tIns="57950" bIns="57950"/>
+          <a:lstStyle/>
+          <a:p>
+            <a:pPr algn="ctr">
+              <a:spcBef>
+                <a:spcPts val="0"/>
+              </a:spcBef>
+              <a:spcAft>
+                <a:spcPts val="0"/>
+              </a:spcAft>
+            </a:pPr>
+            <a:r>
+              <a:rPr sz="2000" b="1">
+                <a:solidFill>
+                  <a:srgbClr val="1A1A1A"/>
+                </a:solidFill>
+                <a:latin typeface="Arial"/>
+              </a:rPr>
+              <a:t>Чем оскорбить любого из</a:t>
+            </a:r>
+          </a:p>
+        </p:txBody>
+      </p:sp>
+      <p:sp>
+        <p:nvSpPr>
+          <p:cNvPr id="3" name="Rectangle 2"/>
+          <p:cNvSpPr/>
+          <p:nvPr/>
+        </p:nvSpPr>
+        <p:spPr>
+          <a:xfrm>
+            <a:off x="2249257" y="585465"/>
+            <a:ext cx="2064494" cy="1597267"/>
+          </a:xfrm>
+          <a:prstGeom prst="rect">
+            <a:avLst/>
+          </a:prstGeom>
+          <a:noFill/>
+          <a:ln>
+            <a:noFill/>
+          </a:ln>
+          <a:effectLst/>
+        </p:spPr>
+        <p:style>
+          <a:lnRef idx="1">
+            <a:schemeClr val="accent1"/>
+          </a:lnRef>
+          <a:fillRef idx="3">
+            <a:schemeClr val="accent1"/>
+          </a:fillRef>
+          <a:effectRef idx="2">
+            <a:schemeClr val="accent1"/>
+          </a:effectRef>
+          <a:fontRef idx="minor">
+            <a:schemeClr val="lt1"/>
+          </a:fontRef>
+        </p:style>
+        <p:txBody>
+          <a:bodyPr rtlCol="0" anchor="b" wrap="square" lIns="72438" rIns="72438" tIns="57950" bIns="57950"/>
+          <a:lstStyle/>
+          <a:p>
+            <a:pPr algn="ctr">
+              <a:spcBef>
+                <a:spcPts val="0"/>
+              </a:spcBef>
+              <a:spcAft>
+                <a:spcPts val="0"/>
+              </a:spcAft>
+            </a:pPr>
+            <a:r>
+              <a:rPr sz="2000" b="1">
+                <a:solidFill>
+                  <a:srgbClr val="1A1A1A"/>
+                </a:solidFill>
+                <a:latin typeface="Arial"/>
+              </a:rPr>
+              <a:t>Без чего нельзя представить*</a:t>
+            </a:r>
+          </a:p>
+        </p:txBody>
+      </p:sp>
+      <p:sp>
+        <p:nvSpPr>
+          <p:cNvPr id="4" name="Rectangle 3"/>
+          <p:cNvSpPr/>
+          <p:nvPr/>
+        </p:nvSpPr>
+        <p:spPr>
+          <a:xfrm>
+            <a:off x="4313752" y="585465"/>
+            <a:ext cx="2064494" cy="1597267"/>
+          </a:xfrm>
+          <a:prstGeom prst="rect">
+            <a:avLst/>
+          </a:prstGeom>
+          <a:noFill/>
+          <a:ln>
+            <a:noFill/>
+          </a:ln>
+          <a:effectLst/>
+        </p:spPr>
+        <p:style>
+          <a:lnRef idx="1">
+            <a:schemeClr val="accent1"/>
+          </a:lnRef>
+          <a:fillRef idx="3">
+            <a:schemeClr val="accent1"/>
+          </a:fillRef>
+          <a:effectRef idx="2">
+            <a:schemeClr val="accent1"/>
+          </a:effectRef>
+          <a:fontRef idx="minor">
+            <a:schemeClr val="lt1"/>
+          </a:fontRef>
+        </p:style>
+        <p:txBody>
+          <a:bodyPr rtlCol="0" anchor="b" wrap="square" lIns="72438" rIns="72438" tIns="57950" bIns="57950"/>
+          <a:lstStyle/>
+          <a:p>
+            <a:pPr algn="ctr">
+              <a:spcBef>
+                <a:spcPts val="0"/>
+              </a:spcBef>
+              <a:spcAft>
+                <a:spcPts val="0"/>
+              </a:spcAft>
+            </a:pPr>
+            <a:r>
+              <a:rPr sz="2000" b="1">
+                <a:solidFill>
+                  <a:srgbClr val="1A1A1A"/>
+                </a:solidFill>
+                <a:latin typeface="Arial"/>
+              </a:rPr>
+              <a:t>За что ненавидят</a:t>
+            </a:r>
+          </a:p>
+        </p:txBody>
+      </p:sp>
+      <p:sp>
+        <p:nvSpPr>
+          <p:cNvPr id="5" name="Rectangle 4"/>
+          <p:cNvSpPr/>
+          <p:nvPr/>
+        </p:nvSpPr>
+        <p:spPr>
+          <a:xfrm>
+            <a:off x="6378247" y="585465"/>
+            <a:ext cx="2064494" cy="1597267"/>
+          </a:xfrm>
+          <a:prstGeom prst="rect">
+            <a:avLst/>
+          </a:prstGeom>
+          <a:noFill/>
+          <a:ln>
+            <a:noFill/>
+          </a:ln>
+          <a:effectLst/>
+        </p:spPr>
+        <p:style>
+          <a:lnRef idx="1">
+            <a:schemeClr val="accent1"/>
+          </a:lnRef>
+          <a:fillRef idx="3">
+            <a:schemeClr val="accent1"/>
+          </a:fillRef>
+          <a:effectRef idx="2">
+            <a:schemeClr val="accent1"/>
+          </a:effectRef>
+          <a:fontRef idx="minor">
+            <a:schemeClr val="lt1"/>
+          </a:fontRef>
+        </p:style>
+        <p:txBody>
+          <a:bodyPr rtlCol="0" anchor="b" wrap="square" lIns="72438" rIns="72438" tIns="57950" bIns="57950"/>
+          <a:lstStyle/>
+          <a:p>
+            <a:pPr algn="ctr">
+              <a:spcBef>
+                <a:spcPts val="0"/>
+              </a:spcBef>
+              <a:spcAft>
+                <a:spcPts val="0"/>
+              </a:spcAft>
+            </a:pPr>
+            <a:r>
+              <a:rPr sz="2000" b="1">
+                <a:solidFill>
+                  <a:srgbClr val="1A1A1A"/>
+                </a:solidFill>
+                <a:latin typeface="Arial"/>
+              </a:rPr>
+              <a:t>Для кого сняли кино про*</a:t>
+            </a:r>
+          </a:p>
+        </p:txBody>
+      </p:sp>
+      <p:sp>
+        <p:nvSpPr>
+          <p:cNvPr id="6" name="Rectangle 5"/>
+          <p:cNvSpPr/>
+          <p:nvPr/>
+        </p:nvSpPr>
+        <p:spPr>
+          <a:xfrm>
+            <a:off x="8442742" y="585465"/>
+            <a:ext cx="2064494" cy="1597267"/>
+          </a:xfrm>
+          <a:prstGeom prst="rect">
+            <a:avLst/>
+          </a:prstGeom>
+          <a:noFill/>
+          <a:ln>
+            <a:noFill/>
+          </a:ln>
+          <a:effectLst/>
+        </p:spPr>
+        <p:style>
+          <a:lnRef idx="1">
+            <a:schemeClr val="accent1"/>
+          </a:lnRef>
+          <a:fillRef idx="3">
+            <a:schemeClr val="accent1"/>
+          </a:fillRef>
+          <a:effectRef idx="2">
+            <a:schemeClr val="accent1"/>
+          </a:effectRef>
+          <a:fontRef idx="minor">
+            <a:schemeClr val="lt1"/>
+          </a:fontRef>
+        </p:style>
+        <p:txBody>
+          <a:bodyPr rtlCol="0" anchor="b" wrap="square" lIns="72438" rIns="72438" tIns="57950" bIns="57950"/>
+          <a:lstStyle/>
+          <a:p>
+            <a:pPr algn="ctr">
+              <a:spcBef>
+                <a:spcPts val="0"/>
+              </a:spcBef>
+              <a:spcAft>
+                <a:spcPts val="0"/>
+              </a:spcAft>
+            </a:pPr>
+            <a:r>
+              <a:rPr sz="2000" b="1">
+                <a:solidFill>
+                  <a:srgbClr val="1A1A1A"/>
+                </a:solidFill>
+                <a:latin typeface="Arial"/>
+              </a:rPr>
+              <a:t>Что пригодится для пранка над любым из*</a:t>
+            </a:r>
+          </a:p>
+        </p:txBody>
+      </p:sp>
+      <p:sp>
+        <p:nvSpPr>
+          <p:cNvPr id="7" name="Rectangle 6"/>
+          <p:cNvSpPr/>
+          <p:nvPr/>
+        </p:nvSpPr>
+        <p:spPr>
+          <a:xfrm>
+            <a:off x="184762" y="2182732"/>
+            <a:ext cx="2064494" cy="1597267"/>
+          </a:xfrm>
+          <a:prstGeom prst="rect">
+            <a:avLst/>
+          </a:prstGeom>
+          <a:noFill/>
+          <a:ln>
+            <a:noFill/>
+          </a:ln>
+          <a:effectLst/>
+        </p:spPr>
+        <p:style>
+          <a:lnRef idx="1">
+            <a:schemeClr val="accent1"/>
+          </a:lnRef>
+          <a:fillRef idx="3">
+            <a:schemeClr val="accent1"/>
+          </a:fillRef>
+          <a:effectRef idx="2">
+            <a:schemeClr val="accent1"/>
+          </a:effectRef>
+          <a:fontRef idx="minor">
+            <a:schemeClr val="lt1"/>
+          </a:fontRef>
+        </p:style>
+        <p:txBody>
+          <a:bodyPr rtlCol="0" anchor="b" wrap="square" lIns="72438" rIns="72438" tIns="57950" bIns="57950"/>
+          <a:lstStyle/>
+          <a:p>
+            <a:pPr algn="ctr">
+              <a:spcBef>
+                <a:spcPts val="0"/>
+              </a:spcBef>
+              <a:spcAft>
+                <a:spcPts val="0"/>
+              </a:spcAft>
+            </a:pPr>
+            <a:r>
+              <a:rPr sz="2000" b="1">
+                <a:solidFill>
+                  <a:srgbClr val="1A1A1A"/>
+                </a:solidFill>
+                <a:latin typeface="Arial"/>
+              </a:rPr>
+              <a:t>Какую пользу можно ожидать от*</a:t>
+            </a:r>
+          </a:p>
+        </p:txBody>
+      </p:sp>
+      <p:sp>
+        <p:nvSpPr>
+          <p:cNvPr id="8" name="Rectangle 7"/>
+          <p:cNvSpPr/>
+          <p:nvPr/>
+        </p:nvSpPr>
+        <p:spPr>
+          <a:xfrm>
+            <a:off x="2249257" y="2182732"/>
+            <a:ext cx="2064494" cy="1597267"/>
+          </a:xfrm>
+          <a:prstGeom prst="rect">
+            <a:avLst/>
+          </a:prstGeom>
+          <a:noFill/>
+          <a:ln>
+            <a:noFill/>
+          </a:ln>
+          <a:effectLst/>
+        </p:spPr>
+        <p:style>
+          <a:lnRef idx="1">
+            <a:schemeClr val="accent1"/>
+          </a:lnRef>
+          <a:fillRef idx="3">
+            <a:schemeClr val="accent1"/>
+          </a:fillRef>
+          <a:effectRef idx="2">
+            <a:schemeClr val="accent1"/>
+          </a:effectRef>
+          <a:fontRef idx="minor">
+            <a:schemeClr val="lt1"/>
+          </a:fontRef>
+        </p:style>
+        <p:txBody>
+          <a:bodyPr rtlCol="0" anchor="b" wrap="square" lIns="72438" rIns="72438" tIns="57950" bIns="57950"/>
+          <a:lstStyle/>
+          <a:p>
+            <a:pPr algn="ctr">
+              <a:spcBef>
+                <a:spcPts val="0"/>
+              </a:spcBef>
+              <a:spcAft>
+                <a:spcPts val="0"/>
+              </a:spcAft>
+            </a:pPr>
+            <a:r>
+              <a:rPr sz="2000" b="1">
+                <a:solidFill>
+                  <a:srgbClr val="1A1A1A"/>
+                </a:solidFill>
+                <a:latin typeface="Arial"/>
+              </a:rPr>
+              <a:t>Какой подлянки можно ожидать от*</a:t>
+            </a:r>
+          </a:p>
+        </p:txBody>
+      </p:sp>
+      <p:sp>
+        <p:nvSpPr>
+          <p:cNvPr id="9" name="Rectangle 8"/>
+          <p:cNvSpPr/>
+          <p:nvPr/>
+        </p:nvSpPr>
+        <p:spPr>
+          <a:xfrm>
+            <a:off x="4313752" y="2182732"/>
+            <a:ext cx="2064494" cy="1597267"/>
+          </a:xfrm>
+          <a:prstGeom prst="rect">
+            <a:avLst/>
+          </a:prstGeom>
+          <a:noFill/>
+          <a:ln>
+            <a:noFill/>
+          </a:ln>
+          <a:effectLst/>
+        </p:spPr>
+        <p:style>
+          <a:lnRef idx="1">
+            <a:schemeClr val="accent1"/>
+          </a:lnRef>
+          <a:fillRef idx="3">
+            <a:schemeClr val="accent1"/>
+          </a:fillRef>
+          <a:effectRef idx="2">
+            <a:schemeClr val="accent1"/>
+          </a:effectRef>
+          <a:fontRef idx="minor">
+            <a:schemeClr val="lt1"/>
+          </a:fontRef>
+        </p:style>
+        <p:txBody>
+          <a:bodyPr rtlCol="0" anchor="b" wrap="square" lIns="72438" rIns="72438" tIns="57950" bIns="57950"/>
+          <a:lstStyle/>
+          <a:p>
+            <a:pPr algn="ctr">
+              <a:spcBef>
+                <a:spcPts val="0"/>
+              </a:spcBef>
+              <a:spcAft>
+                <a:spcPts val="0"/>
+              </a:spcAft>
+            </a:pPr>
+            <a:r>
+              <a:rPr sz="2000" b="1">
+                <a:solidFill>
+                  <a:srgbClr val="1A1A1A"/>
+                </a:solidFill>
+                <a:latin typeface="Arial"/>
+              </a:rPr>
+              <a:t>Какое наказание ждёт в аду для</a:t>
+            </a:r>
+          </a:p>
+        </p:txBody>
+      </p:sp>
+      <p:sp>
+        <p:nvSpPr>
+          <p:cNvPr id="10" name="Rectangle 9"/>
+          <p:cNvSpPr/>
+          <p:nvPr/>
+        </p:nvSpPr>
+        <p:spPr>
+          <a:xfrm>
+            <a:off x="6378247" y="2182732"/>
+            <a:ext cx="2064494" cy="1597267"/>
+          </a:xfrm>
+          <a:prstGeom prst="rect">
+            <a:avLst/>
+          </a:prstGeom>
+          <a:noFill/>
+          <a:ln>
+            <a:noFill/>
+          </a:ln>
+          <a:effectLst/>
+        </p:spPr>
+        <p:style>
+          <a:lnRef idx="1">
+            <a:schemeClr val="accent1"/>
+          </a:lnRef>
+          <a:fillRef idx="3">
+            <a:schemeClr val="accent1"/>
+          </a:fillRef>
+          <a:effectRef idx="2">
+            <a:schemeClr val="accent1"/>
+          </a:effectRef>
+          <a:fontRef idx="minor">
+            <a:schemeClr val="lt1"/>
+          </a:fontRef>
+        </p:style>
+        <p:txBody>
+          <a:bodyPr rtlCol="0" anchor="b" wrap="square" lIns="72438" rIns="72438" tIns="57950" bIns="57950"/>
+          <a:lstStyle/>
+          <a:p>
+            <a:pPr algn="ctr">
+              <a:spcBef>
+                <a:spcPts val="0"/>
+              </a:spcBef>
+              <a:spcAft>
+                <a:spcPts val="0"/>
+              </a:spcAft>
+            </a:pPr>
+            <a:r>
+              <a:rPr sz="2000" b="1">
+                <a:solidFill>
+                  <a:srgbClr val="1A1A1A"/>
+                </a:solidFill>
+                <a:latin typeface="Arial"/>
+              </a:rPr>
+              <a:t>Любимая игра*</a:t>
+            </a:r>
+          </a:p>
+        </p:txBody>
+      </p:sp>
+      <p:sp>
+        <p:nvSpPr>
+          <p:cNvPr id="11" name="Rectangle 10"/>
+          <p:cNvSpPr/>
+          <p:nvPr/>
+        </p:nvSpPr>
+        <p:spPr>
+          <a:xfrm>
+            <a:off x="8442742" y="2182732"/>
+            <a:ext cx="2064494" cy="1597267"/>
+          </a:xfrm>
+          <a:prstGeom prst="rect">
+            <a:avLst/>
+          </a:prstGeom>
+          <a:noFill/>
+          <a:ln>
+            <a:noFill/>
+          </a:ln>
+          <a:effectLst/>
+        </p:spPr>
+        <p:style>
+          <a:lnRef idx="1">
+            <a:schemeClr val="accent1"/>
+          </a:lnRef>
+          <a:fillRef idx="3">
+            <a:schemeClr val="accent1"/>
+          </a:fillRef>
+          <a:effectRef idx="2">
+            <a:schemeClr val="accent1"/>
+          </a:effectRef>
+          <a:fontRef idx="minor">
+            <a:schemeClr val="lt1"/>
+          </a:fontRef>
+        </p:style>
+        <p:txBody>
+          <a:bodyPr rtlCol="0" anchor="b" wrap="square" lIns="72438" rIns="72438" tIns="57950" bIns="57950"/>
+          <a:lstStyle/>
+          <a:p>
+            <a:pPr algn="ctr">
+              <a:spcBef>
+                <a:spcPts val="0"/>
+              </a:spcBef>
+              <a:spcAft>
+                <a:spcPts val="0"/>
+              </a:spcAft>
+            </a:pPr>
+            <a:r>
+              <a:rPr sz="2000" b="1">
+                <a:solidFill>
+                  <a:srgbClr val="1A1A1A"/>
+                </a:solidFill>
+                <a:latin typeface="Arial"/>
+              </a:rPr>
+              <a:t>Какое лекарство от головной боли лучше всего подойдёт для*</a:t>
+            </a:r>
+          </a:p>
+        </p:txBody>
+      </p:sp>
+      <p:sp>
+        <p:nvSpPr>
+          <p:cNvPr id="12" name="Rectangle 11"/>
+          <p:cNvSpPr/>
+          <p:nvPr/>
+        </p:nvSpPr>
+        <p:spPr>
+          <a:xfrm>
+            <a:off x="184762" y="3780000"/>
+            <a:ext cx="2064494" cy="1597267"/>
+          </a:xfrm>
+          <a:prstGeom prst="rect">
+            <a:avLst/>
+          </a:prstGeom>
+          <a:noFill/>
+          <a:ln>
+            <a:noFill/>
+          </a:ln>
+          <a:effectLst/>
+        </p:spPr>
+        <p:style>
+          <a:lnRef idx="1">
+            <a:schemeClr val="accent1"/>
+          </a:lnRef>
+          <a:fillRef idx="3">
+            <a:schemeClr val="accent1"/>
+          </a:fillRef>
+          <a:effectRef idx="2">
+            <a:schemeClr val="accent1"/>
+          </a:effectRef>
+          <a:fontRef idx="minor">
+            <a:schemeClr val="lt1"/>
+          </a:fontRef>
+        </p:style>
+        <p:txBody>
+          <a:bodyPr rtlCol="0" anchor="b" wrap="square" lIns="72438" rIns="72438" tIns="57950" bIns="57950"/>
+          <a:lstStyle/>
+          <a:p>
+            <a:pPr algn="ctr">
+              <a:spcBef>
+                <a:spcPts val="0"/>
+              </a:spcBef>
+              <a:spcAft>
+                <a:spcPts val="0"/>
+              </a:spcAft>
+            </a:pPr>
+            <a:r>
+              <a:rPr sz="2000" b="1">
+                <a:solidFill>
+                  <a:srgbClr val="1A1A1A"/>
+                </a:solidFill>
+                <a:latin typeface="Arial"/>
+              </a:rPr>
+              <a:t>Лучший подарок*</a:t>
+            </a:r>
+          </a:p>
+        </p:txBody>
+      </p:sp>
+      <p:sp>
+        <p:nvSpPr>
+          <p:cNvPr id="13" name="Rectangle 12"/>
+          <p:cNvSpPr/>
+          <p:nvPr/>
+        </p:nvSpPr>
+        <p:spPr>
+          <a:xfrm>
+            <a:off x="184762" y="580703"/>
+            <a:ext cx="2064494" cy="9525"/>
+          </a:xfrm>
+          <a:prstGeom prst="rect">
+            <a:avLst/>
+          </a:prstGeom>
+          <a:solidFill>
+            <a:srgbClr val="C0C0C0"/>
+          </a:solidFill>
+          <a:ln>
+            <a:noFill/>
+          </a:ln>
+          <a:effectLst/>
+        </p:spPr>
+        <p:style>
+          <a:lnRef idx="1">
+            <a:schemeClr val="accent1"/>
+          </a:lnRef>
+          <a:fillRef idx="3">
+            <a:schemeClr val="accent1"/>
+          </a:fillRef>
+          <a:effectRef idx="2">
+            <a:schemeClr val="accent1"/>
+          </a:effectRef>
+          <a:fontRef idx="minor">
+            <a:schemeClr val="lt1"/>
+          </a:fontRef>
+        </p:style>
+        <p:txBody>
+          <a:bodyPr rtlCol="0" anchor="ctr"/>
+          <a:lstStyle/>
+          <a:p>
+            <a:pPr algn="ctr"/>
+          </a:p>
+        </p:txBody>
+      </p:sp>
+      <p:sp>
+        <p:nvSpPr>
+          <p:cNvPr id="14" name="Rectangle 13"/>
+          <p:cNvSpPr/>
+          <p:nvPr/>
+        </p:nvSpPr>
+        <p:spPr>
+          <a:xfrm>
+            <a:off x="2249257" y="580703"/>
+            <a:ext cx="2064494" cy="9525"/>
+          </a:xfrm>
+          <a:prstGeom prst="rect">
+            <a:avLst/>
+          </a:prstGeom>
+          <a:solidFill>
+            <a:srgbClr val="C0C0C0"/>
+          </a:solidFill>
+          <a:ln>
+            <a:noFill/>
+          </a:ln>
+          <a:effectLst/>
+        </p:spPr>
+        <p:style>
+          <a:lnRef idx="1">
+            <a:schemeClr val="accent1"/>
+          </a:lnRef>
+          <a:fillRef idx="3">
+            <a:schemeClr val="accent1"/>
+          </a:fillRef>
+          <a:effectRef idx="2">
+            <a:schemeClr val="accent1"/>
+          </a:effectRef>
+          <a:fontRef idx="minor">
+            <a:schemeClr val="lt1"/>
+          </a:fontRef>
+        </p:style>
+        <p:txBody>
+          <a:bodyPr rtlCol="0" anchor="ctr"/>
+          <a:lstStyle/>
+          <a:p>
+            <a:pPr algn="ctr"/>
+          </a:p>
+        </p:txBody>
+      </p:sp>
+      <p:sp>
+        <p:nvSpPr>
+          <p:cNvPr id="15" name="Rectangle 14"/>
+          <p:cNvSpPr/>
+          <p:nvPr/>
+        </p:nvSpPr>
+        <p:spPr>
+          <a:xfrm>
+            <a:off x="4313752" y="580703"/>
+            <a:ext cx="2064494" cy="9525"/>
+          </a:xfrm>
+          <a:prstGeom prst="rect">
+            <a:avLst/>
+          </a:prstGeom>
+          <a:solidFill>
+            <a:srgbClr val="C0C0C0"/>
+          </a:solidFill>
+          <a:ln>
+            <a:noFill/>
+          </a:ln>
+          <a:effectLst/>
+        </p:spPr>
+        <p:style>
+          <a:lnRef idx="1">
+            <a:schemeClr val="accent1"/>
+          </a:lnRef>
+          <a:fillRef idx="3">
+            <a:schemeClr val="accent1"/>
+          </a:fillRef>
+          <a:effectRef idx="2">
+            <a:schemeClr val="accent1"/>
+          </a:effectRef>
+          <a:fontRef idx="minor">
+            <a:schemeClr val="lt1"/>
+          </a:fontRef>
+        </p:style>
+        <p:txBody>
+          <a:bodyPr rtlCol="0" anchor="ctr"/>
+          <a:lstStyle/>
+          <a:p>
+            <a:pPr algn="ctr"/>
+          </a:p>
+        </p:txBody>
+      </p:sp>
+      <p:sp>
+        <p:nvSpPr>
+          <p:cNvPr id="16" name="Rectangle 15"/>
+          <p:cNvSpPr/>
+          <p:nvPr/>
+        </p:nvSpPr>
+        <p:spPr>
+          <a:xfrm>
+            <a:off x="6378247" y="580703"/>
+            <a:ext cx="2064494" cy="9525"/>
+          </a:xfrm>
+          <a:prstGeom prst="rect">
+            <a:avLst/>
+          </a:prstGeom>
+          <a:solidFill>
+            <a:srgbClr val="C0C0C0"/>
+          </a:solidFill>
+          <a:ln>
+            <a:noFill/>
+          </a:ln>
+          <a:effectLst/>
+        </p:spPr>
+        <p:style>
+          <a:lnRef idx="1">
+            <a:schemeClr val="accent1"/>
+          </a:lnRef>
+          <a:fillRef idx="3">
+            <a:schemeClr val="accent1"/>
+          </a:fillRef>
+          <a:effectRef idx="2">
+            <a:schemeClr val="accent1"/>
+          </a:effectRef>
+          <a:fontRef idx="minor">
+            <a:schemeClr val="lt1"/>
+          </a:fontRef>
+        </p:style>
+        <p:txBody>
+          <a:bodyPr rtlCol="0" anchor="ctr"/>
+          <a:lstStyle/>
+          <a:p>
+            <a:pPr algn="ctr"/>
+          </a:p>
+        </p:txBody>
+      </p:sp>
+      <p:sp>
+        <p:nvSpPr>
+          <p:cNvPr id="17" name="Rectangle 16"/>
+          <p:cNvSpPr/>
+          <p:nvPr/>
+        </p:nvSpPr>
+        <p:spPr>
+          <a:xfrm>
+            <a:off x="8442742" y="580703"/>
+            <a:ext cx="2064494" cy="9525"/>
+          </a:xfrm>
+          <a:prstGeom prst="rect">
+            <a:avLst/>
+          </a:prstGeom>
+          <a:solidFill>
+            <a:srgbClr val="C0C0C0"/>
+          </a:solidFill>
+          <a:ln>
+            <a:noFill/>
+          </a:ln>
+          <a:effectLst/>
+        </p:spPr>
+        <p:style>
+          <a:lnRef idx="1">
+            <a:schemeClr val="accent1"/>
+          </a:lnRef>
+          <a:fillRef idx="3">
+            <a:schemeClr val="accent1"/>
+          </a:fillRef>
+          <a:effectRef idx="2">
+            <a:schemeClr val="accent1"/>
+          </a:effectRef>
+          <a:fontRef idx="minor">
+            <a:schemeClr val="lt1"/>
+          </a:fontRef>
+        </p:style>
+        <p:txBody>
+          <a:bodyPr rtlCol="0" anchor="ctr"/>
+          <a:lstStyle/>
+          <a:p>
+            <a:pPr algn="ctr"/>
+          </a:p>
+        </p:txBody>
+      </p:sp>
+      <p:sp>
+        <p:nvSpPr>
+          <p:cNvPr id="18" name="Rectangle 17"/>
+          <p:cNvSpPr/>
+          <p:nvPr/>
+        </p:nvSpPr>
+        <p:spPr>
+          <a:xfrm>
+            <a:off x="184762" y="2177970"/>
+            <a:ext cx="2064494" cy="9525"/>
+          </a:xfrm>
+          <a:prstGeom prst="rect">
+            <a:avLst/>
+          </a:prstGeom>
+          <a:solidFill>
+            <a:srgbClr val="C0C0C0"/>
+          </a:solidFill>
+          <a:ln>
+            <a:noFill/>
+          </a:ln>
+          <a:effectLst/>
+        </p:spPr>
+        <p:style>
+          <a:lnRef idx="1">
+            <a:schemeClr val="accent1"/>
+          </a:lnRef>
+          <a:fillRef idx="3">
+            <a:schemeClr val="accent1"/>
+          </a:fillRef>
+          <a:effectRef idx="2">
+            <a:schemeClr val="accent1"/>
+          </a:effectRef>
+          <a:fontRef idx="minor">
+            <a:schemeClr val="lt1"/>
+          </a:fontRef>
+        </p:style>
+        <p:txBody>
+          <a:bodyPr rtlCol="0" anchor="ctr"/>
+          <a:lstStyle/>
+          <a:p>
+            <a:pPr algn="ctr"/>
+          </a:p>
+        </p:txBody>
+      </p:sp>
+      <p:sp>
+        <p:nvSpPr>
+          <p:cNvPr id="19" name="Rectangle 18"/>
+          <p:cNvSpPr/>
+          <p:nvPr/>
+        </p:nvSpPr>
+        <p:spPr>
+          <a:xfrm>
+            <a:off x="2249257" y="2177970"/>
+            <a:ext cx="2064494" cy="9525"/>
+          </a:xfrm>
+          <a:prstGeom prst="rect">
+            <a:avLst/>
+          </a:prstGeom>
+          <a:solidFill>
+            <a:srgbClr val="C0C0C0"/>
+          </a:solidFill>
+          <a:ln>
+            <a:noFill/>
+          </a:ln>
+          <a:effectLst/>
+        </p:spPr>
+        <p:style>
+          <a:lnRef idx="1">
+            <a:schemeClr val="accent1"/>
+          </a:lnRef>
+          <a:fillRef idx="3">
+            <a:schemeClr val="accent1"/>
+          </a:fillRef>
+          <a:effectRef idx="2">
+            <a:schemeClr val="accent1"/>
+          </a:effectRef>
+          <a:fontRef idx="minor">
+            <a:schemeClr val="lt1"/>
+          </a:fontRef>
+        </p:style>
+        <p:txBody>
+          <a:bodyPr rtlCol="0" anchor="ctr"/>
+          <a:lstStyle/>
+          <a:p>
+            <a:pPr algn="ctr"/>
+          </a:p>
+        </p:txBody>
+      </p:sp>
+      <p:sp>
+        <p:nvSpPr>
+          <p:cNvPr id="20" name="Rectangle 19"/>
+          <p:cNvSpPr/>
+          <p:nvPr/>
+        </p:nvSpPr>
+        <p:spPr>
+          <a:xfrm>
+            <a:off x="4313752" y="2177970"/>
+            <a:ext cx="2064494" cy="9525"/>
+          </a:xfrm>
+          <a:prstGeom prst="rect">
+            <a:avLst/>
+          </a:prstGeom>
+          <a:solidFill>
+            <a:srgbClr val="C0C0C0"/>
+          </a:solidFill>
+          <a:ln>
+            <a:noFill/>
+          </a:ln>
+          <a:effectLst/>
+        </p:spPr>
+        <p:style>
+          <a:lnRef idx="1">
+            <a:schemeClr val="accent1"/>
+          </a:lnRef>
+          <a:fillRef idx="3">
+            <a:schemeClr val="accent1"/>
+          </a:fillRef>
+          <a:effectRef idx="2">
+            <a:schemeClr val="accent1"/>
+          </a:effectRef>
+          <a:fontRef idx="minor">
+            <a:schemeClr val="lt1"/>
+          </a:fontRef>
+        </p:style>
+        <p:txBody>
+          <a:bodyPr rtlCol="0" anchor="ctr"/>
+          <a:lstStyle/>
+          <a:p>
+            <a:pPr algn="ctr"/>
+          </a:p>
+        </p:txBody>
+      </p:sp>
+      <p:sp>
+        <p:nvSpPr>
+          <p:cNvPr id="21" name="Rectangle 20"/>
+          <p:cNvSpPr/>
+          <p:nvPr/>
+        </p:nvSpPr>
+        <p:spPr>
+          <a:xfrm>
+            <a:off x="6378247" y="2177970"/>
+            <a:ext cx="2064494" cy="9525"/>
+          </a:xfrm>
+          <a:prstGeom prst="rect">
+            <a:avLst/>
+          </a:prstGeom>
+          <a:solidFill>
+            <a:srgbClr val="C0C0C0"/>
+          </a:solidFill>
+          <a:ln>
+            <a:noFill/>
+          </a:ln>
+          <a:effectLst/>
+        </p:spPr>
+        <p:style>
+          <a:lnRef idx="1">
+            <a:schemeClr val="accent1"/>
+          </a:lnRef>
+          <a:fillRef idx="3">
+            <a:schemeClr val="accent1"/>
+          </a:fillRef>
+          <a:effectRef idx="2">
+            <a:schemeClr val="accent1"/>
+          </a:effectRef>
+          <a:fontRef idx="minor">
+            <a:schemeClr val="lt1"/>
+          </a:fontRef>
+        </p:style>
+        <p:txBody>
+          <a:bodyPr rtlCol="0" anchor="ctr"/>
+          <a:lstStyle/>
+          <a:p>
+            <a:pPr algn="ctr"/>
+          </a:p>
+        </p:txBody>
+      </p:sp>
+      <p:sp>
+        <p:nvSpPr>
+          <p:cNvPr id="22" name="Rectangle 21"/>
+          <p:cNvSpPr/>
+          <p:nvPr/>
+        </p:nvSpPr>
+        <p:spPr>
+          <a:xfrm>
+            <a:off x="8442742" y="2177970"/>
+            <a:ext cx="2064494" cy="9525"/>
+          </a:xfrm>
+          <a:prstGeom prst="rect">
+            <a:avLst/>
+          </a:prstGeom>
+          <a:solidFill>
+            <a:srgbClr val="C0C0C0"/>
+          </a:solidFill>
+          <a:ln>
+            <a:noFill/>
+          </a:ln>
+          <a:effectLst/>
+        </p:spPr>
+        <p:style>
+          <a:lnRef idx="1">
+            <a:schemeClr val="accent1"/>
+          </a:lnRef>
+          <a:fillRef idx="3">
+            <a:schemeClr val="accent1"/>
+          </a:fillRef>
+          <a:effectRef idx="2">
+            <a:schemeClr val="accent1"/>
+          </a:effectRef>
+          <a:fontRef idx="minor">
+            <a:schemeClr val="lt1"/>
+          </a:fontRef>
+        </p:style>
+        <p:txBody>
+          <a:bodyPr rtlCol="0" anchor="ctr"/>
+          <a:lstStyle/>
+          <a:p>
+            <a:pPr algn="ctr"/>
+          </a:p>
+        </p:txBody>
+      </p:sp>
+      <p:sp>
+        <p:nvSpPr>
+          <p:cNvPr id="23" name="Rectangle 22"/>
+          <p:cNvSpPr/>
+          <p:nvPr/>
+        </p:nvSpPr>
+        <p:spPr>
+          <a:xfrm>
+            <a:off x="184762" y="3775237"/>
+            <a:ext cx="2064494" cy="9525"/>
+          </a:xfrm>
+          <a:prstGeom prst="rect">
+            <a:avLst/>
+          </a:prstGeom>
+          <a:solidFill>
+            <a:srgbClr val="C0C0C0"/>
+          </a:solidFill>
+          <a:ln>
+            <a:noFill/>
+          </a:ln>
+          <a:effectLst/>
+        </p:spPr>
+        <p:style>
+          <a:lnRef idx="1">
+            <a:schemeClr val="accent1"/>
+          </a:lnRef>
+          <a:fillRef idx="3">
+            <a:schemeClr val="accent1"/>
+          </a:fillRef>
+          <a:effectRef idx="2">
+            <a:schemeClr val="accent1"/>
+          </a:effectRef>
+          <a:fontRef idx="minor">
+            <a:schemeClr val="lt1"/>
+          </a:fontRef>
+        </p:style>
+        <p:txBody>
+          <a:bodyPr rtlCol="0" anchor="ctr"/>
+          <a:lstStyle/>
+          <a:p>
+            <a:pPr algn="ctr"/>
+          </a:p>
+        </p:txBody>
+      </p:sp>
+      <p:sp>
+        <p:nvSpPr>
+          <p:cNvPr id="24" name="Rectangle 23"/>
+          <p:cNvSpPr/>
+          <p:nvPr/>
+        </p:nvSpPr>
+        <p:spPr>
+          <a:xfrm>
+            <a:off x="2249257" y="3775237"/>
+            <a:ext cx="2064494" cy="9525"/>
+          </a:xfrm>
+          <a:prstGeom prst="rect">
+            <a:avLst/>
+          </a:prstGeom>
+          <a:solidFill>
+            <a:srgbClr val="C0C0C0"/>
+          </a:solidFill>
+          <a:ln>
+            <a:noFill/>
+          </a:ln>
+          <a:effectLst/>
+        </p:spPr>
+        <p:style>
+          <a:lnRef idx="1">
+            <a:schemeClr val="accent1"/>
+          </a:lnRef>
+          <a:fillRef idx="3">
+            <a:schemeClr val="accent1"/>
+          </a:fillRef>
+          <a:effectRef idx="2">
+            <a:schemeClr val="accent1"/>
+          </a:effectRef>
+          <a:fontRef idx="minor">
+            <a:schemeClr val="lt1"/>
+          </a:fontRef>
+        </p:style>
+        <p:txBody>
+          <a:bodyPr rtlCol="0" anchor="ctr"/>
+          <a:lstStyle/>
+          <a:p>
+            <a:pPr algn="ctr"/>
+          </a:p>
+        </p:txBody>
+      </p:sp>
+      <p:sp>
+        <p:nvSpPr>
+          <p:cNvPr id="25" name="Rectangle 24"/>
+          <p:cNvSpPr/>
+          <p:nvPr/>
+        </p:nvSpPr>
+        <p:spPr>
+          <a:xfrm>
+            <a:off x="4313752" y="3775237"/>
+            <a:ext cx="2064494" cy="9525"/>
+          </a:xfrm>
+          <a:prstGeom prst="rect">
+            <a:avLst/>
+          </a:prstGeom>
+          <a:solidFill>
+            <a:srgbClr val="C0C0C0"/>
+          </a:solidFill>
+          <a:ln>
+            <a:noFill/>
+          </a:ln>
+          <a:effectLst/>
+        </p:spPr>
+        <p:style>
+          <a:lnRef idx="1">
+            <a:schemeClr val="accent1"/>
+          </a:lnRef>
+          <a:fillRef idx="3">
+            <a:schemeClr val="accent1"/>
+          </a:fillRef>
+          <a:effectRef idx="2">
+            <a:schemeClr val="accent1"/>
+          </a:effectRef>
+          <a:fontRef idx="minor">
+            <a:schemeClr val="lt1"/>
+          </a:fontRef>
+        </p:style>
+        <p:txBody>
+          <a:bodyPr rtlCol="0" anchor="ctr"/>
+          <a:lstStyle/>
+          <a:p>
+            <a:pPr algn="ctr"/>
+          </a:p>
+        </p:txBody>
+      </p:sp>
+      <p:sp>
+        <p:nvSpPr>
+          <p:cNvPr id="26" name="Rectangle 25"/>
+          <p:cNvSpPr/>
+          <p:nvPr/>
+        </p:nvSpPr>
+        <p:spPr>
+          <a:xfrm>
+            <a:off x="6378247" y="3775237"/>
+            <a:ext cx="2064494" cy="9525"/>
+          </a:xfrm>
+          <a:prstGeom prst="rect">
+            <a:avLst/>
+          </a:prstGeom>
+          <a:solidFill>
+            <a:srgbClr val="C0C0C0"/>
+          </a:solidFill>
+          <a:ln>
+            <a:noFill/>
+          </a:ln>
+          <a:effectLst/>
+        </p:spPr>
+        <p:style>
+          <a:lnRef idx="1">
+            <a:schemeClr val="accent1"/>
+          </a:lnRef>
+          <a:fillRef idx="3">
+            <a:schemeClr val="accent1"/>
+          </a:fillRef>
+          <a:effectRef idx="2">
+            <a:schemeClr val="accent1"/>
+          </a:effectRef>
+          <a:fontRef idx="minor">
+            <a:schemeClr val="lt1"/>
+          </a:fontRef>
+        </p:style>
+        <p:txBody>
+          <a:bodyPr rtlCol="0" anchor="ctr"/>
+          <a:lstStyle/>
+          <a:p>
+            <a:pPr algn="ctr"/>
+          </a:p>
+        </p:txBody>
+      </p:sp>
+      <p:sp>
+        <p:nvSpPr>
+          <p:cNvPr id="27" name="Rectangle 26"/>
+          <p:cNvSpPr/>
+          <p:nvPr/>
+        </p:nvSpPr>
+        <p:spPr>
+          <a:xfrm>
+            <a:off x="8442742" y="3775237"/>
+            <a:ext cx="2064494" cy="9525"/>
+          </a:xfrm>
+          <a:prstGeom prst="rect">
+            <a:avLst/>
+          </a:prstGeom>
+          <a:solidFill>
+            <a:srgbClr val="C0C0C0"/>
+          </a:solidFill>
+          <a:ln>
+            <a:noFill/>
+          </a:ln>
+          <a:effectLst/>
+        </p:spPr>
+        <p:style>
+          <a:lnRef idx="1">
+            <a:schemeClr val="accent1"/>
+          </a:lnRef>
+          <a:fillRef idx="3">
+            <a:schemeClr val="accent1"/>
+          </a:fillRef>
+          <a:effectRef idx="2">
+            <a:schemeClr val="accent1"/>
+          </a:effectRef>
+          <a:fontRef idx="minor">
+            <a:schemeClr val="lt1"/>
+          </a:fontRef>
+        </p:style>
+        <p:txBody>
+          <a:bodyPr rtlCol="0" anchor="ctr"/>
+          <a:lstStyle/>
+          <a:p>
+            <a:pPr algn="ctr"/>
+          </a:p>
+        </p:txBody>
+      </p:sp>
+      <p:sp>
+        <p:nvSpPr>
+          <p:cNvPr id="28" name="Rectangle 27"/>
+          <p:cNvSpPr/>
+          <p:nvPr/>
+        </p:nvSpPr>
+        <p:spPr>
+          <a:xfrm>
+            <a:off x="184762" y="5372504"/>
+            <a:ext cx="2064494" cy="9525"/>
+          </a:xfrm>
+          <a:prstGeom prst="rect">
+            <a:avLst/>
+          </a:prstGeom>
+          <a:solidFill>
+            <a:srgbClr val="C0C0C0"/>
+          </a:solidFill>
+          <a:ln>
+            <a:noFill/>
+          </a:ln>
+          <a:effectLst/>
+        </p:spPr>
+        <p:style>
+          <a:lnRef idx="1">
+            <a:schemeClr val="accent1"/>
+          </a:lnRef>
+          <a:fillRef idx="3">
+            <a:schemeClr val="accent1"/>
+          </a:fillRef>
+          <a:effectRef idx="2">
+            <a:schemeClr val="accent1"/>
+          </a:effectRef>
+          <a:fontRef idx="minor">
+            <a:schemeClr val="lt1"/>
+          </a:fontRef>
+        </p:style>
+        <p:txBody>
+          <a:bodyPr rtlCol="0" anchor="ctr"/>
+          <a:lstStyle/>
+          <a:p>
+            <a:pPr algn="ctr"/>
+          </a:p>
+        </p:txBody>
+      </p:sp>
+      <p:sp>
+        <p:nvSpPr>
+          <p:cNvPr id="29" name="Rectangle 28"/>
+          <p:cNvSpPr/>
+          <p:nvPr/>
+        </p:nvSpPr>
+        <p:spPr>
+          <a:xfrm>
+            <a:off x="180000" y="585465"/>
+            <a:ext cx="9525" cy="1597267"/>
+          </a:xfrm>
+          <a:prstGeom prst="rect">
+            <a:avLst/>
+          </a:prstGeom>
+          <a:solidFill>
+            <a:srgbClr val="C0C0C0"/>
+          </a:solidFill>
+          <a:ln>
+            <a:noFill/>
+          </a:ln>
+          <a:effectLst/>
+        </p:spPr>
+        <p:style>
+          <a:lnRef idx="1">
+            <a:schemeClr val="accent1"/>
+          </a:lnRef>
+          <a:fillRef idx="3">
+            <a:schemeClr val="accent1"/>
+          </a:fillRef>
+          <a:effectRef idx="2">
+            <a:schemeClr val="accent1"/>
+          </a:effectRef>
+          <a:fontRef idx="minor">
+            <a:schemeClr val="lt1"/>
+          </a:fontRef>
+        </p:style>
+        <p:txBody>
+          <a:bodyPr rtlCol="0" anchor="ctr"/>
+          <a:lstStyle/>
+          <a:p>
+            <a:pPr algn="ctr"/>
+          </a:p>
+        </p:txBody>
+      </p:sp>
+      <p:sp>
+        <p:nvSpPr>
+          <p:cNvPr id="30" name="Rectangle 29"/>
+          <p:cNvSpPr/>
+          <p:nvPr/>
+        </p:nvSpPr>
+        <p:spPr>
+          <a:xfrm>
+            <a:off x="180000" y="2182732"/>
+            <a:ext cx="9525" cy="1597267"/>
+          </a:xfrm>
+          <a:prstGeom prst="rect">
+            <a:avLst/>
+          </a:prstGeom>
+          <a:solidFill>
+            <a:srgbClr val="C0C0C0"/>
+          </a:solidFill>
+          <a:ln>
+            <a:noFill/>
+          </a:ln>
+          <a:effectLst/>
+        </p:spPr>
+        <p:style>
+          <a:lnRef idx="1">
+            <a:schemeClr val="accent1"/>
+          </a:lnRef>
+          <a:fillRef idx="3">
+            <a:schemeClr val="accent1"/>
+          </a:fillRef>
+          <a:effectRef idx="2">
+            <a:schemeClr val="accent1"/>
+          </a:effectRef>
+          <a:fontRef idx="minor">
+            <a:schemeClr val="lt1"/>
+          </a:fontRef>
+        </p:style>
+        <p:txBody>
+          <a:bodyPr rtlCol="0" anchor="ctr"/>
+          <a:lstStyle/>
+          <a:p>
+            <a:pPr algn="ctr"/>
+          </a:p>
+        </p:txBody>
+      </p:sp>
+      <p:sp>
+        <p:nvSpPr>
+          <p:cNvPr id="31" name="Rectangle 30"/>
+          <p:cNvSpPr/>
+          <p:nvPr/>
+        </p:nvSpPr>
+        <p:spPr>
+          <a:xfrm>
+            <a:off x="180000" y="3780000"/>
+            <a:ext cx="9525" cy="1597267"/>
+          </a:xfrm>
+          <a:prstGeom prst="rect">
+            <a:avLst/>
+          </a:prstGeom>
+          <a:solidFill>
+            <a:srgbClr val="C0C0C0"/>
+          </a:solidFill>
+          <a:ln>
+            <a:noFill/>
+          </a:ln>
+          <a:effectLst/>
+        </p:spPr>
+        <p:style>
+          <a:lnRef idx="1">
+            <a:schemeClr val="accent1"/>
+          </a:lnRef>
+          <a:fillRef idx="3">
+            <a:schemeClr val="accent1"/>
+          </a:fillRef>
+          <a:effectRef idx="2">
+            <a:schemeClr val="accent1"/>
+          </a:effectRef>
+          <a:fontRef idx="minor">
+            <a:schemeClr val="lt1"/>
+          </a:fontRef>
+        </p:style>
+        <p:txBody>
+          <a:bodyPr rtlCol="0" anchor="ctr"/>
+          <a:lstStyle/>
+          <a:p>
+            <a:pPr algn="ctr"/>
+          </a:p>
+        </p:txBody>
+      </p:sp>
+      <p:sp>
+        <p:nvSpPr>
+          <p:cNvPr id="32" name="Rectangle 31"/>
+          <p:cNvSpPr/>
+          <p:nvPr/>
+        </p:nvSpPr>
+        <p:spPr>
+          <a:xfrm>
+            <a:off x="2244495" y="585465"/>
+            <a:ext cx="9525" cy="1597267"/>
+          </a:xfrm>
+          <a:prstGeom prst="rect">
+            <a:avLst/>
+          </a:prstGeom>
+          <a:solidFill>
+            <a:srgbClr val="C0C0C0"/>
+          </a:solidFill>
+          <a:ln>
+            <a:noFill/>
+          </a:ln>
+          <a:effectLst/>
+        </p:spPr>
+        <p:style>
+          <a:lnRef idx="1">
+            <a:schemeClr val="accent1"/>
+          </a:lnRef>
+          <a:fillRef idx="3">
+            <a:schemeClr val="accent1"/>
+          </a:fillRef>
+          <a:effectRef idx="2">
+            <a:schemeClr val="accent1"/>
+          </a:effectRef>
+          <a:fontRef idx="minor">
+            <a:schemeClr val="lt1"/>
+          </a:fontRef>
+        </p:style>
+        <p:txBody>
+          <a:bodyPr rtlCol="0" anchor="ctr"/>
+          <a:lstStyle/>
+          <a:p>
+            <a:pPr algn="ctr"/>
+          </a:p>
+        </p:txBody>
+      </p:sp>
+      <p:sp>
+        <p:nvSpPr>
+          <p:cNvPr id="33" name="Rectangle 32"/>
+          <p:cNvSpPr/>
+          <p:nvPr/>
+        </p:nvSpPr>
+        <p:spPr>
+          <a:xfrm>
+            <a:off x="2244495" y="2182732"/>
+            <a:ext cx="9525" cy="1597267"/>
+          </a:xfrm>
+          <a:prstGeom prst="rect">
+            <a:avLst/>
+          </a:prstGeom>
+          <a:solidFill>
+            <a:srgbClr val="C0C0C0"/>
+          </a:solidFill>
+          <a:ln>
+            <a:noFill/>
+          </a:ln>
+          <a:effectLst/>
+        </p:spPr>
+        <p:style>
+          <a:lnRef idx="1">
+            <a:schemeClr val="accent1"/>
+          </a:lnRef>
+          <a:fillRef idx="3">
+            <a:schemeClr val="accent1"/>
+          </a:fillRef>
+          <a:effectRef idx="2">
+            <a:schemeClr val="accent1"/>
+          </a:effectRef>
+          <a:fontRef idx="minor">
+            <a:schemeClr val="lt1"/>
+          </a:fontRef>
+        </p:style>
+        <p:txBody>
+          <a:bodyPr rtlCol="0" anchor="ctr"/>
+          <a:lstStyle/>
+          <a:p>
+            <a:pPr algn="ctr"/>
+          </a:p>
+        </p:txBody>
+      </p:sp>
+      <p:sp>
+        <p:nvSpPr>
+          <p:cNvPr id="34" name="Rectangle 33"/>
+          <p:cNvSpPr/>
+          <p:nvPr/>
+        </p:nvSpPr>
+        <p:spPr>
+          <a:xfrm>
+            <a:off x="2244495" y="3780000"/>
+            <a:ext cx="9525" cy="1597267"/>
+          </a:xfrm>
+          <a:prstGeom prst="rect">
+            <a:avLst/>
+          </a:prstGeom>
+          <a:solidFill>
+            <a:srgbClr val="C0C0C0"/>
+          </a:solidFill>
+          <a:ln>
+            <a:noFill/>
+          </a:ln>
+          <a:effectLst/>
+        </p:spPr>
+        <p:style>
+          <a:lnRef idx="1">
+            <a:schemeClr val="accent1"/>
+          </a:lnRef>
+          <a:fillRef idx="3">
+            <a:schemeClr val="accent1"/>
+          </a:fillRef>
+          <a:effectRef idx="2">
+            <a:schemeClr val="accent1"/>
+          </a:effectRef>
+          <a:fontRef idx="minor">
+            <a:schemeClr val="lt1"/>
+          </a:fontRef>
+        </p:style>
+        <p:txBody>
+          <a:bodyPr rtlCol="0" anchor="ctr"/>
+          <a:lstStyle/>
+          <a:p>
+            <a:pPr algn="ctr"/>
+          </a:p>
+        </p:txBody>
+      </p:sp>
+      <p:sp>
+        <p:nvSpPr>
+          <p:cNvPr id="35" name="Rectangle 34"/>
+          <p:cNvSpPr/>
+          <p:nvPr/>
+        </p:nvSpPr>
+        <p:spPr>
+          <a:xfrm>
+            <a:off x="4308990" y="585465"/>
+            <a:ext cx="9525" cy="1597267"/>
+          </a:xfrm>
+          <a:prstGeom prst="rect">
+            <a:avLst/>
+          </a:prstGeom>
+          <a:solidFill>
+            <a:srgbClr val="C0C0C0"/>
+          </a:solidFill>
+          <a:ln>
+            <a:noFill/>
+          </a:ln>
+          <a:effectLst/>
+        </p:spPr>
+        <p:style>
+          <a:lnRef idx="1">
+            <a:schemeClr val="accent1"/>
+          </a:lnRef>
+          <a:fillRef idx="3">
+            <a:schemeClr val="accent1"/>
+          </a:fillRef>
+          <a:effectRef idx="2">
+            <a:schemeClr val="accent1"/>
+          </a:effectRef>
+          <a:fontRef idx="minor">
+            <a:schemeClr val="lt1"/>
+          </a:fontRef>
+        </p:style>
+        <p:txBody>
+          <a:bodyPr rtlCol="0" anchor="ctr"/>
+          <a:lstStyle/>
+          <a:p>
+            <a:pPr algn="ctr"/>
+          </a:p>
+        </p:txBody>
+      </p:sp>
+      <p:sp>
+        <p:nvSpPr>
+          <p:cNvPr id="36" name="Rectangle 35"/>
+          <p:cNvSpPr/>
+          <p:nvPr/>
+        </p:nvSpPr>
+        <p:spPr>
+          <a:xfrm>
+            <a:off x="4308990" y="2182732"/>
+            <a:ext cx="9525" cy="1597267"/>
+          </a:xfrm>
+          <a:prstGeom prst="rect">
+            <a:avLst/>
+          </a:prstGeom>
+          <a:solidFill>
+            <a:srgbClr val="C0C0C0"/>
+          </a:solidFill>
+          <a:ln>
+            <a:noFill/>
+          </a:ln>
+          <a:effectLst/>
+        </p:spPr>
+        <p:style>
+          <a:lnRef idx="1">
+            <a:schemeClr val="accent1"/>
+          </a:lnRef>
+          <a:fillRef idx="3">
+            <a:schemeClr val="accent1"/>
+          </a:fillRef>
+          <a:effectRef idx="2">
+            <a:schemeClr val="accent1"/>
+          </a:effectRef>
+          <a:fontRef idx="minor">
+            <a:schemeClr val="lt1"/>
+          </a:fontRef>
+        </p:style>
+        <p:txBody>
+          <a:bodyPr rtlCol="0" anchor="ctr"/>
+          <a:lstStyle/>
+          <a:p>
+            <a:pPr algn="ctr"/>
+          </a:p>
+        </p:txBody>
+      </p:sp>
+      <p:sp>
+        <p:nvSpPr>
+          <p:cNvPr id="37" name="Rectangle 36"/>
+          <p:cNvSpPr/>
+          <p:nvPr/>
+        </p:nvSpPr>
+        <p:spPr>
+          <a:xfrm>
+            <a:off x="6373485" y="585465"/>
+            <a:ext cx="9525" cy="1597267"/>
+          </a:xfrm>
+          <a:prstGeom prst="rect">
+            <a:avLst/>
+          </a:prstGeom>
+          <a:solidFill>
+            <a:srgbClr val="C0C0C0"/>
+          </a:solidFill>
+          <a:ln>
+            <a:noFill/>
+          </a:ln>
+          <a:effectLst/>
+        </p:spPr>
+        <p:style>
+          <a:lnRef idx="1">
+            <a:schemeClr val="accent1"/>
+          </a:lnRef>
+          <a:fillRef idx="3">
+            <a:schemeClr val="accent1"/>
+          </a:fillRef>
+          <a:effectRef idx="2">
+            <a:schemeClr val="accent1"/>
+          </a:effectRef>
+          <a:fontRef idx="minor">
+            <a:schemeClr val="lt1"/>
+          </a:fontRef>
+        </p:style>
+        <p:txBody>
+          <a:bodyPr rtlCol="0" anchor="ctr"/>
+          <a:lstStyle/>
+          <a:p>
+            <a:pPr algn="ctr"/>
+          </a:p>
+        </p:txBody>
+      </p:sp>
+      <p:sp>
+        <p:nvSpPr>
+          <p:cNvPr id="38" name="Rectangle 37"/>
+          <p:cNvSpPr/>
+          <p:nvPr/>
+        </p:nvSpPr>
+        <p:spPr>
+          <a:xfrm>
+            <a:off x="6373485" y="2182732"/>
+            <a:ext cx="9525" cy="1597267"/>
+          </a:xfrm>
+          <a:prstGeom prst="rect">
+            <a:avLst/>
+          </a:prstGeom>
+          <a:solidFill>
+            <a:srgbClr val="C0C0C0"/>
+          </a:solidFill>
+          <a:ln>
+            <a:noFill/>
+          </a:ln>
+          <a:effectLst/>
+        </p:spPr>
+        <p:style>
+          <a:lnRef idx="1">
+            <a:schemeClr val="accent1"/>
+          </a:lnRef>
+          <a:fillRef idx="3">
+            <a:schemeClr val="accent1"/>
+          </a:fillRef>
+          <a:effectRef idx="2">
+            <a:schemeClr val="accent1"/>
+          </a:effectRef>
+          <a:fontRef idx="minor">
+            <a:schemeClr val="lt1"/>
+          </a:fontRef>
+        </p:style>
+        <p:txBody>
+          <a:bodyPr rtlCol="0" anchor="ctr"/>
+          <a:lstStyle/>
+          <a:p>
+            <a:pPr algn="ctr"/>
+          </a:p>
+        </p:txBody>
+      </p:sp>
+      <p:sp>
+        <p:nvSpPr>
+          <p:cNvPr id="39" name="Rectangle 38"/>
+          <p:cNvSpPr/>
+          <p:nvPr/>
+        </p:nvSpPr>
+        <p:spPr>
+          <a:xfrm>
+            <a:off x="8437980" y="585465"/>
+            <a:ext cx="9525" cy="1597267"/>
+          </a:xfrm>
+          <a:prstGeom prst="rect">
+            <a:avLst/>
+          </a:prstGeom>
+          <a:solidFill>
+            <a:srgbClr val="C0C0C0"/>
+          </a:solidFill>
+          <a:ln>
+            <a:noFill/>
+          </a:ln>
+          <a:effectLst/>
+        </p:spPr>
+        <p:style>
+          <a:lnRef idx="1">
+            <a:schemeClr val="accent1"/>
+          </a:lnRef>
+          <a:fillRef idx="3">
+            <a:schemeClr val="accent1"/>
+          </a:fillRef>
+          <a:effectRef idx="2">
+            <a:schemeClr val="accent1"/>
+          </a:effectRef>
+          <a:fontRef idx="minor">
+            <a:schemeClr val="lt1"/>
+          </a:fontRef>
+        </p:style>
+        <p:txBody>
+          <a:bodyPr rtlCol="0" anchor="ctr"/>
+          <a:lstStyle/>
+          <a:p>
+            <a:pPr algn="ctr"/>
+          </a:p>
+        </p:txBody>
+      </p:sp>
+      <p:sp>
+        <p:nvSpPr>
+          <p:cNvPr id="40" name="Rectangle 39"/>
+          <p:cNvSpPr/>
+          <p:nvPr/>
+        </p:nvSpPr>
+        <p:spPr>
+          <a:xfrm>
+            <a:off x="8437980" y="2182732"/>
+            <a:ext cx="9525" cy="1597267"/>
+          </a:xfrm>
+          <a:prstGeom prst="rect">
+            <a:avLst/>
+          </a:prstGeom>
+          <a:solidFill>
+            <a:srgbClr val="C0C0C0"/>
+          </a:solidFill>
+          <a:ln>
+            <a:noFill/>
+          </a:ln>
+          <a:effectLst/>
+        </p:spPr>
+        <p:style>
+          <a:lnRef idx="1">
+            <a:schemeClr val="accent1"/>
+          </a:lnRef>
+          <a:fillRef idx="3">
+            <a:schemeClr val="accent1"/>
+          </a:fillRef>
+          <a:effectRef idx="2">
+            <a:schemeClr val="accent1"/>
+          </a:effectRef>
+          <a:fontRef idx="minor">
+            <a:schemeClr val="lt1"/>
+          </a:fontRef>
+        </p:style>
+        <p:txBody>
+          <a:bodyPr rtlCol="0" anchor="ctr"/>
+          <a:lstStyle/>
+          <a:p>
+            <a:pPr algn="ctr"/>
+          </a:p>
+        </p:txBody>
+      </p:sp>
+      <p:sp>
+        <p:nvSpPr>
+          <p:cNvPr id="41" name="Rectangle 40"/>
+          <p:cNvSpPr/>
+          <p:nvPr/>
+        </p:nvSpPr>
+        <p:spPr>
+          <a:xfrm>
+            <a:off x="10502475" y="585465"/>
+            <a:ext cx="9525" cy="1597267"/>
+          </a:xfrm>
+          <a:prstGeom prst="rect">
+            <a:avLst/>
+          </a:prstGeom>
+          <a:solidFill>
+            <a:srgbClr val="C0C0C0"/>
+          </a:solidFill>
+          <a:ln>
+            <a:noFill/>
+          </a:ln>
+          <a:effectLst/>
+        </p:spPr>
+        <p:style>
+          <a:lnRef idx="1">
+            <a:schemeClr val="accent1"/>
+          </a:lnRef>
+          <a:fillRef idx="3">
+            <a:schemeClr val="accent1"/>
+          </a:fillRef>
+          <a:effectRef idx="2">
+            <a:schemeClr val="accent1"/>
+          </a:effectRef>
+          <a:fontRef idx="minor">
+            <a:schemeClr val="lt1"/>
+          </a:fontRef>
+        </p:style>
+        <p:txBody>
+          <a:bodyPr rtlCol="0" anchor="ctr"/>
+          <a:lstStyle/>
+          <a:p>
+            <a:pPr algn="ctr"/>
+          </a:p>
+        </p:txBody>
+      </p:sp>
+      <p:sp>
+        <p:nvSpPr>
+          <p:cNvPr id="42" name="Rectangle 41"/>
+          <p:cNvSpPr/>
+          <p:nvPr/>
+        </p:nvSpPr>
+        <p:spPr>
+          <a:xfrm>
+            <a:off x="10502475" y="2182732"/>
+            <a:ext cx="9525" cy="1597267"/>
+          </a:xfrm>
+          <a:prstGeom prst="rect">
+            <a:avLst/>
+          </a:prstGeom>
+          <a:solidFill>
+            <a:srgbClr val="C0C0C0"/>
+          </a:solidFill>
+          <a:ln>
+            <a:noFill/>
+          </a:ln>
+          <a:effectLst/>
+        </p:spPr>
+        <p:style>
+          <a:lnRef idx="1">
+            <a:schemeClr val="accent1"/>
+          </a:lnRef>
+          <a:fillRef idx="3">
+            <a:schemeClr val="accent1"/>
+          </a:fillRef>
+          <a:effectRef idx="2">
+            <a:schemeClr val="accent1"/>
+          </a:effectRef>
+          <a:fontRef idx="minor">
+            <a:schemeClr val="lt1"/>
+          </a:fontRef>
+        </p:style>
+        <p:txBody>
+          <a:bodyPr rtlCol="0" anchor="ctr"/>
+          <a:lstStyle/>
+          <a:p>
+            <a:pPr algn="ctr"/>
+          </a:p>
+        </p:txBody>
+      </p:sp>
+    </p:spTree>
+  </p:cSld>
+  <p:clrMapOvr>
+    <a:masterClrMapping/>
+  </p:clrMapOvr>
+</p:sld>
+</file>
+
+<file path=ppt/slides/slide4.xml><?xml version="1.0" encoding="utf-8"?>
+<p:sld xmlns:a="http://schemas.openxmlformats.org/drawingml/2006/main" xmlns:p="http://schemas.openxmlformats.org/presentationml/2006/main" xmlns:r="http://schemas.openxmlformats.org/officeDocument/2006/relationships">
+  <p:cSld>
+    <p:spTree>
+      <p:nvGrpSpPr>
+        <p:cNvPr id="1" name=""/>
+        <p:cNvGrpSpPr/>
+        <p:nvPr/>
+      </p:nvGrpSpPr>
+      <p:grpSpPr/>
+      <p:sp>
+        <p:nvSpPr>
+          <p:cNvPr id="2" name="Rectangle 1"/>
+          <p:cNvSpPr/>
+          <p:nvPr/>
+        </p:nvSpPr>
+        <p:spPr>
+          <a:xfrm>
+            <a:off x="184762" y="585465"/>
+            <a:ext cx="2064494" cy="1597267"/>
+          </a:xfrm>
+          <a:prstGeom prst="rect">
+            <a:avLst/>
+          </a:prstGeom>
+          <a:noFill/>
+          <a:ln>
+            <a:noFill/>
+          </a:ln>
+          <a:effectLst/>
+        </p:spPr>
+        <p:style>
+          <a:lnRef idx="1">
+            <a:schemeClr val="accent1"/>
+          </a:lnRef>
+          <a:fillRef idx="3">
+            <a:schemeClr val="accent1"/>
+          </a:fillRef>
+          <a:effectRef idx="2">
+            <a:schemeClr val="accent1"/>
+          </a:effectRef>
+          <a:fontRef idx="minor">
+            <a:schemeClr val="lt1"/>
+          </a:fontRef>
+        </p:style>
+        <p:txBody>
+          <a:bodyPr rtlCol="0" anchor="t" wrap="square" lIns="72438" rIns="72438" tIns="57950" bIns="57950"/>
+          <a:lstStyle/>
+          <a:p>
+            <a:pPr algn="ctr">
+              <a:spcBef>
+                <a:spcPts val="0"/>
+              </a:spcBef>
+              <a:spcAft>
+                <a:spcPts val="0"/>
+              </a:spcAft>
+            </a:pPr>
+            <a:r>
+              <a:rPr sz="2000" b="1">
+                <a:solidFill>
+                  <a:srgbClr val="1A1A1A"/>
+                </a:solidFill>
+                <a:latin typeface="Arial"/>
+              </a:rPr>
+              <a:t>*кошатниц</a:t>
+            </a:r>
+          </a:p>
+        </p:txBody>
+      </p:sp>
+      <p:sp>
+        <p:nvSpPr>
+          <p:cNvPr id="3" name="Rectangle 2"/>
+          <p:cNvSpPr/>
+          <p:nvPr/>
+        </p:nvSpPr>
+        <p:spPr>
+          <a:xfrm>
+            <a:off x="2249257" y="585465"/>
+            <a:ext cx="2064494" cy="1597267"/>
+          </a:xfrm>
+          <a:prstGeom prst="rect">
+            <a:avLst/>
+          </a:prstGeom>
+          <a:noFill/>
+          <a:ln>
+            <a:noFill/>
+          </a:ln>
+          <a:effectLst/>
+        </p:spPr>
+        <p:style>
+          <a:lnRef idx="1">
+            <a:schemeClr val="accent1"/>
+          </a:lnRef>
+          <a:fillRef idx="3">
+            <a:schemeClr val="accent1"/>
+          </a:fillRef>
+          <a:effectRef idx="2">
+            <a:schemeClr val="accent1"/>
+          </a:effectRef>
+          <a:fontRef idx="minor">
+            <a:schemeClr val="lt1"/>
+          </a:fontRef>
+        </p:style>
+        <p:txBody>
+          <a:bodyPr rtlCol="0" anchor="t" wrap="square" lIns="72438" rIns="72438" tIns="57950" bIns="57950"/>
+          <a:lstStyle/>
+          <a:p>
+            <a:pPr algn="ctr">
+              <a:spcBef>
+                <a:spcPts val="0"/>
+              </a:spcBef>
+              <a:spcAft>
+                <a:spcPts val="0"/>
+              </a:spcAft>
+            </a:pPr>
+            <a:r>
+              <a:rPr sz="2000" b="1">
+                <a:solidFill>
+                  <a:srgbClr val="1A1A1A"/>
+                </a:solidFill>
+                <a:latin typeface="Arial"/>
+              </a:rPr>
+              <a:t>*собачников</a:t>
+            </a:r>
+          </a:p>
+        </p:txBody>
+      </p:sp>
+      <p:sp>
+        <p:nvSpPr>
+          <p:cNvPr id="4" name="Rectangle 3"/>
+          <p:cNvSpPr/>
+          <p:nvPr/>
+        </p:nvSpPr>
+        <p:spPr>
+          <a:xfrm>
+            <a:off x="4313752" y="585465"/>
+            <a:ext cx="2064494" cy="1597267"/>
+          </a:xfrm>
+          <a:prstGeom prst="rect">
+            <a:avLst/>
+          </a:prstGeom>
+          <a:noFill/>
+          <a:ln>
+            <a:noFill/>
+          </a:ln>
+          <a:effectLst/>
+        </p:spPr>
+        <p:style>
+          <a:lnRef idx="1">
+            <a:schemeClr val="accent1"/>
+          </a:lnRef>
+          <a:fillRef idx="3">
+            <a:schemeClr val="accent1"/>
+          </a:fillRef>
+          <a:effectRef idx="2">
+            <a:schemeClr val="accent1"/>
+          </a:effectRef>
+          <a:fontRef idx="minor">
+            <a:schemeClr val="lt1"/>
+          </a:fontRef>
+        </p:style>
+        <p:txBody>
+          <a:bodyPr rtlCol="0" anchor="t" wrap="square" lIns="72438" rIns="72438" tIns="57950" bIns="57950"/>
+          <a:lstStyle/>
+          <a:p>
+            <a:pPr algn="ctr">
+              <a:spcBef>
+                <a:spcPts val="0"/>
+              </a:spcBef>
+              <a:spcAft>
+                <a:spcPts val="0"/>
+              </a:spcAft>
+            </a:pPr>
+            <a:r>
+              <a:rPr sz="2000" b="1">
+                <a:solidFill>
+                  <a:srgbClr val="1A1A1A"/>
+                </a:solidFill>
+                <a:latin typeface="Arial"/>
+              </a:rPr>
+              <a:t>чемпионов френдзоны</a:t>
+            </a:r>
+          </a:p>
+        </p:txBody>
+      </p:sp>
+      <p:sp>
+        <p:nvSpPr>
+          <p:cNvPr id="5" name="Rectangle 4"/>
+          <p:cNvSpPr/>
+          <p:nvPr/>
+        </p:nvSpPr>
+        <p:spPr>
+          <a:xfrm>
+            <a:off x="6378247" y="585465"/>
+            <a:ext cx="2064494" cy="1597267"/>
+          </a:xfrm>
+          <a:prstGeom prst="rect">
+            <a:avLst/>
+          </a:prstGeom>
+          <a:noFill/>
+          <a:ln>
+            <a:noFill/>
+          </a:ln>
+          <a:effectLst/>
+        </p:spPr>
+        <p:style>
+          <a:lnRef idx="1">
+            <a:schemeClr val="accent1"/>
+          </a:lnRef>
+          <a:fillRef idx="3">
+            <a:schemeClr val="accent1"/>
+          </a:fillRef>
+          <a:effectRef idx="2">
+            <a:schemeClr val="accent1"/>
+          </a:effectRef>
+          <a:fontRef idx="minor">
+            <a:schemeClr val="lt1"/>
+          </a:fontRef>
+        </p:style>
+        <p:txBody>
+          <a:bodyPr rtlCol="0" anchor="t" wrap="square" lIns="72438" rIns="72438" tIns="57950" bIns="57950"/>
+          <a:lstStyle/>
+          <a:p>
+            <a:pPr algn="ctr">
+              <a:spcBef>
+                <a:spcPts val="0"/>
+              </a:spcBef>
+              <a:spcAft>
+                <a:spcPts val="0"/>
+              </a:spcAft>
+            </a:pPr>
+            <a:r>
+              <a:rPr sz="2000" b="1">
+                <a:solidFill>
+                  <a:srgbClr val="1A1A1A"/>
+                </a:solidFill>
+                <a:latin typeface="Arial"/>
+              </a:rPr>
+              <a:t>алкашей</a:t>
+            </a:r>
+          </a:p>
+        </p:txBody>
+      </p:sp>
+      <p:sp>
+        <p:nvSpPr>
+          <p:cNvPr id="6" name="Rectangle 5"/>
+          <p:cNvSpPr/>
+          <p:nvPr/>
+        </p:nvSpPr>
+        <p:spPr>
+          <a:xfrm>
+            <a:off x="8442742" y="585465"/>
+            <a:ext cx="2064494" cy="1597267"/>
+          </a:xfrm>
+          <a:prstGeom prst="rect">
+            <a:avLst/>
+          </a:prstGeom>
+          <a:noFill/>
+          <a:ln>
+            <a:noFill/>
+          </a:ln>
+          <a:effectLst/>
+        </p:spPr>
+        <p:style>
+          <a:lnRef idx="1">
+            <a:schemeClr val="accent1"/>
+          </a:lnRef>
+          <a:fillRef idx="3">
+            <a:schemeClr val="accent1"/>
+          </a:fillRef>
+          <a:effectRef idx="2">
+            <a:schemeClr val="accent1"/>
+          </a:effectRef>
+          <a:fontRef idx="minor">
+            <a:schemeClr val="lt1"/>
+          </a:fontRef>
+        </p:style>
+        <p:txBody>
+          <a:bodyPr rtlCol="0" anchor="t" wrap="square" lIns="72438" rIns="72438" tIns="57950" bIns="57950"/>
+          <a:lstStyle/>
+          <a:p>
+            <a:pPr algn="ctr">
+              <a:spcBef>
+                <a:spcPts val="0"/>
+              </a:spcBef>
+              <a:spcAft>
+                <a:spcPts val="0"/>
+              </a:spcAft>
+            </a:pPr>
+            <a:r>
+              <a:rPr sz="2000" b="1">
+                <a:solidFill>
+                  <a:srgbClr val="1A1A1A"/>
+                </a:solidFill>
+                <a:latin typeface="Arial"/>
+              </a:rPr>
+              <a:t>*бабок у подъезда</a:t>
+            </a:r>
+          </a:p>
+        </p:txBody>
+      </p:sp>
+      <p:sp>
+        <p:nvSpPr>
+          <p:cNvPr id="7" name="Rectangle 6"/>
+          <p:cNvSpPr/>
+          <p:nvPr/>
+        </p:nvSpPr>
+        <p:spPr>
+          <a:xfrm>
+            <a:off x="184762" y="2182732"/>
+            <a:ext cx="2064494" cy="1597267"/>
+          </a:xfrm>
+          <a:prstGeom prst="rect">
+            <a:avLst/>
+          </a:prstGeom>
+          <a:noFill/>
+          <a:ln>
+            <a:noFill/>
+          </a:ln>
+          <a:effectLst/>
+        </p:spPr>
+        <p:style>
+          <a:lnRef idx="1">
+            <a:schemeClr val="accent1"/>
+          </a:lnRef>
+          <a:fillRef idx="3">
+            <a:schemeClr val="accent1"/>
+          </a:fillRef>
+          <a:effectRef idx="2">
+            <a:schemeClr val="accent1"/>
+          </a:effectRef>
+          <a:fontRef idx="minor">
+            <a:schemeClr val="lt1"/>
+          </a:fontRef>
+        </p:style>
+        <p:txBody>
+          <a:bodyPr rtlCol="0" anchor="t" wrap="square" lIns="72438" rIns="72438" tIns="57950" bIns="57950"/>
+          <a:lstStyle/>
+          <a:p>
+            <a:pPr algn="ctr">
+              <a:spcBef>
+                <a:spcPts val="0"/>
+              </a:spcBef>
+              <a:spcAft>
+                <a:spcPts val="0"/>
+              </a:spcAft>
+            </a:pPr>
+            <a:r>
+              <a:rPr sz="2000" b="1">
+                <a:solidFill>
+                  <a:srgbClr val="1A1A1A"/>
+                </a:solidFill>
+                <a:latin typeface="Arial"/>
+              </a:rPr>
+              <a:t>*качков</a:t>
+            </a:r>
+          </a:p>
+        </p:txBody>
+      </p:sp>
+      <p:sp>
+        <p:nvSpPr>
+          <p:cNvPr id="8" name="Rectangle 7"/>
+          <p:cNvSpPr/>
+          <p:nvPr/>
+        </p:nvSpPr>
+        <p:spPr>
+          <a:xfrm>
+            <a:off x="2249257" y="2182732"/>
+            <a:ext cx="2064494" cy="1597267"/>
+          </a:xfrm>
+          <a:prstGeom prst="rect">
+            <a:avLst/>
+          </a:prstGeom>
+          <a:noFill/>
+          <a:ln>
+            <a:noFill/>
+          </a:ln>
+          <a:effectLst/>
+        </p:spPr>
+        <p:style>
+          <a:lnRef idx="1">
+            <a:schemeClr val="accent1"/>
+          </a:lnRef>
+          <a:fillRef idx="3">
+            <a:schemeClr val="accent1"/>
+          </a:fillRef>
+          <a:effectRef idx="2">
+            <a:schemeClr val="accent1"/>
+          </a:effectRef>
+          <a:fontRef idx="minor">
+            <a:schemeClr val="lt1"/>
+          </a:fontRef>
+        </p:style>
+        <p:txBody>
+          <a:bodyPr rtlCol="0" anchor="t" wrap="square" lIns="72438" rIns="72438" tIns="57950" bIns="57950"/>
+          <a:lstStyle/>
+          <a:p>
+            <a:pPr algn="ctr">
+              <a:spcBef>
+                <a:spcPts val="0"/>
+              </a:spcBef>
+              <a:spcAft>
+                <a:spcPts val="0"/>
+              </a:spcAft>
+            </a:pPr>
+            <a:r>
+              <a:rPr sz="2000" b="1">
+                <a:solidFill>
+                  <a:srgbClr val="1A1A1A"/>
+                </a:solidFill>
+                <a:latin typeface="Arial"/>
+              </a:rPr>
+              <a:t>вахтёров женской общаги</a:t>
+            </a:r>
+          </a:p>
+        </p:txBody>
+      </p:sp>
+      <p:sp>
+        <p:nvSpPr>
+          <p:cNvPr id="9" name="Rectangle 8"/>
+          <p:cNvSpPr/>
+          <p:nvPr/>
+        </p:nvSpPr>
+        <p:spPr>
+          <a:xfrm>
+            <a:off x="4313752" y="2182732"/>
+            <a:ext cx="2064494" cy="1597267"/>
+          </a:xfrm>
+          <a:prstGeom prst="rect">
+            <a:avLst/>
+          </a:prstGeom>
+          <a:noFill/>
+          <a:ln>
+            <a:noFill/>
+          </a:ln>
+          <a:effectLst/>
+        </p:spPr>
+        <p:style>
+          <a:lnRef idx="1">
+            <a:schemeClr val="accent1"/>
+          </a:lnRef>
+          <a:fillRef idx="3">
+            <a:schemeClr val="accent1"/>
+          </a:fillRef>
+          <a:effectRef idx="2">
+            <a:schemeClr val="accent1"/>
+          </a:effectRef>
+          <a:fontRef idx="minor">
+            <a:schemeClr val="lt1"/>
+          </a:fontRef>
+        </p:style>
+        <p:txBody>
+          <a:bodyPr rtlCol="0" anchor="t" wrap="square" lIns="72438" rIns="72438" tIns="57950" bIns="57950"/>
+          <a:lstStyle/>
+          <a:p>
+            <a:pPr algn="ctr">
+              <a:spcBef>
+                <a:spcPts val="0"/>
+              </a:spcBef>
+              <a:spcAft>
+                <a:spcPts val="0"/>
+              </a:spcAft>
+            </a:pPr>
+            <a:r>
+              <a:rPr sz="2000" b="1">
+                <a:solidFill>
+                  <a:srgbClr val="1A1A1A"/>
+                </a:solidFill>
+                <a:latin typeface="Arial"/>
+              </a:rPr>
+              <a:t>*душнил</a:t>
+            </a:r>
+          </a:p>
+        </p:txBody>
+      </p:sp>
+      <p:sp>
+        <p:nvSpPr>
+          <p:cNvPr id="10" name="Rectangle 9"/>
+          <p:cNvSpPr/>
+          <p:nvPr/>
+        </p:nvSpPr>
+        <p:spPr>
+          <a:xfrm>
+            <a:off x="6378247" y="2182732"/>
+            <a:ext cx="2064494" cy="1597267"/>
+          </a:xfrm>
+          <a:prstGeom prst="rect">
+            <a:avLst/>
+          </a:prstGeom>
+          <a:noFill/>
+          <a:ln>
+            <a:noFill/>
+          </a:ln>
+          <a:effectLst/>
+        </p:spPr>
+        <p:style>
+          <a:lnRef idx="1">
+            <a:schemeClr val="accent1"/>
+          </a:lnRef>
+          <a:fillRef idx="3">
+            <a:schemeClr val="accent1"/>
+          </a:fillRef>
+          <a:effectRef idx="2">
+            <a:schemeClr val="accent1"/>
+          </a:effectRef>
+          <a:fontRef idx="minor">
+            <a:schemeClr val="lt1"/>
+          </a:fontRef>
+        </p:style>
+        <p:txBody>
+          <a:bodyPr rtlCol="0" anchor="t" wrap="square" lIns="72438" rIns="72438" tIns="57950" bIns="57950"/>
+          <a:lstStyle/>
+          <a:p>
+            <a:pPr algn="ctr">
+              <a:spcBef>
+                <a:spcPts val="0"/>
+              </a:spcBef>
+              <a:spcAft>
+                <a:spcPts val="0"/>
+              </a:spcAft>
+            </a:pPr>
+            <a:r>
+              <a:rPr sz="2000" b="1">
+                <a:solidFill>
+                  <a:srgbClr val="1A1A1A"/>
+                </a:solidFill>
+                <a:latin typeface="Arial"/>
+              </a:rPr>
+              <a:t>милф</a:t>
+            </a:r>
+          </a:p>
+        </p:txBody>
+      </p:sp>
+      <p:sp>
+        <p:nvSpPr>
+          <p:cNvPr id="11" name="Rectangle 10"/>
+          <p:cNvSpPr/>
+          <p:nvPr/>
+        </p:nvSpPr>
+        <p:spPr>
+          <a:xfrm>
+            <a:off x="8442742" y="2182732"/>
+            <a:ext cx="2064494" cy="1597267"/>
+          </a:xfrm>
+          <a:prstGeom prst="rect">
+            <a:avLst/>
+          </a:prstGeom>
+          <a:noFill/>
+          <a:ln>
+            <a:noFill/>
+          </a:ln>
+          <a:effectLst/>
+        </p:spPr>
+        <p:style>
+          <a:lnRef idx="1">
+            <a:schemeClr val="accent1"/>
+          </a:lnRef>
+          <a:fillRef idx="3">
+            <a:schemeClr val="accent1"/>
+          </a:fillRef>
+          <a:effectRef idx="2">
+            <a:schemeClr val="accent1"/>
+          </a:effectRef>
+          <a:fontRef idx="minor">
+            <a:schemeClr val="lt1"/>
+          </a:fontRef>
+        </p:style>
+        <p:txBody>
+          <a:bodyPr rtlCol="0" anchor="t" wrap="square" lIns="72438" rIns="72438" tIns="57950" bIns="57950"/>
+          <a:lstStyle/>
+          <a:p>
+            <a:pPr algn="ctr">
+              <a:spcBef>
+                <a:spcPts val="0"/>
+              </a:spcBef>
+              <a:spcAft>
+                <a:spcPts val="0"/>
+              </a:spcAft>
+            </a:pPr>
+            <a:r>
+              <a:rPr sz="2000" b="1">
+                <a:solidFill>
+                  <a:srgbClr val="1A1A1A"/>
+                </a:solidFill>
+                <a:latin typeface="Arial"/>
+              </a:rPr>
+              <a:t>пузатых скуфов</a:t>
+            </a:r>
+          </a:p>
+        </p:txBody>
+      </p:sp>
+      <p:sp>
+        <p:nvSpPr>
+          <p:cNvPr id="12" name="Rectangle 11"/>
+          <p:cNvSpPr/>
+          <p:nvPr/>
+        </p:nvSpPr>
+        <p:spPr>
+          <a:xfrm>
+            <a:off x="184762" y="3780000"/>
+            <a:ext cx="2064494" cy="1597267"/>
+          </a:xfrm>
+          <a:prstGeom prst="rect">
+            <a:avLst/>
+          </a:prstGeom>
+          <a:noFill/>
+          <a:ln>
+            <a:noFill/>
+          </a:ln>
+          <a:effectLst/>
+        </p:spPr>
+        <p:style>
+          <a:lnRef idx="1">
+            <a:schemeClr val="accent1"/>
+          </a:lnRef>
+          <a:fillRef idx="3">
+            <a:schemeClr val="accent1"/>
+          </a:fillRef>
+          <a:effectRef idx="2">
+            <a:schemeClr val="accent1"/>
+          </a:effectRef>
+          <a:fontRef idx="minor">
+            <a:schemeClr val="lt1"/>
+          </a:fontRef>
+        </p:style>
+        <p:txBody>
+          <a:bodyPr rtlCol="0" anchor="t" wrap="square" lIns="72438" rIns="72438" tIns="57950" bIns="57950"/>
+          <a:lstStyle/>
+          <a:p>
+            <a:pPr algn="ctr">
+              <a:spcBef>
+                <a:spcPts val="0"/>
+              </a:spcBef>
+              <a:spcAft>
+                <a:spcPts val="0"/>
+              </a:spcAft>
+            </a:pPr>
+            <a:r>
+              <a:rPr sz="2000" b="1">
+                <a:solidFill>
+                  <a:srgbClr val="1A1A1A"/>
+                </a:solidFill>
+                <a:latin typeface="Arial"/>
+              </a:rPr>
+              <a:t>*очкариков</a:t>
+            </a:r>
+          </a:p>
+        </p:txBody>
+      </p:sp>
+      <p:sp>
+        <p:nvSpPr>
+          <p:cNvPr id="13" name="Rectangle 12"/>
+          <p:cNvSpPr/>
+          <p:nvPr/>
+        </p:nvSpPr>
+        <p:spPr>
+          <a:xfrm>
+            <a:off x="2249257" y="3780000"/>
+            <a:ext cx="2064494" cy="1597267"/>
+          </a:xfrm>
+          <a:prstGeom prst="rect">
+            <a:avLst/>
+          </a:prstGeom>
+          <a:noFill/>
+          <a:ln>
+            <a:noFill/>
+          </a:ln>
+          <a:effectLst/>
+        </p:spPr>
+        <p:style>
+          <a:lnRef idx="1">
+            <a:schemeClr val="accent1"/>
+          </a:lnRef>
+          <a:fillRef idx="3">
+            <a:schemeClr val="accent1"/>
+          </a:fillRef>
+          <a:effectRef idx="2">
+            <a:schemeClr val="accent1"/>
+          </a:effectRef>
+          <a:fontRef idx="minor">
+            <a:schemeClr val="lt1"/>
+          </a:fontRef>
+        </p:style>
+        <p:txBody>
+          <a:bodyPr rtlCol="0" anchor="t" wrap="square" lIns="72438" rIns="72438" tIns="57950" bIns="57950"/>
+          <a:lstStyle/>
+          <a:p>
+            <a:pPr algn="ctr">
+              <a:spcBef>
+                <a:spcPts val="0"/>
+              </a:spcBef>
+              <a:spcAft>
+                <a:spcPts val="0"/>
+              </a:spcAft>
+            </a:pPr>
+            <a:r>
+              <a:rPr sz="2000" b="1">
+                <a:solidFill>
+                  <a:srgbClr val="1A1A1A"/>
+                </a:solidFill>
+                <a:latin typeface="Arial"/>
+              </a:rPr>
+              <a:t>*ботаников</a:t>
+            </a:r>
+          </a:p>
+        </p:txBody>
+      </p:sp>
+      <p:sp>
+        <p:nvSpPr>
+          <p:cNvPr id="14" name="Rectangle 13"/>
+          <p:cNvSpPr/>
+          <p:nvPr/>
+        </p:nvSpPr>
+        <p:spPr>
+          <a:xfrm>
+            <a:off x="4313752" y="3780000"/>
+            <a:ext cx="2064494" cy="1597267"/>
+          </a:xfrm>
+          <a:prstGeom prst="rect">
+            <a:avLst/>
+          </a:prstGeom>
+          <a:noFill/>
+          <a:ln>
+            <a:noFill/>
+          </a:ln>
+          <a:effectLst/>
+        </p:spPr>
+        <p:style>
+          <a:lnRef idx="1">
+            <a:schemeClr val="accent1"/>
+          </a:lnRef>
+          <a:fillRef idx="3">
+            <a:schemeClr val="accent1"/>
+          </a:fillRef>
+          <a:effectRef idx="2">
+            <a:schemeClr val="accent1"/>
+          </a:effectRef>
+          <a:fontRef idx="minor">
+            <a:schemeClr val="lt1"/>
+          </a:fontRef>
+        </p:style>
+        <p:txBody>
+          <a:bodyPr rtlCol="0" anchor="t" wrap="square" lIns="72438" rIns="72438" tIns="57950" bIns="57950"/>
+          <a:lstStyle/>
+          <a:p>
+            <a:pPr algn="ctr">
+              <a:spcBef>
+                <a:spcPts val="0"/>
+              </a:spcBef>
+              <a:spcAft>
+                <a:spcPts val="0"/>
+              </a:spcAft>
+            </a:pPr>
+            <a:r>
+              <a:rPr sz="2000" b="1">
+                <a:solidFill>
+                  <a:srgbClr val="1A1A1A"/>
+                </a:solidFill>
+                <a:latin typeface="Arial"/>
+              </a:rPr>
+              <a:t>*нейросетей</a:t>
+            </a:r>
+          </a:p>
+        </p:txBody>
+      </p:sp>
+      <p:sp>
+        <p:nvSpPr>
+          <p:cNvPr id="15" name="Rectangle 14"/>
+          <p:cNvSpPr/>
+          <p:nvPr/>
+        </p:nvSpPr>
+        <p:spPr>
+          <a:xfrm>
+            <a:off x="6378247" y="3780000"/>
+            <a:ext cx="2064494" cy="1597267"/>
+          </a:xfrm>
+          <a:prstGeom prst="rect">
+            <a:avLst/>
+          </a:prstGeom>
+          <a:noFill/>
+          <a:ln>
+            <a:noFill/>
+          </a:ln>
+          <a:effectLst/>
+        </p:spPr>
+        <p:style>
+          <a:lnRef idx="1">
+            <a:schemeClr val="accent1"/>
+          </a:lnRef>
+          <a:fillRef idx="3">
+            <a:schemeClr val="accent1"/>
+          </a:fillRef>
+          <a:effectRef idx="2">
+            <a:schemeClr val="accent1"/>
+          </a:effectRef>
+          <a:fontRef idx="minor">
+            <a:schemeClr val="lt1"/>
+          </a:fontRef>
+        </p:style>
+        <p:txBody>
+          <a:bodyPr rtlCol="0" anchor="t" wrap="square" lIns="72438" rIns="72438" tIns="57950" bIns="57950"/>
+          <a:lstStyle/>
+          <a:p>
+            <a:pPr algn="ctr">
+              <a:spcBef>
+                <a:spcPts val="0"/>
+              </a:spcBef>
+              <a:spcAft>
+                <a:spcPts val="0"/>
+              </a:spcAft>
+            </a:pPr>
+            <a:r>
+              <a:rPr sz="2000" b="1">
+                <a:solidFill>
+                  <a:srgbClr val="1A1A1A"/>
+                </a:solidFill>
+                <a:latin typeface="Arial"/>
+              </a:rPr>
+              <a:t>яжмамок</a:t>
+            </a:r>
+          </a:p>
+        </p:txBody>
+      </p:sp>
+      <p:sp>
+        <p:nvSpPr>
+          <p:cNvPr id="16" name="Rectangle 15"/>
+          <p:cNvSpPr/>
+          <p:nvPr/>
+        </p:nvSpPr>
+        <p:spPr>
+          <a:xfrm>
+            <a:off x="184762" y="580703"/>
+            <a:ext cx="2064494" cy="9525"/>
+          </a:xfrm>
+          <a:prstGeom prst="rect">
+            <a:avLst/>
+          </a:prstGeom>
+          <a:solidFill>
+            <a:srgbClr val="C0C0C0"/>
+          </a:solidFill>
+          <a:ln>
+            <a:noFill/>
+          </a:ln>
+          <a:effectLst/>
+        </p:spPr>
+        <p:style>
+          <a:lnRef idx="1">
+            <a:schemeClr val="accent1"/>
+          </a:lnRef>
+          <a:fillRef idx="3">
+            <a:schemeClr val="accent1"/>
+          </a:fillRef>
+          <a:effectRef idx="2">
+            <a:schemeClr val="accent1"/>
+          </a:effectRef>
+          <a:fontRef idx="minor">
+            <a:schemeClr val="lt1"/>
+          </a:fontRef>
+        </p:style>
+        <p:txBody>
+          <a:bodyPr rtlCol="0" anchor="ctr"/>
+          <a:lstStyle/>
+          <a:p>
+            <a:pPr algn="ctr"/>
+          </a:p>
+        </p:txBody>
+      </p:sp>
+      <p:sp>
+        <p:nvSpPr>
+          <p:cNvPr id="17" name="Rectangle 16"/>
+          <p:cNvSpPr/>
+          <p:nvPr/>
+        </p:nvSpPr>
+        <p:spPr>
+          <a:xfrm>
+            <a:off x="2249257" y="580703"/>
+            <a:ext cx="2064494" cy="9525"/>
+          </a:xfrm>
+          <a:prstGeom prst="rect">
+            <a:avLst/>
+          </a:prstGeom>
+          <a:solidFill>
+            <a:srgbClr val="C0C0C0"/>
+          </a:solidFill>
+          <a:ln>
+            <a:noFill/>
+          </a:ln>
+          <a:effectLst/>
+        </p:spPr>
+        <p:style>
+          <a:lnRef idx="1">
+            <a:schemeClr val="accent1"/>
+          </a:lnRef>
+          <a:fillRef idx="3">
+            <a:schemeClr val="accent1"/>
+          </a:fillRef>
+          <a:effectRef idx="2">
+            <a:schemeClr val="accent1"/>
+          </a:effectRef>
+          <a:fontRef idx="minor">
+            <a:schemeClr val="lt1"/>
+          </a:fontRef>
+        </p:style>
+        <p:txBody>
+          <a:bodyPr rtlCol="0" anchor="ctr"/>
+          <a:lstStyle/>
+          <a:p>
+            <a:pPr algn="ctr"/>
+          </a:p>
+        </p:txBody>
+      </p:sp>
+      <p:sp>
+        <p:nvSpPr>
+          <p:cNvPr id="18" name="Rectangle 17"/>
+          <p:cNvSpPr/>
+          <p:nvPr/>
+        </p:nvSpPr>
+        <p:spPr>
+          <a:xfrm>
+            <a:off x="4313752" y="580703"/>
+            <a:ext cx="2064494" cy="9525"/>
+          </a:xfrm>
+          <a:prstGeom prst="rect">
+            <a:avLst/>
+          </a:prstGeom>
+          <a:solidFill>
+            <a:srgbClr val="C0C0C0"/>
+          </a:solidFill>
+          <a:ln>
+            <a:noFill/>
+          </a:ln>
+          <a:effectLst/>
+        </p:spPr>
+        <p:style>
+          <a:lnRef idx="1">
+            <a:schemeClr val="accent1"/>
+          </a:lnRef>
+          <a:fillRef idx="3">
+            <a:schemeClr val="accent1"/>
+          </a:fillRef>
+          <a:effectRef idx="2">
+            <a:schemeClr val="accent1"/>
+          </a:effectRef>
+          <a:fontRef idx="minor">
+            <a:schemeClr val="lt1"/>
+          </a:fontRef>
+        </p:style>
+        <p:txBody>
+          <a:bodyPr rtlCol="0" anchor="ctr"/>
+          <a:lstStyle/>
+          <a:p>
+            <a:pPr algn="ctr"/>
+          </a:p>
+        </p:txBody>
+      </p:sp>
+      <p:sp>
+        <p:nvSpPr>
+          <p:cNvPr id="19" name="Rectangle 18"/>
+          <p:cNvSpPr/>
+          <p:nvPr/>
+        </p:nvSpPr>
+        <p:spPr>
+          <a:xfrm>
+            <a:off x="6378247" y="580703"/>
+            <a:ext cx="2064494" cy="9525"/>
+          </a:xfrm>
+          <a:prstGeom prst="rect">
+            <a:avLst/>
+          </a:prstGeom>
+          <a:solidFill>
+            <a:srgbClr val="C0C0C0"/>
+          </a:solidFill>
+          <a:ln>
+            <a:noFill/>
+          </a:ln>
+          <a:effectLst/>
+        </p:spPr>
+        <p:style>
+          <a:lnRef idx="1">
+            <a:schemeClr val="accent1"/>
+          </a:lnRef>
+          <a:fillRef idx="3">
+            <a:schemeClr val="accent1"/>
+          </a:fillRef>
+          <a:effectRef idx="2">
+            <a:schemeClr val="accent1"/>
+          </a:effectRef>
+          <a:fontRef idx="minor">
+            <a:schemeClr val="lt1"/>
+          </a:fontRef>
+        </p:style>
+        <p:txBody>
+          <a:bodyPr rtlCol="0" anchor="ctr"/>
+          <a:lstStyle/>
+          <a:p>
+            <a:pPr algn="ctr"/>
+          </a:p>
+        </p:txBody>
+      </p:sp>
+      <p:sp>
+        <p:nvSpPr>
+          <p:cNvPr id="20" name="Rectangle 19"/>
+          <p:cNvSpPr/>
+          <p:nvPr/>
+        </p:nvSpPr>
+        <p:spPr>
+          <a:xfrm>
+            <a:off x="8442742" y="580703"/>
+            <a:ext cx="2064494" cy="9525"/>
+          </a:xfrm>
+          <a:prstGeom prst="rect">
+            <a:avLst/>
+          </a:prstGeom>
+          <a:solidFill>
+            <a:srgbClr val="C0C0C0"/>
+          </a:solidFill>
+          <a:ln>
+            <a:noFill/>
+          </a:ln>
+          <a:effectLst/>
+        </p:spPr>
+        <p:style>
+          <a:lnRef idx="1">
+            <a:schemeClr val="accent1"/>
+          </a:lnRef>
+          <a:fillRef idx="3">
+            <a:schemeClr val="accent1"/>
+          </a:fillRef>
+          <a:effectRef idx="2">
+            <a:schemeClr val="accent1"/>
+          </a:effectRef>
+          <a:fontRef idx="minor">
+            <a:schemeClr val="lt1"/>
+          </a:fontRef>
+        </p:style>
+        <p:txBody>
+          <a:bodyPr rtlCol="0" anchor="ctr"/>
+          <a:lstStyle/>
+          <a:p>
+            <a:pPr algn="ctr"/>
+          </a:p>
+        </p:txBody>
+      </p:sp>
+      <p:sp>
+        <p:nvSpPr>
+          <p:cNvPr id="21" name="Rectangle 20"/>
+          <p:cNvSpPr/>
+          <p:nvPr/>
+        </p:nvSpPr>
+        <p:spPr>
+          <a:xfrm>
+            <a:off x="184762" y="2177970"/>
+            <a:ext cx="2064494" cy="9525"/>
+          </a:xfrm>
+          <a:prstGeom prst="rect">
+            <a:avLst/>
+          </a:prstGeom>
+          <a:solidFill>
+            <a:srgbClr val="C0C0C0"/>
+          </a:solidFill>
+          <a:ln>
+            <a:noFill/>
+          </a:ln>
+          <a:effectLst/>
+        </p:spPr>
+        <p:style>
+          <a:lnRef idx="1">
+            <a:schemeClr val="accent1"/>
+          </a:lnRef>
+          <a:fillRef idx="3">
+            <a:schemeClr val="accent1"/>
+          </a:fillRef>
+          <a:effectRef idx="2">
+            <a:schemeClr val="accent1"/>
+          </a:effectRef>
+          <a:fontRef idx="minor">
+            <a:schemeClr val="lt1"/>
+          </a:fontRef>
+        </p:style>
+        <p:txBody>
+          <a:bodyPr rtlCol="0" anchor="ctr"/>
+          <a:lstStyle/>
+          <a:p>
+            <a:pPr algn="ctr"/>
+          </a:p>
+        </p:txBody>
+      </p:sp>
+      <p:sp>
+        <p:nvSpPr>
+          <p:cNvPr id="22" name="Rectangle 21"/>
+          <p:cNvSpPr/>
+          <p:nvPr/>
+        </p:nvSpPr>
+        <p:spPr>
+          <a:xfrm>
+            <a:off x="2249257" y="2177970"/>
+            <a:ext cx="2064494" cy="9525"/>
+          </a:xfrm>
+          <a:prstGeom prst="rect">
+            <a:avLst/>
+          </a:prstGeom>
+          <a:solidFill>
+            <a:srgbClr val="C0C0C0"/>
+          </a:solidFill>
+          <a:ln>
+            <a:noFill/>
+          </a:ln>
+          <a:effectLst/>
+        </p:spPr>
+        <p:style>
+          <a:lnRef idx="1">
+            <a:schemeClr val="accent1"/>
+          </a:lnRef>
+          <a:fillRef idx="3">
+            <a:schemeClr val="accent1"/>
+          </a:fillRef>
+          <a:effectRef idx="2">
+            <a:schemeClr val="accent1"/>
+          </a:effectRef>
+          <a:fontRef idx="minor">
+            <a:schemeClr val="lt1"/>
+          </a:fontRef>
+        </p:style>
+        <p:txBody>
+          <a:bodyPr rtlCol="0" anchor="ctr"/>
+          <a:lstStyle/>
+          <a:p>
+            <a:pPr algn="ctr"/>
+          </a:p>
+        </p:txBody>
+      </p:sp>
+      <p:sp>
+        <p:nvSpPr>
+          <p:cNvPr id="23" name="Rectangle 22"/>
+          <p:cNvSpPr/>
+          <p:nvPr/>
+        </p:nvSpPr>
+        <p:spPr>
+          <a:xfrm>
+            <a:off x="4313752" y="2177970"/>
+            <a:ext cx="2064494" cy="9525"/>
+          </a:xfrm>
+          <a:prstGeom prst="rect">
+            <a:avLst/>
+          </a:prstGeom>
+          <a:solidFill>
+            <a:srgbClr val="C0C0C0"/>
+          </a:solidFill>
+          <a:ln>
+            <a:noFill/>
+          </a:ln>
+          <a:effectLst/>
+        </p:spPr>
+        <p:style>
+          <a:lnRef idx="1">
+            <a:schemeClr val="accent1"/>
+          </a:lnRef>
+          <a:fillRef idx="3">
+            <a:schemeClr val="accent1"/>
+          </a:fillRef>
+          <a:effectRef idx="2">
+            <a:schemeClr val="accent1"/>
+          </a:effectRef>
+          <a:fontRef idx="minor">
+            <a:schemeClr val="lt1"/>
+          </a:fontRef>
+        </p:style>
+        <p:txBody>
+          <a:bodyPr rtlCol="0" anchor="ctr"/>
+          <a:lstStyle/>
+          <a:p>
+            <a:pPr algn="ctr"/>
+          </a:p>
+        </p:txBody>
+      </p:sp>
+      <p:sp>
+        <p:nvSpPr>
+          <p:cNvPr id="24" name="Rectangle 23"/>
+          <p:cNvSpPr/>
+          <p:nvPr/>
+        </p:nvSpPr>
+        <p:spPr>
+          <a:xfrm>
+            <a:off x="6378247" y="2177970"/>
+            <a:ext cx="2064494" cy="9525"/>
+          </a:xfrm>
+          <a:prstGeom prst="rect">
+            <a:avLst/>
+          </a:prstGeom>
+          <a:solidFill>
+            <a:srgbClr val="C0C0C0"/>
+          </a:solidFill>
+          <a:ln>
+            <a:noFill/>
+          </a:ln>
+          <a:effectLst/>
+        </p:spPr>
+        <p:style>
+          <a:lnRef idx="1">
+            <a:schemeClr val="accent1"/>
+          </a:lnRef>
+          <a:fillRef idx="3">
+            <a:schemeClr val="accent1"/>
+          </a:fillRef>
+          <a:effectRef idx="2">
+            <a:schemeClr val="accent1"/>
+          </a:effectRef>
+          <a:fontRef idx="minor">
+            <a:schemeClr val="lt1"/>
+          </a:fontRef>
+        </p:style>
+        <p:txBody>
+          <a:bodyPr rtlCol="0" anchor="ctr"/>
+          <a:lstStyle/>
+          <a:p>
+            <a:pPr algn="ctr"/>
+          </a:p>
+        </p:txBody>
+      </p:sp>
+      <p:sp>
+        <p:nvSpPr>
+          <p:cNvPr id="25" name="Rectangle 24"/>
+          <p:cNvSpPr/>
+          <p:nvPr/>
+        </p:nvSpPr>
+        <p:spPr>
+          <a:xfrm>
+            <a:off x="8442742" y="2177970"/>
+            <a:ext cx="2064494" cy="9525"/>
+          </a:xfrm>
+          <a:prstGeom prst="rect">
+            <a:avLst/>
+          </a:prstGeom>
+          <a:solidFill>
+            <a:srgbClr val="C0C0C0"/>
+          </a:solidFill>
+          <a:ln>
+            <a:noFill/>
+          </a:ln>
+          <a:effectLst/>
+        </p:spPr>
+        <p:style>
+          <a:lnRef idx="1">
+            <a:schemeClr val="accent1"/>
+          </a:lnRef>
+          <a:fillRef idx="3">
+            <a:schemeClr val="accent1"/>
+          </a:fillRef>
+          <a:effectRef idx="2">
+            <a:schemeClr val="accent1"/>
+          </a:effectRef>
+          <a:fontRef idx="minor">
+            <a:schemeClr val="lt1"/>
+          </a:fontRef>
+        </p:style>
+        <p:txBody>
+          <a:bodyPr rtlCol="0" anchor="ctr"/>
+          <a:lstStyle/>
+          <a:p>
+            <a:pPr algn="ctr"/>
+          </a:p>
+        </p:txBody>
+      </p:sp>
+      <p:sp>
+        <p:nvSpPr>
+          <p:cNvPr id="26" name="Rectangle 25"/>
+          <p:cNvSpPr/>
+          <p:nvPr/>
+        </p:nvSpPr>
+        <p:spPr>
+          <a:xfrm>
+            <a:off x="184762" y="3775237"/>
+            <a:ext cx="2064494" cy="9525"/>
+          </a:xfrm>
+          <a:prstGeom prst="rect">
+            <a:avLst/>
+          </a:prstGeom>
+          <a:solidFill>
+            <a:srgbClr val="C0C0C0"/>
+          </a:solidFill>
+          <a:ln>
+            <a:noFill/>
+          </a:ln>
+          <a:effectLst/>
+        </p:spPr>
+        <p:style>
+          <a:lnRef idx="1">
+            <a:schemeClr val="accent1"/>
+          </a:lnRef>
+          <a:fillRef idx="3">
+            <a:schemeClr val="accent1"/>
+          </a:fillRef>
+          <a:effectRef idx="2">
+            <a:schemeClr val="accent1"/>
+          </a:effectRef>
+          <a:fontRef idx="minor">
+            <a:schemeClr val="lt1"/>
+          </a:fontRef>
+        </p:style>
+        <p:txBody>
+          <a:bodyPr rtlCol="0" anchor="ctr"/>
+          <a:lstStyle/>
+          <a:p>
+            <a:pPr algn="ctr"/>
+          </a:p>
+        </p:txBody>
+      </p:sp>
+      <p:sp>
+        <p:nvSpPr>
+          <p:cNvPr id="27" name="Rectangle 26"/>
+          <p:cNvSpPr/>
+          <p:nvPr/>
+        </p:nvSpPr>
+        <p:spPr>
+          <a:xfrm>
+            <a:off x="2249257" y="3775237"/>
+            <a:ext cx="2064494" cy="9525"/>
+          </a:xfrm>
+          <a:prstGeom prst="rect">
+            <a:avLst/>
+          </a:prstGeom>
+          <a:solidFill>
+            <a:srgbClr val="C0C0C0"/>
+          </a:solidFill>
+          <a:ln>
+            <a:noFill/>
+          </a:ln>
+          <a:effectLst/>
+        </p:spPr>
+        <p:style>
+          <a:lnRef idx="1">
+            <a:schemeClr val="accent1"/>
+          </a:lnRef>
+          <a:fillRef idx="3">
+            <a:schemeClr val="accent1"/>
+          </a:fillRef>
+          <a:effectRef idx="2">
+            <a:schemeClr val="accent1"/>
+          </a:effectRef>
+          <a:fontRef idx="minor">
+            <a:schemeClr val="lt1"/>
+          </a:fontRef>
+        </p:style>
+        <p:txBody>
+          <a:bodyPr rtlCol="0" anchor="ctr"/>
+          <a:lstStyle/>
+          <a:p>
+            <a:pPr algn="ctr"/>
+          </a:p>
+        </p:txBody>
+      </p:sp>
+      <p:sp>
+        <p:nvSpPr>
+          <p:cNvPr id="28" name="Rectangle 27"/>
+          <p:cNvSpPr/>
+          <p:nvPr/>
+        </p:nvSpPr>
+        <p:spPr>
+          <a:xfrm>
+            <a:off x="4313752" y="3775237"/>
+            <a:ext cx="2064494" cy="9525"/>
+          </a:xfrm>
+          <a:prstGeom prst="rect">
+            <a:avLst/>
+          </a:prstGeom>
+          <a:solidFill>
+            <a:srgbClr val="C0C0C0"/>
+          </a:solidFill>
+          <a:ln>
+            <a:noFill/>
+          </a:ln>
+          <a:effectLst/>
+        </p:spPr>
+        <p:style>
+          <a:lnRef idx="1">
+            <a:schemeClr val="accent1"/>
+          </a:lnRef>
+          <a:fillRef idx="3">
+            <a:schemeClr val="accent1"/>
+          </a:fillRef>
+          <a:effectRef idx="2">
+            <a:schemeClr val="accent1"/>
+          </a:effectRef>
+          <a:fontRef idx="minor">
+            <a:schemeClr val="lt1"/>
+          </a:fontRef>
+        </p:style>
+        <p:txBody>
+          <a:bodyPr rtlCol="0" anchor="ctr"/>
+          <a:lstStyle/>
+          <a:p>
+            <a:pPr algn="ctr"/>
+          </a:p>
+        </p:txBody>
+      </p:sp>
+      <p:sp>
+        <p:nvSpPr>
+          <p:cNvPr id="29" name="Rectangle 28"/>
+          <p:cNvSpPr/>
+          <p:nvPr/>
+        </p:nvSpPr>
+        <p:spPr>
+          <a:xfrm>
+            <a:off x="6378247" y="3775237"/>
+            <a:ext cx="2064494" cy="9525"/>
+          </a:xfrm>
+          <a:prstGeom prst="rect">
+            <a:avLst/>
+          </a:prstGeom>
+          <a:solidFill>
+            <a:srgbClr val="C0C0C0"/>
+          </a:solidFill>
+          <a:ln>
+            <a:noFill/>
+          </a:ln>
+          <a:effectLst/>
+        </p:spPr>
+        <p:style>
+          <a:lnRef idx="1">
+            <a:schemeClr val="accent1"/>
+          </a:lnRef>
+          <a:fillRef idx="3">
+            <a:schemeClr val="accent1"/>
+          </a:fillRef>
+          <a:effectRef idx="2">
+            <a:schemeClr val="accent1"/>
+          </a:effectRef>
+          <a:fontRef idx="minor">
+            <a:schemeClr val="lt1"/>
+          </a:fontRef>
+        </p:style>
+        <p:txBody>
+          <a:bodyPr rtlCol="0" anchor="ctr"/>
+          <a:lstStyle/>
+          <a:p>
+            <a:pPr algn="ctr"/>
+          </a:p>
+        </p:txBody>
+      </p:sp>
+      <p:sp>
+        <p:nvSpPr>
+          <p:cNvPr id="30" name="Rectangle 29"/>
+          <p:cNvSpPr/>
+          <p:nvPr/>
+        </p:nvSpPr>
+        <p:spPr>
+          <a:xfrm>
+            <a:off x="8442742" y="3775237"/>
+            <a:ext cx="2064494" cy="9525"/>
+          </a:xfrm>
+          <a:prstGeom prst="rect">
+            <a:avLst/>
+          </a:prstGeom>
+          <a:solidFill>
+            <a:srgbClr val="C0C0C0"/>
+          </a:solidFill>
+          <a:ln>
+            <a:noFill/>
+          </a:ln>
+          <a:effectLst/>
+        </p:spPr>
+        <p:style>
+          <a:lnRef idx="1">
+            <a:schemeClr val="accent1"/>
+          </a:lnRef>
+          <a:fillRef idx="3">
+            <a:schemeClr val="accent1"/>
+          </a:fillRef>
+          <a:effectRef idx="2">
+            <a:schemeClr val="accent1"/>
+          </a:effectRef>
+          <a:fontRef idx="minor">
+            <a:schemeClr val="lt1"/>
+          </a:fontRef>
+        </p:style>
+        <p:txBody>
+          <a:bodyPr rtlCol="0" anchor="ctr"/>
+          <a:lstStyle/>
+          <a:p>
+            <a:pPr algn="ctr"/>
+          </a:p>
+        </p:txBody>
+      </p:sp>
+      <p:sp>
+        <p:nvSpPr>
+          <p:cNvPr id="31" name="Rectangle 30"/>
+          <p:cNvSpPr/>
+          <p:nvPr/>
+        </p:nvSpPr>
+        <p:spPr>
+          <a:xfrm>
+            <a:off x="184762" y="5372504"/>
+            <a:ext cx="2064494" cy="9525"/>
+          </a:xfrm>
+          <a:prstGeom prst="rect">
+            <a:avLst/>
+          </a:prstGeom>
+          <a:solidFill>
+            <a:srgbClr val="C0C0C0"/>
+          </a:solidFill>
+          <a:ln>
+            <a:noFill/>
+          </a:ln>
+          <a:effectLst/>
+        </p:spPr>
+        <p:style>
+          <a:lnRef idx="1">
+            <a:schemeClr val="accent1"/>
+          </a:lnRef>
+          <a:fillRef idx="3">
+            <a:schemeClr val="accent1"/>
+          </a:fillRef>
+          <a:effectRef idx="2">
+            <a:schemeClr val="accent1"/>
+          </a:effectRef>
+          <a:fontRef idx="minor">
+            <a:schemeClr val="lt1"/>
+          </a:fontRef>
+        </p:style>
+        <p:txBody>
+          <a:bodyPr rtlCol="0" anchor="ctr"/>
+          <a:lstStyle/>
+          <a:p>
+            <a:pPr algn="ctr"/>
+          </a:p>
+        </p:txBody>
+      </p:sp>
+      <p:sp>
+        <p:nvSpPr>
+          <p:cNvPr id="32" name="Rectangle 31"/>
+          <p:cNvSpPr/>
+          <p:nvPr/>
+        </p:nvSpPr>
+        <p:spPr>
+          <a:xfrm>
+            <a:off x="2249257" y="5372504"/>
+            <a:ext cx="2064494" cy="9525"/>
+          </a:xfrm>
+          <a:prstGeom prst="rect">
+            <a:avLst/>
+          </a:prstGeom>
+          <a:solidFill>
+            <a:srgbClr val="C0C0C0"/>
+          </a:solidFill>
+          <a:ln>
+            <a:noFill/>
+          </a:ln>
+          <a:effectLst/>
+        </p:spPr>
+        <p:style>
+          <a:lnRef idx="1">
+            <a:schemeClr val="accent1"/>
+          </a:lnRef>
+          <a:fillRef idx="3">
+            <a:schemeClr val="accent1"/>
+          </a:fillRef>
+          <a:effectRef idx="2">
+            <a:schemeClr val="accent1"/>
+          </a:effectRef>
+          <a:fontRef idx="minor">
+            <a:schemeClr val="lt1"/>
+          </a:fontRef>
+        </p:style>
+        <p:txBody>
+          <a:bodyPr rtlCol="0" anchor="ctr"/>
+          <a:lstStyle/>
+          <a:p>
+            <a:pPr algn="ctr"/>
+          </a:p>
+        </p:txBody>
+      </p:sp>
+      <p:sp>
+        <p:nvSpPr>
+          <p:cNvPr id="33" name="Rectangle 32"/>
+          <p:cNvSpPr/>
+          <p:nvPr/>
+        </p:nvSpPr>
+        <p:spPr>
+          <a:xfrm>
+            <a:off x="4313752" y="5372504"/>
+            <a:ext cx="2064494" cy="9525"/>
+          </a:xfrm>
+          <a:prstGeom prst="rect">
+            <a:avLst/>
+          </a:prstGeom>
+          <a:solidFill>
+            <a:srgbClr val="C0C0C0"/>
+          </a:solidFill>
+          <a:ln>
+            <a:noFill/>
+          </a:ln>
+          <a:effectLst/>
+        </p:spPr>
+        <p:style>
+          <a:lnRef idx="1">
+            <a:schemeClr val="accent1"/>
+          </a:lnRef>
+          <a:fillRef idx="3">
+            <a:schemeClr val="accent1"/>
+          </a:fillRef>
+          <a:effectRef idx="2">
+            <a:schemeClr val="accent1"/>
+          </a:effectRef>
+          <a:fontRef idx="minor">
+            <a:schemeClr val="lt1"/>
+          </a:fontRef>
+        </p:style>
+        <p:txBody>
+          <a:bodyPr rtlCol="0" anchor="ctr"/>
+          <a:lstStyle/>
+          <a:p>
+            <a:pPr algn="ctr"/>
+          </a:p>
+        </p:txBody>
+      </p:sp>
+      <p:sp>
+        <p:nvSpPr>
+          <p:cNvPr id="34" name="Rectangle 33"/>
+          <p:cNvSpPr/>
+          <p:nvPr/>
+        </p:nvSpPr>
+        <p:spPr>
+          <a:xfrm>
+            <a:off x="6378247" y="5372504"/>
+            <a:ext cx="2064494" cy="9525"/>
+          </a:xfrm>
+          <a:prstGeom prst="rect">
+            <a:avLst/>
+          </a:prstGeom>
+          <a:solidFill>
+            <a:srgbClr val="C0C0C0"/>
+          </a:solidFill>
+          <a:ln>
+            <a:noFill/>
+          </a:ln>
+          <a:effectLst/>
+        </p:spPr>
+        <p:style>
+          <a:lnRef idx="1">
+            <a:schemeClr val="accent1"/>
+          </a:lnRef>
+          <a:fillRef idx="3">
+            <a:schemeClr val="accent1"/>
+          </a:fillRef>
+          <a:effectRef idx="2">
+            <a:schemeClr val="accent1"/>
+          </a:effectRef>
+          <a:fontRef idx="minor">
+            <a:schemeClr val="lt1"/>
+          </a:fontRef>
+        </p:style>
+        <p:txBody>
+          <a:bodyPr rtlCol="0" anchor="ctr"/>
+          <a:lstStyle/>
+          <a:p>
+            <a:pPr algn="ctr"/>
+          </a:p>
+        </p:txBody>
+      </p:sp>
+      <p:sp>
+        <p:nvSpPr>
+          <p:cNvPr id="35" name="Rectangle 34"/>
+          <p:cNvSpPr/>
+          <p:nvPr/>
+        </p:nvSpPr>
+        <p:spPr>
+          <a:xfrm>
+            <a:off x="180000" y="585465"/>
+            <a:ext cx="9525" cy="1597267"/>
+          </a:xfrm>
+          <a:prstGeom prst="rect">
+            <a:avLst/>
+          </a:prstGeom>
+          <a:solidFill>
+            <a:srgbClr val="C0C0C0"/>
+          </a:solidFill>
+          <a:ln>
+            <a:noFill/>
+          </a:ln>
+          <a:effectLst/>
+        </p:spPr>
+        <p:style>
+          <a:lnRef idx="1">
+            <a:schemeClr val="accent1"/>
+          </a:lnRef>
+          <a:fillRef idx="3">
+            <a:schemeClr val="accent1"/>
+          </a:fillRef>
+          <a:effectRef idx="2">
+            <a:schemeClr val="accent1"/>
+          </a:effectRef>
+          <a:fontRef idx="minor">
+            <a:schemeClr val="lt1"/>
+          </a:fontRef>
+        </p:style>
+        <p:txBody>
+          <a:bodyPr rtlCol="0" anchor="ctr"/>
+          <a:lstStyle/>
+          <a:p>
+            <a:pPr algn="ctr"/>
+          </a:p>
+        </p:txBody>
+      </p:sp>
+      <p:sp>
+        <p:nvSpPr>
+          <p:cNvPr id="36" name="Rectangle 35"/>
+          <p:cNvSpPr/>
+          <p:nvPr/>
+        </p:nvSpPr>
+        <p:spPr>
+          <a:xfrm>
+            <a:off x="180000" y="2182732"/>
+            <a:ext cx="9525" cy="1597267"/>
+          </a:xfrm>
+          <a:prstGeom prst="rect">
+            <a:avLst/>
+          </a:prstGeom>
+          <a:solidFill>
+            <a:srgbClr val="C0C0C0"/>
+          </a:solidFill>
+          <a:ln>
+            <a:noFill/>
+          </a:ln>
+          <a:effectLst/>
+        </p:spPr>
+        <p:style>
+          <a:lnRef idx="1">
+            <a:schemeClr val="accent1"/>
+          </a:lnRef>
+          <a:fillRef idx="3">
+            <a:schemeClr val="accent1"/>
+          </a:fillRef>
+          <a:effectRef idx="2">
+            <a:schemeClr val="accent1"/>
+          </a:effectRef>
+          <a:fontRef idx="minor">
+            <a:schemeClr val="lt1"/>
+          </a:fontRef>
+        </p:style>
+        <p:txBody>
+          <a:bodyPr rtlCol="0" anchor="ctr"/>
+          <a:lstStyle/>
+          <a:p>
+            <a:pPr algn="ctr"/>
+          </a:p>
+        </p:txBody>
+      </p:sp>
+      <p:sp>
+        <p:nvSpPr>
+          <p:cNvPr id="37" name="Rectangle 36"/>
+          <p:cNvSpPr/>
+          <p:nvPr/>
+        </p:nvSpPr>
+        <p:spPr>
+          <a:xfrm>
+            <a:off x="180000" y="3780000"/>
+            <a:ext cx="9525" cy="1597267"/>
+          </a:xfrm>
+          <a:prstGeom prst="rect">
+            <a:avLst/>
+          </a:prstGeom>
+          <a:solidFill>
+            <a:srgbClr val="C0C0C0"/>
+          </a:solidFill>
+          <a:ln>
+            <a:noFill/>
+          </a:ln>
+          <a:effectLst/>
+        </p:spPr>
+        <p:style>
+          <a:lnRef idx="1">
+            <a:schemeClr val="accent1"/>
+          </a:lnRef>
+          <a:fillRef idx="3">
+            <a:schemeClr val="accent1"/>
+          </a:fillRef>
+          <a:effectRef idx="2">
+            <a:schemeClr val="accent1"/>
+          </a:effectRef>
+          <a:fontRef idx="minor">
+            <a:schemeClr val="lt1"/>
+          </a:fontRef>
+        </p:style>
+        <p:txBody>
+          <a:bodyPr rtlCol="0" anchor="ctr"/>
+          <a:lstStyle/>
+          <a:p>
+            <a:pPr algn="ctr"/>
+          </a:p>
+        </p:txBody>
+      </p:sp>
+      <p:sp>
+        <p:nvSpPr>
+          <p:cNvPr id="38" name="Rectangle 37"/>
+          <p:cNvSpPr/>
+          <p:nvPr/>
+        </p:nvSpPr>
+        <p:spPr>
+          <a:xfrm>
+            <a:off x="2244495" y="585465"/>
+            <a:ext cx="9525" cy="1597267"/>
+          </a:xfrm>
+          <a:prstGeom prst="rect">
+            <a:avLst/>
+          </a:prstGeom>
+          <a:solidFill>
+            <a:srgbClr val="C0C0C0"/>
+          </a:solidFill>
+          <a:ln>
+            <a:noFill/>
+          </a:ln>
+          <a:effectLst/>
+        </p:spPr>
+        <p:style>
+          <a:lnRef idx="1">
+            <a:schemeClr val="accent1"/>
+          </a:lnRef>
+          <a:fillRef idx="3">
+            <a:schemeClr val="accent1"/>
+          </a:fillRef>
+          <a:effectRef idx="2">
+            <a:schemeClr val="accent1"/>
+          </a:effectRef>
+          <a:fontRef idx="minor">
+            <a:schemeClr val="lt1"/>
+          </a:fontRef>
+        </p:style>
+        <p:txBody>
+          <a:bodyPr rtlCol="0" anchor="ctr"/>
+          <a:lstStyle/>
+          <a:p>
+            <a:pPr algn="ctr"/>
+          </a:p>
+        </p:txBody>
+      </p:sp>
+      <p:sp>
+        <p:nvSpPr>
+          <p:cNvPr id="39" name="Rectangle 38"/>
+          <p:cNvSpPr/>
+          <p:nvPr/>
+        </p:nvSpPr>
+        <p:spPr>
+          <a:xfrm>
+            <a:off x="2244495" y="2182732"/>
+            <a:ext cx="9525" cy="1597267"/>
+          </a:xfrm>
+          <a:prstGeom prst="rect">
+            <a:avLst/>
+          </a:prstGeom>
+          <a:solidFill>
+            <a:srgbClr val="C0C0C0"/>
+          </a:solidFill>
+          <a:ln>
+            <a:noFill/>
+          </a:ln>
+          <a:effectLst/>
+        </p:spPr>
+        <p:style>
+          <a:lnRef idx="1">
+            <a:schemeClr val="accent1"/>
+          </a:lnRef>
+          <a:fillRef idx="3">
+            <a:schemeClr val="accent1"/>
+          </a:fillRef>
+          <a:effectRef idx="2">
+            <a:schemeClr val="accent1"/>
+          </a:effectRef>
+          <a:fontRef idx="minor">
+            <a:schemeClr val="lt1"/>
+          </a:fontRef>
+        </p:style>
+        <p:txBody>
+          <a:bodyPr rtlCol="0" anchor="ctr"/>
+          <a:lstStyle/>
+          <a:p>
+            <a:pPr algn="ctr"/>
+          </a:p>
+        </p:txBody>
+      </p:sp>
+      <p:sp>
+        <p:nvSpPr>
+          <p:cNvPr id="40" name="Rectangle 39"/>
+          <p:cNvSpPr/>
+          <p:nvPr/>
+        </p:nvSpPr>
+        <p:spPr>
+          <a:xfrm>
+            <a:off x="2244495" y="3780000"/>
+            <a:ext cx="9525" cy="1597267"/>
+          </a:xfrm>
+          <a:prstGeom prst="rect">
+            <a:avLst/>
+          </a:prstGeom>
+          <a:solidFill>
+            <a:srgbClr val="C0C0C0"/>
+          </a:solidFill>
+          <a:ln>
+            <a:noFill/>
+          </a:ln>
+          <a:effectLst/>
+        </p:spPr>
+        <p:style>
+          <a:lnRef idx="1">
+            <a:schemeClr val="accent1"/>
+          </a:lnRef>
+          <a:fillRef idx="3">
+            <a:schemeClr val="accent1"/>
+          </a:fillRef>
+          <a:effectRef idx="2">
+            <a:schemeClr val="accent1"/>
+          </a:effectRef>
+          <a:fontRef idx="minor">
+            <a:schemeClr val="lt1"/>
+          </a:fontRef>
+        </p:style>
+        <p:txBody>
+          <a:bodyPr rtlCol="0" anchor="ctr"/>
+          <a:lstStyle/>
+          <a:p>
+            <a:pPr algn="ctr"/>
+          </a:p>
+        </p:txBody>
+      </p:sp>
+      <p:sp>
+        <p:nvSpPr>
+          <p:cNvPr id="41" name="Rectangle 40"/>
+          <p:cNvSpPr/>
+          <p:nvPr/>
+        </p:nvSpPr>
+        <p:spPr>
+          <a:xfrm>
+            <a:off x="4308990" y="585465"/>
+            <a:ext cx="9525" cy="1597267"/>
+          </a:xfrm>
+          <a:prstGeom prst="rect">
+            <a:avLst/>
+          </a:prstGeom>
+          <a:solidFill>
+            <a:srgbClr val="C0C0C0"/>
+          </a:solidFill>
+          <a:ln>
+            <a:noFill/>
+          </a:ln>
+          <a:effectLst/>
+        </p:spPr>
+        <p:style>
+          <a:lnRef idx="1">
+            <a:schemeClr val="accent1"/>
+          </a:lnRef>
+          <a:fillRef idx="3">
+            <a:schemeClr val="accent1"/>
+          </a:fillRef>
+          <a:effectRef idx="2">
+            <a:schemeClr val="accent1"/>
+          </a:effectRef>
+          <a:fontRef idx="minor">
+            <a:schemeClr val="lt1"/>
+          </a:fontRef>
+        </p:style>
+        <p:txBody>
+          <a:bodyPr rtlCol="0" anchor="ctr"/>
+          <a:lstStyle/>
+          <a:p>
+            <a:pPr algn="ctr"/>
+          </a:p>
+        </p:txBody>
+      </p:sp>
+      <p:sp>
+        <p:nvSpPr>
+          <p:cNvPr id="42" name="Rectangle 41"/>
+          <p:cNvSpPr/>
+          <p:nvPr/>
+        </p:nvSpPr>
+        <p:spPr>
+          <a:xfrm>
+            <a:off x="4308990" y="2182732"/>
+            <a:ext cx="9525" cy="1597267"/>
+          </a:xfrm>
+          <a:prstGeom prst="rect">
+            <a:avLst/>
+          </a:prstGeom>
+          <a:solidFill>
+            <a:srgbClr val="C0C0C0"/>
+          </a:solidFill>
+          <a:ln>
+            <a:noFill/>
+          </a:ln>
+          <a:effectLst/>
+        </p:spPr>
+        <p:style>
+          <a:lnRef idx="1">
+            <a:schemeClr val="accent1"/>
+          </a:lnRef>
+          <a:fillRef idx="3">
+            <a:schemeClr val="accent1"/>
+          </a:fillRef>
+          <a:effectRef idx="2">
+            <a:schemeClr val="accent1"/>
+          </a:effectRef>
+          <a:fontRef idx="minor">
+            <a:schemeClr val="lt1"/>
+          </a:fontRef>
+        </p:style>
+        <p:txBody>
+          <a:bodyPr rtlCol="0" anchor="ctr"/>
+          <a:lstStyle/>
+          <a:p>
+            <a:pPr algn="ctr"/>
+          </a:p>
+        </p:txBody>
+      </p:sp>
+      <p:sp>
+        <p:nvSpPr>
+          <p:cNvPr id="43" name="Rectangle 42"/>
+          <p:cNvSpPr/>
+          <p:nvPr/>
+        </p:nvSpPr>
+        <p:spPr>
+          <a:xfrm>
+            <a:off x="4308990" y="3780000"/>
+            <a:ext cx="9525" cy="1597267"/>
+          </a:xfrm>
+          <a:prstGeom prst="rect">
+            <a:avLst/>
+          </a:prstGeom>
+          <a:solidFill>
+            <a:srgbClr val="C0C0C0"/>
+          </a:solidFill>
+          <a:ln>
+            <a:noFill/>
+          </a:ln>
+          <a:effectLst/>
+        </p:spPr>
+        <p:style>
+          <a:lnRef idx="1">
+            <a:schemeClr val="accent1"/>
+          </a:lnRef>
+          <a:fillRef idx="3">
+            <a:schemeClr val="accent1"/>
+          </a:fillRef>
+          <a:effectRef idx="2">
+            <a:schemeClr val="accent1"/>
+          </a:effectRef>
+          <a:fontRef idx="minor">
+            <a:schemeClr val="lt1"/>
+          </a:fontRef>
+        </p:style>
+        <p:txBody>
+          <a:bodyPr rtlCol="0" anchor="ctr"/>
+          <a:lstStyle/>
+          <a:p>
+            <a:pPr algn="ctr"/>
+          </a:p>
+        </p:txBody>
+      </p:sp>
+      <p:sp>
+        <p:nvSpPr>
+          <p:cNvPr id="44" name="Rectangle 43"/>
+          <p:cNvSpPr/>
+          <p:nvPr/>
+        </p:nvSpPr>
+        <p:spPr>
+          <a:xfrm>
+            <a:off x="6373485" y="585465"/>
+            <a:ext cx="9525" cy="1597267"/>
+          </a:xfrm>
+          <a:prstGeom prst="rect">
+            <a:avLst/>
+          </a:prstGeom>
+          <a:solidFill>
+            <a:srgbClr val="C0C0C0"/>
+          </a:solidFill>
+          <a:ln>
+            <a:noFill/>
+          </a:ln>
+          <a:effectLst/>
+        </p:spPr>
+        <p:style>
+          <a:lnRef idx="1">
+            <a:schemeClr val="accent1"/>
+          </a:lnRef>
+          <a:fillRef idx="3">
+            <a:schemeClr val="accent1"/>
+          </a:fillRef>
+          <a:effectRef idx="2">
+            <a:schemeClr val="accent1"/>
+          </a:effectRef>
+          <a:fontRef idx="minor">
+            <a:schemeClr val="lt1"/>
+          </a:fontRef>
+        </p:style>
+        <p:txBody>
+          <a:bodyPr rtlCol="0" anchor="ctr"/>
+          <a:lstStyle/>
+          <a:p>
+            <a:pPr algn="ctr"/>
+          </a:p>
+        </p:txBody>
+      </p:sp>
+      <p:sp>
+        <p:nvSpPr>
+          <p:cNvPr id="45" name="Rectangle 44"/>
+          <p:cNvSpPr/>
+          <p:nvPr/>
+        </p:nvSpPr>
+        <p:spPr>
+          <a:xfrm>
+            <a:off x="6373485" y="2182732"/>
+            <a:ext cx="9525" cy="1597267"/>
+          </a:xfrm>
+          <a:prstGeom prst="rect">
+            <a:avLst/>
+          </a:prstGeom>
+          <a:solidFill>
+            <a:srgbClr val="C0C0C0"/>
+          </a:solidFill>
+          <a:ln>
+            <a:noFill/>
+          </a:ln>
+          <a:effectLst/>
+        </p:spPr>
+        <p:style>
+          <a:lnRef idx="1">
+            <a:schemeClr val="accent1"/>
+          </a:lnRef>
+          <a:fillRef idx="3">
+            <a:schemeClr val="accent1"/>
+          </a:fillRef>
+          <a:effectRef idx="2">
+            <a:schemeClr val="accent1"/>
+          </a:effectRef>
+          <a:fontRef idx="minor">
+            <a:schemeClr val="lt1"/>
+          </a:fontRef>
+        </p:style>
+        <p:txBody>
+          <a:bodyPr rtlCol="0" anchor="ctr"/>
+          <a:lstStyle/>
+          <a:p>
+            <a:pPr algn="ctr"/>
+          </a:p>
+        </p:txBody>
+      </p:sp>
+      <p:sp>
+        <p:nvSpPr>
+          <p:cNvPr id="46" name="Rectangle 45"/>
+          <p:cNvSpPr/>
+          <p:nvPr/>
+        </p:nvSpPr>
+        <p:spPr>
+          <a:xfrm>
+            <a:off x="6373485" y="3780000"/>
+            <a:ext cx="9525" cy="1597267"/>
+          </a:xfrm>
+          <a:prstGeom prst="rect">
+            <a:avLst/>
+          </a:prstGeom>
+          <a:solidFill>
+            <a:srgbClr val="C0C0C0"/>
+          </a:solidFill>
+          <a:ln>
+            <a:noFill/>
+          </a:ln>
+          <a:effectLst/>
+        </p:spPr>
+        <p:style>
+          <a:lnRef idx="1">
+            <a:schemeClr val="accent1"/>
+          </a:lnRef>
+          <a:fillRef idx="3">
+            <a:schemeClr val="accent1"/>
+          </a:fillRef>
+          <a:effectRef idx="2">
+            <a:schemeClr val="accent1"/>
+          </a:effectRef>
+          <a:fontRef idx="minor">
+            <a:schemeClr val="lt1"/>
+          </a:fontRef>
+        </p:style>
+        <p:txBody>
+          <a:bodyPr rtlCol="0" anchor="ctr"/>
+          <a:lstStyle/>
+          <a:p>
+            <a:pPr algn="ctr"/>
+          </a:p>
+        </p:txBody>
+      </p:sp>
+      <p:sp>
+        <p:nvSpPr>
+          <p:cNvPr id="47" name="Rectangle 46"/>
+          <p:cNvSpPr/>
+          <p:nvPr/>
+        </p:nvSpPr>
+        <p:spPr>
+          <a:xfrm>
+            <a:off x="8437980" y="585465"/>
+            <a:ext cx="9525" cy="1597267"/>
+          </a:xfrm>
+          <a:prstGeom prst="rect">
+            <a:avLst/>
+          </a:prstGeom>
+          <a:solidFill>
+            <a:srgbClr val="C0C0C0"/>
+          </a:solidFill>
+          <a:ln>
+            <a:noFill/>
+          </a:ln>
+          <a:effectLst/>
+        </p:spPr>
+        <p:style>
+          <a:lnRef idx="1">
+            <a:schemeClr val="accent1"/>
+          </a:lnRef>
+          <a:fillRef idx="3">
+            <a:schemeClr val="accent1"/>
+          </a:fillRef>
+          <a:effectRef idx="2">
+            <a:schemeClr val="accent1"/>
+          </a:effectRef>
+          <a:fontRef idx="minor">
+            <a:schemeClr val="lt1"/>
+          </a:fontRef>
+        </p:style>
+        <p:txBody>
+          <a:bodyPr rtlCol="0" anchor="ctr"/>
+          <a:lstStyle/>
+          <a:p>
+            <a:pPr algn="ctr"/>
+          </a:p>
+        </p:txBody>
+      </p:sp>
+      <p:sp>
+        <p:nvSpPr>
+          <p:cNvPr id="48" name="Rectangle 47"/>
+          <p:cNvSpPr/>
+          <p:nvPr/>
+        </p:nvSpPr>
+        <p:spPr>
+          <a:xfrm>
+            <a:off x="8437980" y="2182732"/>
+            <a:ext cx="9525" cy="1597267"/>
+          </a:xfrm>
+          <a:prstGeom prst="rect">
+            <a:avLst/>
+          </a:prstGeom>
+          <a:solidFill>
+            <a:srgbClr val="C0C0C0"/>
+          </a:solidFill>
+          <a:ln>
+            <a:noFill/>
+          </a:ln>
+          <a:effectLst/>
+        </p:spPr>
+        <p:style>
+          <a:lnRef idx="1">
+            <a:schemeClr val="accent1"/>
+          </a:lnRef>
+          <a:fillRef idx="3">
+            <a:schemeClr val="accent1"/>
+          </a:fillRef>
+          <a:effectRef idx="2">
+            <a:schemeClr val="accent1"/>
+          </a:effectRef>
+          <a:fontRef idx="minor">
+            <a:schemeClr val="lt1"/>
+          </a:fontRef>
+        </p:style>
+        <p:txBody>
+          <a:bodyPr rtlCol="0" anchor="ctr"/>
+          <a:lstStyle/>
+          <a:p>
+            <a:pPr algn="ctr"/>
+          </a:p>
+        </p:txBody>
+      </p:sp>
+      <p:sp>
+        <p:nvSpPr>
+          <p:cNvPr id="49" name="Rectangle 48"/>
+          <p:cNvSpPr/>
+          <p:nvPr/>
+        </p:nvSpPr>
+        <p:spPr>
+          <a:xfrm>
+            <a:off x="8437980" y="3780000"/>
+            <a:ext cx="9525" cy="1597267"/>
+          </a:xfrm>
+          <a:prstGeom prst="rect">
+            <a:avLst/>
+          </a:prstGeom>
+          <a:solidFill>
+            <a:srgbClr val="C0C0C0"/>
+          </a:solidFill>
+          <a:ln>
+            <a:noFill/>
+          </a:ln>
+          <a:effectLst/>
+        </p:spPr>
+        <p:style>
+          <a:lnRef idx="1">
+            <a:schemeClr val="accent1"/>
+          </a:lnRef>
+          <a:fillRef idx="3">
+            <a:schemeClr val="accent1"/>
+          </a:fillRef>
+          <a:effectRef idx="2">
+            <a:schemeClr val="accent1"/>
+          </a:effectRef>
+          <a:fontRef idx="minor">
+            <a:schemeClr val="lt1"/>
+          </a:fontRef>
+        </p:style>
+        <p:txBody>
+          <a:bodyPr rtlCol="0" anchor="ctr"/>
+          <a:lstStyle/>
+          <a:p>
+            <a:pPr algn="ctr"/>
+          </a:p>
+        </p:txBody>
+      </p:sp>
+      <p:sp>
+        <p:nvSpPr>
+          <p:cNvPr id="50" name="Rectangle 49"/>
+          <p:cNvSpPr/>
+          <p:nvPr/>
+        </p:nvSpPr>
+        <p:spPr>
+          <a:xfrm>
+            <a:off x="10502475" y="585465"/>
+            <a:ext cx="9525" cy="1597267"/>
+          </a:xfrm>
+          <a:prstGeom prst="rect">
+            <a:avLst/>
+          </a:prstGeom>
+          <a:solidFill>
+            <a:srgbClr val="C0C0C0"/>
+          </a:solidFill>
+          <a:ln>
+            <a:noFill/>
+          </a:ln>
+          <a:effectLst/>
+        </p:spPr>
+        <p:style>
+          <a:lnRef idx="1">
+            <a:schemeClr val="accent1"/>
+          </a:lnRef>
+          <a:fillRef idx="3">
+            <a:schemeClr val="accent1"/>
+          </a:fillRef>
+          <a:effectRef idx="2">
+            <a:schemeClr val="accent1"/>
+          </a:effectRef>
+          <a:fontRef idx="minor">
+            <a:schemeClr val="lt1"/>
+          </a:fontRef>
+        </p:style>
+        <p:txBody>
+          <a:bodyPr rtlCol="0" anchor="ctr"/>
+          <a:lstStyle/>
+          <a:p>
+            <a:pPr algn="ctr"/>
+          </a:p>
+        </p:txBody>
+      </p:sp>
+      <p:sp>
+        <p:nvSpPr>
+          <p:cNvPr id="51" name="Rectangle 50"/>
+          <p:cNvSpPr/>
+          <p:nvPr/>
+        </p:nvSpPr>
+        <p:spPr>
+          <a:xfrm>
+            <a:off x="10502475" y="2182732"/>
+            <a:ext cx="9525" cy="1597267"/>
+          </a:xfrm>
+          <a:prstGeom prst="rect">
+            <a:avLst/>
+          </a:prstGeom>
+          <a:solidFill>
+            <a:srgbClr val="C0C0C0"/>
+          </a:solidFill>
+          <a:ln>
+            <a:noFill/>
+          </a:ln>
+          <a:effectLst/>
+        </p:spPr>
+        <p:style>
+          <a:lnRef idx="1">
+            <a:schemeClr val="accent1"/>
+          </a:lnRef>
+          <a:fillRef idx="3">
+            <a:schemeClr val="accent1"/>
+          </a:fillRef>
+          <a:effectRef idx="2">
+            <a:schemeClr val="accent1"/>
+          </a:effectRef>
+          <a:fontRef idx="minor">
+            <a:schemeClr val="lt1"/>
+          </a:fontRef>
+        </p:style>
+        <p:txBody>
+          <a:bodyPr rtlCol="0" anchor="ctr"/>
+          <a:lstStyle/>
+          <a:p>
+            <a:pPr algn="ctr"/>
+          </a:p>
+        </p:txBody>
+      </p:sp>
+    </p:spTree>
+  </p:cSld>
+  <p:clrMapOvr>
+    <a:masterClrMapping/>
+  </p:clrMapOvr>
+</p:sld>
+</file>
+
+<file path=ppt/slides/slide5.xml><?xml version="1.0" encoding="utf-8"?>
 <p:sld xmlns:a="http://schemas.openxmlformats.org/drawingml/2006/main" xmlns:p="http://schemas.openxmlformats.org/presentationml/2006/main" xmlns:r="http://schemas.openxmlformats.org/officeDocument/2006/relationships">
   <p:cSld>
     <p:spTree>

</xml_diff>

<commit_message>
Remove three request backs from content pools.
</commit_message>
<xml_diff>
--- a/output/svet-moy-zerkalce-cards.pptx
+++ b/output/svet-moy-zerkalce-cards.pptx
@@ -6769,6 +6769,64 @@
                 </a:solidFill>
                 <a:latin typeface="Arial"/>
               </a:rPr>
+              <a:t>*вечных опоздунов</a:t>
+            </a:r>
+          </a:p>
+        </p:txBody>
+      </p:sp>
+      <p:sp>
+        <p:nvSpPr>
+          <p:cNvPr id="8" name="Rectangle 7"/>
+          <p:cNvSpPr/>
+          <p:nvPr/>
+        </p:nvSpPr>
+        <p:spPr>
+          <a:xfrm>
+            <a:off x="2249257" y="2182732"/>
+            <a:ext cx="2064494" cy="1597267"/>
+          </a:xfrm>
+          <a:prstGeom prst="rect">
+            <a:avLst/>
+          </a:prstGeom>
+          <a:noFill/>
+          <a:ln>
+            <a:noFill/>
+          </a:ln>
+          <a:effectLst/>
+        </p:spPr>
+        <p:style>
+          <a:lnRef idx="1">
+            <a:schemeClr val="accent1"/>
+          </a:lnRef>
+          <a:fillRef idx="3">
+            <a:schemeClr val="accent1"/>
+          </a:fillRef>
+          <a:effectRef idx="2">
+            <a:schemeClr val="accent1"/>
+          </a:effectRef>
+          <a:fontRef idx="minor">
+            <a:schemeClr val="lt1"/>
+          </a:fontRef>
+        </p:style>
+        <p:txBody>
+          <a:bodyPr rtlCol="0" anchor="t" wrap="square" lIns="72438" rIns="72438" tIns="57950" bIns="57950"/>
+          <a:lstStyle/>
+          <a:p>
+            <a:pPr algn="ctr">
+              <a:spcBef>
+                <a:spcPts val="0"/>
+              </a:spcBef>
+              <a:spcAft>
+                <a:spcPts val="0"/>
+              </a:spcAft>
+            </a:pPr>
+            <a:r>
+              <a:rPr sz="2000" b="1">
+                <a:solidFill>
+                  <a:srgbClr val="1A1A1A"/>
+                </a:solidFill>
+                <a:latin typeface="Arial"/>
+              </a:rPr>
               <a:t>*соседей сверху</a:t>
             </a:r>
           </a:p>
@@ -6776,13 +6834,13 @@
       </p:sp>
       <p:sp>
         <p:nvSpPr>
-          <p:cNvPr id="8" name="Rectangle 7"/>
-          <p:cNvSpPr/>
-          <p:nvPr/>
-        </p:nvSpPr>
-        <p:spPr>
-          <a:xfrm>
-            <a:off x="2249257" y="2182732"/>
+          <p:cNvPr id="9" name="Rectangle 8"/>
+          <p:cNvSpPr/>
+          <p:nvPr/>
+        </p:nvSpPr>
+        <p:spPr>
+          <a:xfrm>
+            <a:off x="4313752" y="2182732"/>
             <a:ext cx="2064494" cy="1597267"/>
           </a:xfrm>
           <a:prstGeom prst="rect">
@@ -6834,13 +6892,13 @@
       </p:sp>
       <p:sp>
         <p:nvSpPr>
-          <p:cNvPr id="9" name="Rectangle 8"/>
-          <p:cNvSpPr/>
-          <p:nvPr/>
-        </p:nvSpPr>
-        <p:spPr>
-          <a:xfrm>
-            <a:off x="4313752" y="2182732"/>
+          <p:cNvPr id="10" name="Rectangle 9"/>
+          <p:cNvSpPr/>
+          <p:nvPr/>
+        </p:nvSpPr>
+        <p:spPr>
+          <a:xfrm>
+            <a:off x="6378247" y="2182732"/>
             <a:ext cx="2064494" cy="1597267"/>
           </a:xfrm>
           <a:prstGeom prst="rect">
@@ -6892,64 +6950,6 @@
       </p:sp>
       <p:sp>
         <p:nvSpPr>
-          <p:cNvPr id="10" name="Rectangle 9"/>
-          <p:cNvSpPr/>
-          <p:nvPr/>
-        </p:nvSpPr>
-        <p:spPr>
-          <a:xfrm>
-            <a:off x="6378247" y="2182732"/>
-            <a:ext cx="2064494" cy="1597267"/>
-          </a:xfrm>
-          <a:prstGeom prst="rect">
-            <a:avLst/>
-          </a:prstGeom>
-          <a:noFill/>
-          <a:ln>
-            <a:noFill/>
-          </a:ln>
-          <a:effectLst/>
-        </p:spPr>
-        <p:style>
-          <a:lnRef idx="1">
-            <a:schemeClr val="accent1"/>
-          </a:lnRef>
-          <a:fillRef idx="3">
-            <a:schemeClr val="accent1"/>
-          </a:fillRef>
-          <a:effectRef idx="2">
-            <a:schemeClr val="accent1"/>
-          </a:effectRef>
-          <a:fontRef idx="minor">
-            <a:schemeClr val="lt1"/>
-          </a:fontRef>
-        </p:style>
-        <p:txBody>
-          <a:bodyPr rtlCol="0" anchor="t" wrap="square" lIns="72438" rIns="72438" tIns="57950" bIns="57950"/>
-          <a:lstStyle/>
-          <a:p>
-            <a:pPr algn="ctr">
-              <a:spcBef>
-                <a:spcPts val="0"/>
-              </a:spcBef>
-              <a:spcAft>
-                <a:spcPts val="0"/>
-              </a:spcAft>
-            </a:pPr>
-            <a:r>
-              <a:rPr sz="2000" b="1">
-                <a:solidFill>
-                  <a:srgbClr val="1A1A1A"/>
-                </a:solidFill>
-                <a:latin typeface="Arial"/>
-              </a:rPr>
-              <a:t>*типичных героев мемов</a:t>
-            </a:r>
-          </a:p>
-        </p:txBody>
-      </p:sp>
-      <p:sp>
-        <p:nvSpPr>
           <p:cNvPr id="11" name="Rectangle 10"/>
           <p:cNvSpPr/>
           <p:nvPr/>
@@ -7059,6 +7059,64 @@
                 </a:solidFill>
                 <a:latin typeface="Arial"/>
               </a:rPr>
+              <a:t>*ручных питомцев</a:t>
+            </a:r>
+          </a:p>
+        </p:txBody>
+      </p:sp>
+      <p:sp>
+        <p:nvSpPr>
+          <p:cNvPr id="13" name="Rectangle 12"/>
+          <p:cNvSpPr/>
+          <p:nvPr/>
+        </p:nvSpPr>
+        <p:spPr>
+          <a:xfrm>
+            <a:off x="2249257" y="3780000"/>
+            <a:ext cx="2064494" cy="1597267"/>
+          </a:xfrm>
+          <a:prstGeom prst="rect">
+            <a:avLst/>
+          </a:prstGeom>
+          <a:noFill/>
+          <a:ln>
+            <a:noFill/>
+          </a:ln>
+          <a:effectLst/>
+        </p:spPr>
+        <p:style>
+          <a:lnRef idx="1">
+            <a:schemeClr val="accent1"/>
+          </a:lnRef>
+          <a:fillRef idx="3">
+            <a:schemeClr val="accent1"/>
+          </a:fillRef>
+          <a:effectRef idx="2">
+            <a:schemeClr val="accent1"/>
+          </a:effectRef>
+          <a:fontRef idx="minor">
+            <a:schemeClr val="lt1"/>
+          </a:fontRef>
+        </p:style>
+        <p:txBody>
+          <a:bodyPr rtlCol="0" anchor="t" wrap="square" lIns="72438" rIns="72438" tIns="57950" bIns="57950"/>
+          <a:lstStyle/>
+          <a:p>
+            <a:pPr algn="ctr">
+              <a:spcBef>
+                <a:spcPts val="0"/>
+              </a:spcBef>
+              <a:spcAft>
+                <a:spcPts val="0"/>
+              </a:spcAft>
+            </a:pPr>
+            <a:r>
+              <a:rPr sz="2000" b="1">
+                <a:solidFill>
+                  <a:srgbClr val="1A1A1A"/>
+                </a:solidFill>
+                <a:latin typeface="Arial"/>
+              </a:rPr>
               <a:t>*любителей настолок</a:t>
             </a:r>
           </a:p>
@@ -7066,13 +7124,13 @@
       </p:sp>
       <p:sp>
         <p:nvSpPr>
-          <p:cNvPr id="13" name="Rectangle 12"/>
-          <p:cNvSpPr/>
-          <p:nvPr/>
-        </p:nvSpPr>
-        <p:spPr>
-          <a:xfrm>
-            <a:off x="2249257" y="3780000"/>
+          <p:cNvPr id="14" name="Rectangle 13"/>
+          <p:cNvSpPr/>
+          <p:nvPr/>
+        </p:nvSpPr>
+        <p:spPr>
+          <a:xfrm>
+            <a:off x="4313752" y="3780000"/>
             <a:ext cx="2064494" cy="1597267"/>
           </a:xfrm>
           <a:prstGeom prst="rect">
@@ -7124,13 +7182,13 @@
       </p:sp>
       <p:sp>
         <p:nvSpPr>
-          <p:cNvPr id="14" name="Rectangle 13"/>
-          <p:cNvSpPr/>
-          <p:nvPr/>
-        </p:nvSpPr>
-        <p:spPr>
-          <a:xfrm>
-            <a:off x="4313752" y="3780000"/>
+          <p:cNvPr id="15" name="Rectangle 14"/>
+          <p:cNvSpPr/>
+          <p:nvPr/>
+        </p:nvSpPr>
+        <p:spPr>
+          <a:xfrm>
+            <a:off x="6378247" y="3780000"/>
             <a:ext cx="2064494" cy="1597267"/>
           </a:xfrm>
           <a:prstGeom prst="rect">
@@ -7182,13 +7240,13 @@
       </p:sp>
       <p:sp>
         <p:nvSpPr>
-          <p:cNvPr id="15" name="Rectangle 14"/>
-          <p:cNvSpPr/>
-          <p:nvPr/>
-        </p:nvSpPr>
-        <p:spPr>
-          <a:xfrm>
-            <a:off x="6378247" y="3780000"/>
+          <p:cNvPr id="16" name="Rectangle 15"/>
+          <p:cNvSpPr/>
+          <p:nvPr/>
+        </p:nvSpPr>
+        <p:spPr>
+          <a:xfrm>
+            <a:off x="8442742" y="3780000"/>
             <a:ext cx="2064494" cy="1597267"/>
           </a:xfrm>
           <a:prstGeom prst="rect">
@@ -7240,13 +7298,13 @@
       </p:sp>
       <p:sp>
         <p:nvSpPr>
-          <p:cNvPr id="16" name="Rectangle 15"/>
-          <p:cNvSpPr/>
-          <p:nvPr/>
-        </p:nvSpPr>
-        <p:spPr>
-          <a:xfrm>
-            <a:off x="8442742" y="3780000"/>
+          <p:cNvPr id="17" name="Rectangle 16"/>
+          <p:cNvSpPr/>
+          <p:nvPr/>
+        </p:nvSpPr>
+        <p:spPr>
+          <a:xfrm>
+            <a:off x="184762" y="5377267"/>
             <a:ext cx="2064494" cy="1597267"/>
           </a:xfrm>
           <a:prstGeom prst="rect">
@@ -7291,20 +7349,20 @@
                 </a:solidFill>
                 <a:latin typeface="Arial"/>
               </a:rPr>
-              <a:t>*вечных опоздунов</a:t>
+              <a:t>чемпионов френдзоны</a:t>
             </a:r>
           </a:p>
         </p:txBody>
       </p:sp>
       <p:sp>
         <p:nvSpPr>
-          <p:cNvPr id="17" name="Rectangle 16"/>
-          <p:cNvSpPr/>
-          <p:nvPr/>
-        </p:nvSpPr>
-        <p:spPr>
-          <a:xfrm>
-            <a:off x="184762" y="5377267"/>
+          <p:cNvPr id="18" name="Rectangle 17"/>
+          <p:cNvSpPr/>
+          <p:nvPr/>
+        </p:nvSpPr>
+        <p:spPr>
+          <a:xfrm>
+            <a:off x="2249257" y="5377267"/>
             <a:ext cx="2064494" cy="1597267"/>
           </a:xfrm>
           <a:prstGeom prst="rect">
@@ -7349,20 +7407,78 @@
                 </a:solidFill>
                 <a:latin typeface="Arial"/>
               </a:rPr>
-              <a:t>*величайших злодеев в истории</a:t>
+              <a:t>алкашей</a:t>
             </a:r>
           </a:p>
         </p:txBody>
       </p:sp>
       <p:sp>
         <p:nvSpPr>
-          <p:cNvPr id="18" name="Rectangle 17"/>
-          <p:cNvSpPr/>
-          <p:nvPr/>
-        </p:nvSpPr>
-        <p:spPr>
-          <a:xfrm>
-            <a:off x="2249257" y="5377267"/>
+          <p:cNvPr id="19" name="Rectangle 18"/>
+          <p:cNvSpPr/>
+          <p:nvPr/>
+        </p:nvSpPr>
+        <p:spPr>
+          <a:xfrm>
+            <a:off x="4313752" y="5377267"/>
+            <a:ext cx="2064494" cy="1597267"/>
+          </a:xfrm>
+          <a:prstGeom prst="rect">
+            <a:avLst/>
+          </a:prstGeom>
+          <a:noFill/>
+          <a:ln>
+            <a:noFill/>
+          </a:ln>
+          <a:effectLst/>
+        </p:spPr>
+        <p:style>
+          <a:lnRef idx="1">
+            <a:schemeClr val="accent1"/>
+          </a:lnRef>
+          <a:fillRef idx="3">
+            <a:schemeClr val="accent1"/>
+          </a:fillRef>
+          <a:effectRef idx="2">
+            <a:schemeClr val="accent1"/>
+          </a:effectRef>
+          <a:fontRef idx="minor">
+            <a:schemeClr val="lt1"/>
+          </a:fontRef>
+        </p:style>
+        <p:txBody>
+          <a:bodyPr rtlCol="0" anchor="t" wrap="square" lIns="72438" rIns="72438" tIns="57950" bIns="57950"/>
+          <a:lstStyle/>
+          <a:p>
+            <a:pPr algn="ctr">
+              <a:spcBef>
+                <a:spcPts val="0"/>
+              </a:spcBef>
+              <a:spcAft>
+                <a:spcPts val="0"/>
+              </a:spcAft>
+            </a:pPr>
+            <a:r>
+              <a:rPr sz="2000" b="1">
+                <a:solidFill>
+                  <a:srgbClr val="1A1A1A"/>
+                </a:solidFill>
+                <a:latin typeface="Arial"/>
+              </a:rPr>
+              <a:t>*бабок у подъезда</a:t>
+            </a:r>
+          </a:p>
+        </p:txBody>
+      </p:sp>
+      <p:sp>
+        <p:nvSpPr>
+          <p:cNvPr id="20" name="Rectangle 19"/>
+          <p:cNvSpPr/>
+          <p:nvPr/>
+        </p:nvSpPr>
+        <p:spPr>
+          <a:xfrm>
+            <a:off x="6378247" y="5377267"/>
             <a:ext cx="2064494" cy="1597267"/>
           </a:xfrm>
           <a:prstGeom prst="rect">
@@ -7414,13 +7530,13 @@
       </p:sp>
       <p:sp>
         <p:nvSpPr>
-          <p:cNvPr id="19" name="Rectangle 18"/>
-          <p:cNvSpPr/>
-          <p:nvPr/>
-        </p:nvSpPr>
-        <p:spPr>
-          <a:xfrm>
-            <a:off x="4313752" y="5377267"/>
+          <p:cNvPr id="21" name="Rectangle 20"/>
+          <p:cNvSpPr/>
+          <p:nvPr/>
+        </p:nvSpPr>
+        <p:spPr>
+          <a:xfrm>
+            <a:off x="8442742" y="5377267"/>
             <a:ext cx="2064494" cy="1597267"/>
           </a:xfrm>
           <a:prstGeom prst="rect">
@@ -7466,122 +7582,6 @@
                 <a:latin typeface="Arial"/>
               </a:rPr>
               <a:t>*самокатчиков</a:t>
-            </a:r>
-          </a:p>
-        </p:txBody>
-      </p:sp>
-      <p:sp>
-        <p:nvSpPr>
-          <p:cNvPr id="20" name="Rectangle 19"/>
-          <p:cNvSpPr/>
-          <p:nvPr/>
-        </p:nvSpPr>
-        <p:spPr>
-          <a:xfrm>
-            <a:off x="6378247" y="5377267"/>
-            <a:ext cx="2064494" cy="1597267"/>
-          </a:xfrm>
-          <a:prstGeom prst="rect">
-            <a:avLst/>
-          </a:prstGeom>
-          <a:noFill/>
-          <a:ln>
-            <a:noFill/>
-          </a:ln>
-          <a:effectLst/>
-        </p:spPr>
-        <p:style>
-          <a:lnRef idx="1">
-            <a:schemeClr val="accent1"/>
-          </a:lnRef>
-          <a:fillRef idx="3">
-            <a:schemeClr val="accent1"/>
-          </a:fillRef>
-          <a:effectRef idx="2">
-            <a:schemeClr val="accent1"/>
-          </a:effectRef>
-          <a:fontRef idx="minor">
-            <a:schemeClr val="lt1"/>
-          </a:fontRef>
-        </p:style>
-        <p:txBody>
-          <a:bodyPr rtlCol="0" anchor="t" wrap="square" lIns="72438" rIns="72438" tIns="57950" bIns="57950"/>
-          <a:lstStyle/>
-          <a:p>
-            <a:pPr algn="ctr">
-              <a:spcBef>
-                <a:spcPts val="0"/>
-              </a:spcBef>
-              <a:spcAft>
-                <a:spcPts val="0"/>
-              </a:spcAft>
-            </a:pPr>
-            <a:r>
-              <a:rPr sz="2000" b="1">
-                <a:solidFill>
-                  <a:srgbClr val="1A1A1A"/>
-                </a:solidFill>
-                <a:latin typeface="Arial"/>
-              </a:rPr>
-              <a:t>*криптоинвестеров</a:t>
-            </a:r>
-          </a:p>
-        </p:txBody>
-      </p:sp>
-      <p:sp>
-        <p:nvSpPr>
-          <p:cNvPr id="21" name="Rectangle 20"/>
-          <p:cNvSpPr/>
-          <p:nvPr/>
-        </p:nvSpPr>
-        <p:spPr>
-          <a:xfrm>
-            <a:off x="8442742" y="5377267"/>
-            <a:ext cx="2064494" cy="1597267"/>
-          </a:xfrm>
-          <a:prstGeom prst="rect">
-            <a:avLst/>
-          </a:prstGeom>
-          <a:noFill/>
-          <a:ln>
-            <a:noFill/>
-          </a:ln>
-          <a:effectLst/>
-        </p:spPr>
-        <p:style>
-          <a:lnRef idx="1">
-            <a:schemeClr val="accent1"/>
-          </a:lnRef>
-          <a:fillRef idx="3">
-            <a:schemeClr val="accent1"/>
-          </a:fillRef>
-          <a:effectRef idx="2">
-            <a:schemeClr val="accent1"/>
-          </a:effectRef>
-          <a:fontRef idx="minor">
-            <a:schemeClr val="lt1"/>
-          </a:fontRef>
-        </p:style>
-        <p:txBody>
-          <a:bodyPr rtlCol="0" anchor="t" wrap="square" lIns="72438" rIns="72438" tIns="57950" bIns="57950"/>
-          <a:lstStyle/>
-          <a:p>
-            <a:pPr algn="ctr">
-              <a:spcBef>
-                <a:spcPts val="0"/>
-              </a:spcBef>
-              <a:spcAft>
-                <a:spcPts val="0"/>
-              </a:spcAft>
-            </a:pPr>
-            <a:r>
-              <a:rPr sz="2000" b="1">
-                <a:solidFill>
-                  <a:srgbClr val="1A1A1A"/>
-                </a:solidFill>
-                <a:latin typeface="Arial"/>
-              </a:rPr>
-              <a:t>*ручных питомцев</a:t>
             </a:r>
           </a:p>
         </p:txBody>
@@ -11789,6 +11789,180 @@
                 </a:solidFill>
                 <a:latin typeface="Arial"/>
               </a:rPr>
+              <a:t>*душнил</a:t>
+            </a:r>
+          </a:p>
+        </p:txBody>
+      </p:sp>
+      <p:sp>
+        <p:nvSpPr>
+          <p:cNvPr id="3" name="Rectangle 2"/>
+          <p:cNvSpPr/>
+          <p:nvPr/>
+        </p:nvSpPr>
+        <p:spPr>
+          <a:xfrm>
+            <a:off x="2249257" y="585465"/>
+            <a:ext cx="2064494" cy="1597267"/>
+          </a:xfrm>
+          <a:prstGeom prst="rect">
+            <a:avLst/>
+          </a:prstGeom>
+          <a:noFill/>
+          <a:ln>
+            <a:noFill/>
+          </a:ln>
+          <a:effectLst/>
+        </p:spPr>
+        <p:style>
+          <a:lnRef idx="1">
+            <a:schemeClr val="accent1"/>
+          </a:lnRef>
+          <a:fillRef idx="3">
+            <a:schemeClr val="accent1"/>
+          </a:fillRef>
+          <a:effectRef idx="2">
+            <a:schemeClr val="accent1"/>
+          </a:effectRef>
+          <a:fontRef idx="minor">
+            <a:schemeClr val="lt1"/>
+          </a:fontRef>
+        </p:style>
+        <p:txBody>
+          <a:bodyPr rtlCol="0" anchor="t" wrap="square" lIns="72438" rIns="72438" tIns="57950" bIns="57950"/>
+          <a:lstStyle/>
+          <a:p>
+            <a:pPr algn="ctr">
+              <a:spcBef>
+                <a:spcPts val="0"/>
+              </a:spcBef>
+              <a:spcAft>
+                <a:spcPts val="0"/>
+              </a:spcAft>
+            </a:pPr>
+            <a:r>
+              <a:rPr sz="2000" b="1">
+                <a:solidFill>
+                  <a:srgbClr val="1A1A1A"/>
+                </a:solidFill>
+                <a:latin typeface="Arial"/>
+              </a:rPr>
+              <a:t>милф</a:t>
+            </a:r>
+          </a:p>
+        </p:txBody>
+      </p:sp>
+      <p:sp>
+        <p:nvSpPr>
+          <p:cNvPr id="4" name="Rectangle 3"/>
+          <p:cNvSpPr/>
+          <p:nvPr/>
+        </p:nvSpPr>
+        <p:spPr>
+          <a:xfrm>
+            <a:off x="4313752" y="585465"/>
+            <a:ext cx="2064494" cy="1597267"/>
+          </a:xfrm>
+          <a:prstGeom prst="rect">
+            <a:avLst/>
+          </a:prstGeom>
+          <a:noFill/>
+          <a:ln>
+            <a:noFill/>
+          </a:ln>
+          <a:effectLst/>
+        </p:spPr>
+        <p:style>
+          <a:lnRef idx="1">
+            <a:schemeClr val="accent1"/>
+          </a:lnRef>
+          <a:fillRef idx="3">
+            <a:schemeClr val="accent1"/>
+          </a:fillRef>
+          <a:effectRef idx="2">
+            <a:schemeClr val="accent1"/>
+          </a:effectRef>
+          <a:fontRef idx="minor">
+            <a:schemeClr val="lt1"/>
+          </a:fontRef>
+        </p:style>
+        <p:txBody>
+          <a:bodyPr rtlCol="0" anchor="t" wrap="square" lIns="72438" rIns="72438" tIns="57950" bIns="57950"/>
+          <a:lstStyle/>
+          <a:p>
+            <a:pPr algn="ctr">
+              <a:spcBef>
+                <a:spcPts val="0"/>
+              </a:spcBef>
+              <a:spcAft>
+                <a:spcPts val="0"/>
+              </a:spcAft>
+            </a:pPr>
+            <a:r>
+              <a:rPr sz="2000" b="1">
+                <a:solidFill>
+                  <a:srgbClr val="1A1A1A"/>
+                </a:solidFill>
+                <a:latin typeface="Arial"/>
+              </a:rPr>
+              <a:t>пузатых скуфов</a:t>
+            </a:r>
+          </a:p>
+        </p:txBody>
+      </p:sp>
+      <p:sp>
+        <p:nvSpPr>
+          <p:cNvPr id="5" name="Rectangle 4"/>
+          <p:cNvSpPr/>
+          <p:nvPr/>
+        </p:nvSpPr>
+        <p:spPr>
+          <a:xfrm>
+            <a:off x="6378247" y="585465"/>
+            <a:ext cx="2064494" cy="1597267"/>
+          </a:xfrm>
+          <a:prstGeom prst="rect">
+            <a:avLst/>
+          </a:prstGeom>
+          <a:noFill/>
+          <a:ln>
+            <a:noFill/>
+          </a:ln>
+          <a:effectLst/>
+        </p:spPr>
+        <p:style>
+          <a:lnRef idx="1">
+            <a:schemeClr val="accent1"/>
+          </a:lnRef>
+          <a:fillRef idx="3">
+            <a:schemeClr val="accent1"/>
+          </a:fillRef>
+          <a:effectRef idx="2">
+            <a:schemeClr val="accent1"/>
+          </a:effectRef>
+          <a:fontRef idx="minor">
+            <a:schemeClr val="lt1"/>
+          </a:fontRef>
+        </p:style>
+        <p:txBody>
+          <a:bodyPr rtlCol="0" anchor="t" wrap="square" lIns="72438" rIns="72438" tIns="57950" bIns="57950"/>
+          <a:lstStyle/>
+          <a:p>
+            <a:pPr algn="ctr">
+              <a:spcBef>
+                <a:spcPts val="0"/>
+              </a:spcBef>
+              <a:spcAft>
+                <a:spcPts val="0"/>
+              </a:spcAft>
+            </a:pPr>
+            <a:r>
+              <a:rPr sz="2000" b="1">
+                <a:solidFill>
+                  <a:srgbClr val="1A1A1A"/>
+                </a:solidFill>
+                <a:latin typeface="Arial"/>
+              </a:rPr>
               <a:t>*кошатниц</a:t>
             </a:r>
           </a:p>
@@ -11796,13 +11970,13 @@
       </p:sp>
       <p:sp>
         <p:nvSpPr>
-          <p:cNvPr id="3" name="Rectangle 2"/>
-          <p:cNvSpPr/>
-          <p:nvPr/>
-        </p:nvSpPr>
-        <p:spPr>
-          <a:xfrm>
-            <a:off x="2249257" y="585465"/>
+          <p:cNvPr id="6" name="Rectangle 5"/>
+          <p:cNvSpPr/>
+          <p:nvPr/>
+        </p:nvSpPr>
+        <p:spPr>
+          <a:xfrm>
+            <a:off x="8442742" y="585465"/>
             <a:ext cx="2064494" cy="1597267"/>
           </a:xfrm>
           <a:prstGeom prst="rect">
@@ -11854,13 +12028,13 @@
       </p:sp>
       <p:sp>
         <p:nvSpPr>
-          <p:cNvPr id="4" name="Rectangle 3"/>
-          <p:cNvSpPr/>
-          <p:nvPr/>
-        </p:nvSpPr>
-        <p:spPr>
-          <a:xfrm>
-            <a:off x="4313752" y="585465"/>
+          <p:cNvPr id="7" name="Rectangle 6"/>
+          <p:cNvSpPr/>
+          <p:nvPr/>
+        </p:nvSpPr>
+        <p:spPr>
+          <a:xfrm>
+            <a:off x="184762" y="2182732"/>
             <a:ext cx="2064494" cy="1597267"/>
           </a:xfrm>
           <a:prstGeom prst="rect">
@@ -11905,20 +12079,20 @@
                 </a:solidFill>
                 <a:latin typeface="Arial"/>
               </a:rPr>
-              <a:t>чемпионов френдзоны</a:t>
+              <a:t>*ботаников</a:t>
             </a:r>
           </a:p>
         </p:txBody>
       </p:sp>
       <p:sp>
         <p:nvSpPr>
-          <p:cNvPr id="5" name="Rectangle 4"/>
-          <p:cNvSpPr/>
-          <p:nvPr/>
-        </p:nvSpPr>
-        <p:spPr>
-          <a:xfrm>
-            <a:off x="6378247" y="585465"/>
+          <p:cNvPr id="8" name="Rectangle 7"/>
+          <p:cNvSpPr/>
+          <p:nvPr/>
+        </p:nvSpPr>
+        <p:spPr>
+          <a:xfrm>
+            <a:off x="2249257" y="2182732"/>
             <a:ext cx="2064494" cy="1597267"/>
           </a:xfrm>
           <a:prstGeom prst="rect">
@@ -11963,20 +12137,20 @@
                 </a:solidFill>
                 <a:latin typeface="Arial"/>
               </a:rPr>
-              <a:t>алкашей</a:t>
+              <a:t>*нейросетей</a:t>
             </a:r>
           </a:p>
         </p:txBody>
       </p:sp>
       <p:sp>
         <p:nvSpPr>
-          <p:cNvPr id="6" name="Rectangle 5"/>
-          <p:cNvSpPr/>
-          <p:nvPr/>
-        </p:nvSpPr>
-        <p:spPr>
-          <a:xfrm>
-            <a:off x="8442742" y="585465"/>
+          <p:cNvPr id="9" name="Rectangle 8"/>
+          <p:cNvSpPr/>
+          <p:nvPr/>
+        </p:nvSpPr>
+        <p:spPr>
+          <a:xfrm>
+            <a:off x="4313752" y="2182732"/>
             <a:ext cx="2064494" cy="1597267"/>
           </a:xfrm>
           <a:prstGeom prst="rect">
@@ -12021,20 +12195,20 @@
                 </a:solidFill>
                 <a:latin typeface="Arial"/>
               </a:rPr>
-              <a:t>*бабок у подъезда</a:t>
+              <a:t>яжмамок</a:t>
             </a:r>
           </a:p>
         </p:txBody>
       </p:sp>
       <p:sp>
         <p:nvSpPr>
-          <p:cNvPr id="7" name="Rectangle 6"/>
-          <p:cNvSpPr/>
-          <p:nvPr/>
-        </p:nvSpPr>
-        <p:spPr>
-          <a:xfrm>
-            <a:off x="184762" y="2182732"/>
+          <p:cNvPr id="10" name="Rectangle 9"/>
+          <p:cNvSpPr/>
+          <p:nvPr/>
+        </p:nvSpPr>
+        <p:spPr>
+          <a:xfrm>
+            <a:off x="6378247" y="2182732"/>
             <a:ext cx="2064494" cy="1597267"/>
           </a:xfrm>
           <a:prstGeom prst="rect">
@@ -12086,13 +12260,13 @@
       </p:sp>
       <p:sp>
         <p:nvSpPr>
-          <p:cNvPr id="8" name="Rectangle 7"/>
-          <p:cNvSpPr/>
-          <p:nvPr/>
-        </p:nvSpPr>
-        <p:spPr>
-          <a:xfrm>
-            <a:off x="2249257" y="2182732"/>
+          <p:cNvPr id="11" name="Rectangle 10"/>
+          <p:cNvSpPr/>
+          <p:nvPr/>
+        </p:nvSpPr>
+        <p:spPr>
+          <a:xfrm>
+            <a:off x="8442742" y="2182732"/>
             <a:ext cx="2064494" cy="1597267"/>
           </a:xfrm>
           <a:prstGeom prst="rect">
@@ -12144,180 +12318,6 @@
       </p:sp>
       <p:sp>
         <p:nvSpPr>
-          <p:cNvPr id="9" name="Rectangle 8"/>
-          <p:cNvSpPr/>
-          <p:nvPr/>
-        </p:nvSpPr>
-        <p:spPr>
-          <a:xfrm>
-            <a:off x="4313752" y="2182732"/>
-            <a:ext cx="2064494" cy="1597267"/>
-          </a:xfrm>
-          <a:prstGeom prst="rect">
-            <a:avLst/>
-          </a:prstGeom>
-          <a:noFill/>
-          <a:ln>
-            <a:noFill/>
-          </a:ln>
-          <a:effectLst/>
-        </p:spPr>
-        <p:style>
-          <a:lnRef idx="1">
-            <a:schemeClr val="accent1"/>
-          </a:lnRef>
-          <a:fillRef idx="3">
-            <a:schemeClr val="accent1"/>
-          </a:fillRef>
-          <a:effectRef idx="2">
-            <a:schemeClr val="accent1"/>
-          </a:effectRef>
-          <a:fontRef idx="minor">
-            <a:schemeClr val="lt1"/>
-          </a:fontRef>
-        </p:style>
-        <p:txBody>
-          <a:bodyPr rtlCol="0" anchor="t" wrap="square" lIns="72438" rIns="72438" tIns="57950" bIns="57950"/>
-          <a:lstStyle/>
-          <a:p>
-            <a:pPr algn="ctr">
-              <a:spcBef>
-                <a:spcPts val="0"/>
-              </a:spcBef>
-              <a:spcAft>
-                <a:spcPts val="0"/>
-              </a:spcAft>
-            </a:pPr>
-            <a:r>
-              <a:rPr sz="2000" b="1">
-                <a:solidFill>
-                  <a:srgbClr val="1A1A1A"/>
-                </a:solidFill>
-                <a:latin typeface="Arial"/>
-              </a:rPr>
-              <a:t>*душнил</a:t>
-            </a:r>
-          </a:p>
-        </p:txBody>
-      </p:sp>
-      <p:sp>
-        <p:nvSpPr>
-          <p:cNvPr id="10" name="Rectangle 9"/>
-          <p:cNvSpPr/>
-          <p:nvPr/>
-        </p:nvSpPr>
-        <p:spPr>
-          <a:xfrm>
-            <a:off x="6378247" y="2182732"/>
-            <a:ext cx="2064494" cy="1597267"/>
-          </a:xfrm>
-          <a:prstGeom prst="rect">
-            <a:avLst/>
-          </a:prstGeom>
-          <a:noFill/>
-          <a:ln>
-            <a:noFill/>
-          </a:ln>
-          <a:effectLst/>
-        </p:spPr>
-        <p:style>
-          <a:lnRef idx="1">
-            <a:schemeClr val="accent1"/>
-          </a:lnRef>
-          <a:fillRef idx="3">
-            <a:schemeClr val="accent1"/>
-          </a:fillRef>
-          <a:effectRef idx="2">
-            <a:schemeClr val="accent1"/>
-          </a:effectRef>
-          <a:fontRef idx="minor">
-            <a:schemeClr val="lt1"/>
-          </a:fontRef>
-        </p:style>
-        <p:txBody>
-          <a:bodyPr rtlCol="0" anchor="t" wrap="square" lIns="72438" rIns="72438" tIns="57950" bIns="57950"/>
-          <a:lstStyle/>
-          <a:p>
-            <a:pPr algn="ctr">
-              <a:spcBef>
-                <a:spcPts val="0"/>
-              </a:spcBef>
-              <a:spcAft>
-                <a:spcPts val="0"/>
-              </a:spcAft>
-            </a:pPr>
-            <a:r>
-              <a:rPr sz="2000" b="1">
-                <a:solidFill>
-                  <a:srgbClr val="1A1A1A"/>
-                </a:solidFill>
-                <a:latin typeface="Arial"/>
-              </a:rPr>
-              <a:t>милф</a:t>
-            </a:r>
-          </a:p>
-        </p:txBody>
-      </p:sp>
-      <p:sp>
-        <p:nvSpPr>
-          <p:cNvPr id="11" name="Rectangle 10"/>
-          <p:cNvSpPr/>
-          <p:nvPr/>
-        </p:nvSpPr>
-        <p:spPr>
-          <a:xfrm>
-            <a:off x="8442742" y="2182732"/>
-            <a:ext cx="2064494" cy="1597267"/>
-          </a:xfrm>
-          <a:prstGeom prst="rect">
-            <a:avLst/>
-          </a:prstGeom>
-          <a:noFill/>
-          <a:ln>
-            <a:noFill/>
-          </a:ln>
-          <a:effectLst/>
-        </p:spPr>
-        <p:style>
-          <a:lnRef idx="1">
-            <a:schemeClr val="accent1"/>
-          </a:lnRef>
-          <a:fillRef idx="3">
-            <a:schemeClr val="accent1"/>
-          </a:fillRef>
-          <a:effectRef idx="2">
-            <a:schemeClr val="accent1"/>
-          </a:effectRef>
-          <a:fontRef idx="minor">
-            <a:schemeClr val="lt1"/>
-          </a:fontRef>
-        </p:style>
-        <p:txBody>
-          <a:bodyPr rtlCol="0" anchor="t" wrap="square" lIns="72438" rIns="72438" tIns="57950" bIns="57950"/>
-          <a:lstStyle/>
-          <a:p>
-            <a:pPr algn="ctr">
-              <a:spcBef>
-                <a:spcPts val="0"/>
-              </a:spcBef>
-              <a:spcAft>
-                <a:spcPts val="0"/>
-              </a:spcAft>
-            </a:pPr>
-            <a:r>
-              <a:rPr sz="2000" b="1">
-                <a:solidFill>
-                  <a:srgbClr val="1A1A1A"/>
-                </a:solidFill>
-                <a:latin typeface="Arial"/>
-              </a:rPr>
-              <a:t>пузатых скуфов</a:t>
-            </a:r>
-          </a:p>
-        </p:txBody>
-      </p:sp>
-      <p:sp>
-        <p:nvSpPr>
           <p:cNvPr id="12" name="Rectangle 11"/>
           <p:cNvSpPr/>
           <p:nvPr/>
@@ -12382,180 +12382,6 @@
         </p:nvSpPr>
         <p:spPr>
           <a:xfrm>
-            <a:off x="2249257" y="3780000"/>
-            <a:ext cx="2064494" cy="1597267"/>
-          </a:xfrm>
-          <a:prstGeom prst="rect">
-            <a:avLst/>
-          </a:prstGeom>
-          <a:noFill/>
-          <a:ln>
-            <a:noFill/>
-          </a:ln>
-          <a:effectLst/>
-        </p:spPr>
-        <p:style>
-          <a:lnRef idx="1">
-            <a:schemeClr val="accent1"/>
-          </a:lnRef>
-          <a:fillRef idx="3">
-            <a:schemeClr val="accent1"/>
-          </a:fillRef>
-          <a:effectRef idx="2">
-            <a:schemeClr val="accent1"/>
-          </a:effectRef>
-          <a:fontRef idx="minor">
-            <a:schemeClr val="lt1"/>
-          </a:fontRef>
-        </p:style>
-        <p:txBody>
-          <a:bodyPr rtlCol="0" anchor="t" wrap="square" lIns="72438" rIns="72438" tIns="57950" bIns="57950"/>
-          <a:lstStyle/>
-          <a:p>
-            <a:pPr algn="ctr">
-              <a:spcBef>
-                <a:spcPts val="0"/>
-              </a:spcBef>
-              <a:spcAft>
-                <a:spcPts val="0"/>
-              </a:spcAft>
-            </a:pPr>
-            <a:r>
-              <a:rPr sz="2000" b="1">
-                <a:solidFill>
-                  <a:srgbClr val="1A1A1A"/>
-                </a:solidFill>
-                <a:latin typeface="Arial"/>
-              </a:rPr>
-              <a:t>*ботаников</a:t>
-            </a:r>
-          </a:p>
-        </p:txBody>
-      </p:sp>
-      <p:sp>
-        <p:nvSpPr>
-          <p:cNvPr id="14" name="Rectangle 13"/>
-          <p:cNvSpPr/>
-          <p:nvPr/>
-        </p:nvSpPr>
-        <p:spPr>
-          <a:xfrm>
-            <a:off x="4313752" y="3780000"/>
-            <a:ext cx="2064494" cy="1597267"/>
-          </a:xfrm>
-          <a:prstGeom prst="rect">
-            <a:avLst/>
-          </a:prstGeom>
-          <a:noFill/>
-          <a:ln>
-            <a:noFill/>
-          </a:ln>
-          <a:effectLst/>
-        </p:spPr>
-        <p:style>
-          <a:lnRef idx="1">
-            <a:schemeClr val="accent1"/>
-          </a:lnRef>
-          <a:fillRef idx="3">
-            <a:schemeClr val="accent1"/>
-          </a:fillRef>
-          <a:effectRef idx="2">
-            <a:schemeClr val="accent1"/>
-          </a:effectRef>
-          <a:fontRef idx="minor">
-            <a:schemeClr val="lt1"/>
-          </a:fontRef>
-        </p:style>
-        <p:txBody>
-          <a:bodyPr rtlCol="0" anchor="t" wrap="square" lIns="72438" rIns="72438" tIns="57950" bIns="57950"/>
-          <a:lstStyle/>
-          <a:p>
-            <a:pPr algn="ctr">
-              <a:spcBef>
-                <a:spcPts val="0"/>
-              </a:spcBef>
-              <a:spcAft>
-                <a:spcPts val="0"/>
-              </a:spcAft>
-            </a:pPr>
-            <a:r>
-              <a:rPr sz="2000" b="1">
-                <a:solidFill>
-                  <a:srgbClr val="1A1A1A"/>
-                </a:solidFill>
-                <a:latin typeface="Arial"/>
-              </a:rPr>
-              <a:t>*нейросетей</a:t>
-            </a:r>
-          </a:p>
-        </p:txBody>
-      </p:sp>
-      <p:sp>
-        <p:nvSpPr>
-          <p:cNvPr id="15" name="Rectangle 14"/>
-          <p:cNvSpPr/>
-          <p:nvPr/>
-        </p:nvSpPr>
-        <p:spPr>
-          <a:xfrm>
-            <a:off x="6378247" y="3780000"/>
-            <a:ext cx="2064494" cy="1597267"/>
-          </a:xfrm>
-          <a:prstGeom prst="rect">
-            <a:avLst/>
-          </a:prstGeom>
-          <a:noFill/>
-          <a:ln>
-            <a:noFill/>
-          </a:ln>
-          <a:effectLst/>
-        </p:spPr>
-        <p:style>
-          <a:lnRef idx="1">
-            <a:schemeClr val="accent1"/>
-          </a:lnRef>
-          <a:fillRef idx="3">
-            <a:schemeClr val="accent1"/>
-          </a:fillRef>
-          <a:effectRef idx="2">
-            <a:schemeClr val="accent1"/>
-          </a:effectRef>
-          <a:fontRef idx="minor">
-            <a:schemeClr val="lt1"/>
-          </a:fontRef>
-        </p:style>
-        <p:txBody>
-          <a:bodyPr rtlCol="0" anchor="t" wrap="square" lIns="72438" rIns="72438" tIns="57950" bIns="57950"/>
-          <a:lstStyle/>
-          <a:p>
-            <a:pPr algn="ctr">
-              <a:spcBef>
-                <a:spcPts val="0"/>
-              </a:spcBef>
-              <a:spcAft>
-                <a:spcPts val="0"/>
-              </a:spcAft>
-            </a:pPr>
-            <a:r>
-              <a:rPr sz="2000" b="1">
-                <a:solidFill>
-                  <a:srgbClr val="1A1A1A"/>
-                </a:solidFill>
-                <a:latin typeface="Arial"/>
-              </a:rPr>
-              <a:t>яжмамок</a:t>
-            </a:r>
-          </a:p>
-        </p:txBody>
-      </p:sp>
-      <p:sp>
-        <p:nvSpPr>
-          <p:cNvPr id="16" name="Rectangle 15"/>
-          <p:cNvSpPr/>
-          <p:nvPr/>
-        </p:nvSpPr>
-        <p:spPr>
-          <a:xfrm>
             <a:off x="184762" y="580703"/>
             <a:ext cx="2064494" cy="9525"/>
           </a:xfrm>
@@ -12594,7 +12420,7 @@
       </p:sp>
       <p:sp>
         <p:nvSpPr>
-          <p:cNvPr id="17" name="Rectangle 16"/>
+          <p:cNvPr id="14" name="Rectangle 13"/>
           <p:cNvSpPr/>
           <p:nvPr/>
         </p:nvSpPr>
@@ -12638,7 +12464,7 @@
       </p:sp>
       <p:sp>
         <p:nvSpPr>
-          <p:cNvPr id="18" name="Rectangle 17"/>
+          <p:cNvPr id="15" name="Rectangle 14"/>
           <p:cNvSpPr/>
           <p:nvPr/>
         </p:nvSpPr>
@@ -12682,7 +12508,7 @@
       </p:sp>
       <p:sp>
         <p:nvSpPr>
-          <p:cNvPr id="19" name="Rectangle 18"/>
+          <p:cNvPr id="16" name="Rectangle 15"/>
           <p:cNvSpPr/>
           <p:nvPr/>
         </p:nvSpPr>
@@ -12726,7 +12552,7 @@
       </p:sp>
       <p:sp>
         <p:nvSpPr>
-          <p:cNvPr id="20" name="Rectangle 19"/>
+          <p:cNvPr id="17" name="Rectangle 16"/>
           <p:cNvSpPr/>
           <p:nvPr/>
         </p:nvSpPr>
@@ -12770,7 +12596,7 @@
       </p:sp>
       <p:sp>
         <p:nvSpPr>
-          <p:cNvPr id="21" name="Rectangle 20"/>
+          <p:cNvPr id="18" name="Rectangle 17"/>
           <p:cNvSpPr/>
           <p:nvPr/>
         </p:nvSpPr>
@@ -12814,7 +12640,7 @@
       </p:sp>
       <p:sp>
         <p:nvSpPr>
-          <p:cNvPr id="22" name="Rectangle 21"/>
+          <p:cNvPr id="19" name="Rectangle 18"/>
           <p:cNvSpPr/>
           <p:nvPr/>
         </p:nvSpPr>
@@ -12858,7 +12684,7 @@
       </p:sp>
       <p:sp>
         <p:nvSpPr>
-          <p:cNvPr id="23" name="Rectangle 22"/>
+          <p:cNvPr id="20" name="Rectangle 19"/>
           <p:cNvSpPr/>
           <p:nvPr/>
         </p:nvSpPr>
@@ -12902,7 +12728,7 @@
       </p:sp>
       <p:sp>
         <p:nvSpPr>
-          <p:cNvPr id="24" name="Rectangle 23"/>
+          <p:cNvPr id="21" name="Rectangle 20"/>
           <p:cNvSpPr/>
           <p:nvPr/>
         </p:nvSpPr>
@@ -12946,7 +12772,7 @@
       </p:sp>
       <p:sp>
         <p:nvSpPr>
-          <p:cNvPr id="25" name="Rectangle 24"/>
+          <p:cNvPr id="22" name="Rectangle 21"/>
           <p:cNvSpPr/>
           <p:nvPr/>
         </p:nvSpPr>
@@ -12990,7 +12816,7 @@
       </p:sp>
       <p:sp>
         <p:nvSpPr>
-          <p:cNvPr id="26" name="Rectangle 25"/>
+          <p:cNvPr id="23" name="Rectangle 22"/>
           <p:cNvSpPr/>
           <p:nvPr/>
         </p:nvSpPr>
@@ -13034,7 +12860,7 @@
       </p:sp>
       <p:sp>
         <p:nvSpPr>
-          <p:cNvPr id="27" name="Rectangle 26"/>
+          <p:cNvPr id="24" name="Rectangle 23"/>
           <p:cNvSpPr/>
           <p:nvPr/>
         </p:nvSpPr>
@@ -13078,7 +12904,7 @@
       </p:sp>
       <p:sp>
         <p:nvSpPr>
-          <p:cNvPr id="28" name="Rectangle 27"/>
+          <p:cNvPr id="25" name="Rectangle 24"/>
           <p:cNvSpPr/>
           <p:nvPr/>
         </p:nvSpPr>
@@ -13122,7 +12948,7 @@
       </p:sp>
       <p:sp>
         <p:nvSpPr>
-          <p:cNvPr id="29" name="Rectangle 28"/>
+          <p:cNvPr id="26" name="Rectangle 25"/>
           <p:cNvSpPr/>
           <p:nvPr/>
         </p:nvSpPr>
@@ -13166,7 +12992,7 @@
       </p:sp>
       <p:sp>
         <p:nvSpPr>
-          <p:cNvPr id="30" name="Rectangle 29"/>
+          <p:cNvPr id="27" name="Rectangle 26"/>
           <p:cNvSpPr/>
           <p:nvPr/>
         </p:nvSpPr>
@@ -13210,7 +13036,7 @@
       </p:sp>
       <p:sp>
         <p:nvSpPr>
-          <p:cNvPr id="31" name="Rectangle 30"/>
+          <p:cNvPr id="28" name="Rectangle 27"/>
           <p:cNvSpPr/>
           <p:nvPr/>
         </p:nvSpPr>
@@ -13254,139 +13080,7 @@
       </p:sp>
       <p:sp>
         <p:nvSpPr>
-          <p:cNvPr id="32" name="Rectangle 31"/>
-          <p:cNvSpPr/>
-          <p:nvPr/>
-        </p:nvSpPr>
-        <p:spPr>
-          <a:xfrm>
-            <a:off x="2249257" y="5372504"/>
-            <a:ext cx="2064494" cy="9525"/>
-          </a:xfrm>
-          <a:prstGeom prst="rect">
-            <a:avLst/>
-          </a:prstGeom>
-          <a:solidFill>
-            <a:srgbClr val="C0C0C0"/>
-          </a:solidFill>
-          <a:ln>
-            <a:noFill/>
-          </a:ln>
-          <a:effectLst/>
-        </p:spPr>
-        <p:style>
-          <a:lnRef idx="1">
-            <a:schemeClr val="accent1"/>
-          </a:lnRef>
-          <a:fillRef idx="3">
-            <a:schemeClr val="accent1"/>
-          </a:fillRef>
-          <a:effectRef idx="2">
-            <a:schemeClr val="accent1"/>
-          </a:effectRef>
-          <a:fontRef idx="minor">
-            <a:schemeClr val="lt1"/>
-          </a:fontRef>
-        </p:style>
-        <p:txBody>
-          <a:bodyPr rtlCol="0" anchor="ctr"/>
-          <a:lstStyle/>
-          <a:p>
-            <a:pPr algn="ctr"/>
-          </a:p>
-        </p:txBody>
-      </p:sp>
-      <p:sp>
-        <p:nvSpPr>
-          <p:cNvPr id="33" name="Rectangle 32"/>
-          <p:cNvSpPr/>
-          <p:nvPr/>
-        </p:nvSpPr>
-        <p:spPr>
-          <a:xfrm>
-            <a:off x="4313752" y="5372504"/>
-            <a:ext cx="2064494" cy="9525"/>
-          </a:xfrm>
-          <a:prstGeom prst="rect">
-            <a:avLst/>
-          </a:prstGeom>
-          <a:solidFill>
-            <a:srgbClr val="C0C0C0"/>
-          </a:solidFill>
-          <a:ln>
-            <a:noFill/>
-          </a:ln>
-          <a:effectLst/>
-        </p:spPr>
-        <p:style>
-          <a:lnRef idx="1">
-            <a:schemeClr val="accent1"/>
-          </a:lnRef>
-          <a:fillRef idx="3">
-            <a:schemeClr val="accent1"/>
-          </a:fillRef>
-          <a:effectRef idx="2">
-            <a:schemeClr val="accent1"/>
-          </a:effectRef>
-          <a:fontRef idx="minor">
-            <a:schemeClr val="lt1"/>
-          </a:fontRef>
-        </p:style>
-        <p:txBody>
-          <a:bodyPr rtlCol="0" anchor="ctr"/>
-          <a:lstStyle/>
-          <a:p>
-            <a:pPr algn="ctr"/>
-          </a:p>
-        </p:txBody>
-      </p:sp>
-      <p:sp>
-        <p:nvSpPr>
-          <p:cNvPr id="34" name="Rectangle 33"/>
-          <p:cNvSpPr/>
-          <p:nvPr/>
-        </p:nvSpPr>
-        <p:spPr>
-          <a:xfrm>
-            <a:off x="6378247" y="5372504"/>
-            <a:ext cx="2064494" cy="9525"/>
-          </a:xfrm>
-          <a:prstGeom prst="rect">
-            <a:avLst/>
-          </a:prstGeom>
-          <a:solidFill>
-            <a:srgbClr val="C0C0C0"/>
-          </a:solidFill>
-          <a:ln>
-            <a:noFill/>
-          </a:ln>
-          <a:effectLst/>
-        </p:spPr>
-        <p:style>
-          <a:lnRef idx="1">
-            <a:schemeClr val="accent1"/>
-          </a:lnRef>
-          <a:fillRef idx="3">
-            <a:schemeClr val="accent1"/>
-          </a:fillRef>
-          <a:effectRef idx="2">
-            <a:schemeClr val="accent1"/>
-          </a:effectRef>
-          <a:fontRef idx="minor">
-            <a:schemeClr val="lt1"/>
-          </a:fontRef>
-        </p:style>
-        <p:txBody>
-          <a:bodyPr rtlCol="0" anchor="ctr"/>
-          <a:lstStyle/>
-          <a:p>
-            <a:pPr algn="ctr"/>
-          </a:p>
-        </p:txBody>
-      </p:sp>
-      <p:sp>
-        <p:nvSpPr>
-          <p:cNvPr id="35" name="Rectangle 34"/>
+          <p:cNvPr id="29" name="Rectangle 28"/>
           <p:cNvSpPr/>
           <p:nvPr/>
         </p:nvSpPr>
@@ -13430,7 +13124,7 @@
       </p:sp>
       <p:sp>
         <p:nvSpPr>
-          <p:cNvPr id="36" name="Rectangle 35"/>
+          <p:cNvPr id="30" name="Rectangle 29"/>
           <p:cNvSpPr/>
           <p:nvPr/>
         </p:nvSpPr>
@@ -13474,7 +13168,7 @@
       </p:sp>
       <p:sp>
         <p:nvSpPr>
-          <p:cNvPr id="37" name="Rectangle 36"/>
+          <p:cNvPr id="31" name="Rectangle 30"/>
           <p:cNvSpPr/>
           <p:nvPr/>
         </p:nvSpPr>
@@ -13518,7 +13212,7 @@
       </p:sp>
       <p:sp>
         <p:nvSpPr>
-          <p:cNvPr id="38" name="Rectangle 37"/>
+          <p:cNvPr id="32" name="Rectangle 31"/>
           <p:cNvSpPr/>
           <p:nvPr/>
         </p:nvSpPr>
@@ -13562,7 +13256,7 @@
       </p:sp>
       <p:sp>
         <p:nvSpPr>
-          <p:cNvPr id="39" name="Rectangle 38"/>
+          <p:cNvPr id="33" name="Rectangle 32"/>
           <p:cNvSpPr/>
           <p:nvPr/>
         </p:nvSpPr>
@@ -13606,7 +13300,7 @@
       </p:sp>
       <p:sp>
         <p:nvSpPr>
-          <p:cNvPr id="40" name="Rectangle 39"/>
+          <p:cNvPr id="34" name="Rectangle 33"/>
           <p:cNvSpPr/>
           <p:nvPr/>
         </p:nvSpPr>
@@ -13650,7 +13344,7 @@
       </p:sp>
       <p:sp>
         <p:nvSpPr>
-          <p:cNvPr id="41" name="Rectangle 40"/>
+          <p:cNvPr id="35" name="Rectangle 34"/>
           <p:cNvSpPr/>
           <p:nvPr/>
         </p:nvSpPr>
@@ -13694,7 +13388,7 @@
       </p:sp>
       <p:sp>
         <p:nvSpPr>
-          <p:cNvPr id="42" name="Rectangle 41"/>
+          <p:cNvPr id="36" name="Rectangle 35"/>
           <p:cNvSpPr/>
           <p:nvPr/>
         </p:nvSpPr>
@@ -13738,51 +13432,7 @@
       </p:sp>
       <p:sp>
         <p:nvSpPr>
-          <p:cNvPr id="43" name="Rectangle 42"/>
-          <p:cNvSpPr/>
-          <p:nvPr/>
-        </p:nvSpPr>
-        <p:spPr>
-          <a:xfrm>
-            <a:off x="4308990" y="3780000"/>
-            <a:ext cx="9525" cy="1597267"/>
-          </a:xfrm>
-          <a:prstGeom prst="rect">
-            <a:avLst/>
-          </a:prstGeom>
-          <a:solidFill>
-            <a:srgbClr val="C0C0C0"/>
-          </a:solidFill>
-          <a:ln>
-            <a:noFill/>
-          </a:ln>
-          <a:effectLst/>
-        </p:spPr>
-        <p:style>
-          <a:lnRef idx="1">
-            <a:schemeClr val="accent1"/>
-          </a:lnRef>
-          <a:fillRef idx="3">
-            <a:schemeClr val="accent1"/>
-          </a:fillRef>
-          <a:effectRef idx="2">
-            <a:schemeClr val="accent1"/>
-          </a:effectRef>
-          <a:fontRef idx="minor">
-            <a:schemeClr val="lt1"/>
-          </a:fontRef>
-        </p:style>
-        <p:txBody>
-          <a:bodyPr rtlCol="0" anchor="ctr"/>
-          <a:lstStyle/>
-          <a:p>
-            <a:pPr algn="ctr"/>
-          </a:p>
-        </p:txBody>
-      </p:sp>
-      <p:sp>
-        <p:nvSpPr>
-          <p:cNvPr id="44" name="Rectangle 43"/>
+          <p:cNvPr id="37" name="Rectangle 36"/>
           <p:cNvSpPr/>
           <p:nvPr/>
         </p:nvSpPr>
@@ -13826,7 +13476,7 @@
       </p:sp>
       <p:sp>
         <p:nvSpPr>
-          <p:cNvPr id="45" name="Rectangle 44"/>
+          <p:cNvPr id="38" name="Rectangle 37"/>
           <p:cNvSpPr/>
           <p:nvPr/>
         </p:nvSpPr>
@@ -13870,51 +13520,7 @@
       </p:sp>
       <p:sp>
         <p:nvSpPr>
-          <p:cNvPr id="46" name="Rectangle 45"/>
-          <p:cNvSpPr/>
-          <p:nvPr/>
-        </p:nvSpPr>
-        <p:spPr>
-          <a:xfrm>
-            <a:off x="6373485" y="3780000"/>
-            <a:ext cx="9525" cy="1597267"/>
-          </a:xfrm>
-          <a:prstGeom prst="rect">
-            <a:avLst/>
-          </a:prstGeom>
-          <a:solidFill>
-            <a:srgbClr val="C0C0C0"/>
-          </a:solidFill>
-          <a:ln>
-            <a:noFill/>
-          </a:ln>
-          <a:effectLst/>
-        </p:spPr>
-        <p:style>
-          <a:lnRef idx="1">
-            <a:schemeClr val="accent1"/>
-          </a:lnRef>
-          <a:fillRef idx="3">
-            <a:schemeClr val="accent1"/>
-          </a:fillRef>
-          <a:effectRef idx="2">
-            <a:schemeClr val="accent1"/>
-          </a:effectRef>
-          <a:fontRef idx="minor">
-            <a:schemeClr val="lt1"/>
-          </a:fontRef>
-        </p:style>
-        <p:txBody>
-          <a:bodyPr rtlCol="0" anchor="ctr"/>
-          <a:lstStyle/>
-          <a:p>
-            <a:pPr algn="ctr"/>
-          </a:p>
-        </p:txBody>
-      </p:sp>
-      <p:sp>
-        <p:nvSpPr>
-          <p:cNvPr id="47" name="Rectangle 46"/>
+          <p:cNvPr id="39" name="Rectangle 38"/>
           <p:cNvSpPr/>
           <p:nvPr/>
         </p:nvSpPr>
@@ -13958,7 +13564,7 @@
       </p:sp>
       <p:sp>
         <p:nvSpPr>
-          <p:cNvPr id="48" name="Rectangle 47"/>
+          <p:cNvPr id="40" name="Rectangle 39"/>
           <p:cNvSpPr/>
           <p:nvPr/>
         </p:nvSpPr>
@@ -14002,51 +13608,7 @@
       </p:sp>
       <p:sp>
         <p:nvSpPr>
-          <p:cNvPr id="49" name="Rectangle 48"/>
-          <p:cNvSpPr/>
-          <p:nvPr/>
-        </p:nvSpPr>
-        <p:spPr>
-          <a:xfrm>
-            <a:off x="8437980" y="3780000"/>
-            <a:ext cx="9525" cy="1597267"/>
-          </a:xfrm>
-          <a:prstGeom prst="rect">
-            <a:avLst/>
-          </a:prstGeom>
-          <a:solidFill>
-            <a:srgbClr val="C0C0C0"/>
-          </a:solidFill>
-          <a:ln>
-            <a:noFill/>
-          </a:ln>
-          <a:effectLst/>
-        </p:spPr>
-        <p:style>
-          <a:lnRef idx="1">
-            <a:schemeClr val="accent1"/>
-          </a:lnRef>
-          <a:fillRef idx="3">
-            <a:schemeClr val="accent1"/>
-          </a:fillRef>
-          <a:effectRef idx="2">
-            <a:schemeClr val="accent1"/>
-          </a:effectRef>
-          <a:fontRef idx="minor">
-            <a:schemeClr val="lt1"/>
-          </a:fontRef>
-        </p:style>
-        <p:txBody>
-          <a:bodyPr rtlCol="0" anchor="ctr"/>
-          <a:lstStyle/>
-          <a:p>
-            <a:pPr algn="ctr"/>
-          </a:p>
-        </p:txBody>
-      </p:sp>
-      <p:sp>
-        <p:nvSpPr>
-          <p:cNvPr id="50" name="Rectangle 49"/>
+          <p:cNvPr id="41" name="Rectangle 40"/>
           <p:cNvSpPr/>
           <p:nvPr/>
         </p:nvSpPr>
@@ -14090,7 +13652,7 @@
       </p:sp>
       <p:sp>
         <p:nvSpPr>
-          <p:cNvPr id="51" name="Rectangle 50"/>
+          <p:cNvPr id="42" name="Rectangle 41"/>
           <p:cNvSpPr/>
           <p:nvPr/>
         </p:nvSpPr>

</xml_diff>

<commit_message>
Remove theme shadows; strengthen sheet labels; rewrite seven face prompts.
</commit_message>
<xml_diff>
--- a/output/svet-moy-zerkalce-cards.pptx
+++ b/output/svet-moy-zerkalce-cards.pptx
@@ -3108,22 +3108,7 @@
           <a:ln>
             <a:noFill/>
           </a:ln>
-          <a:effectLst/>
-        </p:spPr>
-        <p:style>
-          <a:lnRef idx="1">
-            <a:schemeClr val="accent1"/>
-          </a:lnRef>
-          <a:fillRef idx="3">
-            <a:schemeClr val="accent1"/>
-          </a:fillRef>
-          <a:effectRef idx="2">
-            <a:schemeClr val="accent1"/>
-          </a:effectRef>
-          <a:fontRef idx="minor">
-            <a:schemeClr val="lt1"/>
-          </a:fontRef>
-        </p:style>
+        </p:spPr>
         <p:txBody>
           <a:bodyPr rtlCol="0" anchor="b" wrap="square" lIns="72438" rIns="72438" tIns="57950" bIns="57950"/>
           <a:lstStyle/>
@@ -3143,7 +3128,7 @@
                 </a:solidFill>
                 <a:latin typeface="Arial"/>
               </a:rPr>
-              <a:t>Произнеси заклинание превращения в</a:t>
+              <a:t>Заклинание превращения в одного из</a:t>
             </a:r>
           </a:p>
         </p:txBody>
@@ -3166,22 +3151,7 @@
           <a:ln>
             <a:noFill/>
           </a:ln>
-          <a:effectLst/>
-        </p:spPr>
-        <p:style>
-          <a:lnRef idx="1">
-            <a:schemeClr val="accent1"/>
-          </a:lnRef>
-          <a:fillRef idx="3">
-            <a:schemeClr val="accent1"/>
-          </a:fillRef>
-          <a:effectRef idx="2">
-            <a:schemeClr val="accent1"/>
-          </a:effectRef>
-          <a:fontRef idx="minor">
-            <a:schemeClr val="lt1"/>
-          </a:fontRef>
-        </p:style>
+        </p:spPr>
         <p:txBody>
           <a:bodyPr rtlCol="0" anchor="b" wrap="square" lIns="72438" rIns="72438" tIns="57950" bIns="57950"/>
           <a:lstStyle/>
@@ -3224,22 +3194,7 @@
           <a:ln>
             <a:noFill/>
           </a:ln>
-          <a:effectLst/>
-        </p:spPr>
-        <p:style>
-          <a:lnRef idx="1">
-            <a:schemeClr val="accent1"/>
-          </a:lnRef>
-          <a:fillRef idx="3">
-            <a:schemeClr val="accent1"/>
-          </a:fillRef>
-          <a:effectRef idx="2">
-            <a:schemeClr val="accent1"/>
-          </a:effectRef>
-          <a:fontRef idx="minor">
-            <a:schemeClr val="lt1"/>
-          </a:fontRef>
-        </p:style>
+        </p:spPr>
         <p:txBody>
           <a:bodyPr rtlCol="0" anchor="b" wrap="square" lIns="72438" rIns="72438" tIns="57950" bIns="57950"/>
           <a:lstStyle/>
@@ -3259,7 +3214,7 @@
                 </a:solidFill>
                 <a:latin typeface="Arial"/>
               </a:rPr>
-              <a:t>Подбери прозвище для любого из</a:t>
+              <a:t>Подбери прозвище для кого-то из</a:t>
             </a:r>
           </a:p>
         </p:txBody>
@@ -3282,22 +3237,7 @@
           <a:ln>
             <a:noFill/>
           </a:ln>
-          <a:effectLst/>
-        </p:spPr>
-        <p:style>
-          <a:lnRef idx="1">
-            <a:schemeClr val="accent1"/>
-          </a:lnRef>
-          <a:fillRef idx="3">
-            <a:schemeClr val="accent1"/>
-          </a:fillRef>
-          <a:effectRef idx="2">
-            <a:schemeClr val="accent1"/>
-          </a:effectRef>
-          <a:fontRef idx="minor">
-            <a:schemeClr val="lt1"/>
-          </a:fontRef>
-        </p:style>
+        </p:spPr>
         <p:txBody>
           <a:bodyPr rtlCol="0" anchor="b" wrap="square" lIns="72438" rIns="72438" tIns="57950" bIns="57950"/>
           <a:lstStyle/>
@@ -3340,22 +3280,7 @@
           <a:ln>
             <a:noFill/>
           </a:ln>
-          <a:effectLst/>
-        </p:spPr>
-        <p:style>
-          <a:lnRef idx="1">
-            <a:schemeClr val="accent1"/>
-          </a:lnRef>
-          <a:fillRef idx="3">
-            <a:schemeClr val="accent1"/>
-          </a:fillRef>
-          <a:effectRef idx="2">
-            <a:schemeClr val="accent1"/>
-          </a:effectRef>
-          <a:fontRef idx="minor">
-            <a:schemeClr val="lt1"/>
-          </a:fontRef>
-        </p:style>
+        </p:spPr>
         <p:txBody>
           <a:bodyPr rtlCol="0" anchor="b" wrap="square" lIns="72438" rIns="72438" tIns="57950" bIns="57950"/>
           <a:lstStyle/>
@@ -3375,7 +3300,7 @@
                 </a:solidFill>
                 <a:latin typeface="Arial"/>
               </a:rPr>
-              <a:t>Составь комплимент, который вгонит в краску</a:t>
+              <a:t>Комплимент, который вгонит в краску</a:t>
             </a:r>
           </a:p>
         </p:txBody>
@@ -3398,22 +3323,7 @@
           <a:ln>
             <a:noFill/>
           </a:ln>
-          <a:effectLst/>
-        </p:spPr>
-        <p:style>
-          <a:lnRef idx="1">
-            <a:schemeClr val="accent1"/>
-          </a:lnRef>
-          <a:fillRef idx="3">
-            <a:schemeClr val="accent1"/>
-          </a:fillRef>
-          <a:effectRef idx="2">
-            <a:schemeClr val="accent1"/>
-          </a:effectRef>
-          <a:fontRef idx="minor">
-            <a:schemeClr val="lt1"/>
-          </a:fontRef>
-        </p:style>
+        </p:spPr>
         <p:txBody>
           <a:bodyPr rtlCol="0" anchor="b" wrap="square" lIns="72438" rIns="72438" tIns="57950" bIns="57950"/>
           <a:lstStyle/>
@@ -3456,22 +3366,7 @@
           <a:ln>
             <a:noFill/>
           </a:ln>
-          <a:effectLst/>
-        </p:spPr>
-        <p:style>
-          <a:lnRef idx="1">
-            <a:schemeClr val="accent1"/>
-          </a:lnRef>
-          <a:fillRef idx="3">
-            <a:schemeClr val="accent1"/>
-          </a:fillRef>
-          <a:effectRef idx="2">
-            <a:schemeClr val="accent1"/>
-          </a:effectRef>
-          <a:fontRef idx="minor">
-            <a:schemeClr val="lt1"/>
-          </a:fontRef>
-        </p:style>
+        </p:spPr>
         <p:txBody>
           <a:bodyPr rtlCol="0" anchor="b" wrap="square" lIns="72438" rIns="72438" tIns="57950" bIns="57950"/>
           <a:lstStyle/>
@@ -3491,7 +3386,7 @@
                 </a:solidFill>
                 <a:latin typeface="Arial"/>
               </a:rPr>
-              <a:t>Что пригодится для пранка над любым из</a:t>
+              <a:t>Почему стоит избегать</a:t>
             </a:r>
           </a:p>
         </p:txBody>
@@ -3514,22 +3409,7 @@
           <a:ln>
             <a:noFill/>
           </a:ln>
-          <a:effectLst/>
-        </p:spPr>
-        <p:style>
-          <a:lnRef idx="1">
-            <a:schemeClr val="accent1"/>
-          </a:lnRef>
-          <a:fillRef idx="3">
-            <a:schemeClr val="accent1"/>
-          </a:fillRef>
-          <a:effectRef idx="2">
-            <a:schemeClr val="accent1"/>
-          </a:effectRef>
-          <a:fontRef idx="minor">
-            <a:schemeClr val="lt1"/>
-          </a:fontRef>
-        </p:style>
+        </p:spPr>
         <p:txBody>
           <a:bodyPr rtlCol="0" anchor="b" wrap="square" lIns="72438" rIns="72438" tIns="57950" bIns="57950"/>
           <a:lstStyle/>
@@ -3549,7 +3429,7 @@
                 </a:solidFill>
                 <a:latin typeface="Arial"/>
               </a:rPr>
-              <a:t>Какую пользу можно ожидать от</a:t>
+              <a:t>Какая польза от</a:t>
             </a:r>
           </a:p>
         </p:txBody>
@@ -3572,22 +3452,7 @@
           <a:ln>
             <a:noFill/>
           </a:ln>
-          <a:effectLst/>
-        </p:spPr>
-        <p:style>
-          <a:lnRef idx="1">
-            <a:schemeClr val="accent1"/>
-          </a:lnRef>
-          <a:fillRef idx="3">
-            <a:schemeClr val="accent1"/>
-          </a:fillRef>
-          <a:effectRef idx="2">
-            <a:schemeClr val="accent1"/>
-          </a:effectRef>
-          <a:fontRef idx="minor">
-            <a:schemeClr val="lt1"/>
-          </a:fontRef>
-        </p:style>
+        </p:spPr>
         <p:txBody>
           <a:bodyPr rtlCol="0" anchor="b" wrap="square" lIns="72438" rIns="72438" tIns="57950" bIns="57950"/>
           <a:lstStyle/>
@@ -3630,22 +3495,7 @@
           <a:ln>
             <a:noFill/>
           </a:ln>
-          <a:effectLst/>
-        </p:spPr>
-        <p:style>
-          <a:lnRef idx="1">
-            <a:schemeClr val="accent1"/>
-          </a:lnRef>
-          <a:fillRef idx="3">
-            <a:schemeClr val="accent1"/>
-          </a:fillRef>
-          <a:effectRef idx="2">
-            <a:schemeClr val="accent1"/>
-          </a:effectRef>
-          <a:fontRef idx="minor">
-            <a:schemeClr val="lt1"/>
-          </a:fontRef>
-        </p:style>
+        </p:spPr>
         <p:txBody>
           <a:bodyPr rtlCol="0" anchor="b" wrap="square" lIns="72438" rIns="72438" tIns="57950" bIns="57950"/>
           <a:lstStyle/>
@@ -3688,22 +3538,7 @@
           <a:ln>
             <a:noFill/>
           </a:ln>
-          <a:effectLst/>
-        </p:spPr>
-        <p:style>
-          <a:lnRef idx="1">
-            <a:schemeClr val="accent1"/>
-          </a:lnRef>
-          <a:fillRef idx="3">
-            <a:schemeClr val="accent1"/>
-          </a:fillRef>
-          <a:effectRef idx="2">
-            <a:schemeClr val="accent1"/>
-          </a:effectRef>
-          <a:fontRef idx="minor">
-            <a:schemeClr val="lt1"/>
-          </a:fontRef>
-        </p:style>
+        </p:spPr>
         <p:txBody>
           <a:bodyPr rtlCol="0" anchor="b" wrap="square" lIns="72438" rIns="72438" tIns="57950" bIns="57950"/>
           <a:lstStyle/>
@@ -3746,22 +3581,7 @@
           <a:ln>
             <a:noFill/>
           </a:ln>
-          <a:effectLst/>
-        </p:spPr>
-        <p:style>
-          <a:lnRef idx="1">
-            <a:schemeClr val="accent1"/>
-          </a:lnRef>
-          <a:fillRef idx="3">
-            <a:schemeClr val="accent1"/>
-          </a:fillRef>
-          <a:effectRef idx="2">
-            <a:schemeClr val="accent1"/>
-          </a:effectRef>
-          <a:fontRef idx="minor">
-            <a:schemeClr val="lt1"/>
-          </a:fontRef>
-        </p:style>
+        </p:spPr>
         <p:txBody>
           <a:bodyPr rtlCol="0" anchor="b" wrap="square" lIns="72438" rIns="72438" tIns="57950" bIns="57950"/>
           <a:lstStyle/>
@@ -3781,7 +3601,7 @@
                 </a:solidFill>
                 <a:latin typeface="Arial"/>
               </a:rPr>
-              <a:t>Какой подлянки можно ожидать от</a:t>
+              <a:t>Какой подлянки ждать от</a:t>
             </a:r>
           </a:p>
         </p:txBody>
@@ -3804,22 +3624,7 @@
           <a:ln>
             <a:noFill/>
           </a:ln>
-          <a:effectLst/>
-        </p:spPr>
-        <p:style>
-          <a:lnRef idx="1">
-            <a:schemeClr val="accent1"/>
-          </a:lnRef>
-          <a:fillRef idx="3">
-            <a:schemeClr val="accent1"/>
-          </a:fillRef>
-          <a:effectRef idx="2">
-            <a:schemeClr val="accent1"/>
-          </a:effectRef>
-          <a:fontRef idx="minor">
-            <a:schemeClr val="lt1"/>
-          </a:fontRef>
-        </p:style>
+        </p:spPr>
         <p:txBody>
           <a:bodyPr rtlCol="0" anchor="b" wrap="square" lIns="72438" rIns="72438" tIns="57950" bIns="57950"/>
           <a:lstStyle/>
@@ -3839,7 +3644,7 @@
                 </a:solidFill>
                 <a:latin typeface="Arial"/>
               </a:rPr>
-              <a:t>Лучший подарок</a:t>
+              <a:t>Лучший подарок для</a:t>
             </a:r>
           </a:p>
         </p:txBody>
@@ -3862,22 +3667,7 @@
           <a:ln>
             <a:noFill/>
           </a:ln>
-          <a:effectLst/>
-        </p:spPr>
-        <p:style>
-          <a:lnRef idx="1">
-            <a:schemeClr val="accent1"/>
-          </a:lnRef>
-          <a:fillRef idx="3">
-            <a:schemeClr val="accent1"/>
-          </a:fillRef>
-          <a:effectRef idx="2">
-            <a:schemeClr val="accent1"/>
-          </a:effectRef>
-          <a:fontRef idx="minor">
-            <a:schemeClr val="lt1"/>
-          </a:fontRef>
-        </p:style>
+        </p:spPr>
         <p:txBody>
           <a:bodyPr rtlCol="0" anchor="b" wrap="square" lIns="72438" rIns="72438" tIns="57950" bIns="57950"/>
           <a:lstStyle/>
@@ -3922,22 +3712,7 @@
           <a:ln>
             <a:noFill/>
           </a:ln>
-          <a:effectLst/>
-        </p:spPr>
-        <p:style>
-          <a:lnRef idx="1">
-            <a:schemeClr val="accent1"/>
-          </a:lnRef>
-          <a:fillRef idx="3">
-            <a:schemeClr val="accent1"/>
-          </a:fillRef>
-          <a:effectRef idx="2">
-            <a:schemeClr val="accent1"/>
-          </a:effectRef>
-          <a:fontRef idx="minor">
-            <a:schemeClr val="lt1"/>
-          </a:fontRef>
-        </p:style>
+        </p:spPr>
         <p:txBody>
           <a:bodyPr rtlCol="0" anchor="ctr"/>
           <a:lstStyle/>
@@ -3966,22 +3741,7 @@
           <a:ln>
             <a:noFill/>
           </a:ln>
-          <a:effectLst/>
-        </p:spPr>
-        <p:style>
-          <a:lnRef idx="1">
-            <a:schemeClr val="accent1"/>
-          </a:lnRef>
-          <a:fillRef idx="3">
-            <a:schemeClr val="accent1"/>
-          </a:fillRef>
-          <a:effectRef idx="2">
-            <a:schemeClr val="accent1"/>
-          </a:effectRef>
-          <a:fontRef idx="minor">
-            <a:schemeClr val="lt1"/>
-          </a:fontRef>
-        </p:style>
+        </p:spPr>
         <p:txBody>
           <a:bodyPr rtlCol="0" anchor="ctr"/>
           <a:lstStyle/>
@@ -4010,22 +3770,7 @@
           <a:ln>
             <a:noFill/>
           </a:ln>
-          <a:effectLst/>
-        </p:spPr>
-        <p:style>
-          <a:lnRef idx="1">
-            <a:schemeClr val="accent1"/>
-          </a:lnRef>
-          <a:fillRef idx="3">
-            <a:schemeClr val="accent1"/>
-          </a:fillRef>
-          <a:effectRef idx="2">
-            <a:schemeClr val="accent1"/>
-          </a:effectRef>
-          <a:fontRef idx="minor">
-            <a:schemeClr val="lt1"/>
-          </a:fontRef>
-        </p:style>
+        </p:spPr>
         <p:txBody>
           <a:bodyPr rtlCol="0" anchor="ctr"/>
           <a:lstStyle/>
@@ -4054,22 +3799,7 @@
           <a:ln>
             <a:noFill/>
           </a:ln>
-          <a:effectLst/>
-        </p:spPr>
-        <p:style>
-          <a:lnRef idx="1">
-            <a:schemeClr val="accent1"/>
-          </a:lnRef>
-          <a:fillRef idx="3">
-            <a:schemeClr val="accent1"/>
-          </a:fillRef>
-          <a:effectRef idx="2">
-            <a:schemeClr val="accent1"/>
-          </a:effectRef>
-          <a:fontRef idx="minor">
-            <a:schemeClr val="lt1"/>
-          </a:fontRef>
-        </p:style>
+        </p:spPr>
         <p:txBody>
           <a:bodyPr rtlCol="0" anchor="ctr"/>
           <a:lstStyle/>
@@ -4098,22 +3828,7 @@
           <a:ln>
             <a:noFill/>
           </a:ln>
-          <a:effectLst/>
-        </p:spPr>
-        <p:style>
-          <a:lnRef idx="1">
-            <a:schemeClr val="accent1"/>
-          </a:lnRef>
-          <a:fillRef idx="3">
-            <a:schemeClr val="accent1"/>
-          </a:fillRef>
-          <a:effectRef idx="2">
-            <a:schemeClr val="accent1"/>
-          </a:effectRef>
-          <a:fontRef idx="minor">
-            <a:schemeClr val="lt1"/>
-          </a:fontRef>
-        </p:style>
+        </p:spPr>
         <p:txBody>
           <a:bodyPr rtlCol="0" anchor="ctr"/>
           <a:lstStyle/>
@@ -4142,22 +3857,7 @@
           <a:ln>
             <a:noFill/>
           </a:ln>
-          <a:effectLst/>
-        </p:spPr>
-        <p:style>
-          <a:lnRef idx="1">
-            <a:schemeClr val="accent1"/>
-          </a:lnRef>
-          <a:fillRef idx="3">
-            <a:schemeClr val="accent1"/>
-          </a:fillRef>
-          <a:effectRef idx="2">
-            <a:schemeClr val="accent1"/>
-          </a:effectRef>
-          <a:fontRef idx="minor">
-            <a:schemeClr val="lt1"/>
-          </a:fontRef>
-        </p:style>
+        </p:spPr>
         <p:txBody>
           <a:bodyPr rtlCol="0" anchor="ctr"/>
           <a:lstStyle/>
@@ -4186,22 +3886,7 @@
           <a:ln>
             <a:noFill/>
           </a:ln>
-          <a:effectLst/>
-        </p:spPr>
-        <p:style>
-          <a:lnRef idx="1">
-            <a:schemeClr val="accent1"/>
-          </a:lnRef>
-          <a:fillRef idx="3">
-            <a:schemeClr val="accent1"/>
-          </a:fillRef>
-          <a:effectRef idx="2">
-            <a:schemeClr val="accent1"/>
-          </a:effectRef>
-          <a:fontRef idx="minor">
-            <a:schemeClr val="lt1"/>
-          </a:fontRef>
-        </p:style>
+        </p:spPr>
         <p:txBody>
           <a:bodyPr rtlCol="0" anchor="ctr"/>
           <a:lstStyle/>
@@ -4230,22 +3915,7 @@
           <a:ln>
             <a:noFill/>
           </a:ln>
-          <a:effectLst/>
-        </p:spPr>
-        <p:style>
-          <a:lnRef idx="1">
-            <a:schemeClr val="accent1"/>
-          </a:lnRef>
-          <a:fillRef idx="3">
-            <a:schemeClr val="accent1"/>
-          </a:fillRef>
-          <a:effectRef idx="2">
-            <a:schemeClr val="accent1"/>
-          </a:effectRef>
-          <a:fontRef idx="minor">
-            <a:schemeClr val="lt1"/>
-          </a:fontRef>
-        </p:style>
+        </p:spPr>
         <p:txBody>
           <a:bodyPr rtlCol="0" anchor="ctr"/>
           <a:lstStyle/>
@@ -4274,22 +3944,7 @@
           <a:ln>
             <a:noFill/>
           </a:ln>
-          <a:effectLst/>
-        </p:spPr>
-        <p:style>
-          <a:lnRef idx="1">
-            <a:schemeClr val="accent1"/>
-          </a:lnRef>
-          <a:fillRef idx="3">
-            <a:schemeClr val="accent1"/>
-          </a:fillRef>
-          <a:effectRef idx="2">
-            <a:schemeClr val="accent1"/>
-          </a:effectRef>
-          <a:fontRef idx="minor">
-            <a:schemeClr val="lt1"/>
-          </a:fontRef>
-        </p:style>
+        </p:spPr>
         <p:txBody>
           <a:bodyPr rtlCol="0" anchor="ctr"/>
           <a:lstStyle/>
@@ -4318,22 +3973,7 @@
           <a:ln>
             <a:noFill/>
           </a:ln>
-          <a:effectLst/>
-        </p:spPr>
-        <p:style>
-          <a:lnRef idx="1">
-            <a:schemeClr val="accent1"/>
-          </a:lnRef>
-          <a:fillRef idx="3">
-            <a:schemeClr val="accent1"/>
-          </a:fillRef>
-          <a:effectRef idx="2">
-            <a:schemeClr val="accent1"/>
-          </a:effectRef>
-          <a:fontRef idx="minor">
-            <a:schemeClr val="lt1"/>
-          </a:fontRef>
-        </p:style>
+        </p:spPr>
         <p:txBody>
           <a:bodyPr rtlCol="0" anchor="ctr"/>
           <a:lstStyle/>
@@ -4362,22 +4002,7 @@
           <a:ln>
             <a:noFill/>
           </a:ln>
-          <a:effectLst/>
-        </p:spPr>
-        <p:style>
-          <a:lnRef idx="1">
-            <a:schemeClr val="accent1"/>
-          </a:lnRef>
-          <a:fillRef idx="3">
-            <a:schemeClr val="accent1"/>
-          </a:fillRef>
-          <a:effectRef idx="2">
-            <a:schemeClr val="accent1"/>
-          </a:effectRef>
-          <a:fontRef idx="minor">
-            <a:schemeClr val="lt1"/>
-          </a:fontRef>
-        </p:style>
+        </p:spPr>
         <p:txBody>
           <a:bodyPr rtlCol="0" anchor="ctr"/>
           <a:lstStyle/>
@@ -4406,22 +4031,7 @@
           <a:ln>
             <a:noFill/>
           </a:ln>
-          <a:effectLst/>
-        </p:spPr>
-        <p:style>
-          <a:lnRef idx="1">
-            <a:schemeClr val="accent1"/>
-          </a:lnRef>
-          <a:fillRef idx="3">
-            <a:schemeClr val="accent1"/>
-          </a:fillRef>
-          <a:effectRef idx="2">
-            <a:schemeClr val="accent1"/>
-          </a:effectRef>
-          <a:fontRef idx="minor">
-            <a:schemeClr val="lt1"/>
-          </a:fontRef>
-        </p:style>
+        </p:spPr>
         <p:txBody>
           <a:bodyPr rtlCol="0" anchor="ctr"/>
           <a:lstStyle/>
@@ -4450,22 +4060,7 @@
           <a:ln>
             <a:noFill/>
           </a:ln>
-          <a:effectLst/>
-        </p:spPr>
-        <p:style>
-          <a:lnRef idx="1">
-            <a:schemeClr val="accent1"/>
-          </a:lnRef>
-          <a:fillRef idx="3">
-            <a:schemeClr val="accent1"/>
-          </a:fillRef>
-          <a:effectRef idx="2">
-            <a:schemeClr val="accent1"/>
-          </a:effectRef>
-          <a:fontRef idx="minor">
-            <a:schemeClr val="lt1"/>
-          </a:fontRef>
-        </p:style>
+        </p:spPr>
         <p:txBody>
           <a:bodyPr rtlCol="0" anchor="ctr"/>
           <a:lstStyle/>
@@ -4494,22 +4089,7 @@
           <a:ln>
             <a:noFill/>
           </a:ln>
-          <a:effectLst/>
-        </p:spPr>
-        <p:style>
-          <a:lnRef idx="1">
-            <a:schemeClr val="accent1"/>
-          </a:lnRef>
-          <a:fillRef idx="3">
-            <a:schemeClr val="accent1"/>
-          </a:fillRef>
-          <a:effectRef idx="2">
-            <a:schemeClr val="accent1"/>
-          </a:effectRef>
-          <a:fontRef idx="minor">
-            <a:schemeClr val="lt1"/>
-          </a:fontRef>
-        </p:style>
+        </p:spPr>
         <p:txBody>
           <a:bodyPr rtlCol="0" anchor="ctr"/>
           <a:lstStyle/>
@@ -4538,22 +4118,7 @@
           <a:ln>
             <a:noFill/>
           </a:ln>
-          <a:effectLst/>
-        </p:spPr>
-        <p:style>
-          <a:lnRef idx="1">
-            <a:schemeClr val="accent1"/>
-          </a:lnRef>
-          <a:fillRef idx="3">
-            <a:schemeClr val="accent1"/>
-          </a:fillRef>
-          <a:effectRef idx="2">
-            <a:schemeClr val="accent1"/>
-          </a:effectRef>
-          <a:fontRef idx="minor">
-            <a:schemeClr val="lt1"/>
-          </a:fontRef>
-        </p:style>
+        </p:spPr>
         <p:txBody>
           <a:bodyPr rtlCol="0" anchor="ctr"/>
           <a:lstStyle/>
@@ -4582,22 +4147,7 @@
           <a:ln>
             <a:noFill/>
           </a:ln>
-          <a:effectLst/>
-        </p:spPr>
-        <p:style>
-          <a:lnRef idx="1">
-            <a:schemeClr val="accent1"/>
-          </a:lnRef>
-          <a:fillRef idx="3">
-            <a:schemeClr val="accent1"/>
-          </a:fillRef>
-          <a:effectRef idx="2">
-            <a:schemeClr val="accent1"/>
-          </a:effectRef>
-          <a:fontRef idx="minor">
-            <a:schemeClr val="lt1"/>
-          </a:fontRef>
-        </p:style>
+        </p:spPr>
         <p:txBody>
           <a:bodyPr rtlCol="0" anchor="ctr"/>
           <a:lstStyle/>
@@ -4626,22 +4176,7 @@
           <a:ln>
             <a:noFill/>
           </a:ln>
-          <a:effectLst/>
-        </p:spPr>
-        <p:style>
-          <a:lnRef idx="1">
-            <a:schemeClr val="accent1"/>
-          </a:lnRef>
-          <a:fillRef idx="3">
-            <a:schemeClr val="accent1"/>
-          </a:fillRef>
-          <a:effectRef idx="2">
-            <a:schemeClr val="accent1"/>
-          </a:effectRef>
-          <a:fontRef idx="minor">
-            <a:schemeClr val="lt1"/>
-          </a:fontRef>
-        </p:style>
+        </p:spPr>
         <p:txBody>
           <a:bodyPr rtlCol="0" anchor="ctr"/>
           <a:lstStyle/>
@@ -4670,22 +4205,7 @@
           <a:ln>
             <a:noFill/>
           </a:ln>
-          <a:effectLst/>
-        </p:spPr>
-        <p:style>
-          <a:lnRef idx="1">
-            <a:schemeClr val="accent1"/>
-          </a:lnRef>
-          <a:fillRef idx="3">
-            <a:schemeClr val="accent1"/>
-          </a:fillRef>
-          <a:effectRef idx="2">
-            <a:schemeClr val="accent1"/>
-          </a:effectRef>
-          <a:fontRef idx="minor">
-            <a:schemeClr val="lt1"/>
-          </a:fontRef>
-        </p:style>
+        </p:spPr>
         <p:txBody>
           <a:bodyPr rtlCol="0" anchor="ctr"/>
           <a:lstStyle/>
@@ -4714,22 +4234,7 @@
           <a:ln>
             <a:noFill/>
           </a:ln>
-          <a:effectLst/>
-        </p:spPr>
-        <p:style>
-          <a:lnRef idx="1">
-            <a:schemeClr val="accent1"/>
-          </a:lnRef>
-          <a:fillRef idx="3">
-            <a:schemeClr val="accent1"/>
-          </a:fillRef>
-          <a:effectRef idx="2">
-            <a:schemeClr val="accent1"/>
-          </a:effectRef>
-          <a:fontRef idx="minor">
-            <a:schemeClr val="lt1"/>
-          </a:fontRef>
-        </p:style>
+        </p:spPr>
         <p:txBody>
           <a:bodyPr rtlCol="0" anchor="ctr"/>
           <a:lstStyle/>
@@ -4758,22 +4263,7 @@
           <a:ln>
             <a:noFill/>
           </a:ln>
-          <a:effectLst/>
-        </p:spPr>
-        <p:style>
-          <a:lnRef idx="1">
-            <a:schemeClr val="accent1"/>
-          </a:lnRef>
-          <a:fillRef idx="3">
-            <a:schemeClr val="accent1"/>
-          </a:fillRef>
-          <a:effectRef idx="2">
-            <a:schemeClr val="accent1"/>
-          </a:effectRef>
-          <a:fontRef idx="minor">
-            <a:schemeClr val="lt1"/>
-          </a:fontRef>
-        </p:style>
+        </p:spPr>
         <p:txBody>
           <a:bodyPr rtlCol="0" anchor="ctr"/>
           <a:lstStyle/>
@@ -4802,22 +4292,7 @@
           <a:ln>
             <a:noFill/>
           </a:ln>
-          <a:effectLst/>
-        </p:spPr>
-        <p:style>
-          <a:lnRef idx="1">
-            <a:schemeClr val="accent1"/>
-          </a:lnRef>
-          <a:fillRef idx="3">
-            <a:schemeClr val="accent1"/>
-          </a:fillRef>
-          <a:effectRef idx="2">
-            <a:schemeClr val="accent1"/>
-          </a:effectRef>
-          <a:fontRef idx="minor">
-            <a:schemeClr val="lt1"/>
-          </a:fontRef>
-        </p:style>
+        </p:spPr>
         <p:txBody>
           <a:bodyPr rtlCol="0" anchor="ctr"/>
           <a:lstStyle/>
@@ -4846,22 +4321,7 @@
           <a:ln>
             <a:noFill/>
           </a:ln>
-          <a:effectLst/>
-        </p:spPr>
-        <p:style>
-          <a:lnRef idx="1">
-            <a:schemeClr val="accent1"/>
-          </a:lnRef>
-          <a:fillRef idx="3">
-            <a:schemeClr val="accent1"/>
-          </a:fillRef>
-          <a:effectRef idx="2">
-            <a:schemeClr val="accent1"/>
-          </a:effectRef>
-          <a:fontRef idx="minor">
-            <a:schemeClr val="lt1"/>
-          </a:fontRef>
-        </p:style>
+        </p:spPr>
         <p:txBody>
           <a:bodyPr rtlCol="0" anchor="ctr"/>
           <a:lstStyle/>
@@ -4890,22 +4350,7 @@
           <a:ln>
             <a:noFill/>
           </a:ln>
-          <a:effectLst/>
-        </p:spPr>
-        <p:style>
-          <a:lnRef idx="1">
-            <a:schemeClr val="accent1"/>
-          </a:lnRef>
-          <a:fillRef idx="3">
-            <a:schemeClr val="accent1"/>
-          </a:fillRef>
-          <a:effectRef idx="2">
-            <a:schemeClr val="accent1"/>
-          </a:effectRef>
-          <a:fontRef idx="minor">
-            <a:schemeClr val="lt1"/>
-          </a:fontRef>
-        </p:style>
+        </p:spPr>
         <p:txBody>
           <a:bodyPr rtlCol="0" anchor="ctr"/>
           <a:lstStyle/>
@@ -4934,22 +4379,7 @@
           <a:ln>
             <a:noFill/>
           </a:ln>
-          <a:effectLst/>
-        </p:spPr>
-        <p:style>
-          <a:lnRef idx="1">
-            <a:schemeClr val="accent1"/>
-          </a:lnRef>
-          <a:fillRef idx="3">
-            <a:schemeClr val="accent1"/>
-          </a:fillRef>
-          <a:effectRef idx="2">
-            <a:schemeClr val="accent1"/>
-          </a:effectRef>
-          <a:fontRef idx="minor">
-            <a:schemeClr val="lt1"/>
-          </a:fontRef>
-        </p:style>
+        </p:spPr>
         <p:txBody>
           <a:bodyPr rtlCol="0" anchor="ctr"/>
           <a:lstStyle/>
@@ -4978,22 +4408,7 @@
           <a:ln>
             <a:noFill/>
           </a:ln>
-          <a:effectLst/>
-        </p:spPr>
-        <p:style>
-          <a:lnRef idx="1">
-            <a:schemeClr val="accent1"/>
-          </a:lnRef>
-          <a:fillRef idx="3">
-            <a:schemeClr val="accent1"/>
-          </a:fillRef>
-          <a:effectRef idx="2">
-            <a:schemeClr val="accent1"/>
-          </a:effectRef>
-          <a:fontRef idx="minor">
-            <a:schemeClr val="lt1"/>
-          </a:fontRef>
-        </p:style>
+        </p:spPr>
         <p:txBody>
           <a:bodyPr rtlCol="0" anchor="ctr"/>
           <a:lstStyle/>
@@ -5022,22 +4437,7 @@
           <a:ln>
             <a:noFill/>
           </a:ln>
-          <a:effectLst/>
-        </p:spPr>
-        <p:style>
-          <a:lnRef idx="1">
-            <a:schemeClr val="accent1"/>
-          </a:lnRef>
-          <a:fillRef idx="3">
-            <a:schemeClr val="accent1"/>
-          </a:fillRef>
-          <a:effectRef idx="2">
-            <a:schemeClr val="accent1"/>
-          </a:effectRef>
-          <a:fontRef idx="minor">
-            <a:schemeClr val="lt1"/>
-          </a:fontRef>
-        </p:style>
+        </p:spPr>
         <p:txBody>
           <a:bodyPr rtlCol="0" anchor="ctr"/>
           <a:lstStyle/>
@@ -5066,22 +4466,7 @@
           <a:ln>
             <a:noFill/>
           </a:ln>
-          <a:effectLst/>
-        </p:spPr>
-        <p:style>
-          <a:lnRef idx="1">
-            <a:schemeClr val="accent1"/>
-          </a:lnRef>
-          <a:fillRef idx="3">
-            <a:schemeClr val="accent1"/>
-          </a:fillRef>
-          <a:effectRef idx="2">
-            <a:schemeClr val="accent1"/>
-          </a:effectRef>
-          <a:fontRef idx="minor">
-            <a:schemeClr val="lt1"/>
-          </a:fontRef>
-        </p:style>
+        </p:spPr>
         <p:txBody>
           <a:bodyPr rtlCol="0" anchor="ctr"/>
           <a:lstStyle/>
@@ -5110,22 +4495,7 @@
           <a:ln>
             <a:noFill/>
           </a:ln>
-          <a:effectLst/>
-        </p:spPr>
-        <p:style>
-          <a:lnRef idx="1">
-            <a:schemeClr val="accent1"/>
-          </a:lnRef>
-          <a:fillRef idx="3">
-            <a:schemeClr val="accent1"/>
-          </a:fillRef>
-          <a:effectRef idx="2">
-            <a:schemeClr val="accent1"/>
-          </a:effectRef>
-          <a:fontRef idx="minor">
-            <a:schemeClr val="lt1"/>
-          </a:fontRef>
-        </p:style>
+        </p:spPr>
         <p:txBody>
           <a:bodyPr rtlCol="0" anchor="ctr"/>
           <a:lstStyle/>
@@ -5154,22 +4524,7 @@
           <a:ln>
             <a:noFill/>
           </a:ln>
-          <a:effectLst/>
-        </p:spPr>
-        <p:style>
-          <a:lnRef idx="1">
-            <a:schemeClr val="accent1"/>
-          </a:lnRef>
-          <a:fillRef idx="3">
-            <a:schemeClr val="accent1"/>
-          </a:fillRef>
-          <a:effectRef idx="2">
-            <a:schemeClr val="accent1"/>
-          </a:effectRef>
-          <a:fontRef idx="minor">
-            <a:schemeClr val="lt1"/>
-          </a:fontRef>
-        </p:style>
+        </p:spPr>
         <p:txBody>
           <a:bodyPr rtlCol="0" anchor="ctr"/>
           <a:lstStyle/>
@@ -5198,22 +4553,7 @@
           <a:ln>
             <a:noFill/>
           </a:ln>
-          <a:effectLst/>
-        </p:spPr>
-        <p:style>
-          <a:lnRef idx="1">
-            <a:schemeClr val="accent1"/>
-          </a:lnRef>
-          <a:fillRef idx="3">
-            <a:schemeClr val="accent1"/>
-          </a:fillRef>
-          <a:effectRef idx="2">
-            <a:schemeClr val="accent1"/>
-          </a:effectRef>
-          <a:fontRef idx="minor">
-            <a:schemeClr val="lt1"/>
-          </a:fontRef>
-        </p:style>
+        </p:spPr>
         <p:txBody>
           <a:bodyPr rtlCol="0" anchor="ctr"/>
           <a:lstStyle/>
@@ -5242,22 +4582,7 @@
           <a:ln>
             <a:noFill/>
           </a:ln>
-          <a:effectLst/>
-        </p:spPr>
-        <p:style>
-          <a:lnRef idx="1">
-            <a:schemeClr val="accent1"/>
-          </a:lnRef>
-          <a:fillRef idx="3">
-            <a:schemeClr val="accent1"/>
-          </a:fillRef>
-          <a:effectRef idx="2">
-            <a:schemeClr val="accent1"/>
-          </a:effectRef>
-          <a:fontRef idx="minor">
-            <a:schemeClr val="lt1"/>
-          </a:fontRef>
-        </p:style>
+        </p:spPr>
         <p:txBody>
           <a:bodyPr rtlCol="0" anchor="ctr"/>
           <a:lstStyle/>
@@ -5286,22 +4611,7 @@
           <a:ln>
             <a:noFill/>
           </a:ln>
-          <a:effectLst/>
-        </p:spPr>
-        <p:style>
-          <a:lnRef idx="1">
-            <a:schemeClr val="accent1"/>
-          </a:lnRef>
-          <a:fillRef idx="3">
-            <a:schemeClr val="accent1"/>
-          </a:fillRef>
-          <a:effectRef idx="2">
-            <a:schemeClr val="accent1"/>
-          </a:effectRef>
-          <a:fontRef idx="minor">
-            <a:schemeClr val="lt1"/>
-          </a:fontRef>
-        </p:style>
+        </p:spPr>
         <p:txBody>
           <a:bodyPr rtlCol="0" anchor="ctr"/>
           <a:lstStyle/>
@@ -5330,22 +4640,7 @@
           <a:ln>
             <a:noFill/>
           </a:ln>
-          <a:effectLst/>
-        </p:spPr>
-        <p:style>
-          <a:lnRef idx="1">
-            <a:schemeClr val="accent1"/>
-          </a:lnRef>
-          <a:fillRef idx="3">
-            <a:schemeClr val="accent1"/>
-          </a:fillRef>
-          <a:effectRef idx="2">
-            <a:schemeClr val="accent1"/>
-          </a:effectRef>
-          <a:fontRef idx="minor">
-            <a:schemeClr val="lt1"/>
-          </a:fontRef>
-        </p:style>
+        </p:spPr>
         <p:txBody>
           <a:bodyPr rtlCol="0" anchor="ctr"/>
           <a:lstStyle/>
@@ -5374,22 +4669,7 @@
           <a:ln>
             <a:noFill/>
           </a:ln>
-          <a:effectLst/>
-        </p:spPr>
-        <p:style>
-          <a:lnRef idx="1">
-            <a:schemeClr val="accent1"/>
-          </a:lnRef>
-          <a:fillRef idx="3">
-            <a:schemeClr val="accent1"/>
-          </a:fillRef>
-          <a:effectRef idx="2">
-            <a:schemeClr val="accent1"/>
-          </a:effectRef>
-          <a:fontRef idx="minor">
-            <a:schemeClr val="lt1"/>
-          </a:fontRef>
-        </p:style>
+        </p:spPr>
         <p:txBody>
           <a:bodyPr rtlCol="0" anchor="ctr"/>
           <a:lstStyle/>
@@ -5418,22 +4698,7 @@
           <a:ln>
             <a:noFill/>
           </a:ln>
-          <a:effectLst/>
-        </p:spPr>
-        <p:style>
-          <a:lnRef idx="1">
-            <a:schemeClr val="accent1"/>
-          </a:lnRef>
-          <a:fillRef idx="3">
-            <a:schemeClr val="accent1"/>
-          </a:fillRef>
-          <a:effectRef idx="2">
-            <a:schemeClr val="accent1"/>
-          </a:effectRef>
-          <a:fontRef idx="minor">
-            <a:schemeClr val="lt1"/>
-          </a:fontRef>
-        </p:style>
+        </p:spPr>
         <p:txBody>
           <a:bodyPr rtlCol="0" anchor="ctr"/>
           <a:lstStyle/>
@@ -5462,22 +4727,7 @@
           <a:ln>
             <a:noFill/>
           </a:ln>
-          <a:effectLst/>
-        </p:spPr>
-        <p:style>
-          <a:lnRef idx="1">
-            <a:schemeClr val="accent1"/>
-          </a:lnRef>
-          <a:fillRef idx="3">
-            <a:schemeClr val="accent1"/>
-          </a:fillRef>
-          <a:effectRef idx="2">
-            <a:schemeClr val="accent1"/>
-          </a:effectRef>
-          <a:fontRef idx="minor">
-            <a:schemeClr val="lt1"/>
-          </a:fontRef>
-        </p:style>
+        </p:spPr>
         <p:txBody>
           <a:bodyPr rtlCol="0" anchor="ctr"/>
           <a:lstStyle/>
@@ -5510,9 +4760,9 @@
           <a:p>
             <a:pPr algn="l"/>
             <a:r>
-              <a:rPr sz="900" b="0">
+              <a:rPr sz="1100" b="1">
                 <a:solidFill>
-                  <a:srgbClr val="555555"/>
+                  <a:srgbClr val="1A1A1A"/>
                 </a:solidFill>
                 <a:latin typeface="Arial"/>
               </a:rPr>
@@ -5557,22 +4807,7 @@
           <a:ln>
             <a:noFill/>
           </a:ln>
-          <a:effectLst/>
-        </p:spPr>
-        <p:style>
-          <a:lnRef idx="1">
-            <a:schemeClr val="accent1"/>
-          </a:lnRef>
-          <a:fillRef idx="3">
-            <a:schemeClr val="accent1"/>
-          </a:fillRef>
-          <a:effectRef idx="2">
-            <a:schemeClr val="accent1"/>
-          </a:effectRef>
-          <a:fontRef idx="minor">
-            <a:schemeClr val="lt1"/>
-          </a:fontRef>
-        </p:style>
+        </p:spPr>
         <p:txBody>
           <a:bodyPr rtlCol="0" anchor="t" wrap="square" lIns="72438" rIns="72438" tIns="57950" bIns="57950"/>
           <a:lstStyle/>
@@ -5615,22 +4850,7 @@
           <a:ln>
             <a:noFill/>
           </a:ln>
-          <a:effectLst/>
-        </p:spPr>
-        <p:style>
-          <a:lnRef idx="1">
-            <a:schemeClr val="accent1"/>
-          </a:lnRef>
-          <a:fillRef idx="3">
-            <a:schemeClr val="accent1"/>
-          </a:fillRef>
-          <a:effectRef idx="2">
-            <a:schemeClr val="accent1"/>
-          </a:effectRef>
-          <a:fontRef idx="minor">
-            <a:schemeClr val="lt1"/>
-          </a:fontRef>
-        </p:style>
+        </p:spPr>
         <p:txBody>
           <a:bodyPr rtlCol="0" anchor="t" wrap="square" lIns="72438" rIns="72438" tIns="57950" bIns="57950"/>
           <a:lstStyle/>
@@ -5673,22 +4893,7 @@
           <a:ln>
             <a:noFill/>
           </a:ln>
-          <a:effectLst/>
-        </p:spPr>
-        <p:style>
-          <a:lnRef idx="1">
-            <a:schemeClr val="accent1"/>
-          </a:lnRef>
-          <a:fillRef idx="3">
-            <a:schemeClr val="accent1"/>
-          </a:fillRef>
-          <a:effectRef idx="2">
-            <a:schemeClr val="accent1"/>
-          </a:effectRef>
-          <a:fontRef idx="minor">
-            <a:schemeClr val="lt1"/>
-          </a:fontRef>
-        </p:style>
+        </p:spPr>
         <p:txBody>
           <a:bodyPr rtlCol="0" anchor="t" wrap="square" lIns="72438" rIns="72438" tIns="57950" bIns="57950"/>
           <a:lstStyle/>
@@ -5731,22 +4936,7 @@
           <a:ln>
             <a:noFill/>
           </a:ln>
-          <a:effectLst/>
-        </p:spPr>
-        <p:style>
-          <a:lnRef idx="1">
-            <a:schemeClr val="accent1"/>
-          </a:lnRef>
-          <a:fillRef idx="3">
-            <a:schemeClr val="accent1"/>
-          </a:fillRef>
-          <a:effectRef idx="2">
-            <a:schemeClr val="accent1"/>
-          </a:effectRef>
-          <a:fontRef idx="minor">
-            <a:schemeClr val="lt1"/>
-          </a:fontRef>
-        </p:style>
+        </p:spPr>
         <p:txBody>
           <a:bodyPr rtlCol="0" anchor="t" wrap="square" lIns="72438" rIns="72438" tIns="57950" bIns="57950"/>
           <a:lstStyle/>
@@ -5789,22 +4979,7 @@
           <a:ln>
             <a:noFill/>
           </a:ln>
-          <a:effectLst/>
-        </p:spPr>
-        <p:style>
-          <a:lnRef idx="1">
-            <a:schemeClr val="accent1"/>
-          </a:lnRef>
-          <a:fillRef idx="3">
-            <a:schemeClr val="accent1"/>
-          </a:fillRef>
-          <a:effectRef idx="2">
-            <a:schemeClr val="accent1"/>
-          </a:effectRef>
-          <a:fontRef idx="minor">
-            <a:schemeClr val="lt1"/>
-          </a:fontRef>
-        </p:style>
+        </p:spPr>
         <p:txBody>
           <a:bodyPr rtlCol="0" anchor="t" wrap="square" lIns="72438" rIns="72438" tIns="57950" bIns="57950"/>
           <a:lstStyle/>
@@ -5847,22 +5022,7 @@
           <a:ln>
             <a:noFill/>
           </a:ln>
-          <a:effectLst/>
-        </p:spPr>
-        <p:style>
-          <a:lnRef idx="1">
-            <a:schemeClr val="accent1"/>
-          </a:lnRef>
-          <a:fillRef idx="3">
-            <a:schemeClr val="accent1"/>
-          </a:fillRef>
-          <a:effectRef idx="2">
-            <a:schemeClr val="accent1"/>
-          </a:effectRef>
-          <a:fontRef idx="minor">
-            <a:schemeClr val="lt1"/>
-          </a:fontRef>
-        </p:style>
+        </p:spPr>
         <p:txBody>
           <a:bodyPr rtlCol="0" anchor="t" wrap="square" lIns="72438" rIns="72438" tIns="57950" bIns="57950"/>
           <a:lstStyle/>
@@ -5905,22 +5065,7 @@
           <a:ln>
             <a:noFill/>
           </a:ln>
-          <a:effectLst/>
-        </p:spPr>
-        <p:style>
-          <a:lnRef idx="1">
-            <a:schemeClr val="accent1"/>
-          </a:lnRef>
-          <a:fillRef idx="3">
-            <a:schemeClr val="accent1"/>
-          </a:fillRef>
-          <a:effectRef idx="2">
-            <a:schemeClr val="accent1"/>
-          </a:effectRef>
-          <a:fontRef idx="minor">
-            <a:schemeClr val="lt1"/>
-          </a:fontRef>
-        </p:style>
+        </p:spPr>
         <p:txBody>
           <a:bodyPr rtlCol="0" anchor="t" wrap="square" lIns="72438" rIns="72438" tIns="57950" bIns="57950"/>
           <a:lstStyle/>
@@ -5963,22 +5108,7 @@
           <a:ln>
             <a:noFill/>
           </a:ln>
-          <a:effectLst/>
-        </p:spPr>
-        <p:style>
-          <a:lnRef idx="1">
-            <a:schemeClr val="accent1"/>
-          </a:lnRef>
-          <a:fillRef idx="3">
-            <a:schemeClr val="accent1"/>
-          </a:fillRef>
-          <a:effectRef idx="2">
-            <a:schemeClr val="accent1"/>
-          </a:effectRef>
-          <a:fontRef idx="minor">
-            <a:schemeClr val="lt1"/>
-          </a:fontRef>
-        </p:style>
+        </p:spPr>
         <p:txBody>
           <a:bodyPr rtlCol="0" anchor="t" wrap="square" lIns="72438" rIns="72438" tIns="57950" bIns="57950"/>
           <a:lstStyle/>
@@ -6021,22 +5151,7 @@
           <a:ln>
             <a:noFill/>
           </a:ln>
-          <a:effectLst/>
-        </p:spPr>
-        <p:style>
-          <a:lnRef idx="1">
-            <a:schemeClr val="accent1"/>
-          </a:lnRef>
-          <a:fillRef idx="3">
-            <a:schemeClr val="accent1"/>
-          </a:fillRef>
-          <a:effectRef idx="2">
-            <a:schemeClr val="accent1"/>
-          </a:effectRef>
-          <a:fontRef idx="minor">
-            <a:schemeClr val="lt1"/>
-          </a:fontRef>
-        </p:style>
+        </p:spPr>
         <p:txBody>
           <a:bodyPr rtlCol="0" anchor="t" wrap="square" lIns="72438" rIns="72438" tIns="57950" bIns="57950"/>
           <a:lstStyle/>
@@ -6079,22 +5194,7 @@
           <a:ln>
             <a:noFill/>
           </a:ln>
-          <a:effectLst/>
-        </p:spPr>
-        <p:style>
-          <a:lnRef idx="1">
-            <a:schemeClr val="accent1"/>
-          </a:lnRef>
-          <a:fillRef idx="3">
-            <a:schemeClr val="accent1"/>
-          </a:fillRef>
-          <a:effectRef idx="2">
-            <a:schemeClr val="accent1"/>
-          </a:effectRef>
-          <a:fontRef idx="minor">
-            <a:schemeClr val="lt1"/>
-          </a:fontRef>
-        </p:style>
+        </p:spPr>
         <p:txBody>
           <a:bodyPr rtlCol="0" anchor="t" wrap="square" lIns="72438" rIns="72438" tIns="57950" bIns="57950"/>
           <a:lstStyle/>
@@ -6137,22 +5237,7 @@
           <a:ln>
             <a:noFill/>
           </a:ln>
-          <a:effectLst/>
-        </p:spPr>
-        <p:style>
-          <a:lnRef idx="1">
-            <a:schemeClr val="accent1"/>
-          </a:lnRef>
-          <a:fillRef idx="3">
-            <a:schemeClr val="accent1"/>
-          </a:fillRef>
-          <a:effectRef idx="2">
-            <a:schemeClr val="accent1"/>
-          </a:effectRef>
-          <a:fontRef idx="minor">
-            <a:schemeClr val="lt1"/>
-          </a:fontRef>
-        </p:style>
+        </p:spPr>
         <p:txBody>
           <a:bodyPr rtlCol="0" anchor="t" wrap="square" lIns="72438" rIns="72438" tIns="57950" bIns="57950"/>
           <a:lstStyle/>
@@ -6195,22 +5280,7 @@
           <a:ln>
             <a:noFill/>
           </a:ln>
-          <a:effectLst/>
-        </p:spPr>
-        <p:style>
-          <a:lnRef idx="1">
-            <a:schemeClr val="accent1"/>
-          </a:lnRef>
-          <a:fillRef idx="3">
-            <a:schemeClr val="accent1"/>
-          </a:fillRef>
-          <a:effectRef idx="2">
-            <a:schemeClr val="accent1"/>
-          </a:effectRef>
-          <a:fontRef idx="minor">
-            <a:schemeClr val="lt1"/>
-          </a:fontRef>
-        </p:style>
+        </p:spPr>
         <p:txBody>
           <a:bodyPr rtlCol="0" anchor="t" wrap="square" lIns="72438" rIns="72438" tIns="57950" bIns="57950"/>
           <a:lstStyle/>
@@ -6253,22 +5323,7 @@
           <a:ln>
             <a:noFill/>
           </a:ln>
-          <a:effectLst/>
-        </p:spPr>
-        <p:style>
-          <a:lnRef idx="1">
-            <a:schemeClr val="accent1"/>
-          </a:lnRef>
-          <a:fillRef idx="3">
-            <a:schemeClr val="accent1"/>
-          </a:fillRef>
-          <a:effectRef idx="2">
-            <a:schemeClr val="accent1"/>
-          </a:effectRef>
-          <a:fontRef idx="minor">
-            <a:schemeClr val="lt1"/>
-          </a:fontRef>
-        </p:style>
+        </p:spPr>
         <p:txBody>
           <a:bodyPr rtlCol="0" anchor="t" wrap="square" lIns="72438" rIns="72438" tIns="57950" bIns="57950"/>
           <a:lstStyle/>
@@ -6311,22 +5366,7 @@
           <a:ln>
             <a:noFill/>
           </a:ln>
-          <a:effectLst/>
-        </p:spPr>
-        <p:style>
-          <a:lnRef idx="1">
-            <a:schemeClr val="accent1"/>
-          </a:lnRef>
-          <a:fillRef idx="3">
-            <a:schemeClr val="accent1"/>
-          </a:fillRef>
-          <a:effectRef idx="2">
-            <a:schemeClr val="accent1"/>
-          </a:effectRef>
-          <a:fontRef idx="minor">
-            <a:schemeClr val="lt1"/>
-          </a:fontRef>
-        </p:style>
+        </p:spPr>
         <p:txBody>
           <a:bodyPr rtlCol="0" anchor="t" wrap="square" lIns="72438" rIns="72438" tIns="57950" bIns="57950"/>
           <a:lstStyle/>
@@ -6375,9 +5415,9 @@
           <a:p>
             <a:pPr algn="l"/>
             <a:r>
-              <a:rPr sz="900" b="0">
+              <a:rPr sz="1100" b="1">
                 <a:solidFill>
-                  <a:srgbClr val="555555"/>
+                  <a:srgbClr val="1A1A1A"/>
                 </a:solidFill>
                 <a:latin typeface="Arial"/>
               </a:rPr>
@@ -6422,22 +5462,7 @@
           <a:ln>
             <a:noFill/>
           </a:ln>
-          <a:effectLst/>
-        </p:spPr>
-        <p:style>
-          <a:lnRef idx="1">
-            <a:schemeClr val="accent1"/>
-          </a:lnRef>
-          <a:fillRef idx="3">
-            <a:schemeClr val="accent1"/>
-          </a:fillRef>
-          <a:effectRef idx="2">
-            <a:schemeClr val="accent1"/>
-          </a:effectRef>
-          <a:fontRef idx="minor">
-            <a:schemeClr val="lt1"/>
-          </a:fontRef>
-        </p:style>
+        </p:spPr>
         <p:txBody>
           <a:bodyPr rtlCol="0" anchor="ctr" wrap="square" lIns="72438" rIns="72438" tIns="57950" bIns="57950"/>
           <a:lstStyle/>
@@ -6499,22 +5524,7 @@
           <a:ln>
             <a:noFill/>
           </a:ln>
-          <a:effectLst/>
-        </p:spPr>
-        <p:style>
-          <a:lnRef idx="1">
-            <a:schemeClr val="accent1"/>
-          </a:lnRef>
-          <a:fillRef idx="3">
-            <a:schemeClr val="accent1"/>
-          </a:fillRef>
-          <a:effectRef idx="2">
-            <a:schemeClr val="accent1"/>
-          </a:effectRef>
-          <a:fontRef idx="minor">
-            <a:schemeClr val="lt1"/>
-          </a:fontRef>
-        </p:style>
+        </p:spPr>
         <p:txBody>
           <a:bodyPr rtlCol="0" anchor="ctr" wrap="square" lIns="72438" rIns="72438" tIns="57950" bIns="57950"/>
           <a:lstStyle/>
@@ -6576,22 +5586,7 @@
           <a:ln>
             <a:noFill/>
           </a:ln>
-          <a:effectLst/>
-        </p:spPr>
-        <p:style>
-          <a:lnRef idx="1">
-            <a:schemeClr val="accent1"/>
-          </a:lnRef>
-          <a:fillRef idx="3">
-            <a:schemeClr val="accent1"/>
-          </a:fillRef>
-          <a:effectRef idx="2">
-            <a:schemeClr val="accent1"/>
-          </a:effectRef>
-          <a:fontRef idx="minor">
-            <a:schemeClr val="lt1"/>
-          </a:fontRef>
-        </p:style>
+        </p:spPr>
         <p:txBody>
           <a:bodyPr rtlCol="0" anchor="ctr" wrap="square" lIns="72438" rIns="72438" tIns="57950" bIns="57950"/>
           <a:lstStyle/>
@@ -6653,22 +5648,7 @@
           <a:ln>
             <a:noFill/>
           </a:ln>
-          <a:effectLst/>
-        </p:spPr>
-        <p:style>
-          <a:lnRef idx="1">
-            <a:schemeClr val="accent1"/>
-          </a:lnRef>
-          <a:fillRef idx="3">
-            <a:schemeClr val="accent1"/>
-          </a:fillRef>
-          <a:effectRef idx="2">
-            <a:schemeClr val="accent1"/>
-          </a:effectRef>
-          <a:fontRef idx="minor">
-            <a:schemeClr val="lt1"/>
-          </a:fontRef>
-        </p:style>
+        </p:spPr>
         <p:txBody>
           <a:bodyPr rtlCol="0" anchor="ctr" wrap="square" lIns="72438" rIns="72438" tIns="57950" bIns="57950"/>
           <a:lstStyle/>
@@ -6730,22 +5710,7 @@
           <a:ln>
             <a:noFill/>
           </a:ln>
-          <a:effectLst/>
-        </p:spPr>
-        <p:style>
-          <a:lnRef idx="1">
-            <a:schemeClr val="accent1"/>
-          </a:lnRef>
-          <a:fillRef idx="3">
-            <a:schemeClr val="accent1"/>
-          </a:fillRef>
-          <a:effectRef idx="2">
-            <a:schemeClr val="accent1"/>
-          </a:effectRef>
-          <a:fontRef idx="minor">
-            <a:schemeClr val="lt1"/>
-          </a:fontRef>
-        </p:style>
+        </p:spPr>
         <p:txBody>
           <a:bodyPr rtlCol="0" anchor="ctr" wrap="square" lIns="72438" rIns="72438" tIns="57950" bIns="57950"/>
           <a:lstStyle/>
@@ -6807,22 +5772,7 @@
           <a:ln>
             <a:noFill/>
           </a:ln>
-          <a:effectLst/>
-        </p:spPr>
-        <p:style>
-          <a:lnRef idx="1">
-            <a:schemeClr val="accent1"/>
-          </a:lnRef>
-          <a:fillRef idx="3">
-            <a:schemeClr val="accent1"/>
-          </a:fillRef>
-          <a:effectRef idx="2">
-            <a:schemeClr val="accent1"/>
-          </a:effectRef>
-          <a:fontRef idx="minor">
-            <a:schemeClr val="lt1"/>
-          </a:fontRef>
-        </p:style>
+        </p:spPr>
         <p:txBody>
           <a:bodyPr rtlCol="0" anchor="ctr" wrap="square" lIns="72438" rIns="72438" tIns="57950" bIns="57950"/>
           <a:lstStyle/>
@@ -6886,22 +5836,7 @@
           <a:ln>
             <a:noFill/>
           </a:ln>
-          <a:effectLst/>
-        </p:spPr>
-        <p:style>
-          <a:lnRef idx="1">
-            <a:schemeClr val="accent1"/>
-          </a:lnRef>
-          <a:fillRef idx="3">
-            <a:schemeClr val="accent1"/>
-          </a:fillRef>
-          <a:effectRef idx="2">
-            <a:schemeClr val="accent1"/>
-          </a:effectRef>
-          <a:fontRef idx="minor">
-            <a:schemeClr val="lt1"/>
-          </a:fontRef>
-        </p:style>
+        </p:spPr>
         <p:txBody>
           <a:bodyPr rtlCol="0" anchor="ctr"/>
           <a:lstStyle/>
@@ -6930,22 +5865,7 @@
           <a:ln>
             <a:noFill/>
           </a:ln>
-          <a:effectLst/>
-        </p:spPr>
-        <p:style>
-          <a:lnRef idx="1">
-            <a:schemeClr val="accent1"/>
-          </a:lnRef>
-          <a:fillRef idx="3">
-            <a:schemeClr val="accent1"/>
-          </a:fillRef>
-          <a:effectRef idx="2">
-            <a:schemeClr val="accent1"/>
-          </a:effectRef>
-          <a:fontRef idx="minor">
-            <a:schemeClr val="lt1"/>
-          </a:fontRef>
-        </p:style>
+        </p:spPr>
         <p:txBody>
           <a:bodyPr rtlCol="0" anchor="ctr"/>
           <a:lstStyle/>
@@ -6974,22 +5894,7 @@
           <a:ln>
             <a:noFill/>
           </a:ln>
-          <a:effectLst/>
-        </p:spPr>
-        <p:style>
-          <a:lnRef idx="1">
-            <a:schemeClr val="accent1"/>
-          </a:lnRef>
-          <a:fillRef idx="3">
-            <a:schemeClr val="accent1"/>
-          </a:fillRef>
-          <a:effectRef idx="2">
-            <a:schemeClr val="accent1"/>
-          </a:effectRef>
-          <a:fontRef idx="minor">
-            <a:schemeClr val="lt1"/>
-          </a:fontRef>
-        </p:style>
+        </p:spPr>
         <p:txBody>
           <a:bodyPr rtlCol="0" anchor="ctr"/>
           <a:lstStyle/>
@@ -7018,22 +5923,7 @@
           <a:ln>
             <a:noFill/>
           </a:ln>
-          <a:effectLst/>
-        </p:spPr>
-        <p:style>
-          <a:lnRef idx="1">
-            <a:schemeClr val="accent1"/>
-          </a:lnRef>
-          <a:fillRef idx="3">
-            <a:schemeClr val="accent1"/>
-          </a:fillRef>
-          <a:effectRef idx="2">
-            <a:schemeClr val="accent1"/>
-          </a:effectRef>
-          <a:fontRef idx="minor">
-            <a:schemeClr val="lt1"/>
-          </a:fontRef>
-        </p:style>
+        </p:spPr>
         <p:txBody>
           <a:bodyPr rtlCol="0" anchor="ctr"/>
           <a:lstStyle/>
@@ -7062,22 +5952,7 @@
           <a:ln>
             <a:noFill/>
           </a:ln>
-          <a:effectLst/>
-        </p:spPr>
-        <p:style>
-          <a:lnRef idx="1">
-            <a:schemeClr val="accent1"/>
-          </a:lnRef>
-          <a:fillRef idx="3">
-            <a:schemeClr val="accent1"/>
-          </a:fillRef>
-          <a:effectRef idx="2">
-            <a:schemeClr val="accent1"/>
-          </a:effectRef>
-          <a:fontRef idx="minor">
-            <a:schemeClr val="lt1"/>
-          </a:fontRef>
-        </p:style>
+        </p:spPr>
         <p:txBody>
           <a:bodyPr rtlCol="0" anchor="ctr"/>
           <a:lstStyle/>
@@ -7106,22 +5981,7 @@
           <a:ln>
             <a:noFill/>
           </a:ln>
-          <a:effectLst/>
-        </p:spPr>
-        <p:style>
-          <a:lnRef idx="1">
-            <a:schemeClr val="accent1"/>
-          </a:lnRef>
-          <a:fillRef idx="3">
-            <a:schemeClr val="accent1"/>
-          </a:fillRef>
-          <a:effectRef idx="2">
-            <a:schemeClr val="accent1"/>
-          </a:effectRef>
-          <a:fontRef idx="minor">
-            <a:schemeClr val="lt1"/>
-          </a:fontRef>
-        </p:style>
+        </p:spPr>
         <p:txBody>
           <a:bodyPr rtlCol="0" anchor="ctr"/>
           <a:lstStyle/>
@@ -7150,22 +6010,7 @@
           <a:ln>
             <a:noFill/>
           </a:ln>
-          <a:effectLst/>
-        </p:spPr>
-        <p:style>
-          <a:lnRef idx="1">
-            <a:schemeClr val="accent1"/>
-          </a:lnRef>
-          <a:fillRef idx="3">
-            <a:schemeClr val="accent1"/>
-          </a:fillRef>
-          <a:effectRef idx="2">
-            <a:schemeClr val="accent1"/>
-          </a:effectRef>
-          <a:fontRef idx="minor">
-            <a:schemeClr val="lt1"/>
-          </a:fontRef>
-        </p:style>
+        </p:spPr>
         <p:txBody>
           <a:bodyPr rtlCol="0" anchor="ctr"/>
           <a:lstStyle/>
@@ -7194,22 +6039,7 @@
           <a:ln>
             <a:noFill/>
           </a:ln>
-          <a:effectLst/>
-        </p:spPr>
-        <p:style>
-          <a:lnRef idx="1">
-            <a:schemeClr val="accent1"/>
-          </a:lnRef>
-          <a:fillRef idx="3">
-            <a:schemeClr val="accent1"/>
-          </a:fillRef>
-          <a:effectRef idx="2">
-            <a:schemeClr val="accent1"/>
-          </a:effectRef>
-          <a:fontRef idx="minor">
-            <a:schemeClr val="lt1"/>
-          </a:fontRef>
-        </p:style>
+        </p:spPr>
         <p:txBody>
           <a:bodyPr rtlCol="0" anchor="ctr"/>
           <a:lstStyle/>
@@ -7238,22 +6068,7 @@
           <a:ln>
             <a:noFill/>
           </a:ln>
-          <a:effectLst/>
-        </p:spPr>
-        <p:style>
-          <a:lnRef idx="1">
-            <a:schemeClr val="accent1"/>
-          </a:lnRef>
-          <a:fillRef idx="3">
-            <a:schemeClr val="accent1"/>
-          </a:fillRef>
-          <a:effectRef idx="2">
-            <a:schemeClr val="accent1"/>
-          </a:effectRef>
-          <a:fontRef idx="minor">
-            <a:schemeClr val="lt1"/>
-          </a:fontRef>
-        </p:style>
+        </p:spPr>
         <p:txBody>
           <a:bodyPr rtlCol="0" anchor="ctr"/>
           <a:lstStyle/>
@@ -7282,22 +6097,7 @@
           <a:ln>
             <a:noFill/>
           </a:ln>
-          <a:effectLst/>
-        </p:spPr>
-        <p:style>
-          <a:lnRef idx="1">
-            <a:schemeClr val="accent1"/>
-          </a:lnRef>
-          <a:fillRef idx="3">
-            <a:schemeClr val="accent1"/>
-          </a:fillRef>
-          <a:effectRef idx="2">
-            <a:schemeClr val="accent1"/>
-          </a:effectRef>
-          <a:fontRef idx="minor">
-            <a:schemeClr val="lt1"/>
-          </a:fontRef>
-        </p:style>
+        </p:spPr>
         <p:txBody>
           <a:bodyPr rtlCol="0" anchor="ctr"/>
           <a:lstStyle/>
@@ -7326,22 +6126,7 @@
           <a:ln>
             <a:noFill/>
           </a:ln>
-          <a:effectLst/>
-        </p:spPr>
-        <p:style>
-          <a:lnRef idx="1">
-            <a:schemeClr val="accent1"/>
-          </a:lnRef>
-          <a:fillRef idx="3">
-            <a:schemeClr val="accent1"/>
-          </a:fillRef>
-          <a:effectRef idx="2">
-            <a:schemeClr val="accent1"/>
-          </a:effectRef>
-          <a:fontRef idx="minor">
-            <a:schemeClr val="lt1"/>
-          </a:fontRef>
-        </p:style>
+        </p:spPr>
         <p:txBody>
           <a:bodyPr rtlCol="0" anchor="ctr"/>
           <a:lstStyle/>
@@ -7370,22 +6155,7 @@
           <a:ln>
             <a:noFill/>
           </a:ln>
-          <a:effectLst/>
-        </p:spPr>
-        <p:style>
-          <a:lnRef idx="1">
-            <a:schemeClr val="accent1"/>
-          </a:lnRef>
-          <a:fillRef idx="3">
-            <a:schemeClr val="accent1"/>
-          </a:fillRef>
-          <a:effectRef idx="2">
-            <a:schemeClr val="accent1"/>
-          </a:effectRef>
-          <a:fontRef idx="minor">
-            <a:schemeClr val="lt1"/>
-          </a:fontRef>
-        </p:style>
+        </p:spPr>
         <p:txBody>
           <a:bodyPr rtlCol="0" anchor="ctr"/>
           <a:lstStyle/>
@@ -7414,22 +6184,7 @@
           <a:ln>
             <a:noFill/>
           </a:ln>
-          <a:effectLst/>
-        </p:spPr>
-        <p:style>
-          <a:lnRef idx="1">
-            <a:schemeClr val="accent1"/>
-          </a:lnRef>
-          <a:fillRef idx="3">
-            <a:schemeClr val="accent1"/>
-          </a:fillRef>
-          <a:effectRef idx="2">
-            <a:schemeClr val="accent1"/>
-          </a:effectRef>
-          <a:fontRef idx="minor">
-            <a:schemeClr val="lt1"/>
-          </a:fontRef>
-        </p:style>
+        </p:spPr>
         <p:txBody>
           <a:bodyPr rtlCol="0" anchor="ctr"/>
           <a:lstStyle/>
@@ -7458,22 +6213,7 @@
           <a:ln>
             <a:noFill/>
           </a:ln>
-          <a:effectLst/>
-        </p:spPr>
-        <p:style>
-          <a:lnRef idx="1">
-            <a:schemeClr val="accent1"/>
-          </a:lnRef>
-          <a:fillRef idx="3">
-            <a:schemeClr val="accent1"/>
-          </a:fillRef>
-          <a:effectRef idx="2">
-            <a:schemeClr val="accent1"/>
-          </a:effectRef>
-          <a:fontRef idx="minor">
-            <a:schemeClr val="lt1"/>
-          </a:fontRef>
-        </p:style>
+        </p:spPr>
         <p:txBody>
           <a:bodyPr rtlCol="0" anchor="ctr"/>
           <a:lstStyle/>
@@ -7502,22 +6242,7 @@
           <a:ln>
             <a:noFill/>
           </a:ln>
-          <a:effectLst/>
-        </p:spPr>
-        <p:style>
-          <a:lnRef idx="1">
-            <a:schemeClr val="accent1"/>
-          </a:lnRef>
-          <a:fillRef idx="3">
-            <a:schemeClr val="accent1"/>
-          </a:fillRef>
-          <a:effectRef idx="2">
-            <a:schemeClr val="accent1"/>
-          </a:effectRef>
-          <a:fontRef idx="minor">
-            <a:schemeClr val="lt1"/>
-          </a:fontRef>
-        </p:style>
+        </p:spPr>
         <p:txBody>
           <a:bodyPr rtlCol="0" anchor="ctr"/>
           <a:lstStyle/>
@@ -7546,22 +6271,7 @@
           <a:ln>
             <a:noFill/>
           </a:ln>
-          <a:effectLst/>
-        </p:spPr>
-        <p:style>
-          <a:lnRef idx="1">
-            <a:schemeClr val="accent1"/>
-          </a:lnRef>
-          <a:fillRef idx="3">
-            <a:schemeClr val="accent1"/>
-          </a:fillRef>
-          <a:effectRef idx="2">
-            <a:schemeClr val="accent1"/>
-          </a:effectRef>
-          <a:fontRef idx="minor">
-            <a:schemeClr val="lt1"/>
-          </a:fontRef>
-        </p:style>
+        </p:spPr>
         <p:txBody>
           <a:bodyPr rtlCol="0" anchor="ctr"/>
           <a:lstStyle/>
@@ -7590,22 +6300,7 @@
           <a:ln>
             <a:noFill/>
           </a:ln>
-          <a:effectLst/>
-        </p:spPr>
-        <p:style>
-          <a:lnRef idx="1">
-            <a:schemeClr val="accent1"/>
-          </a:lnRef>
-          <a:fillRef idx="3">
-            <a:schemeClr val="accent1"/>
-          </a:fillRef>
-          <a:effectRef idx="2">
-            <a:schemeClr val="accent1"/>
-          </a:effectRef>
-          <a:fontRef idx="minor">
-            <a:schemeClr val="lt1"/>
-          </a:fontRef>
-        </p:style>
+        </p:spPr>
         <p:txBody>
           <a:bodyPr rtlCol="0" anchor="ctr"/>
           <a:lstStyle/>
@@ -7634,22 +6329,7 @@
           <a:ln>
             <a:noFill/>
           </a:ln>
-          <a:effectLst/>
-        </p:spPr>
-        <p:style>
-          <a:lnRef idx="1">
-            <a:schemeClr val="accent1"/>
-          </a:lnRef>
-          <a:fillRef idx="3">
-            <a:schemeClr val="accent1"/>
-          </a:fillRef>
-          <a:effectRef idx="2">
-            <a:schemeClr val="accent1"/>
-          </a:effectRef>
-          <a:fontRef idx="minor">
-            <a:schemeClr val="lt1"/>
-          </a:fontRef>
-        </p:style>
+        </p:spPr>
         <p:txBody>
           <a:bodyPr rtlCol="0" anchor="ctr"/>
           <a:lstStyle/>
@@ -7678,22 +6358,7 @@
           <a:ln>
             <a:noFill/>
           </a:ln>
-          <a:effectLst/>
-        </p:spPr>
-        <p:style>
-          <a:lnRef idx="1">
-            <a:schemeClr val="accent1"/>
-          </a:lnRef>
-          <a:fillRef idx="3">
-            <a:schemeClr val="accent1"/>
-          </a:fillRef>
-          <a:effectRef idx="2">
-            <a:schemeClr val="accent1"/>
-          </a:effectRef>
-          <a:fontRef idx="minor">
-            <a:schemeClr val="lt1"/>
-          </a:fontRef>
-        </p:style>
+        </p:spPr>
         <p:txBody>
           <a:bodyPr rtlCol="0" anchor="ctr"/>
           <a:lstStyle/>
@@ -7726,9 +6391,9 @@
           <a:p>
             <a:pPr algn="l"/>
             <a:r>
-              <a:rPr sz="900" b="0">
+              <a:rPr sz="1100" b="1">
                 <a:solidFill>
-                  <a:srgbClr val="555555"/>
+                  <a:srgbClr val="1A1A1A"/>
                 </a:solidFill>
                 <a:latin typeface="Arial"/>
               </a:rPr>

</xml_diff>

<commit_message>
Split request card backs into a separate PnP file for KORNI 15 and add application form drafts.
</commit_message>
<xml_diff>
--- a/output/svet-moy-zerkalce-cards.pptx
+++ b/output/svet-moy-zerkalce-cards.pptx
@@ -7,7 +7,6 @@
   <p:sldIdLst>
     <p:sldId id="256" r:id="rId7"/>
     <p:sldId id="257" r:id="rId8"/>
-    <p:sldId id="258" r:id="rId9"/>
   </p:sldIdLst>
   <p:sldSz cx="10692000" cy="7560000" type="screen4x3"/>
   <p:notesSz cx="6858000" cy="9144000"/>
@@ -4780,661 +4779,6 @@
 </file>
 
 <file path=ppt/slides/slide2.xml><?xml version="1.0" encoding="utf-8"?>
-<p:sld xmlns:a="http://schemas.openxmlformats.org/drawingml/2006/main" xmlns:p="http://schemas.openxmlformats.org/presentationml/2006/main" xmlns:r="http://schemas.openxmlformats.org/officeDocument/2006/relationships">
-  <p:cSld>
-    <p:spTree>
-      <p:nvGrpSpPr>
-        <p:cNvPr id="1" name=""/>
-        <p:cNvGrpSpPr/>
-        <p:nvPr/>
-      </p:nvGrpSpPr>
-      <p:grpSpPr/>
-      <p:sp>
-        <p:nvSpPr>
-          <p:cNvPr id="2" name="Rectangle 1"/>
-          <p:cNvSpPr/>
-          <p:nvPr/>
-        </p:nvSpPr>
-        <p:spPr>
-          <a:xfrm>
-            <a:off x="8442742" y="693465"/>
-            <a:ext cx="2064494" cy="1597267"/>
-          </a:xfrm>
-          <a:prstGeom prst="rect">
-            <a:avLst/>
-          </a:prstGeom>
-          <a:noFill/>
-          <a:ln>
-            <a:noFill/>
-          </a:ln>
-        </p:spPr>
-        <p:txBody>
-          <a:bodyPr rtlCol="0" anchor="t" wrap="square" lIns="72438" rIns="72438" tIns="57950" bIns="57950"/>
-          <a:lstStyle/>
-          <a:p>
-            <a:pPr algn="ctr">
-              <a:spcBef>
-                <a:spcPts val="0"/>
-              </a:spcBef>
-              <a:spcAft>
-                <a:spcPts val="0"/>
-              </a:spcAft>
-            </a:pPr>
-            <a:r>
-              <a:rPr sz="1800" b="1">
-                <a:solidFill>
-                  <a:srgbClr val="1A1A1A"/>
-                </a:solidFill>
-                <a:latin typeface="Arial"/>
-              </a:rPr>
-              <a:t>конченных интровертов</a:t>
-            </a:r>
-          </a:p>
-        </p:txBody>
-      </p:sp>
-      <p:sp>
-        <p:nvSpPr>
-          <p:cNvPr id="3" name="Rectangle 2"/>
-          <p:cNvSpPr/>
-          <p:nvPr/>
-        </p:nvSpPr>
-        <p:spPr>
-          <a:xfrm>
-            <a:off x="6378247" y="693465"/>
-            <a:ext cx="2064494" cy="1597267"/>
-          </a:xfrm>
-          <a:prstGeom prst="rect">
-            <a:avLst/>
-          </a:prstGeom>
-          <a:noFill/>
-          <a:ln>
-            <a:noFill/>
-          </a:ln>
-        </p:spPr>
-        <p:txBody>
-          <a:bodyPr rtlCol="0" anchor="t" wrap="square" lIns="72438" rIns="72438" tIns="57950" bIns="57950"/>
-          <a:lstStyle/>
-          <a:p>
-            <a:pPr algn="ctr">
-              <a:spcBef>
-                <a:spcPts val="0"/>
-              </a:spcBef>
-              <a:spcAft>
-                <a:spcPts val="0"/>
-              </a:spcAft>
-            </a:pPr>
-            <a:r>
-              <a:rPr sz="1700" b="1">
-                <a:solidFill>
-                  <a:srgbClr val="1A1A1A"/>
-                </a:solidFill>
-                <a:latin typeface="Arial"/>
-              </a:rPr>
-              <a:t>здесь присутствующих</a:t>
-            </a:r>
-          </a:p>
-        </p:txBody>
-      </p:sp>
-      <p:sp>
-        <p:nvSpPr>
-          <p:cNvPr id="4" name="Rectangle 3"/>
-          <p:cNvSpPr/>
-          <p:nvPr/>
-        </p:nvSpPr>
-        <p:spPr>
-          <a:xfrm>
-            <a:off x="4313752" y="693465"/>
-            <a:ext cx="2064494" cy="1597267"/>
-          </a:xfrm>
-          <a:prstGeom prst="rect">
-            <a:avLst/>
-          </a:prstGeom>
-          <a:noFill/>
-          <a:ln>
-            <a:noFill/>
-          </a:ln>
-        </p:spPr>
-        <p:txBody>
-          <a:bodyPr rtlCol="0" anchor="t" wrap="square" lIns="72438" rIns="72438" tIns="57950" bIns="57950"/>
-          <a:lstStyle/>
-          <a:p>
-            <a:pPr algn="ctr">
-              <a:spcBef>
-                <a:spcPts val="0"/>
-              </a:spcBef>
-              <a:spcAft>
-                <a:spcPts val="0"/>
-              </a:spcAft>
-            </a:pPr>
-            <a:r>
-              <a:rPr sz="1800" b="1">
-                <a:solidFill>
-                  <a:srgbClr val="1A1A1A"/>
-                </a:solidFill>
-                <a:latin typeface="Arial"/>
-              </a:rPr>
-              <a:t>ухоженных дровосеков</a:t>
-            </a:r>
-          </a:p>
-        </p:txBody>
-      </p:sp>
-      <p:sp>
-        <p:nvSpPr>
-          <p:cNvPr id="5" name="Rectangle 4"/>
-          <p:cNvSpPr/>
-          <p:nvPr/>
-        </p:nvSpPr>
-        <p:spPr>
-          <a:xfrm>
-            <a:off x="2249257" y="693465"/>
-            <a:ext cx="2064494" cy="1597267"/>
-          </a:xfrm>
-          <a:prstGeom prst="rect">
-            <a:avLst/>
-          </a:prstGeom>
-          <a:noFill/>
-          <a:ln>
-            <a:noFill/>
-          </a:ln>
-        </p:spPr>
-        <p:txBody>
-          <a:bodyPr rtlCol="0" anchor="t" wrap="square" lIns="72438" rIns="72438" tIns="57950" bIns="57950"/>
-          <a:lstStyle/>
-          <a:p>
-            <a:pPr algn="ctr">
-              <a:spcBef>
-                <a:spcPts val="0"/>
-              </a:spcBef>
-              <a:spcAft>
-                <a:spcPts val="0"/>
-              </a:spcAft>
-            </a:pPr>
-            <a:r>
-              <a:rPr sz="1800" b="1">
-                <a:solidFill>
-                  <a:srgbClr val="1A1A1A"/>
-                </a:solidFill>
-                <a:latin typeface="Arial"/>
-              </a:rPr>
-              <a:t>твоих бывших</a:t>
-            </a:r>
-          </a:p>
-        </p:txBody>
-      </p:sp>
-      <p:sp>
-        <p:nvSpPr>
-          <p:cNvPr id="6" name="Rectangle 5"/>
-          <p:cNvSpPr/>
-          <p:nvPr/>
-        </p:nvSpPr>
-        <p:spPr>
-          <a:xfrm>
-            <a:off x="184762" y="693465"/>
-            <a:ext cx="2064494" cy="1597267"/>
-          </a:xfrm>
-          <a:prstGeom prst="rect">
-            <a:avLst/>
-          </a:prstGeom>
-          <a:noFill/>
-          <a:ln>
-            <a:noFill/>
-          </a:ln>
-        </p:spPr>
-        <p:txBody>
-          <a:bodyPr rtlCol="0" anchor="t" wrap="square" lIns="72438" rIns="72438" tIns="57950" bIns="57950"/>
-          <a:lstStyle/>
-          <a:p>
-            <a:pPr algn="ctr">
-              <a:spcBef>
-                <a:spcPts val="0"/>
-              </a:spcBef>
-              <a:spcAft>
-                <a:spcPts val="0"/>
-              </a:spcAft>
-            </a:pPr>
-            <a:r>
-              <a:rPr sz="1800" b="1">
-                <a:solidFill>
-                  <a:srgbClr val="1A1A1A"/>
-                </a:solidFill>
-                <a:latin typeface="Arial"/>
-              </a:rPr>
-              <a:t>соседей сверху</a:t>
-            </a:r>
-          </a:p>
-        </p:txBody>
-      </p:sp>
-      <p:sp>
-        <p:nvSpPr>
-          <p:cNvPr id="7" name="Rectangle 6"/>
-          <p:cNvSpPr/>
-          <p:nvPr/>
-        </p:nvSpPr>
-        <p:spPr>
-          <a:xfrm>
-            <a:off x="8442742" y="2290732"/>
-            <a:ext cx="2064494" cy="1597267"/>
-          </a:xfrm>
-          <a:prstGeom prst="rect">
-            <a:avLst/>
-          </a:prstGeom>
-          <a:noFill/>
-          <a:ln>
-            <a:noFill/>
-          </a:ln>
-        </p:spPr>
-        <p:txBody>
-          <a:bodyPr rtlCol="0" anchor="t" wrap="square" lIns="72438" rIns="72438" tIns="57950" bIns="57950"/>
-          <a:lstStyle/>
-          <a:p>
-            <a:pPr algn="ctr">
-              <a:spcBef>
-                <a:spcPts val="0"/>
-              </a:spcBef>
-              <a:spcAft>
-                <a:spcPts val="0"/>
-              </a:spcAft>
-            </a:pPr>
-            <a:r>
-              <a:rPr sz="1800" b="1">
-                <a:solidFill>
-                  <a:srgbClr val="1A1A1A"/>
-                </a:solidFill>
-                <a:latin typeface="Arial"/>
-              </a:rPr>
-              <a:t>любителей настолок</a:t>
-            </a:r>
-          </a:p>
-        </p:txBody>
-      </p:sp>
-      <p:sp>
-        <p:nvSpPr>
-          <p:cNvPr id="8" name="Rectangle 7"/>
-          <p:cNvSpPr/>
-          <p:nvPr/>
-        </p:nvSpPr>
-        <p:spPr>
-          <a:xfrm>
-            <a:off x="6378247" y="2290732"/>
-            <a:ext cx="2064494" cy="1597267"/>
-          </a:xfrm>
-          <a:prstGeom prst="rect">
-            <a:avLst/>
-          </a:prstGeom>
-          <a:noFill/>
-          <a:ln>
-            <a:noFill/>
-          </a:ln>
-        </p:spPr>
-        <p:txBody>
-          <a:bodyPr rtlCol="0" anchor="t" wrap="square" lIns="72438" rIns="72438" tIns="57950" bIns="57950"/>
-          <a:lstStyle/>
-          <a:p>
-            <a:pPr algn="ctr">
-              <a:spcBef>
-                <a:spcPts val="0"/>
-              </a:spcBef>
-              <a:spcAft>
-                <a:spcPts val="0"/>
-              </a:spcAft>
-            </a:pPr>
-            <a:r>
-              <a:rPr sz="1800" b="1">
-                <a:solidFill>
-                  <a:srgbClr val="1A1A1A"/>
-                </a:solidFill>
-                <a:latin typeface="Arial"/>
-              </a:rPr>
-              <a:t>самокатчиков</a:t>
-            </a:r>
-          </a:p>
-        </p:txBody>
-      </p:sp>
-      <p:sp>
-        <p:nvSpPr>
-          <p:cNvPr id="9" name="Rectangle 8"/>
-          <p:cNvSpPr/>
-          <p:nvPr/>
-        </p:nvSpPr>
-        <p:spPr>
-          <a:xfrm>
-            <a:off x="4313752" y="2290732"/>
-            <a:ext cx="2064494" cy="1597267"/>
-          </a:xfrm>
-          <a:prstGeom prst="rect">
-            <a:avLst/>
-          </a:prstGeom>
-          <a:noFill/>
-          <a:ln>
-            <a:noFill/>
-          </a:ln>
-        </p:spPr>
-        <p:txBody>
-          <a:bodyPr rtlCol="0" anchor="t" wrap="square" lIns="72438" rIns="72438" tIns="57950" bIns="57950"/>
-          <a:lstStyle/>
-          <a:p>
-            <a:pPr algn="ctr">
-              <a:spcBef>
-                <a:spcPts val="0"/>
-              </a:spcBef>
-              <a:spcAft>
-                <a:spcPts val="0"/>
-              </a:spcAft>
-            </a:pPr>
-            <a:r>
-              <a:rPr sz="1800" b="1">
-                <a:solidFill>
-                  <a:srgbClr val="1A1A1A"/>
-                </a:solidFill>
-                <a:latin typeface="Arial"/>
-              </a:rPr>
-              <a:t>бабок у подъезда</a:t>
-            </a:r>
-          </a:p>
-        </p:txBody>
-      </p:sp>
-      <p:sp>
-        <p:nvSpPr>
-          <p:cNvPr id="10" name="Rectangle 9"/>
-          <p:cNvSpPr/>
-          <p:nvPr/>
-        </p:nvSpPr>
-        <p:spPr>
-          <a:xfrm>
-            <a:off x="2249257" y="2290732"/>
-            <a:ext cx="2064494" cy="1597267"/>
-          </a:xfrm>
-          <a:prstGeom prst="rect">
-            <a:avLst/>
-          </a:prstGeom>
-          <a:noFill/>
-          <a:ln>
-            <a:noFill/>
-          </a:ln>
-        </p:spPr>
-        <p:txBody>
-          <a:bodyPr rtlCol="0" anchor="t" wrap="square" lIns="72438" rIns="72438" tIns="57950" bIns="57950"/>
-          <a:lstStyle/>
-          <a:p>
-            <a:pPr algn="ctr">
-              <a:spcBef>
-                <a:spcPts val="0"/>
-              </a:spcBef>
-              <a:spcAft>
-                <a:spcPts val="0"/>
-              </a:spcAft>
-            </a:pPr>
-            <a:r>
-              <a:rPr sz="1800" b="1">
-                <a:solidFill>
-                  <a:srgbClr val="1A1A1A"/>
-                </a:solidFill>
-                <a:latin typeface="Arial"/>
-              </a:rPr>
-              <a:t>чемпионов френдзоны</a:t>
-            </a:r>
-          </a:p>
-        </p:txBody>
-      </p:sp>
-      <p:sp>
-        <p:nvSpPr>
-          <p:cNvPr id="11" name="Rectangle 10"/>
-          <p:cNvSpPr/>
-          <p:nvPr/>
-        </p:nvSpPr>
-        <p:spPr>
-          <a:xfrm>
-            <a:off x="184762" y="2290732"/>
-            <a:ext cx="2064494" cy="1597267"/>
-          </a:xfrm>
-          <a:prstGeom prst="rect">
-            <a:avLst/>
-          </a:prstGeom>
-          <a:noFill/>
-          <a:ln>
-            <a:noFill/>
-          </a:ln>
-        </p:spPr>
-        <p:txBody>
-          <a:bodyPr rtlCol="0" anchor="t" wrap="square" lIns="72438" rIns="72438" tIns="57950" bIns="57950"/>
-          <a:lstStyle/>
-          <a:p>
-            <a:pPr algn="ctr">
-              <a:spcBef>
-                <a:spcPts val="0"/>
-              </a:spcBef>
-              <a:spcAft>
-                <a:spcPts val="0"/>
-              </a:spcAft>
-            </a:pPr>
-            <a:r>
-              <a:rPr sz="1800" b="1">
-                <a:solidFill>
-                  <a:srgbClr val="1A1A1A"/>
-                </a:solidFill>
-                <a:latin typeface="Arial"/>
-              </a:rPr>
-              <a:t>пузатых скуфов</a:t>
-            </a:r>
-          </a:p>
-        </p:txBody>
-      </p:sp>
-      <p:sp>
-        <p:nvSpPr>
-          <p:cNvPr id="12" name="Rectangle 11"/>
-          <p:cNvSpPr/>
-          <p:nvPr/>
-        </p:nvSpPr>
-        <p:spPr>
-          <a:xfrm>
-            <a:off x="8442742" y="3888000"/>
-            <a:ext cx="2064494" cy="1597267"/>
-          </a:xfrm>
-          <a:prstGeom prst="rect">
-            <a:avLst/>
-          </a:prstGeom>
-          <a:noFill/>
-          <a:ln>
-            <a:noFill/>
-          </a:ln>
-        </p:spPr>
-        <p:txBody>
-          <a:bodyPr rtlCol="0" anchor="t" wrap="square" lIns="72438" rIns="72438" tIns="57950" bIns="57950"/>
-          <a:lstStyle/>
-          <a:p>
-            <a:pPr algn="ctr">
-              <a:spcBef>
-                <a:spcPts val="0"/>
-              </a:spcBef>
-              <a:spcAft>
-                <a:spcPts val="0"/>
-              </a:spcAft>
-            </a:pPr>
-            <a:r>
-              <a:rPr sz="1800" b="1">
-                <a:solidFill>
-                  <a:srgbClr val="1A1A1A"/>
-                </a:solidFill>
-                <a:latin typeface="Arial"/>
-              </a:rPr>
-              <a:t>милф</a:t>
-            </a:r>
-          </a:p>
-        </p:txBody>
-      </p:sp>
-      <p:sp>
-        <p:nvSpPr>
-          <p:cNvPr id="13" name="Rectangle 12"/>
-          <p:cNvSpPr/>
-          <p:nvPr/>
-        </p:nvSpPr>
-        <p:spPr>
-          <a:xfrm>
-            <a:off x="6378247" y="3888000"/>
-            <a:ext cx="2064494" cy="1597267"/>
-          </a:xfrm>
-          <a:prstGeom prst="rect">
-            <a:avLst/>
-          </a:prstGeom>
-          <a:noFill/>
-          <a:ln>
-            <a:noFill/>
-          </a:ln>
-        </p:spPr>
-        <p:txBody>
-          <a:bodyPr rtlCol="0" anchor="t" wrap="square" lIns="72438" rIns="72438" tIns="57950" bIns="57950"/>
-          <a:lstStyle/>
-          <a:p>
-            <a:pPr algn="ctr">
-              <a:spcBef>
-                <a:spcPts val="0"/>
-              </a:spcBef>
-              <a:spcAft>
-                <a:spcPts val="0"/>
-              </a:spcAft>
-            </a:pPr>
-            <a:r>
-              <a:rPr sz="1800" b="1">
-                <a:solidFill>
-                  <a:srgbClr val="1A1A1A"/>
-                </a:solidFill>
-                <a:latin typeface="Arial"/>
-              </a:rPr>
-              <a:t>душнил</a:t>
-            </a:r>
-          </a:p>
-        </p:txBody>
-      </p:sp>
-      <p:sp>
-        <p:nvSpPr>
-          <p:cNvPr id="14" name="Rectangle 13"/>
-          <p:cNvSpPr/>
-          <p:nvPr/>
-        </p:nvSpPr>
-        <p:spPr>
-          <a:xfrm>
-            <a:off x="4313752" y="3888000"/>
-            <a:ext cx="2064494" cy="1597267"/>
-          </a:xfrm>
-          <a:prstGeom prst="rect">
-            <a:avLst/>
-          </a:prstGeom>
-          <a:noFill/>
-          <a:ln>
-            <a:noFill/>
-          </a:ln>
-        </p:spPr>
-        <p:txBody>
-          <a:bodyPr rtlCol="0" anchor="t" wrap="square" lIns="72438" rIns="72438" tIns="57950" bIns="57950"/>
-          <a:lstStyle/>
-          <a:p>
-            <a:pPr algn="ctr">
-              <a:spcBef>
-                <a:spcPts val="0"/>
-              </a:spcBef>
-              <a:spcAft>
-                <a:spcPts val="0"/>
-              </a:spcAft>
-            </a:pPr>
-            <a:r>
-              <a:rPr sz="1800" b="1">
-                <a:solidFill>
-                  <a:srgbClr val="1A1A1A"/>
-                </a:solidFill>
-                <a:latin typeface="Arial"/>
-              </a:rPr>
-              <a:t>нейросетей</a:t>
-            </a:r>
-          </a:p>
-        </p:txBody>
-      </p:sp>
-      <p:sp>
-        <p:nvSpPr>
-          <p:cNvPr id="15" name="Rectangle 14"/>
-          <p:cNvSpPr/>
-          <p:nvPr/>
-        </p:nvSpPr>
-        <p:spPr>
-          <a:xfrm>
-            <a:off x="2249257" y="3888000"/>
-            <a:ext cx="2064494" cy="1597267"/>
-          </a:xfrm>
-          <a:prstGeom prst="rect">
-            <a:avLst/>
-          </a:prstGeom>
-          <a:noFill/>
-          <a:ln>
-            <a:noFill/>
-          </a:ln>
-        </p:spPr>
-        <p:txBody>
-          <a:bodyPr rtlCol="0" anchor="t" wrap="square" lIns="72438" rIns="72438" tIns="57950" bIns="57950"/>
-          <a:lstStyle/>
-          <a:p>
-            <a:pPr algn="ctr">
-              <a:spcBef>
-                <a:spcPts val="0"/>
-              </a:spcBef>
-              <a:spcAft>
-                <a:spcPts val="0"/>
-              </a:spcAft>
-            </a:pPr>
-            <a:r>
-              <a:rPr sz="1800" b="1">
-                <a:solidFill>
-                  <a:srgbClr val="1A1A1A"/>
-                </a:solidFill>
-                <a:latin typeface="Arial"/>
-              </a:rPr>
-              <a:t>очкариков</a:t>
-            </a:r>
-          </a:p>
-        </p:txBody>
-      </p:sp>
-      <p:sp>
-        <p:nvSpPr>
-          <p:cNvPr id="16" name="TextBox 15"/>
-          <p:cNvSpPr txBox="1"/>
-          <p:nvPr/>
-        </p:nvSpPr>
-        <p:spPr>
-          <a:xfrm>
-            <a:off x="184762" y="184762"/>
-            <a:ext cx="10322475" cy="198000"/>
-          </a:xfrm>
-          <a:prstGeom prst="rect">
-            <a:avLst/>
-          </a:prstGeom>
-          <a:noFill/>
-        </p:spPr>
-        <p:txBody>
-          <a:bodyPr wrap="none" lIns="0" rIns="0" tIns="0" bIns="0">
-            <a:spAutoFit/>
-          </a:bodyPr>
-          <a:lstStyle/>
-          <a:p>
-            <a:pPr algn="l"/>
-            <a:r>
-              <a:rPr sz="1100" b="1">
-                <a:solidFill>
-                  <a:srgbClr val="1A1A1A"/>
-                </a:solidFill>
-                <a:latin typeface="Arial"/>
-              </a:rPr>
-              <a:t>Карты запросов · ОБОРОТ</a:t>
-            </a:r>
-          </a:p>
-        </p:txBody>
-      </p:sp>
-    </p:spTree>
-  </p:cSld>
-  <p:clrMapOvr>
-    <a:masterClrMapping/>
-  </p:clrMapOvr>
-</p:sld>
-</file>
-
-<file path=ppt/slides/slide3.xml><?xml version="1.0" encoding="utf-8"?>
 <p:sld xmlns:a="http://schemas.openxmlformats.org/drawingml/2006/main" xmlns:p="http://schemas.openxmlformats.org/presentationml/2006/main" xmlns:r="http://schemas.openxmlformats.org/officeDocument/2006/relationships">
   <p:cSld>
     <p:spTree>

</xml_diff>

<commit_message>
Narrow nickname request card text to three lines at 20pt.
</commit_message>
<xml_diff>
--- a/output/svet-moy-zerkalce-cards.pptx
+++ b/output/svet-moy-zerkalce-cards.pptx
@@ -3210,7 +3210,7 @@
           </a:ln>
         </p:spPr>
         <p:txBody>
-          <a:bodyPr rtlCol="0" anchor="b" wrap="square" lIns="348480" rIns="348480" tIns="816480" bIns="126000"/>
+          <a:bodyPr rtlCol="0" anchor="b" wrap="square" lIns="560520" rIns="560520" tIns="816480" bIns="126000"/>
           <a:lstStyle/>
           <a:p>
             <a:pPr algn="ctr">
@@ -3228,7 +3228,45 @@
                 </a:solidFill>
                 <a:latin typeface="Arial"/>
               </a:rPr>
-              <a:t>Подбери прозвище для кого-то из</a:t>
+              <a:t>Подбери</a:t>
+            </a:r>
+          </a:p>
+          <a:p>
+            <a:pPr algn="ctr">
+              <a:spcBef>
+                <a:spcPts val="0"/>
+              </a:spcBef>
+              <a:spcAft>
+                <a:spcPts val="0"/>
+              </a:spcAft>
+            </a:pPr>
+            <a:r>
+              <a:rPr sz="2000" b="1">
+                <a:solidFill>
+                  <a:srgbClr val="1A1A1A"/>
+                </a:solidFill>
+                <a:latin typeface="Arial"/>
+              </a:rPr>
+              <a:t>прозвище для</a:t>
+            </a:r>
+          </a:p>
+          <a:p>
+            <a:pPr algn="ctr">
+              <a:spcBef>
+                <a:spcPts val="0"/>
+              </a:spcBef>
+              <a:spcAft>
+                <a:spcPts val="0"/>
+              </a:spcAft>
+            </a:pPr>
+            <a:r>
+              <a:rPr sz="2000" b="1">
+                <a:solidFill>
+                  <a:srgbClr val="1A1A1A"/>
+                </a:solidFill>
+                <a:latin typeface="Arial"/>
+              </a:rPr>
+              <a:t>кого-то из</a:t>
             </a:r>
           </a:p>
         </p:txBody>

</xml_diff>